<commit_message>
vault backup: 2026-09-21 15:48:07
</commit_message>
<xml_diff>
--- a/SDLC/Projects/TMP-specimen-sorter-api — Specimen Sorter API/assets/Specimen Sorter API v3.pptx
+++ b/SDLC/Projects/TMP-specimen-sorter-api — Specimen Sorter API/assets/Specimen Sorter API v3.pptx
@@ -2426,7 +2426,7 @@
         <p:spPr>
           <a:xfrm>
             <a:off x="2904744" y="4315016"/>
-            <a:ext cx="643128" cy="173736"/>
+            <a:ext cx="795528" cy="173736"/>
           </a:xfrm>
           <a:prstGeom prst="rect">
             <a:avLst/>
@@ -2468,7 +2468,7 @@
         <p:spPr>
           <a:xfrm>
             <a:off x="2904744" y="4525328"/>
-            <a:ext cx="643128" cy="219456"/>
+            <a:ext cx="795528" cy="219456"/>
           </a:xfrm>
           <a:prstGeom prst="rect">
             <a:avLst/>
@@ -2495,7 +2495,7 @@
                 <a:ea typeface="Segoe UI" pitchFamily="34" charset="-122"/>
                 <a:cs typeface="Segoe UI" pitchFamily="34" charset="-120"/>
               </a:rPr>
-              <a:t>TMP-000</a:t>
+              <a:t>LIS-XXXXX</a:t>
             </a:r>
             <a:endParaRPr lang="en-US" sz="1200" dirty="0"/>
           </a:p>
@@ -2509,7 +2509,7 @@
         </p:nvSpPr>
         <p:spPr>
           <a:xfrm>
-            <a:off x="3803904" y="4315016"/>
+            <a:off x="3956304" y="4315016"/>
             <a:ext cx="10973" cy="384048"/>
           </a:xfrm>
           <a:prstGeom prst="rect">
@@ -2534,8 +2534,8 @@
         </p:nvSpPr>
         <p:spPr>
           <a:xfrm>
-            <a:off x="4059936" y="4315016"/>
-            <a:ext cx="947928" cy="173736"/>
+            <a:off x="4212336" y="4315016"/>
+            <a:ext cx="909828" cy="173736"/>
           </a:xfrm>
           <a:prstGeom prst="rect">
             <a:avLst/>
@@ -2562,7 +2562,7 @@
                 <a:ea typeface="Segoe UI" pitchFamily="34" charset="-122"/>
                 <a:cs typeface="Segoe UI" pitchFamily="34" charset="-120"/>
               </a:rPr>
-              <a:t>TARGET</a:t>
+              <a:t>PRESENTERS</a:t>
             </a:r>
             <a:endParaRPr lang="en-US" sz="1050" dirty="0"/>
           </a:p>
@@ -2576,8 +2576,8 @@
         </p:nvSpPr>
         <p:spPr>
           <a:xfrm>
-            <a:off x="4059936" y="4525328"/>
-            <a:ext cx="947928" cy="219456"/>
+            <a:off x="4212336" y="4525328"/>
+            <a:ext cx="909828" cy="219456"/>
           </a:xfrm>
           <a:prstGeom prst="rect">
             <a:avLst/>
@@ -2604,334 +2604,7 @@
                 <a:ea typeface="Segoe UI" pitchFamily="34" charset="-122"/>
                 <a:cs typeface="Segoe UI" pitchFamily="34" charset="-120"/>
               </a:rPr>
-              <a:t>30 May 2027</a:t>
-            </a:r>
-            <a:endParaRPr lang="en-US" sz="1200" dirty="0"/>
-          </a:p>
-        </p:txBody>
-      </p:sp>
-      <p:sp>
-        <p:nvSpPr>
-          <p:cNvPr id="15" name="Shape 13"/>
-          <p:cNvSpPr/>
-          <p:nvPr/>
-        </p:nvSpPr>
-        <p:spPr>
-          <a:xfrm>
-            <a:off x="5263896" y="4315016"/>
-            <a:ext cx="10973" cy="384048"/>
-          </a:xfrm>
-          <a:prstGeom prst="rect">
-            <a:avLst/>
-          </a:prstGeom>
-          <a:solidFill>
-            <a:srgbClr val="1E293B"/>
-          </a:solidFill>
-          <a:ln w="12700">
-            <a:solidFill>
-              <a:srgbClr val="1E293B"/>
-            </a:solidFill>
-            <a:prstDash val="solid"/>
-          </a:ln>
-        </p:spPr>
-      </p:sp>
-      <p:sp>
-        <p:nvSpPr>
-          <p:cNvPr id="16" name="Text 14"/>
-          <p:cNvSpPr/>
-          <p:nvPr/>
-        </p:nvSpPr>
-        <p:spPr>
-          <a:xfrm>
-            <a:off x="5519928" y="4315016"/>
-            <a:ext cx="1252728" cy="173736"/>
-          </a:xfrm>
-          <a:prstGeom prst="rect">
-            <a:avLst/>
-          </a:prstGeom>
-          <a:noFill/>
-          <a:ln/>
-        </p:spPr>
-        <p:txBody>
-          <a:bodyPr wrap="square" lIns="0" tIns="0" rIns="0" bIns="0" rtlCol="0" anchor="t"/>
-          <a:lstStyle/>
-          <a:p>
-            <a:pPr algn="l" indent="0" marL="0">
-              <a:lnSpc>
-                <a:spcPct val="115000"/>
-              </a:lnSpc>
-              <a:buNone/>
-            </a:pPr>
-            <a:r>
-              <a:rPr lang="en-US" sz="1050" dirty="0">
-                <a:solidFill>
-                  <a:srgbClr val="64748B"/>
-                </a:solidFill>
-                <a:latin typeface="Segoe UI" pitchFamily="34" charset="0"/>
-                <a:ea typeface="Segoe UI" pitchFamily="34" charset="-122"/>
-                <a:cs typeface="Segoe UI" pitchFamily="34" charset="-120"/>
-              </a:rPr>
-              <a:t>STATUS</a:t>
-            </a:r>
-            <a:endParaRPr lang="en-US" sz="1050" dirty="0"/>
-          </a:p>
-        </p:txBody>
-      </p:sp>
-      <p:sp>
-        <p:nvSpPr>
-          <p:cNvPr id="17" name="Text 15"/>
-          <p:cNvSpPr/>
-          <p:nvPr/>
-        </p:nvSpPr>
-        <p:spPr>
-          <a:xfrm>
-            <a:off x="5519928" y="4525328"/>
-            <a:ext cx="1252728" cy="219456"/>
-          </a:xfrm>
-          <a:prstGeom prst="rect">
-            <a:avLst/>
-          </a:prstGeom>
-          <a:noFill/>
-          <a:ln/>
-        </p:spPr>
-        <p:txBody>
-          <a:bodyPr wrap="square" lIns="0" tIns="0" rIns="0" bIns="0" rtlCol="0" anchor="t"/>
-          <a:lstStyle/>
-          <a:p>
-            <a:pPr algn="l" indent="0" marL="0">
-              <a:lnSpc>
-                <a:spcPct val="115000"/>
-              </a:lnSpc>
-              <a:buNone/>
-            </a:pPr>
-            <a:r>
-              <a:rPr lang="en-US" sz="1200" dirty="0">
-                <a:solidFill>
-                  <a:srgbClr val="38BDF8"/>
-                </a:solidFill>
-                <a:latin typeface="Segoe UI" pitchFamily="34" charset="0"/>
-                <a:ea typeface="Segoe UI" pitchFamily="34" charset="-122"/>
-                <a:cs typeface="Segoe UI" pitchFamily="34" charset="-120"/>
-              </a:rPr>
-              <a:t>Design approved</a:t>
-            </a:r>
-            <a:endParaRPr lang="en-US" sz="1200" dirty="0"/>
-          </a:p>
-        </p:txBody>
-      </p:sp>
-      <p:sp>
-        <p:nvSpPr>
-          <p:cNvPr id="18" name="Shape 16"/>
-          <p:cNvSpPr/>
-          <p:nvPr/>
-        </p:nvSpPr>
-        <p:spPr>
-          <a:xfrm>
-            <a:off x="7028688" y="4315016"/>
-            <a:ext cx="10973" cy="384048"/>
-          </a:xfrm>
-          <a:prstGeom prst="rect">
-            <a:avLst/>
-          </a:prstGeom>
-          <a:solidFill>
-            <a:srgbClr val="1E293B"/>
-          </a:solidFill>
-          <a:ln w="12700">
-            <a:solidFill>
-              <a:srgbClr val="1E293B"/>
-            </a:solidFill>
-            <a:prstDash val="solid"/>
-          </a:ln>
-        </p:spPr>
-      </p:sp>
-      <p:sp>
-        <p:nvSpPr>
-          <p:cNvPr id="19" name="Text 17"/>
-          <p:cNvSpPr/>
-          <p:nvPr/>
-        </p:nvSpPr>
-        <p:spPr>
-          <a:xfrm>
-            <a:off x="7284720" y="4315016"/>
-            <a:ext cx="909828" cy="173736"/>
-          </a:xfrm>
-          <a:prstGeom prst="rect">
-            <a:avLst/>
-          </a:prstGeom>
-          <a:noFill/>
-          <a:ln/>
-        </p:spPr>
-        <p:txBody>
-          <a:bodyPr wrap="square" lIns="0" tIns="0" rIns="0" bIns="0" rtlCol="0" anchor="t"/>
-          <a:lstStyle/>
-          <a:p>
-            <a:pPr algn="l" indent="0" marL="0">
-              <a:lnSpc>
-                <a:spcPct val="115000"/>
-              </a:lnSpc>
-              <a:buNone/>
-            </a:pPr>
-            <a:r>
-              <a:rPr lang="en-US" sz="1050" dirty="0">
-                <a:solidFill>
-                  <a:srgbClr val="64748B"/>
-                </a:solidFill>
-                <a:latin typeface="Segoe UI" pitchFamily="34" charset="0"/>
-                <a:ea typeface="Segoe UI" pitchFamily="34" charset="-122"/>
-                <a:cs typeface="Segoe UI" pitchFamily="34" charset="-120"/>
-              </a:rPr>
-              <a:t>PRESENTERS</a:t>
-            </a:r>
-            <a:endParaRPr lang="en-US" sz="1050" dirty="0"/>
-          </a:p>
-        </p:txBody>
-      </p:sp>
-      <p:sp>
-        <p:nvSpPr>
-          <p:cNvPr id="20" name="Text 18"/>
-          <p:cNvSpPr/>
-          <p:nvPr/>
-        </p:nvSpPr>
-        <p:spPr>
-          <a:xfrm>
-            <a:off x="7284720" y="4525328"/>
-            <a:ext cx="909828" cy="219456"/>
-          </a:xfrm>
-          <a:prstGeom prst="rect">
-            <a:avLst/>
-          </a:prstGeom>
-          <a:noFill/>
-          <a:ln/>
-        </p:spPr>
-        <p:txBody>
-          <a:bodyPr wrap="square" lIns="0" tIns="0" rIns="0" bIns="0" rtlCol="0" anchor="t"/>
-          <a:lstStyle/>
-          <a:p>
-            <a:pPr algn="l" indent="0" marL="0">
-              <a:lnSpc>
-                <a:spcPct val="115000"/>
-              </a:lnSpc>
-              <a:buNone/>
-            </a:pPr>
-            <a:r>
-              <a:rPr lang="en-US" sz="1200" dirty="0">
-                <a:solidFill>
-                  <a:srgbClr val="F1F5F9"/>
-                </a:solidFill>
-                <a:latin typeface="Segoe UI" pitchFamily="34" charset="0"/>
-                <a:ea typeface="Segoe UI" pitchFamily="34" charset="-122"/>
-                <a:cs typeface="Segoe UI" pitchFamily="34" charset="-120"/>
-              </a:rPr>
-              <a:t>Ka</a:t>
-            </a:r>
-            <a:endParaRPr lang="en-US" sz="1200" dirty="0"/>
-          </a:p>
-        </p:txBody>
-      </p:sp>
-      <p:sp>
-        <p:nvSpPr>
-          <p:cNvPr id="21" name="Shape 19"/>
-          <p:cNvSpPr/>
-          <p:nvPr/>
-        </p:nvSpPr>
-        <p:spPr>
-          <a:xfrm>
-            <a:off x="8450580" y="4315016"/>
-            <a:ext cx="10973" cy="384048"/>
-          </a:xfrm>
-          <a:prstGeom prst="rect">
-            <a:avLst/>
-          </a:prstGeom>
-          <a:solidFill>
-            <a:srgbClr val="1E293B"/>
-          </a:solidFill>
-          <a:ln w="12700">
-            <a:solidFill>
-              <a:srgbClr val="1E293B"/>
-            </a:solidFill>
-            <a:prstDash val="solid"/>
-          </a:ln>
-        </p:spPr>
-      </p:sp>
-      <p:sp>
-        <p:nvSpPr>
-          <p:cNvPr id="22" name="Text 20"/>
-          <p:cNvSpPr/>
-          <p:nvPr/>
-        </p:nvSpPr>
-        <p:spPr>
-          <a:xfrm>
-            <a:off x="8706612" y="4315016"/>
-            <a:ext cx="1709928" cy="173736"/>
-          </a:xfrm>
-          <a:prstGeom prst="rect">
-            <a:avLst/>
-          </a:prstGeom>
-          <a:noFill/>
-          <a:ln/>
-        </p:spPr>
-        <p:txBody>
-          <a:bodyPr wrap="square" lIns="0" tIns="0" rIns="0" bIns="0" rtlCol="0" anchor="t"/>
-          <a:lstStyle/>
-          <a:p>
-            <a:pPr algn="l" indent="0" marL="0">
-              <a:lnSpc>
-                <a:spcPct val="115000"/>
-              </a:lnSpc>
-              <a:buNone/>
-            </a:pPr>
-            <a:r>
-              <a:rPr lang="en-US" sz="1050" dirty="0">
-                <a:solidFill>
-                  <a:srgbClr val="64748B"/>
-                </a:solidFill>
-                <a:latin typeface="Segoe UI" pitchFamily="34" charset="0"/>
-                <a:ea typeface="Segoe UI" pitchFamily="34" charset="-122"/>
-                <a:cs typeface="Segoe UI" pitchFamily="34" charset="-120"/>
-              </a:rPr>
-              <a:t>REVIEWERS</a:t>
-            </a:r>
-            <a:endParaRPr lang="en-US" sz="1050" dirty="0"/>
-          </a:p>
-        </p:txBody>
-      </p:sp>
-      <p:sp>
-        <p:nvSpPr>
-          <p:cNvPr id="23" name="Text 21"/>
-          <p:cNvSpPr/>
-          <p:nvPr/>
-        </p:nvSpPr>
-        <p:spPr>
-          <a:xfrm>
-            <a:off x="8706612" y="4525328"/>
-            <a:ext cx="1709928" cy="219456"/>
-          </a:xfrm>
-          <a:prstGeom prst="rect">
-            <a:avLst/>
-          </a:prstGeom>
-          <a:noFill/>
-          <a:ln/>
-        </p:spPr>
-        <p:txBody>
-          <a:bodyPr wrap="square" lIns="0" tIns="0" rIns="0" bIns="0" rtlCol="0" anchor="t"/>
-          <a:lstStyle/>
-          <a:p>
-            <a:pPr algn="l" indent="0" marL="0">
-              <a:lnSpc>
-                <a:spcPct val="115000"/>
-              </a:lnSpc>
-              <a:buNone/>
-            </a:pPr>
-            <a:r>
-              <a:rPr lang="en-US" sz="1200" dirty="0">
-                <a:solidFill>
-                  <a:srgbClr val="F1F5F9"/>
-                </a:solidFill>
-                <a:latin typeface="Segoe UI" pitchFamily="34" charset="0"/>
-                <a:ea typeface="Segoe UI" pitchFamily="34" charset="-122"/>
-                <a:cs typeface="Segoe UI" pitchFamily="34" charset="-120"/>
-              </a:rPr>
-              <a:t>Tony Chong, CP3 panel</a:t>
+              <a:t>Tony Chong</a:t>
             </a:r>
             <a:endParaRPr lang="en-US" sz="1200" dirty="0"/>
           </a:p>

</xml_diff>

<commit_message>
vault backup: 2026-09-21 15:58:25
</commit_message>
<xml_diff>
--- a/SDLC/Projects/TMP-specimen-sorter-api — Specimen Sorter API/assets/Specimen Sorter API v3.pptx
+++ b/SDLC/Projects/TMP-specimen-sorter-api — Specimen Sorter API/assets/Specimen Sorter API v3.pptx
@@ -18,11 +18,9 @@
     <p:sldId id="266" r:id="rId12"/>
     <p:sldId id="267" r:id="rId13"/>
     <p:sldId id="268" r:id="rId14"/>
-    <p:sldId id="269" r:id="rId15"/>
-    <p:sldId id="270" r:id="rId16"/>
   </p:sldIdLst>
   <p:notesMasterIdLst>
-    <p:notesMasterId r:id="rId17"/>
+    <p:notesMasterId r:id="rId15"/>
   </p:notesMasterIdLst>
   <p:sldSz cx="12192000" cy="6858000"/>
   <p:notesSz cx="6858000" cy="12192000"/>
@@ -868,7 +866,7 @@
           <a:p>
             <a:r>
               <a:rPr lang="en-US" dirty="0"/>
-              <a:t>D1 to D12 and D14 are answered. D13 is the only open design point; the other two are delivery.</a:t>
+              <a:t>Likely questions: why not let middleware call the staff register; why hospital can be omitted; why mixed tubes fail; why server name is not on the map.</a:t>
             </a:r>
             <a:endParaRPr lang="en-US" dirty="0"/>
           </a:p>
@@ -892,182 +890,6 @@
             <a:fld id="{F7021451-1387-4CA6-816F-3879F97B5CBC}" type="slidenum">
               <a:rPr lang="en-US"/>
               <a:t>13</a:t>
-            </a:fld>
-            <a:endParaRPr lang="en-US"/>
-          </a:p>
-        </p:txBody>
-      </p:sp>
-    </p:spTree>
-    <p:extLst>
-      <p:ext uri="{BB962C8B-B14F-4D97-AF65-F5344CB8AC3E}">
-        <p14:creationId xmlns:p14="http://schemas.microsoft.com/office/powerpoint/2010/main" val="1024086991"/>
-      </p:ext>
-    </p:extLst>
-  </p:cSld>
-  <p:clrMapOvr>
-    <a:masterClrMapping/>
-  </p:clrMapOvr>
-</p:notes>
-</file>
-
-<file path=ppt/notesSlides/notesSlide14.xml><?xml version="1.0" encoding="utf-8"?>
-<p:notes xmlns:a="http://schemas.openxmlformats.org/drawingml/2006/main" xmlns:r="http://schemas.openxmlformats.org/officeDocument/2006/relationships" xmlns:p="http://schemas.openxmlformats.org/presentationml/2006/main">
-  <p:cSld>
-    <p:spTree>
-      <p:nvGrpSpPr>
-        <p:cNvPr id="1" name=""/>
-        <p:cNvGrpSpPr/>
-        <p:nvPr/>
-      </p:nvGrpSpPr>
-      <p:grpSpPr>
-        <a:xfrm>
-          <a:off x="0" y="0"/>
-          <a:ext cx="0" cy="0"/>
-          <a:chOff x="0" y="0"/>
-          <a:chExt cx="0" cy="0"/>
-        </a:xfrm>
-      </p:grpSpPr>
-      <p:sp>
-        <p:nvSpPr>
-          <p:cNvPr id="2" name="Slide Image Placeholder 1"/>
-          <p:cNvSpPr>
-            <a:spLocks noGrp="1" noRot="1" noChangeAspect="1"/>
-          </p:cNvSpPr>
-          <p:nvPr>
-            <p:ph type="sldImg"/>
-          </p:nvPr>
-        </p:nvSpPr>
-        <p:spPr/>
-      </p:sp>
-      <p:sp>
-        <p:nvSpPr>
-          <p:cNvPr id="3" name="Notes Placeholder 2"/>
-          <p:cNvSpPr>
-            <a:spLocks noGrp="1"/>
-          </p:cNvSpPr>
-          <p:nvPr>
-            <p:ph type="body" idx="1"/>
-          </p:nvPr>
-        </p:nvSpPr>
-        <p:spPr/>
-        <p:txBody>
-          <a:bodyPr/>
-          <a:lstStyle/>
-          <a:p>
-            <a:r>
-              <a:rPr lang="en-US" dirty="0"/>
-              <a:t>Likely questions: why not let middleware call the staff register; why hospital can be omitted; why mixed tubes fail; why server name is not on the map.</a:t>
-            </a:r>
-            <a:endParaRPr lang="en-US" dirty="0"/>
-          </a:p>
-        </p:txBody>
-      </p:sp>
-      <p:sp>
-        <p:nvSpPr>
-          <p:cNvPr id="4" name="Slide Number Placeholder 3"/>
-          <p:cNvSpPr>
-            <a:spLocks noGrp="1"/>
-          </p:cNvSpPr>
-          <p:nvPr>
-            <p:ph type="sldNum" sz="quarter" idx="10"/>
-          </p:nvPr>
-        </p:nvSpPr>
-        <p:spPr/>
-        <p:txBody>
-          <a:bodyPr/>
-          <a:lstStyle/>
-          <a:p>
-            <a:fld id="{F7021451-1387-4CA6-816F-3879F97B5CBC}" type="slidenum">
-              <a:rPr lang="en-US"/>
-              <a:t>14</a:t>
-            </a:fld>
-            <a:endParaRPr lang="en-US"/>
-          </a:p>
-        </p:txBody>
-      </p:sp>
-    </p:spTree>
-    <p:extLst>
-      <p:ext uri="{BB962C8B-B14F-4D97-AF65-F5344CB8AC3E}">
-        <p14:creationId xmlns:p14="http://schemas.microsoft.com/office/powerpoint/2010/main" val="1024086991"/>
-      </p:ext>
-    </p:extLst>
-  </p:cSld>
-  <p:clrMapOvr>
-    <a:masterClrMapping/>
-  </p:clrMapOvr>
-</p:notes>
-</file>
-
-<file path=ppt/notesSlides/notesSlide15.xml><?xml version="1.0" encoding="utf-8"?>
-<p:notes xmlns:a="http://schemas.openxmlformats.org/drawingml/2006/main" xmlns:r="http://schemas.openxmlformats.org/officeDocument/2006/relationships" xmlns:p="http://schemas.openxmlformats.org/presentationml/2006/main">
-  <p:cSld>
-    <p:spTree>
-      <p:nvGrpSpPr>
-        <p:cNvPr id="1" name=""/>
-        <p:cNvGrpSpPr/>
-        <p:nvPr/>
-      </p:nvGrpSpPr>
-      <p:grpSpPr>
-        <a:xfrm>
-          <a:off x="0" y="0"/>
-          <a:ext cx="0" cy="0"/>
-          <a:chOff x="0" y="0"/>
-          <a:chExt cx="0" cy="0"/>
-        </a:xfrm>
-      </p:grpSpPr>
-      <p:sp>
-        <p:nvSpPr>
-          <p:cNvPr id="2" name="Slide Image Placeholder 1"/>
-          <p:cNvSpPr>
-            <a:spLocks noGrp="1" noRot="1" noChangeAspect="1"/>
-          </p:cNvSpPr>
-          <p:nvPr>
-            <p:ph type="sldImg"/>
-          </p:nvPr>
-        </p:nvSpPr>
-        <p:spPr/>
-      </p:sp>
-      <p:sp>
-        <p:nvSpPr>
-          <p:cNvPr id="3" name="Notes Placeholder 2"/>
-          <p:cNvSpPr>
-            <a:spLocks noGrp="1"/>
-          </p:cNvSpPr>
-          <p:nvPr>
-            <p:ph type="body" idx="1"/>
-          </p:nvPr>
-        </p:nvSpPr>
-        <p:spPr/>
-        <p:txBody>
-          <a:bodyPr/>
-          <a:lstStyle/>
-          <a:p>
-            <a:r>
-              <a:rPr lang="en-US" dirty="0"/>
-              <a:t>The date is the end of promotion preparation. Submission is June and pilot July 2027 per the project plan.</a:t>
-            </a:r>
-            <a:endParaRPr lang="en-US" dirty="0"/>
-          </a:p>
-        </p:txBody>
-      </p:sp>
-      <p:sp>
-        <p:nvSpPr>
-          <p:cNvPr id="4" name="Slide Number Placeholder 3"/>
-          <p:cNvSpPr>
-            <a:spLocks noGrp="1"/>
-          </p:cNvSpPr>
-          <p:nvPr>
-            <p:ph type="sldNum" sz="quarter" idx="10"/>
-          </p:nvPr>
-        </p:nvSpPr>
-        <p:spPr/>
-        <p:txBody>
-          <a:bodyPr/>
-          <a:lstStyle/>
-          <a:p>
-            <a:fld id="{F7021451-1387-4CA6-816F-3879F97B5CBC}" type="slidenum">
-              <a:rPr lang="en-US"/>
-              <a:t>15</a:t>
             </a:fld>
             <a:endParaRPr lang="en-US"/>
           </a:p>
@@ -5429,575 +5251,6 @@
     <p:bg>
       <p:bgPr>
         <a:solidFill>
-          <a:srgbClr val="F8FAFC"/>
-        </a:solidFill>
-      </p:bgPr>
-    </p:bg>
-    <p:spTree>
-      <p:nvGrpSpPr>
-        <p:cNvPr id="1" name=""/>
-        <p:cNvGrpSpPr/>
-        <p:nvPr/>
-      </p:nvGrpSpPr>
-      <p:grpSpPr>
-        <a:xfrm>
-          <a:off x="0" y="0"/>
-          <a:ext cx="0" cy="0"/>
-          <a:chOff x="0" y="0"/>
-          <a:chExt cx="0" cy="0"/>
-        </a:xfrm>
-      </p:grpSpPr>
-      <p:sp>
-        <p:nvSpPr>
-          <p:cNvPr id="2" name="Text 0"/>
-          <p:cNvSpPr/>
-          <p:nvPr/>
-        </p:nvSpPr>
-        <p:spPr>
-          <a:xfrm>
-            <a:off x="609600" y="457200"/>
-            <a:ext cx="10972800" cy="228600"/>
-          </a:xfrm>
-          <a:prstGeom prst="rect">
-            <a:avLst/>
-          </a:prstGeom>
-          <a:noFill/>
-          <a:ln/>
-        </p:spPr>
-        <p:txBody>
-          <a:bodyPr wrap="square" lIns="0" tIns="0" rIns="0" bIns="0" rtlCol="0" anchor="ctr"/>
-          <a:lstStyle/>
-          <a:p>
-            <a:pPr indent="0" marL="0">
-              <a:buNone/>
-            </a:pPr>
-            <a:r>
-              <a:rPr lang="en-US" sz="1050" spc="150" kern="0" dirty="0">
-                <a:solidFill>
-                  <a:srgbClr val="0284C7"/>
-                </a:solidFill>
-                <a:latin typeface="Segoe UI Semibold" pitchFamily="34" charset="0"/>
-                <a:ea typeface="Segoe UI Semibold" pitchFamily="34" charset="-122"/>
-                <a:cs typeface="Segoe UI Semibold" pitchFamily="34" charset="-120"/>
-              </a:rPr>
-              <a:t>07. OPEN QUESTIONS</a:t>
-            </a:r>
-            <a:endParaRPr lang="en-US" sz="1050" dirty="0"/>
-          </a:p>
-        </p:txBody>
-      </p:sp>
-      <p:sp>
-        <p:nvSpPr>
-          <p:cNvPr id="3" name="Text 1"/>
-          <p:cNvSpPr/>
-          <p:nvPr/>
-        </p:nvSpPr>
-        <p:spPr>
-          <a:xfrm>
-            <a:off x="609600" y="722376"/>
-            <a:ext cx="10972800" cy="457200"/>
-          </a:xfrm>
-          <a:prstGeom prst="rect">
-            <a:avLst/>
-          </a:prstGeom>
-          <a:noFill/>
-          <a:ln/>
-        </p:spPr>
-        <p:txBody>
-          <a:bodyPr wrap="square" lIns="0" tIns="0" rIns="0" bIns="0" rtlCol="0" anchor="ctr"/>
-          <a:lstStyle/>
-          <a:p>
-            <a:pPr indent="0" marL="0">
-              <a:buNone/>
-            </a:pPr>
-            <a:r>
-              <a:rPr lang="en-US" sz="2400" dirty="0">
-                <a:solidFill>
-                  <a:srgbClr val="0F172A"/>
-                </a:solidFill>
-                <a:latin typeface="Segoe UI Semibold" pitchFamily="34" charset="0"/>
-                <a:ea typeface="Segoe UI Semibold" pitchFamily="34" charset="-122"/>
-                <a:cs typeface="Segoe UI Semibold" pitchFamily="34" charset="-120"/>
-              </a:rPr>
-              <a:t>Three things to settle before SIT</a:t>
-            </a:r>
-            <a:endParaRPr lang="en-US" sz="2400" dirty="0"/>
-          </a:p>
-        </p:txBody>
-      </p:sp>
-      <p:sp>
-        <p:nvSpPr>
-          <p:cNvPr id="4" name="Shape 2"/>
-          <p:cNvSpPr/>
-          <p:nvPr/>
-        </p:nvSpPr>
-        <p:spPr>
-          <a:xfrm>
-            <a:off x="609600" y="2561463"/>
-            <a:ext cx="10972800" cy="797814"/>
-          </a:xfrm>
-          <a:prstGeom prst="roundRect">
-            <a:avLst>
-              <a:gd name="adj" fmla="val 13754"/>
-            </a:avLst>
-          </a:prstGeom>
-          <a:solidFill>
-            <a:srgbClr val="FFFFFF"/>
-          </a:solidFill>
-          <a:ln w="9525">
-            <a:solidFill>
-              <a:srgbClr val="E2E8F0"/>
-            </a:solidFill>
-            <a:prstDash val="solid"/>
-          </a:ln>
-        </p:spPr>
-      </p:sp>
-      <p:sp>
-        <p:nvSpPr>
-          <p:cNvPr id="5" name="Text 3"/>
-          <p:cNvSpPr/>
-          <p:nvPr/>
-        </p:nvSpPr>
-        <p:spPr>
-          <a:xfrm>
-            <a:off x="847344" y="2561463"/>
-            <a:ext cx="502920" cy="797814"/>
-          </a:xfrm>
-          <a:prstGeom prst="rect">
-            <a:avLst/>
-          </a:prstGeom>
-          <a:noFill/>
-          <a:ln/>
-        </p:spPr>
-        <p:txBody>
-          <a:bodyPr wrap="square" lIns="0" tIns="0" rIns="0" bIns="0" rtlCol="0" anchor="ctr"/>
-          <a:lstStyle/>
-          <a:p>
-            <a:pPr algn="l" indent="0" marL="0">
-              <a:lnSpc>
-                <a:spcPct val="115000"/>
-              </a:lnSpc>
-              <a:buNone/>
-            </a:pPr>
-            <a:r>
-              <a:rPr lang="en-US" sz="1500" dirty="0">
-                <a:solidFill>
-                  <a:srgbClr val="0284C7"/>
-                </a:solidFill>
-                <a:latin typeface="Segoe UI Semibold" pitchFamily="34" charset="0"/>
-                <a:ea typeface="Segoe UI Semibold" pitchFamily="34" charset="-122"/>
-                <a:cs typeface="Segoe UI Semibold" pitchFamily="34" charset="-120"/>
-              </a:rPr>
-              <a:t>01</a:t>
-            </a:r>
-            <a:endParaRPr lang="en-US" sz="1500" dirty="0"/>
-          </a:p>
-        </p:txBody>
-      </p:sp>
-      <p:sp>
-        <p:nvSpPr>
-          <p:cNvPr id="6" name="Text 4"/>
-          <p:cNvSpPr/>
-          <p:nvPr/>
-        </p:nvSpPr>
-        <p:spPr>
-          <a:xfrm>
-            <a:off x="1341120" y="2744343"/>
-            <a:ext cx="10003536" cy="205740"/>
-          </a:xfrm>
-          <a:prstGeom prst="rect">
-            <a:avLst/>
-          </a:prstGeom>
-          <a:noFill/>
-          <a:ln/>
-        </p:spPr>
-        <p:txBody>
-          <a:bodyPr wrap="square" lIns="0" tIns="0" rIns="0" bIns="0" rtlCol="0" anchor="t"/>
-          <a:lstStyle/>
-          <a:p>
-            <a:pPr algn="l" indent="0" marL="0">
-              <a:lnSpc>
-                <a:spcPct val="110000"/>
-              </a:lnSpc>
-              <a:buNone/>
-            </a:pPr>
-            <a:r>
-              <a:rPr lang="en-US" sz="1350" b="1" dirty="0">
-                <a:solidFill>
-                  <a:srgbClr val="0F172A"/>
-                </a:solidFill>
-                <a:latin typeface="Segoe UI" pitchFamily="34" charset="0"/>
-                <a:ea typeface="Segoe UI" pitchFamily="34" charset="-122"/>
-                <a:cs typeface="Segoe UI" pitchFamily="34" charset="-120"/>
-              </a:rPr>
-              <a:t>Does in-process retrieveGcrOrder need the lab before the USID lookup?</a:t>
-            </a:r>
-            <a:endParaRPr lang="en-US" sz="1350" dirty="0"/>
-          </a:p>
-        </p:txBody>
-      </p:sp>
-      <p:sp>
-        <p:nvSpPr>
-          <p:cNvPr id="7" name="Text 5"/>
-          <p:cNvSpPr/>
-          <p:nvPr/>
-        </p:nvSpPr>
-        <p:spPr>
-          <a:xfrm>
-            <a:off x="1341120" y="3004947"/>
-            <a:ext cx="10003536" cy="171450"/>
-          </a:xfrm>
-          <a:prstGeom prst="rect">
-            <a:avLst/>
-          </a:prstGeom>
-          <a:noFill/>
-          <a:ln/>
-        </p:spPr>
-        <p:txBody>
-          <a:bodyPr wrap="square" lIns="0" tIns="0" rIns="0" bIns="0" rtlCol="0" anchor="t"/>
-          <a:lstStyle/>
-          <a:p>
-            <a:pPr algn="l" indent="0" marL="0">
-              <a:lnSpc>
-                <a:spcPct val="110000"/>
-              </a:lnSpc>
-              <a:buNone/>
-            </a:pPr>
-            <a:r>
-              <a:rPr lang="en-US" sz="1125" dirty="0">
-                <a:solidFill>
-                  <a:srgbClr val="64748B"/>
-                </a:solidFill>
-                <a:latin typeface="Segoe UI" pitchFamily="34" charset="0"/>
-                <a:ea typeface="Segoe UI" pitchFamily="34" charset="-122"/>
-                <a:cs typeface="Segoe UI" pitchFamily="34" charset="-120"/>
-              </a:rPr>
-              <a:t>D13. If yes, fix the retrieve, not the map. Do not put lab or server name on the map.</a:t>
-            </a:r>
-            <a:endParaRPr lang="en-US" sz="1125" dirty="0"/>
-          </a:p>
-        </p:txBody>
-      </p:sp>
-      <p:sp>
-        <p:nvSpPr>
-          <p:cNvPr id="8" name="Shape 6"/>
-          <p:cNvSpPr/>
-          <p:nvPr/>
-        </p:nvSpPr>
-        <p:spPr>
-          <a:xfrm>
-            <a:off x="609600" y="3487293"/>
-            <a:ext cx="10972800" cy="797814"/>
-          </a:xfrm>
-          <a:prstGeom prst="roundRect">
-            <a:avLst>
-              <a:gd name="adj" fmla="val 13754"/>
-            </a:avLst>
-          </a:prstGeom>
-          <a:solidFill>
-            <a:srgbClr val="FFFFFF"/>
-          </a:solidFill>
-          <a:ln w="9525">
-            <a:solidFill>
-              <a:srgbClr val="E2E8F0"/>
-            </a:solidFill>
-            <a:prstDash val="solid"/>
-          </a:ln>
-        </p:spPr>
-      </p:sp>
-      <p:sp>
-        <p:nvSpPr>
-          <p:cNvPr id="9" name="Text 7"/>
-          <p:cNvSpPr/>
-          <p:nvPr/>
-        </p:nvSpPr>
-        <p:spPr>
-          <a:xfrm>
-            <a:off x="847344" y="3487293"/>
-            <a:ext cx="502920" cy="797814"/>
-          </a:xfrm>
-          <a:prstGeom prst="rect">
-            <a:avLst/>
-          </a:prstGeom>
-          <a:noFill/>
-          <a:ln/>
-        </p:spPr>
-        <p:txBody>
-          <a:bodyPr wrap="square" lIns="0" tIns="0" rIns="0" bIns="0" rtlCol="0" anchor="ctr"/>
-          <a:lstStyle/>
-          <a:p>
-            <a:pPr algn="l" indent="0" marL="0">
-              <a:lnSpc>
-                <a:spcPct val="115000"/>
-              </a:lnSpc>
-              <a:buNone/>
-            </a:pPr>
-            <a:r>
-              <a:rPr lang="en-US" sz="1500" dirty="0">
-                <a:solidFill>
-                  <a:srgbClr val="0284C7"/>
-                </a:solidFill>
-                <a:latin typeface="Segoe UI Semibold" pitchFamily="34" charset="0"/>
-                <a:ea typeface="Segoe UI Semibold" pitchFamily="34" charset="-122"/>
-                <a:cs typeface="Segoe UI Semibold" pitchFamily="34" charset="-120"/>
-              </a:rPr>
-              <a:t>02</a:t>
-            </a:r>
-            <a:endParaRPr lang="en-US" sz="1500" dirty="0"/>
-          </a:p>
-        </p:txBody>
-      </p:sp>
-      <p:sp>
-        <p:nvSpPr>
-          <p:cNvPr id="10" name="Text 8"/>
-          <p:cNvSpPr/>
-          <p:nvPr/>
-        </p:nvSpPr>
-        <p:spPr>
-          <a:xfrm>
-            <a:off x="1341120" y="3670173"/>
-            <a:ext cx="10003536" cy="205740"/>
-          </a:xfrm>
-          <a:prstGeom prst="rect">
-            <a:avLst/>
-          </a:prstGeom>
-          <a:noFill/>
-          <a:ln/>
-        </p:spPr>
-        <p:txBody>
-          <a:bodyPr wrap="square" lIns="0" tIns="0" rIns="0" bIns="0" rtlCol="0" anchor="t"/>
-          <a:lstStyle/>
-          <a:p>
-            <a:pPr algn="l" indent="0" marL="0">
-              <a:lnSpc>
-                <a:spcPct val="110000"/>
-              </a:lnSpc>
-              <a:buNone/>
-            </a:pPr>
-            <a:r>
-              <a:rPr lang="en-US" sz="1350" b="1" dirty="0">
-                <a:solidFill>
-                  <a:srgbClr val="0F172A"/>
-                </a:solidFill>
-                <a:latin typeface="Segoe UI" pitchFamily="34" charset="0"/>
-                <a:ea typeface="Segoe UI" pitchFamily="34" charset="-122"/>
-                <a:cs typeface="Segoe UI" pitchFamily="34" charset="-120"/>
-              </a:rPr>
-              <a:t>Who creates the Change Request key?</a:t>
-            </a:r>
-            <a:endParaRPr lang="en-US" sz="1350" dirty="0"/>
-          </a:p>
-        </p:txBody>
-      </p:sp>
-      <p:sp>
-        <p:nvSpPr>
-          <p:cNvPr id="11" name="Text 9"/>
-          <p:cNvSpPr/>
-          <p:nvPr/>
-        </p:nvSpPr>
-        <p:spPr>
-          <a:xfrm>
-            <a:off x="1341120" y="3930777"/>
-            <a:ext cx="10003536" cy="171450"/>
-          </a:xfrm>
-          <a:prstGeom prst="rect">
-            <a:avLst/>
-          </a:prstGeom>
-          <a:noFill/>
-          <a:ln/>
-        </p:spPr>
-        <p:txBody>
-          <a:bodyPr wrap="square" lIns="0" tIns="0" rIns="0" bIns="0" rtlCol="0" anchor="t"/>
-          <a:lstStyle/>
-          <a:p>
-            <a:pPr algn="l" indent="0" marL="0">
-              <a:lnSpc>
-                <a:spcPct val="110000"/>
-              </a:lnSpc>
-              <a:buNone/>
-            </a:pPr>
-            <a:r>
-              <a:rPr lang="en-US" sz="1125" dirty="0">
-                <a:solidFill>
-                  <a:srgbClr val="64748B"/>
-                </a:solidFill>
-                <a:latin typeface="Segoe UI" pitchFamily="34" charset="0"/>
-                <a:ea typeface="Segoe UI" pitchFamily="34" charset="-122"/>
-                <a:cs typeface="Segoe UI" pitchFamily="34" charset="-120"/>
-              </a:rPr>
-              <a:t>SIT evidence has no ticket yet.</a:t>
-            </a:r>
-            <a:endParaRPr lang="en-US" sz="1125" dirty="0"/>
-          </a:p>
-        </p:txBody>
-      </p:sp>
-      <p:sp>
-        <p:nvSpPr>
-          <p:cNvPr id="12" name="Shape 10"/>
-          <p:cNvSpPr/>
-          <p:nvPr/>
-        </p:nvSpPr>
-        <p:spPr>
-          <a:xfrm>
-            <a:off x="609600" y="4413123"/>
-            <a:ext cx="10972800" cy="797814"/>
-          </a:xfrm>
-          <a:prstGeom prst="roundRect">
-            <a:avLst>
-              <a:gd name="adj" fmla="val 13754"/>
-            </a:avLst>
-          </a:prstGeom>
-          <a:solidFill>
-            <a:srgbClr val="FFFFFF"/>
-          </a:solidFill>
-          <a:ln w="9525">
-            <a:solidFill>
-              <a:srgbClr val="E2E8F0"/>
-            </a:solidFill>
-            <a:prstDash val="solid"/>
-          </a:ln>
-        </p:spPr>
-      </p:sp>
-      <p:sp>
-        <p:nvSpPr>
-          <p:cNvPr id="13" name="Text 11"/>
-          <p:cNvSpPr/>
-          <p:nvPr/>
-        </p:nvSpPr>
-        <p:spPr>
-          <a:xfrm>
-            <a:off x="847344" y="4413123"/>
-            <a:ext cx="502920" cy="797814"/>
-          </a:xfrm>
-          <a:prstGeom prst="rect">
-            <a:avLst/>
-          </a:prstGeom>
-          <a:noFill/>
-          <a:ln/>
-        </p:spPr>
-        <p:txBody>
-          <a:bodyPr wrap="square" lIns="0" tIns="0" rIns="0" bIns="0" rtlCol="0" anchor="ctr"/>
-          <a:lstStyle/>
-          <a:p>
-            <a:pPr algn="l" indent="0" marL="0">
-              <a:lnSpc>
-                <a:spcPct val="115000"/>
-              </a:lnSpc>
-              <a:buNone/>
-            </a:pPr>
-            <a:r>
-              <a:rPr lang="en-US" sz="1500" dirty="0">
-                <a:solidFill>
-                  <a:srgbClr val="0284C7"/>
-                </a:solidFill>
-                <a:latin typeface="Segoe UI Semibold" pitchFamily="34" charset="0"/>
-                <a:ea typeface="Segoe UI Semibold" pitchFamily="34" charset="-122"/>
-                <a:cs typeface="Segoe UI Semibold" pitchFamily="34" charset="-120"/>
-              </a:rPr>
-              <a:t>03</a:t>
-            </a:r>
-            <a:endParaRPr lang="en-US" sz="1500" dirty="0"/>
-          </a:p>
-        </p:txBody>
-      </p:sp>
-      <p:sp>
-        <p:nvSpPr>
-          <p:cNvPr id="14" name="Text 12"/>
-          <p:cNvSpPr/>
-          <p:nvPr/>
-        </p:nvSpPr>
-        <p:spPr>
-          <a:xfrm>
-            <a:off x="1341120" y="4596003"/>
-            <a:ext cx="10003536" cy="205740"/>
-          </a:xfrm>
-          <a:prstGeom prst="rect">
-            <a:avLst/>
-          </a:prstGeom>
-          <a:noFill/>
-          <a:ln/>
-        </p:spPr>
-        <p:txBody>
-          <a:bodyPr wrap="square" lIns="0" tIns="0" rIns="0" bIns="0" rtlCol="0" anchor="t"/>
-          <a:lstStyle/>
-          <a:p>
-            <a:pPr algn="l" indent="0" marL="0">
-              <a:lnSpc>
-                <a:spcPct val="110000"/>
-              </a:lnSpc>
-              <a:buNone/>
-            </a:pPr>
-            <a:r>
-              <a:rPr lang="en-US" sz="1350" b="1" dirty="0">
-                <a:solidFill>
-                  <a:srgbClr val="0F172A"/>
-                </a:solidFill>
-                <a:latin typeface="Segoe UI" pitchFamily="34" charset="0"/>
-                <a:ea typeface="Segoe UI" pitchFamily="34" charset="-122"/>
-                <a:cs typeface="Segoe UI" pitchFamily="34" charset="-120"/>
-              </a:rPr>
-              <a:t>Which 2027 promotion window do we file under?</a:t>
-            </a:r>
-            <a:endParaRPr lang="en-US" sz="1350" dirty="0"/>
-          </a:p>
-        </p:txBody>
-      </p:sp>
-      <p:sp>
-        <p:nvSpPr>
-          <p:cNvPr id="15" name="Text 13"/>
-          <p:cNvSpPr/>
-          <p:nvPr/>
-        </p:nvSpPr>
-        <p:spPr>
-          <a:xfrm>
-            <a:off x="1341120" y="4856607"/>
-            <a:ext cx="10003536" cy="171450"/>
-          </a:xfrm>
-          <a:prstGeom prst="rect">
-            <a:avLst/>
-          </a:prstGeom>
-          <a:noFill/>
-          <a:ln/>
-        </p:spPr>
-        <p:txBody>
-          <a:bodyPr wrap="square" lIns="0" tIns="0" rIns="0" bIns="0" rtlCol="0" anchor="t"/>
-          <a:lstStyle/>
-          <a:p>
-            <a:pPr algn="l" indent="0" marL="0">
-              <a:lnSpc>
-                <a:spcPct val="110000"/>
-              </a:lnSpc>
-              <a:buNone/>
-            </a:pPr>
-            <a:r>
-              <a:rPr lang="en-US" sz="1125" dirty="0">
-                <a:solidFill>
-                  <a:srgbClr val="64748B"/>
-                </a:solidFill>
-                <a:latin typeface="Segoe UI" pitchFamily="34" charset="0"/>
-                <a:ea typeface="Segoe UI" pitchFamily="34" charset="-122"/>
-                <a:cs typeface="Segoe UI" pitchFamily="34" charset="-120"/>
-              </a:rPr>
-              <a:t>Target 30 May 2027. June and July 2027 are past the published calendar.</a:t>
-            </a:r>
-            <a:endParaRPr lang="en-US" sz="1125" dirty="0"/>
-          </a:p>
-        </p:txBody>
-      </p:sp>
-    </p:spTree>
-  </p:cSld>
-  <p:clrMapOvr>
-    <a:masterClrMapping/>
-  </p:clrMapOvr>
-</p:sld>
-</file>
-
-<file path=ppt/slides/slide14.xml><?xml version="1.0" encoding="utf-8"?>
-<p:sld xmlns:a="http://schemas.openxmlformats.org/drawingml/2006/main" xmlns:r="http://schemas.openxmlformats.org/officeDocument/2006/relationships" xmlns:p="http://schemas.openxmlformats.org/presentationml/2006/main">
-  <p:cSld name="Slide 14">
-    <p:bg>
-      <p:bgPr>
-        <a:solidFill>
           <a:srgbClr val="090D16"/>
         </a:solidFill>
       </p:bgPr>
@@ -6097,616 +5350,6 @@
               <a:t>Q&amp;A</a:t>
             </a:r>
             <a:endParaRPr lang="en-US" sz="3300" dirty="0"/>
-          </a:p>
-        </p:txBody>
-      </p:sp>
-    </p:spTree>
-  </p:cSld>
-  <p:clrMapOvr>
-    <a:masterClrMapping/>
-  </p:clrMapOvr>
-</p:sld>
-</file>
-
-<file path=ppt/slides/slide15.xml><?xml version="1.0" encoding="utf-8"?>
-<p:sld xmlns:a="http://schemas.openxmlformats.org/drawingml/2006/main" xmlns:r="http://schemas.openxmlformats.org/officeDocument/2006/relationships" xmlns:p="http://schemas.openxmlformats.org/presentationml/2006/main">
-  <p:cSld name="Slide 15">
-    <p:bg>
-      <p:bgPr>
-        <a:solidFill>
-          <a:srgbClr val="090D16"/>
-        </a:solidFill>
-      </p:bgPr>
-    </p:bg>
-    <p:spTree>
-      <p:nvGrpSpPr>
-        <p:cNvPr id="1" name=""/>
-        <p:cNvGrpSpPr/>
-        <p:nvPr/>
-      </p:nvGrpSpPr>
-      <p:grpSpPr>
-        <a:xfrm>
-          <a:off x="0" y="0"/>
-          <a:ext cx="0" cy="0"/>
-          <a:chOff x="0" y="0"/>
-          <a:chExt cx="0" cy="0"/>
-        </a:xfrm>
-      </p:grpSpPr>
-      <p:sp>
-        <p:nvSpPr>
-          <p:cNvPr id="2" name="Shape 0"/>
-          <p:cNvSpPr/>
-          <p:nvPr/>
-        </p:nvSpPr>
-        <p:spPr>
-          <a:xfrm>
-            <a:off x="5867400" y="1523143"/>
-            <a:ext cx="457200" cy="457200"/>
-          </a:xfrm>
-          <a:prstGeom prst="ellipse">
-            <a:avLst/>
-          </a:prstGeom>
-          <a:solidFill>
-            <a:srgbClr val="082F49"/>
-          </a:solidFill>
-          <a:ln w="12700">
-            <a:solidFill>
-              <a:srgbClr val="082F49"/>
-            </a:solidFill>
-            <a:prstDash val="solid"/>
-          </a:ln>
-        </p:spPr>
-      </p:sp>
-      <p:pic>
-        <p:nvPicPr>
-          <p:cNvPr id="3" name="Image 0" descr="D:\Github\HA-Notes\LIS\skills\design-review-pptx\assets\icons\png\onDark\rocket.png">    </p:cNvPr>
-          <p:cNvPicPr>
-            <a:picLocks noChangeAspect="1"/>
-          </p:cNvPicPr>
-          <p:nvPr/>
-        </p:nvPicPr>
-        <p:blipFill>
-          <a:blip r:embed="rId1"/>
-          <a:stretch>
-            <a:fillRect/>
-          </a:stretch>
-        </p:blipFill>
-        <p:spPr>
-          <a:xfrm>
-            <a:off x="5981700" y="1637443"/>
-            <a:ext cx="228600" cy="228600"/>
-          </a:xfrm>
-          <a:prstGeom prst="rect">
-            <a:avLst/>
-          </a:prstGeom>
-        </p:spPr>
-      </p:pic>
-      <p:sp>
-        <p:nvSpPr>
-          <p:cNvPr id="4" name="Text 1"/>
-          <p:cNvSpPr/>
-          <p:nvPr/>
-        </p:nvSpPr>
-        <p:spPr>
-          <a:xfrm>
-            <a:off x="1752600" y="2172367"/>
-            <a:ext cx="8686800" cy="219456"/>
-          </a:xfrm>
-          <a:prstGeom prst="rect">
-            <a:avLst/>
-          </a:prstGeom>
-          <a:noFill/>
-          <a:ln/>
-        </p:spPr>
-        <p:txBody>
-          <a:bodyPr wrap="square" lIns="0" tIns="0" rIns="0" bIns="0" rtlCol="0" anchor="t"/>
-          <a:lstStyle/>
-          <a:p>
-            <a:pPr algn="ctr" indent="0" marL="0">
-              <a:lnSpc>
-                <a:spcPct val="115000"/>
-              </a:lnSpc>
-              <a:buNone/>
-            </a:pPr>
-            <a:r>
-              <a:rPr lang="en-US" sz="1050" spc="150" kern="0" dirty="0">
-                <a:solidFill>
-                  <a:srgbClr val="38BDF8"/>
-                </a:solidFill>
-                <a:latin typeface="Segoe UI Semibold" pitchFamily="34" charset="0"/>
-                <a:ea typeface="Segoe UI Semibold" pitchFamily="34" charset="-122"/>
-                <a:cs typeface="Segoe UI Semibold" pitchFamily="34" charset="-120"/>
-              </a:rPr>
-              <a:t>NEXT</a:t>
-            </a:r>
-            <a:endParaRPr lang="en-US" sz="1050" dirty="0"/>
-          </a:p>
-        </p:txBody>
-      </p:sp>
-      <p:sp>
-        <p:nvSpPr>
-          <p:cNvPr id="5" name="Text 2"/>
-          <p:cNvSpPr/>
-          <p:nvPr/>
-        </p:nvSpPr>
-        <p:spPr>
-          <a:xfrm>
-            <a:off x="1752600" y="2501551"/>
-            <a:ext cx="8686800" cy="481965"/>
-          </a:xfrm>
-          <a:prstGeom prst="rect">
-            <a:avLst/>
-          </a:prstGeom>
-          <a:noFill/>
-          <a:ln/>
-        </p:spPr>
-        <p:txBody>
-          <a:bodyPr wrap="square" lIns="0" tIns="0" rIns="0" bIns="0" rtlCol="0" anchor="t"/>
-          <a:lstStyle/>
-          <a:p>
-            <a:pPr algn="ctr" indent="0" marL="0">
-              <a:lnSpc>
-                <a:spcPct val="105000"/>
-              </a:lnSpc>
-              <a:buNone/>
-            </a:pPr>
-            <a:r>
-              <a:rPr lang="en-US" sz="3300" dirty="0">
-                <a:solidFill>
-                  <a:srgbClr val="FFFFFF"/>
-                </a:solidFill>
-                <a:latin typeface="Segoe UI Semibold" pitchFamily="34" charset="0"/>
-                <a:ea typeface="Segoe UI Semibold" pitchFamily="34" charset="-122"/>
-                <a:cs typeface="Segoe UI Semibold" pitchFamily="34" charset="-120"/>
-              </a:rPr>
-              <a:t>Target completion</a:t>
-            </a:r>
-            <a:endParaRPr lang="en-US" sz="3300" dirty="0"/>
-          </a:p>
-        </p:txBody>
-      </p:sp>
-      <p:sp>
-        <p:nvSpPr>
-          <p:cNvPr id="6" name="Text 3"/>
-          <p:cNvSpPr/>
-          <p:nvPr/>
-        </p:nvSpPr>
-        <p:spPr>
-          <a:xfrm>
-            <a:off x="1752600" y="3093244"/>
-            <a:ext cx="8686800" cy="619125"/>
-          </a:xfrm>
-          <a:prstGeom prst="rect">
-            <a:avLst/>
-          </a:prstGeom>
-          <a:noFill/>
-          <a:ln/>
-        </p:spPr>
-        <p:txBody>
-          <a:bodyPr wrap="square" lIns="0" tIns="0" rIns="0" bIns="0" rtlCol="0" anchor="ctr"/>
-          <a:lstStyle/>
-          <a:p>
-            <a:pPr algn="ctr" indent="0" marL="0">
-              <a:lnSpc>
-                <a:spcPct val="115000"/>
-              </a:lnSpc>
-              <a:buNone/>
-            </a:pPr>
-            <a:r>
-              <a:rPr lang="en-US" sz="3900" dirty="0">
-                <a:solidFill>
-                  <a:srgbClr val="38BDF8"/>
-                </a:solidFill>
-                <a:latin typeface="Segoe UI Semibold" pitchFamily="34" charset="0"/>
-                <a:ea typeface="Segoe UI Semibold" pitchFamily="34" charset="-122"/>
-                <a:cs typeface="Segoe UI Semibold" pitchFamily="34" charset="-120"/>
-              </a:rPr>
-              <a:t>30 MAY 2027</a:t>
-            </a:r>
-            <a:endParaRPr lang="en-US" sz="3900" dirty="0"/>
-          </a:p>
-        </p:txBody>
-      </p:sp>
-      <p:sp>
-        <p:nvSpPr>
-          <p:cNvPr id="7" name="Text 4"/>
-          <p:cNvSpPr/>
-          <p:nvPr/>
-        </p:nvSpPr>
-        <p:spPr>
-          <a:xfrm>
-            <a:off x="2406396" y="3867817"/>
-            <a:ext cx="7379208" cy="214313"/>
-          </a:xfrm>
-          <a:prstGeom prst="rect">
-            <a:avLst/>
-          </a:prstGeom>
-          <a:noFill/>
-          <a:ln/>
-        </p:spPr>
-        <p:txBody>
-          <a:bodyPr wrap="square" lIns="0" tIns="0" rIns="0" bIns="0" rtlCol="0" anchor="t"/>
-          <a:lstStyle/>
-          <a:p>
-            <a:pPr algn="ctr" indent="0" marL="0">
-              <a:lnSpc>
-                <a:spcPct val="120000"/>
-              </a:lnSpc>
-              <a:buNone/>
-            </a:pPr>
-            <a:r>
-              <a:rPr lang="en-US" sz="1350" dirty="0">
-                <a:solidFill>
-                  <a:srgbClr val="94A3B8"/>
-                </a:solidFill>
-                <a:latin typeface="Segoe UI" pitchFamily="34" charset="0"/>
-                <a:ea typeface="Segoe UI" pitchFamily="34" charset="-122"/>
-                <a:cs typeface="Segoe UI" pitchFamily="34" charset="-120"/>
-              </a:rPr>
-              <a:t>Development runs to 31 Dec 2026. Integration test starts January 2027.</a:t>
-            </a:r>
-            <a:endParaRPr lang="en-US" sz="1350" dirty="0"/>
-          </a:p>
-        </p:txBody>
-      </p:sp>
-      <p:sp>
-        <p:nvSpPr>
-          <p:cNvPr id="8" name="Text 5"/>
-          <p:cNvSpPr/>
-          <p:nvPr/>
-        </p:nvSpPr>
-        <p:spPr>
-          <a:xfrm>
-            <a:off x="838200" y="4466177"/>
-            <a:ext cx="3163824" cy="182880"/>
-          </a:xfrm>
-          <a:prstGeom prst="rect">
-            <a:avLst/>
-          </a:prstGeom>
-          <a:noFill/>
-          <a:ln/>
-        </p:spPr>
-        <p:txBody>
-          <a:bodyPr wrap="square" lIns="0" tIns="0" rIns="0" bIns="0" rtlCol="0" anchor="t"/>
-          <a:lstStyle/>
-          <a:p>
-            <a:pPr algn="l" indent="0" marL="0">
-              <a:lnSpc>
-                <a:spcPct val="115000"/>
-              </a:lnSpc>
-              <a:buNone/>
-            </a:pPr>
-            <a:r>
-              <a:rPr lang="en-US" sz="1050" dirty="0">
-                <a:solidFill>
-                  <a:srgbClr val="64748B"/>
-                </a:solidFill>
-                <a:latin typeface="Segoe UI" pitchFamily="34" charset="0"/>
-                <a:ea typeface="Segoe UI" pitchFamily="34" charset="-122"/>
-                <a:cs typeface="Segoe UI" pitchFamily="34" charset="-120"/>
-              </a:rPr>
-              <a:t>CHANGE REQUEST</a:t>
-            </a:r>
-            <a:endParaRPr lang="en-US" sz="1050" dirty="0"/>
-          </a:p>
-        </p:txBody>
-      </p:sp>
-      <p:sp>
-        <p:nvSpPr>
-          <p:cNvPr id="9" name="Text 6"/>
-          <p:cNvSpPr/>
-          <p:nvPr/>
-        </p:nvSpPr>
-        <p:spPr>
-          <a:xfrm>
-            <a:off x="838200" y="4685633"/>
-            <a:ext cx="3163824" cy="640080"/>
-          </a:xfrm>
-          <a:prstGeom prst="rect">
-            <a:avLst/>
-          </a:prstGeom>
-          <a:noFill/>
-          <a:ln/>
-        </p:spPr>
-        <p:txBody>
-          <a:bodyPr wrap="square" lIns="0" tIns="0" rIns="0" bIns="0" rtlCol="0" anchor="t"/>
-          <a:lstStyle/>
-          <a:p>
-            <a:pPr algn="l" indent="0" marL="0">
-              <a:lnSpc>
-                <a:spcPct val="115000"/>
-              </a:lnSpc>
-              <a:buNone/>
-            </a:pPr>
-            <a:r>
-              <a:rPr lang="en-US" sz="1200" dirty="0">
-                <a:solidFill>
-                  <a:srgbClr val="F1F5F9"/>
-                </a:solidFill>
-                <a:latin typeface="Segoe UI" pitchFamily="34" charset="0"/>
-                <a:ea typeface="Segoe UI" pitchFamily="34" charset="-122"/>
-                <a:cs typeface="Segoe UI" pitchFamily="34" charset="-120"/>
-              </a:rPr>
-              <a:t>Create the key by hand</a:t>
-            </a:r>
-            <a:endParaRPr lang="en-US" sz="1200" dirty="0"/>
-          </a:p>
-        </p:txBody>
-      </p:sp>
-      <p:sp>
-        <p:nvSpPr>
-          <p:cNvPr id="10" name="Shape 7"/>
-          <p:cNvSpPr/>
-          <p:nvPr/>
-        </p:nvSpPr>
-        <p:spPr>
-          <a:xfrm>
-            <a:off x="4258056" y="4466177"/>
-            <a:ext cx="10973" cy="566928"/>
-          </a:xfrm>
-          <a:prstGeom prst="rect">
-            <a:avLst/>
-          </a:prstGeom>
-          <a:solidFill>
-            <a:srgbClr val="1E293B"/>
-          </a:solidFill>
-          <a:ln w="12700">
-            <a:solidFill>
-              <a:srgbClr val="1E293B"/>
-            </a:solidFill>
-            <a:prstDash val="solid"/>
-          </a:ln>
-        </p:spPr>
-      </p:sp>
-      <p:sp>
-        <p:nvSpPr>
-          <p:cNvPr id="11" name="Text 8"/>
-          <p:cNvSpPr/>
-          <p:nvPr/>
-        </p:nvSpPr>
-        <p:spPr>
-          <a:xfrm>
-            <a:off x="4514088" y="4466177"/>
-            <a:ext cx="3163824" cy="182880"/>
-          </a:xfrm>
-          <a:prstGeom prst="rect">
-            <a:avLst/>
-          </a:prstGeom>
-          <a:noFill/>
-          <a:ln/>
-        </p:spPr>
-        <p:txBody>
-          <a:bodyPr wrap="square" lIns="0" tIns="0" rIns="0" bIns="0" rtlCol="0" anchor="t"/>
-          <a:lstStyle/>
-          <a:p>
-            <a:pPr algn="l" indent="0" marL="0">
-              <a:lnSpc>
-                <a:spcPct val="115000"/>
-              </a:lnSpc>
-              <a:buNone/>
-            </a:pPr>
-            <a:r>
-              <a:rPr lang="en-US" sz="1050" dirty="0">
-                <a:solidFill>
-                  <a:srgbClr val="64748B"/>
-                </a:solidFill>
-                <a:latin typeface="Segoe UI" pitchFamily="34" charset="0"/>
-                <a:ea typeface="Segoe UI" pitchFamily="34" charset="-122"/>
-                <a:cs typeface="Segoe UI" pitchFamily="34" charset="-120"/>
-              </a:rPr>
-              <a:t>WP1</a:t>
-            </a:r>
-            <a:endParaRPr lang="en-US" sz="1050" dirty="0"/>
-          </a:p>
-        </p:txBody>
-      </p:sp>
-      <p:sp>
-        <p:nvSpPr>
-          <p:cNvPr id="12" name="Text 9"/>
-          <p:cNvSpPr/>
-          <p:nvPr/>
-        </p:nvSpPr>
-        <p:spPr>
-          <a:xfrm>
-            <a:off x="4514088" y="4685633"/>
-            <a:ext cx="3163824" cy="640080"/>
-          </a:xfrm>
-          <a:prstGeom prst="rect">
-            <a:avLst/>
-          </a:prstGeom>
-          <a:noFill/>
-          <a:ln/>
-        </p:spPr>
-        <p:txBody>
-          <a:bodyPr wrap="square" lIns="0" tIns="0" rIns="0" bIns="0" rtlCol="0" anchor="t"/>
-          <a:lstStyle/>
-          <a:p>
-            <a:pPr algn="l" indent="0" marL="0">
-              <a:lnSpc>
-                <a:spcPct val="115000"/>
-              </a:lnSpc>
-              <a:buNone/>
-            </a:pPr>
-            <a:r>
-              <a:rPr lang="en-US" sz="1200" dirty="0">
-                <a:solidFill>
-                  <a:srgbClr val="F1F5F9"/>
-                </a:solidFill>
-                <a:latin typeface="Segoe UI" pitchFamily="34" charset="0"/>
-                <a:ea typeface="Segoe UI" pitchFamily="34" charset="-122"/>
-                <a:cs typeface="Segoe UI" pitchFamily="34" charset="-120"/>
-              </a:rPr>
-              <a:t>Close D13 in the retrieve</a:t>
-            </a:r>
-            <a:endParaRPr lang="en-US" sz="1200" dirty="0"/>
-          </a:p>
-        </p:txBody>
-      </p:sp>
-      <p:sp>
-        <p:nvSpPr>
-          <p:cNvPr id="13" name="Shape 10"/>
-          <p:cNvSpPr/>
-          <p:nvPr/>
-        </p:nvSpPr>
-        <p:spPr>
-          <a:xfrm>
-            <a:off x="7933944" y="4466177"/>
-            <a:ext cx="10973" cy="566928"/>
-          </a:xfrm>
-          <a:prstGeom prst="rect">
-            <a:avLst/>
-          </a:prstGeom>
-          <a:solidFill>
-            <a:srgbClr val="1E293B"/>
-          </a:solidFill>
-          <a:ln w="12700">
-            <a:solidFill>
-              <a:srgbClr val="1E293B"/>
-            </a:solidFill>
-            <a:prstDash val="solid"/>
-          </a:ln>
-        </p:spPr>
-      </p:sp>
-      <p:sp>
-        <p:nvSpPr>
-          <p:cNvPr id="14" name="Text 11"/>
-          <p:cNvSpPr/>
-          <p:nvPr/>
-        </p:nvSpPr>
-        <p:spPr>
-          <a:xfrm>
-            <a:off x="8189976" y="4466177"/>
-            <a:ext cx="3163824" cy="182880"/>
-          </a:xfrm>
-          <a:prstGeom prst="rect">
-            <a:avLst/>
-          </a:prstGeom>
-          <a:noFill/>
-          <a:ln/>
-        </p:spPr>
-        <p:txBody>
-          <a:bodyPr wrap="square" lIns="0" tIns="0" rIns="0" bIns="0" rtlCol="0" anchor="t"/>
-          <a:lstStyle/>
-          <a:p>
-            <a:pPr algn="l" indent="0" marL="0">
-              <a:lnSpc>
-                <a:spcPct val="115000"/>
-              </a:lnSpc>
-              <a:buNone/>
-            </a:pPr>
-            <a:r>
-              <a:rPr lang="en-US" sz="1050" dirty="0">
-                <a:solidFill>
-                  <a:srgbClr val="64748B"/>
-                </a:solidFill>
-                <a:latin typeface="Segoe UI" pitchFamily="34" charset="0"/>
-                <a:ea typeface="Segoe UI" pitchFamily="34" charset="-122"/>
-                <a:cs typeface="Segoe UI" pitchFamily="34" charset="-120"/>
-              </a:rPr>
-              <a:t>SIT SEED</a:t>
-            </a:r>
-            <a:endParaRPr lang="en-US" sz="1050" dirty="0"/>
-          </a:p>
-        </p:txBody>
-      </p:sp>
-      <p:sp>
-        <p:nvSpPr>
-          <p:cNvPr id="15" name="Text 12"/>
-          <p:cNvSpPr/>
-          <p:nvPr/>
-        </p:nvSpPr>
-        <p:spPr>
-          <a:xfrm>
-            <a:off x="8189976" y="4685633"/>
-            <a:ext cx="3163824" cy="640080"/>
-          </a:xfrm>
-          <a:prstGeom prst="rect">
-            <a:avLst/>
-          </a:prstGeom>
-          <a:noFill/>
-          <a:ln/>
-        </p:spPr>
-        <p:txBody>
-          <a:bodyPr wrap="square" lIns="0" tIns="0" rIns="0" bIns="0" rtlCol="0" anchor="t"/>
-          <a:lstStyle/>
-          <a:p>
-            <a:pPr algn="l" indent="0" marL="0">
-              <a:lnSpc>
-                <a:spcPct val="115000"/>
-              </a:lnSpc>
-              <a:buNone/>
-            </a:pPr>
-            <a:r>
-              <a:rPr lang="en-US" sz="1200" dirty="0">
-                <a:solidFill>
-                  <a:srgbClr val="F1F5F9"/>
-                </a:solidFill>
-                <a:latin typeface="Segoe UI" pitchFamily="34" charset="0"/>
-                <a:ea typeface="Segoe UI" pitchFamily="34" charset="-122"/>
-                <a:cs typeface="Segoe UI" pitchFamily="34" charset="-120"/>
-              </a:rPr>
-              <a:t>Sorter user, workbench, map row</a:t>
-            </a:r>
-            <a:endParaRPr lang="en-US" sz="1200" dirty="0"/>
-          </a:p>
-        </p:txBody>
-      </p:sp>
-      <p:sp>
-        <p:nvSpPr>
-          <p:cNvPr id="16" name="Text 13"/>
-          <p:cNvSpPr/>
-          <p:nvPr/>
-        </p:nvSpPr>
-        <p:spPr>
-          <a:xfrm>
-            <a:off x="758952" y="6089904"/>
-            <a:ext cx="10674096" cy="237744"/>
-          </a:xfrm>
-          <a:prstGeom prst="rect">
-            <a:avLst/>
-          </a:prstGeom>
-          <a:noFill/>
-          <a:ln/>
-        </p:spPr>
-        <p:txBody>
-          <a:bodyPr wrap="square" lIns="0" tIns="0" rIns="0" bIns="0" rtlCol="0" anchor="t"/>
-          <a:lstStyle/>
-          <a:p>
-            <a:pPr algn="ctr" indent="0" marL="0">
-              <a:lnSpc>
-                <a:spcPct val="120000"/>
-              </a:lnSpc>
-              <a:buNone/>
-            </a:pPr>
-            <a:r>
-              <a:rPr lang="en-US" sz="1125" dirty="0">
-                <a:solidFill>
-                  <a:srgbClr val="38BDF8"/>
-                </a:solidFill>
-                <a:latin typeface="Consolas" pitchFamily="34" charset="0"/>
-                <a:ea typeface="Consolas" pitchFamily="34" charset="-122"/>
-                <a:cs typeface="Consolas" pitchFamily="34" charset="-120"/>
-              </a:rPr>
-              <a:t>TMP-000   </a:t>
-            </a:r>
-            <a:pPr algn="ctr" indent="0" marL="0">
-              <a:lnSpc>
-                <a:spcPct val="120000"/>
-              </a:lnSpc>
-              <a:buNone/>
-            </a:pPr>
-            <a:r>
-              <a:rPr lang="en-US" sz="1125" dirty="0">
-                <a:solidFill>
-                  <a:srgbClr val="64748B"/>
-                </a:solidFill>
-                <a:latin typeface="Segoe UI" pitchFamily="34" charset="0"/>
-                <a:ea typeface="Segoe UI" pitchFamily="34" charset="-122"/>
-                <a:cs typeface="Segoe UI" pitchFamily="34" charset="-120"/>
-              </a:rPr>
-              <a:t>lis-crs-spec-ack-svc  ·  Specimen Sorter API  ·  ref SEM20260612</a:t>
-            </a:r>
-            <a:endParaRPr lang="en-US" sz="1125" dirty="0"/>
           </a:p>
         </p:txBody>
       </p:sp>
@@ -6828,12 +5471,12 @@
         </p:nvSpPr>
         <p:spPr>
           <a:xfrm>
-            <a:off x="609600" y="1371600"/>
-            <a:ext cx="10972800" cy="716280"/>
+            <a:off x="609600" y="1581912"/>
+            <a:ext cx="10972800" cy="804672"/>
           </a:xfrm>
           <a:prstGeom prst="roundRect">
             <a:avLst>
-              <a:gd name="adj" fmla="val 15319"/>
+              <a:gd name="adj" fmla="val 13636"/>
             </a:avLst>
           </a:prstGeom>
           <a:solidFill>
@@ -6855,8 +5498,8 @@
         </p:nvSpPr>
         <p:spPr>
           <a:xfrm>
-            <a:off x="847344" y="1371600"/>
-            <a:ext cx="502920" cy="716280"/>
+            <a:off x="847344" y="1581912"/>
+            <a:ext cx="502920" cy="804672"/>
           </a:xfrm>
           <a:prstGeom prst="rect">
             <a:avLst/>
@@ -6897,7 +5540,7 @@
         </p:nvSpPr>
         <p:spPr>
           <a:xfrm>
-            <a:off x="1341120" y="1473708"/>
+            <a:off x="1341120" y="1728216"/>
             <a:ext cx="10003536" cy="246888"/>
           </a:xfrm>
           <a:prstGeom prst="rect">
@@ -6939,7 +5582,7 @@
         </p:nvSpPr>
         <p:spPr>
           <a:xfrm>
-            <a:off x="1341120" y="1738884"/>
+            <a:off x="1341120" y="1993392"/>
             <a:ext cx="10003536" cy="219456"/>
           </a:xfrm>
           <a:prstGeom prst="rect">
@@ -6981,12 +5624,12 @@
         </p:nvSpPr>
         <p:spPr>
           <a:xfrm>
-            <a:off x="609600" y="2234184"/>
-            <a:ext cx="10972800" cy="716280"/>
+            <a:off x="609600" y="2532888"/>
+            <a:ext cx="10972800" cy="804672"/>
           </a:xfrm>
           <a:prstGeom prst="roundRect">
             <a:avLst>
-              <a:gd name="adj" fmla="val 15319"/>
+              <a:gd name="adj" fmla="val 13636"/>
             </a:avLst>
           </a:prstGeom>
           <a:solidFill>
@@ -7008,8 +5651,8 @@
         </p:nvSpPr>
         <p:spPr>
           <a:xfrm>
-            <a:off x="847344" y="2234184"/>
-            <a:ext cx="502920" cy="716280"/>
+            <a:off x="847344" y="2532888"/>
+            <a:ext cx="502920" cy="804672"/>
           </a:xfrm>
           <a:prstGeom prst="rect">
             <a:avLst/>
@@ -7050,7 +5693,7 @@
         </p:nvSpPr>
         <p:spPr>
           <a:xfrm>
-            <a:off x="1341120" y="2336292"/>
+            <a:off x="1341120" y="2679192"/>
             <a:ext cx="10003536" cy="246888"/>
           </a:xfrm>
           <a:prstGeom prst="rect">
@@ -7092,7 +5735,7 @@
         </p:nvSpPr>
         <p:spPr>
           <a:xfrm>
-            <a:off x="1341120" y="2601468"/>
+            <a:off x="1341120" y="2944368"/>
             <a:ext cx="10003536" cy="219456"/>
           </a:xfrm>
           <a:prstGeom prst="rect">
@@ -7134,12 +5777,12 @@
         </p:nvSpPr>
         <p:spPr>
           <a:xfrm>
-            <a:off x="609600" y="3096768"/>
-            <a:ext cx="10972800" cy="716280"/>
+            <a:off x="609600" y="3483864"/>
+            <a:ext cx="10972800" cy="804672"/>
           </a:xfrm>
           <a:prstGeom prst="roundRect">
             <a:avLst>
-              <a:gd name="adj" fmla="val 15319"/>
+              <a:gd name="adj" fmla="val 13636"/>
             </a:avLst>
           </a:prstGeom>
           <a:solidFill>
@@ -7161,8 +5804,8 @@
         </p:nvSpPr>
         <p:spPr>
           <a:xfrm>
-            <a:off x="847344" y="3096768"/>
-            <a:ext cx="502920" cy="716280"/>
+            <a:off x="847344" y="3483864"/>
+            <a:ext cx="502920" cy="804672"/>
           </a:xfrm>
           <a:prstGeom prst="rect">
             <a:avLst/>
@@ -7203,7 +5846,7 @@
         </p:nvSpPr>
         <p:spPr>
           <a:xfrm>
-            <a:off x="1341120" y="3198876"/>
+            <a:off x="1341120" y="3630168"/>
             <a:ext cx="10003536" cy="246888"/>
           </a:xfrm>
           <a:prstGeom prst="rect">
@@ -7245,7 +5888,7 @@
         </p:nvSpPr>
         <p:spPr>
           <a:xfrm>
-            <a:off x="1341120" y="3464052"/>
+            <a:off x="1341120" y="3895344"/>
             <a:ext cx="10003536" cy="219456"/>
           </a:xfrm>
           <a:prstGeom prst="rect">
@@ -7287,12 +5930,12 @@
         </p:nvSpPr>
         <p:spPr>
           <a:xfrm>
-            <a:off x="609600" y="3959352"/>
-            <a:ext cx="10972800" cy="716280"/>
+            <a:off x="609600" y="4434840"/>
+            <a:ext cx="10972800" cy="804672"/>
           </a:xfrm>
           <a:prstGeom prst="roundRect">
             <a:avLst>
-              <a:gd name="adj" fmla="val 15319"/>
+              <a:gd name="adj" fmla="val 13636"/>
             </a:avLst>
           </a:prstGeom>
           <a:solidFill>
@@ -7314,8 +5957,8 @@
         </p:nvSpPr>
         <p:spPr>
           <a:xfrm>
-            <a:off x="847344" y="3959352"/>
-            <a:ext cx="502920" cy="716280"/>
+            <a:off x="847344" y="4434840"/>
+            <a:ext cx="502920" cy="804672"/>
           </a:xfrm>
           <a:prstGeom prst="rect">
             <a:avLst/>
@@ -7356,7 +5999,7 @@
         </p:nvSpPr>
         <p:spPr>
           <a:xfrm>
-            <a:off x="1341120" y="4061460"/>
+            <a:off x="1341120" y="4581144"/>
             <a:ext cx="10003536" cy="246888"/>
           </a:xfrm>
           <a:prstGeom prst="rect">
@@ -7398,7 +6041,7 @@
         </p:nvSpPr>
         <p:spPr>
           <a:xfrm>
-            <a:off x="1341120" y="4326636"/>
+            <a:off x="1341120" y="4846320"/>
             <a:ext cx="10003536" cy="219456"/>
           </a:xfrm>
           <a:prstGeom prst="rect">
@@ -7440,12 +6083,12 @@
         </p:nvSpPr>
         <p:spPr>
           <a:xfrm>
-            <a:off x="609600" y="4821936"/>
-            <a:ext cx="10972800" cy="716280"/>
+            <a:off x="609600" y="5385816"/>
+            <a:ext cx="10972800" cy="804672"/>
           </a:xfrm>
           <a:prstGeom prst="roundRect">
             <a:avLst>
-              <a:gd name="adj" fmla="val 15319"/>
+              <a:gd name="adj" fmla="val 13636"/>
             </a:avLst>
           </a:prstGeom>
           <a:solidFill>
@@ -7467,8 +6110,8 @@
         </p:nvSpPr>
         <p:spPr>
           <a:xfrm>
-            <a:off x="847344" y="4821936"/>
-            <a:ext cx="502920" cy="716280"/>
+            <a:off x="847344" y="5385816"/>
+            <a:ext cx="502920" cy="804672"/>
           </a:xfrm>
           <a:prstGeom prst="rect">
             <a:avLst/>
@@ -7509,7 +6152,7 @@
         </p:nvSpPr>
         <p:spPr>
           <a:xfrm>
-            <a:off x="1341120" y="4924044"/>
+            <a:off x="1341120" y="5532120"/>
             <a:ext cx="10003536" cy="246888"/>
           </a:xfrm>
           <a:prstGeom prst="rect">
@@ -7551,7 +6194,7 @@
         </p:nvSpPr>
         <p:spPr>
           <a:xfrm>
-            <a:off x="1341120" y="5189220"/>
+            <a:off x="1341120" y="5797296"/>
             <a:ext cx="10003536" cy="219456"/>
           </a:xfrm>
           <a:prstGeom prst="rect">
@@ -7580,159 +6223,6 @@
                 <a:cs typeface="Segoe UI" pitchFamily="34" charset="-120"/>
               </a:rPr>
               <a:t>Seed, deploy, pilot, roll back</a:t>
-            </a:r>
-            <a:endParaRPr lang="en-US" sz="1125" dirty="0"/>
-          </a:p>
-        </p:txBody>
-      </p:sp>
-      <p:sp>
-        <p:nvSpPr>
-          <p:cNvPr id="24" name="Shape 22"/>
-          <p:cNvSpPr/>
-          <p:nvPr/>
-        </p:nvSpPr>
-        <p:spPr>
-          <a:xfrm>
-            <a:off x="609600" y="5684520"/>
-            <a:ext cx="10972800" cy="716280"/>
-          </a:xfrm>
-          <a:prstGeom prst="roundRect">
-            <a:avLst>
-              <a:gd name="adj" fmla="val 15319"/>
-            </a:avLst>
-          </a:prstGeom>
-          <a:solidFill>
-            <a:srgbClr val="FFFFFF"/>
-          </a:solidFill>
-          <a:ln w="9525">
-            <a:solidFill>
-              <a:srgbClr val="E2E8F0"/>
-            </a:solidFill>
-            <a:prstDash val="solid"/>
-          </a:ln>
-        </p:spPr>
-      </p:sp>
-      <p:sp>
-        <p:nvSpPr>
-          <p:cNvPr id="25" name="Text 23"/>
-          <p:cNvSpPr/>
-          <p:nvPr/>
-        </p:nvSpPr>
-        <p:spPr>
-          <a:xfrm>
-            <a:off x="847344" y="5684520"/>
-            <a:ext cx="502920" cy="716280"/>
-          </a:xfrm>
-          <a:prstGeom prst="rect">
-            <a:avLst/>
-          </a:prstGeom>
-          <a:noFill/>
-          <a:ln/>
-        </p:spPr>
-        <p:txBody>
-          <a:bodyPr wrap="square" lIns="0" tIns="0" rIns="0" bIns="0" rtlCol="0" anchor="ctr"/>
-          <a:lstStyle/>
-          <a:p>
-            <a:pPr algn="l" indent="0" marL="0">
-              <a:lnSpc>
-                <a:spcPct val="115000"/>
-              </a:lnSpc>
-              <a:buNone/>
-            </a:pPr>
-            <a:r>
-              <a:rPr lang="en-US" sz="1500" dirty="0">
-                <a:solidFill>
-                  <a:srgbClr val="0284C7"/>
-                </a:solidFill>
-                <a:latin typeface="Segoe UI Semibold" pitchFamily="34" charset="0"/>
-                <a:ea typeface="Segoe UI Semibold" pitchFamily="34" charset="-122"/>
-                <a:cs typeface="Segoe UI Semibold" pitchFamily="34" charset="-120"/>
-              </a:rPr>
-              <a:t>06</a:t>
-            </a:r>
-            <a:endParaRPr lang="en-US" sz="1500" dirty="0"/>
-          </a:p>
-        </p:txBody>
-      </p:sp>
-      <p:sp>
-        <p:nvSpPr>
-          <p:cNvPr id="26" name="Text 24"/>
-          <p:cNvSpPr/>
-          <p:nvPr/>
-        </p:nvSpPr>
-        <p:spPr>
-          <a:xfrm>
-            <a:off x="1341120" y="5786628"/>
-            <a:ext cx="10003536" cy="246888"/>
-          </a:xfrm>
-          <a:prstGeom prst="rect">
-            <a:avLst/>
-          </a:prstGeom>
-          <a:noFill/>
-          <a:ln/>
-        </p:spPr>
-        <p:txBody>
-          <a:bodyPr wrap="square" lIns="0" tIns="0" rIns="0" bIns="0" rtlCol="0" anchor="ctr"/>
-          <a:lstStyle/>
-          <a:p>
-            <a:pPr algn="l" indent="0" marL="0">
-              <a:lnSpc>
-                <a:spcPct val="115000"/>
-              </a:lnSpc>
-              <a:buNone/>
-            </a:pPr>
-            <a:r>
-              <a:rPr lang="en-US" sz="1350" b="1" dirty="0">
-                <a:solidFill>
-                  <a:srgbClr val="0F172A"/>
-                </a:solidFill>
-                <a:latin typeface="Segoe UI" pitchFamily="34" charset="0"/>
-                <a:ea typeface="Segoe UI" pitchFamily="34" charset="-122"/>
-                <a:cs typeface="Segoe UI" pitchFamily="34" charset="-120"/>
-              </a:rPr>
-              <a:t>Open questions</a:t>
-            </a:r>
-            <a:endParaRPr lang="en-US" sz="1350" dirty="0"/>
-          </a:p>
-        </p:txBody>
-      </p:sp>
-      <p:sp>
-        <p:nvSpPr>
-          <p:cNvPr id="27" name="Text 25"/>
-          <p:cNvSpPr/>
-          <p:nvPr/>
-        </p:nvSpPr>
-        <p:spPr>
-          <a:xfrm>
-            <a:off x="1341120" y="6051804"/>
-            <a:ext cx="10003536" cy="219456"/>
-          </a:xfrm>
-          <a:prstGeom prst="rect">
-            <a:avLst/>
-          </a:prstGeom>
-          <a:noFill/>
-          <a:ln/>
-        </p:spPr>
-        <p:txBody>
-          <a:bodyPr wrap="square" lIns="0" tIns="0" rIns="0" bIns="0" rtlCol="0" anchor="ctr"/>
-          <a:lstStyle/>
-          <a:p>
-            <a:pPr algn="l" indent="0" marL="0">
-              <a:lnSpc>
-                <a:spcPct val="115000"/>
-              </a:lnSpc>
-              <a:buNone/>
-            </a:pPr>
-            <a:r>
-              <a:rPr lang="en-US" sz="1125" dirty="0">
-                <a:solidFill>
-                  <a:srgbClr val="64748B"/>
-                </a:solidFill>
-                <a:latin typeface="Segoe UI" pitchFamily="34" charset="0"/>
-                <a:ea typeface="Segoe UI" pitchFamily="34" charset="-122"/>
-                <a:cs typeface="Segoe UI" pitchFamily="34" charset="-120"/>
-              </a:rPr>
-              <a:t>What to settle before SIT</a:t>
             </a:r>
             <a:endParaRPr lang="en-US" sz="1125" dirty="0"/>
           </a:p>
@@ -8892,7 +7382,7 @@
                           <a:ea typeface="Consolas" pitchFamily="34" charset="-122"/>
                           <a:cs typeface="Consolas" pitchFamily="34" charset="-120"/>
                         </a:rPr>
-                        <a:t>retrieveGcrOrder (GET hard-codes ltc611)</a:t>
+                        <a:t>retrieveGcrOrder</a:t>
                       </a:r>
                       <a:endParaRPr lang="en-US" sz="1125" dirty="0">
                         <a:latin typeface="Consolas" charset="0"/>

</xml_diff>

<commit_message>
vault backup: 2026-09-21 16:57:57
</commit_message>
<xml_diff>
--- a/SDLC/Projects/TMP-specimen-sorter-api — Specimen Sorter API/assets/Specimen Sorter API v3.pptx
+++ b/SDLC/Projects/TMP-specimen-sorter-api — Specimen Sorter API/assets/Specimen Sorter API v3.pptx
@@ -5540,8 +5540,8 @@
         </p:nvSpPr>
         <p:spPr>
           <a:xfrm>
-            <a:off x="1341120" y="1728216"/>
-            <a:ext cx="10003536" cy="246888"/>
+            <a:off x="1341120" y="1581912"/>
+            <a:ext cx="10003536" cy="804672"/>
           </a:xfrm>
           <a:prstGeom prst="rect">
             <a:avLst/>
@@ -5576,49 +5576,7 @@
       </p:sp>
       <p:sp>
         <p:nvSpPr>
-          <p:cNvPr id="7" name="Text 5"/>
-          <p:cNvSpPr/>
-          <p:nvPr/>
-        </p:nvSpPr>
-        <p:spPr>
-          <a:xfrm>
-            <a:off x="1341120" y="1993392"/>
-            <a:ext cx="10003536" cy="219456"/>
-          </a:xfrm>
-          <a:prstGeom prst="rect">
-            <a:avLst/>
-          </a:prstGeom>
-          <a:noFill/>
-          <a:ln/>
-        </p:spPr>
-        <p:txBody>
-          <a:bodyPr wrap="square" lIns="0" tIns="0" rIns="0" bIns="0" rtlCol="0" anchor="ctr"/>
-          <a:lstStyle/>
-          <a:p>
-            <a:pPr algn="l" indent="0" marL="0">
-              <a:lnSpc>
-                <a:spcPct val="115000"/>
-              </a:lnSpc>
-              <a:buNone/>
-            </a:pPr>
-            <a:r>
-              <a:rPr lang="en-US" sz="1125" dirty="0">
-                <a:solidFill>
-                  <a:srgbClr val="64748B"/>
-                </a:solidFill>
-                <a:latin typeface="Segoe UI" pitchFamily="34" charset="0"/>
-                <a:ea typeface="Segoe UI" pitchFamily="34" charset="-122"/>
-                <a:cs typeface="Segoe UI" pitchFamily="34" charset="-120"/>
-              </a:rPr>
-              <a:t>Staff clicks today, sorter calls tomorrow</a:t>
-            </a:r>
-            <a:endParaRPr lang="en-US" sz="1125" dirty="0"/>
-          </a:p>
-        </p:txBody>
-      </p:sp>
-      <p:sp>
-        <p:nvSpPr>
-          <p:cNvPr id="8" name="Shape 6"/>
+          <p:cNvPr id="7" name="Shape 5"/>
           <p:cNvSpPr/>
           <p:nvPr/>
         </p:nvSpPr>
@@ -5645,7 +5603,7 @@
       </p:sp>
       <p:sp>
         <p:nvSpPr>
-          <p:cNvPr id="9" name="Text 7"/>
+          <p:cNvPr id="8" name="Text 6"/>
           <p:cNvSpPr/>
           <p:nvPr/>
         </p:nvSpPr>
@@ -5687,14 +5645,14 @@
       </p:sp>
       <p:sp>
         <p:nvSpPr>
-          <p:cNvPr id="10" name="Text 8"/>
-          <p:cNvSpPr/>
-          <p:nvPr/>
-        </p:nvSpPr>
-        <p:spPr>
-          <a:xfrm>
-            <a:off x="1341120" y="2679192"/>
-            <a:ext cx="10003536" cy="246888"/>
+          <p:cNvPr id="9" name="Text 7"/>
+          <p:cNvSpPr/>
+          <p:nvPr/>
+        </p:nvSpPr>
+        <p:spPr>
+          <a:xfrm>
+            <a:off x="1341120" y="2532888"/>
+            <a:ext cx="10003536" cy="804672"/>
           </a:xfrm>
           <a:prstGeom prst="rect">
             <a:avLst/>
@@ -5729,49 +5687,7 @@
       </p:sp>
       <p:sp>
         <p:nvSpPr>
-          <p:cNvPr id="11" name="Text 9"/>
-          <p:cNvSpPr/>
-          <p:nvPr/>
-        </p:nvSpPr>
-        <p:spPr>
-          <a:xfrm>
-            <a:off x="1341120" y="2944368"/>
-            <a:ext cx="10003536" cy="219456"/>
-          </a:xfrm>
-          <a:prstGeom prst="rect">
-            <a:avLst/>
-          </a:prstGeom>
-          <a:noFill/>
-          <a:ln/>
-        </p:spPr>
-        <p:txBody>
-          <a:bodyPr wrap="square" lIns="0" tIns="0" rIns="0" bIns="0" rtlCol="0" anchor="ctr"/>
-          <a:lstStyle/>
-          <a:p>
-            <a:pPr algn="l" indent="0" marL="0">
-              <a:lnSpc>
-                <a:spcPct val="115000"/>
-              </a:lnSpc>
-              <a:buNone/>
-            </a:pPr>
-            <a:r>
-              <a:rPr lang="en-US" sz="1125" dirty="0">
-                <a:solidFill>
-                  <a:srgbClr val="64748B"/>
-                </a:solidFill>
-                <a:latin typeface="Segoe UI" pitchFamily="34" charset="0"/>
-                <a:ea typeface="Segoe UI" pitchFamily="34" charset="-122"/>
-                <a:cs typeface="Segoe UI" pitchFamily="34" charset="-120"/>
-              </a:rPr>
-              <a:t>What the Spec Ack screen owns</a:t>
-            </a:r>
-            <a:endParaRPr lang="en-US" sz="1125" dirty="0"/>
-          </a:p>
-        </p:txBody>
-      </p:sp>
-      <p:sp>
-        <p:nvSpPr>
-          <p:cNvPr id="12" name="Shape 10"/>
+          <p:cNvPr id="10" name="Shape 8"/>
           <p:cNvSpPr/>
           <p:nvPr/>
         </p:nvSpPr>
@@ -5798,7 +5714,7 @@
       </p:sp>
       <p:sp>
         <p:nvSpPr>
-          <p:cNvPr id="13" name="Text 11"/>
+          <p:cNvPr id="11" name="Text 9"/>
           <p:cNvSpPr/>
           <p:nvPr/>
         </p:nvSpPr>
@@ -5840,14 +5756,14 @@
       </p:sp>
       <p:sp>
         <p:nvSpPr>
-          <p:cNvPr id="14" name="Text 12"/>
-          <p:cNvSpPr/>
-          <p:nvPr/>
-        </p:nvSpPr>
-        <p:spPr>
-          <a:xfrm>
-            <a:off x="1341120" y="3630168"/>
-            <a:ext cx="10003536" cy="246888"/>
+          <p:cNvPr id="12" name="Text 10"/>
+          <p:cNvSpPr/>
+          <p:nvPr/>
+        </p:nvSpPr>
+        <p:spPr>
+          <a:xfrm>
+            <a:off x="1341120" y="3483864"/>
+            <a:ext cx="10003536" cy="804672"/>
           </a:xfrm>
           <a:prstGeom prst="rect">
             <a:avLst/>
@@ -5882,49 +5798,7 @@
       </p:sp>
       <p:sp>
         <p:nvSpPr>
-          <p:cNvPr id="15" name="Text 13"/>
-          <p:cNvSpPr/>
-          <p:nvPr/>
-        </p:nvSpPr>
-        <p:spPr>
-          <a:xfrm>
-            <a:off x="1341120" y="3895344"/>
-            <a:ext cx="10003536" cy="219456"/>
-          </a:xfrm>
-          <a:prstGeom prst="rect">
-            <a:avLst/>
-          </a:prstGeom>
-          <a:noFill/>
-          <a:ln/>
-        </p:spPr>
-        <p:txBody>
-          <a:bodyPr wrap="square" lIns="0" tIns="0" rIns="0" bIns="0" rtlCol="0" anchor="ctr"/>
-          <a:lstStyle/>
-          <a:p>
-            <a:pPr algn="l" indent="0" marL="0">
-              <a:lnSpc>
-                <a:spcPct val="115000"/>
-              </a:lnSpc>
-              <a:buNone/>
-            </a:pPr>
-            <a:r>
-              <a:rPr lang="en-US" sz="1125" dirty="0">
-                <a:solidFill>
-                  <a:srgbClr val="64748B"/>
-                </a:solidFill>
-                <a:latin typeface="Segoe UI" pitchFamily="34" charset="0"/>
-                <a:ea typeface="Segoe UI" pitchFamily="34" charset="-122"/>
-                <a:cs typeface="Segoe UI" pitchFamily="34" charset="-120"/>
-              </a:rPr>
-              <a:t>One POST, four outcomes</a:t>
-            </a:r>
-            <a:endParaRPr lang="en-US" sz="1125" dirty="0"/>
-          </a:p>
-        </p:txBody>
-      </p:sp>
-      <p:sp>
-        <p:nvSpPr>
-          <p:cNvPr id="16" name="Shape 14"/>
+          <p:cNvPr id="13" name="Shape 11"/>
           <p:cNvSpPr/>
           <p:nvPr/>
         </p:nvSpPr>
@@ -5951,7 +5825,7 @@
       </p:sp>
       <p:sp>
         <p:nvSpPr>
-          <p:cNvPr id="17" name="Text 15"/>
+          <p:cNvPr id="14" name="Text 12"/>
           <p:cNvSpPr/>
           <p:nvPr/>
         </p:nvSpPr>
@@ -5993,14 +5867,14 @@
       </p:sp>
       <p:sp>
         <p:nvSpPr>
-          <p:cNvPr id="18" name="Text 16"/>
-          <p:cNvSpPr/>
-          <p:nvPr/>
-        </p:nvSpPr>
-        <p:spPr>
-          <a:xfrm>
-            <a:off x="1341120" y="4581144"/>
-            <a:ext cx="10003536" cy="246888"/>
+          <p:cNvPr id="15" name="Text 13"/>
+          <p:cNvSpPr/>
+          <p:nvPr/>
+        </p:nvSpPr>
+        <p:spPr>
+          <a:xfrm>
+            <a:off x="1341120" y="4434840"/>
+            <a:ext cx="10003536" cy="804672"/>
           </a:xfrm>
           <a:prstGeom prst="rect">
             <a:avLst/>
@@ -6035,49 +5909,7 @@
       </p:sp>
       <p:sp>
         <p:nvSpPr>
-          <p:cNvPr id="19" name="Text 17"/>
-          <p:cNvSpPr/>
-          <p:nvPr/>
-        </p:nvSpPr>
-        <p:spPr>
-          <a:xfrm>
-            <a:off x="1341120" y="4846320"/>
-            <a:ext cx="10003536" cy="219456"/>
-          </a:xfrm>
-          <a:prstGeom prst="rect">
-            <a:avLst/>
-          </a:prstGeom>
-          <a:noFill/>
-          <a:ln/>
-        </p:spPr>
-        <p:txBody>
-          <a:bodyPr wrap="square" lIns="0" tIns="0" rIns="0" bIns="0" rtlCol="0" anchor="ctr"/>
-          <a:lstStyle/>
-          <a:p>
-            <a:pPr algn="l" indent="0" marL="0">
-              <a:lnSpc>
-                <a:spcPct val="115000"/>
-              </a:lnSpc>
-              <a:buNone/>
-            </a:pPr>
-            <a:r>
-              <a:rPr lang="en-US" sz="1125" dirty="0">
-                <a:solidFill>
-                  <a:srgbClr val="64748B"/>
-                </a:solidFill>
-                <a:latin typeface="Segoe UI" pitchFamily="34" charset="0"/>
-                <a:ea typeface="Segoe UI" pitchFamily="34" charset="-122"/>
-                <a:cs typeface="Segoe UI" pitchFamily="34" charset="-120"/>
-              </a:rPr>
-              <a:t>APIM call, sorter map, audit</a:t>
-            </a:r>
-            <a:endParaRPr lang="en-US" sz="1125" dirty="0"/>
-          </a:p>
-        </p:txBody>
-      </p:sp>
-      <p:sp>
-        <p:nvSpPr>
-          <p:cNvPr id="20" name="Shape 18"/>
+          <p:cNvPr id="16" name="Shape 14"/>
           <p:cNvSpPr/>
           <p:nvPr/>
         </p:nvSpPr>
@@ -6104,7 +5936,7 @@
       </p:sp>
       <p:sp>
         <p:nvSpPr>
-          <p:cNvPr id="21" name="Text 19"/>
+          <p:cNvPr id="17" name="Text 15"/>
           <p:cNvSpPr/>
           <p:nvPr/>
         </p:nvSpPr>
@@ -6146,14 +5978,14 @@
       </p:sp>
       <p:sp>
         <p:nvSpPr>
-          <p:cNvPr id="22" name="Text 20"/>
-          <p:cNvSpPr/>
-          <p:nvPr/>
-        </p:nvSpPr>
-        <p:spPr>
-          <a:xfrm>
-            <a:off x="1341120" y="5532120"/>
-            <a:ext cx="10003536" cy="246888"/>
+          <p:cNvPr id="18" name="Text 16"/>
+          <p:cNvSpPr/>
+          <p:nvPr/>
+        </p:nvSpPr>
+        <p:spPr>
+          <a:xfrm>
+            <a:off x="1341120" y="5385816"/>
+            <a:ext cx="10003536" cy="804672"/>
           </a:xfrm>
           <a:prstGeom prst="rect">
             <a:avLst/>
@@ -6183,48 +6015,6 @@
               <a:t>Promotion and fallback</a:t>
             </a:r>
             <a:endParaRPr lang="en-US" sz="1350" dirty="0"/>
-          </a:p>
-        </p:txBody>
-      </p:sp>
-      <p:sp>
-        <p:nvSpPr>
-          <p:cNvPr id="23" name="Text 21"/>
-          <p:cNvSpPr/>
-          <p:nvPr/>
-        </p:nvSpPr>
-        <p:spPr>
-          <a:xfrm>
-            <a:off x="1341120" y="5797296"/>
-            <a:ext cx="10003536" cy="219456"/>
-          </a:xfrm>
-          <a:prstGeom prst="rect">
-            <a:avLst/>
-          </a:prstGeom>
-          <a:noFill/>
-          <a:ln/>
-        </p:spPr>
-        <p:txBody>
-          <a:bodyPr wrap="square" lIns="0" tIns="0" rIns="0" bIns="0" rtlCol="0" anchor="ctr"/>
-          <a:lstStyle/>
-          <a:p>
-            <a:pPr algn="l" indent="0" marL="0">
-              <a:lnSpc>
-                <a:spcPct val="115000"/>
-              </a:lnSpc>
-              <a:buNone/>
-            </a:pPr>
-            <a:r>
-              <a:rPr lang="en-US" sz="1125" dirty="0">
-                <a:solidFill>
-                  <a:srgbClr val="64748B"/>
-                </a:solidFill>
-                <a:latin typeface="Segoe UI" pitchFamily="34" charset="0"/>
-                <a:ea typeface="Segoe UI" pitchFamily="34" charset="-122"/>
-                <a:cs typeface="Segoe UI" pitchFamily="34" charset="-120"/>
-              </a:rPr>
-              <a:t>Seed, deploy, pilot, roll back</a:t>
-            </a:r>
-            <a:endParaRPr lang="en-US" sz="1125" dirty="0"/>
           </a:p>
         </p:txBody>
       </p:sp>
@@ -6507,7 +6297,7 @@
                 <a:ea typeface="Segoe UI" pitchFamily="34" charset="-122"/>
                 <a:cs typeface="Segoe UI" pitchFamily="34" charset="-120"/>
               </a:rPr>
-              <a:t>Specimen Acknowledgement in lab-crs-app</a:t>
+              <a:t>Specimen Acknowledgement in ECPath</a:t>
             </a:r>
             <a:endParaRPr lang="en-US" sz="1200" dirty="0"/>
           </a:p>
@@ -8603,12 +8393,12 @@
         </p:nvSpPr>
         <p:spPr>
           <a:xfrm>
-            <a:off x="609600" y="2848832"/>
-            <a:ext cx="2599182" cy="2074735"/>
+            <a:off x="609600" y="2753582"/>
+            <a:ext cx="2599182" cy="2265235"/>
           </a:xfrm>
           <a:prstGeom prst="roundRect">
             <a:avLst>
-              <a:gd name="adj" fmla="val 5289"/>
+              <a:gd name="adj" fmla="val 4844"/>
             </a:avLst>
           </a:prstGeom>
           <a:solidFill>
@@ -8638,7 +8428,7 @@
         </p:blipFill>
         <p:spPr>
           <a:xfrm>
-            <a:off x="847344" y="3132296"/>
+            <a:off x="847344" y="3037046"/>
             <a:ext cx="265176" cy="265176"/>
           </a:xfrm>
           <a:prstGeom prst="rect">
@@ -8654,7 +8444,7 @@
         </p:nvSpPr>
         <p:spPr>
           <a:xfrm>
-            <a:off x="847344" y="3589496"/>
+            <a:off x="847344" y="3494246"/>
             <a:ext cx="2123694" cy="197167"/>
           </a:xfrm>
           <a:prstGeom prst="rect">
@@ -8696,8 +8486,8 @@
         </p:nvSpPr>
         <p:spPr>
           <a:xfrm>
-            <a:off x="847344" y="3878104"/>
-            <a:ext cx="2123694" cy="902818"/>
+            <a:off x="847344" y="3782854"/>
+            <a:ext cx="2123694" cy="1093318"/>
           </a:xfrm>
           <a:prstGeom prst="rect">
             <a:avLst/>
@@ -8724,10 +8514,30 @@
                 <a:ea typeface="Segoe UI" pitchFamily="34" charset="-122"/>
                 <a:cs typeface="Segoe UI" pitchFamily="34" charset="-120"/>
               </a:rPr>
-              <a:t>POST /api/sorter/auto-register on lis-crs-spec-ack-svc. Staff /api/specack is unchanged.</a:t>
+              <a:t>POST /api/sorter/auto-register on lis-crs-spec-ack-svc.</a:t>
             </a:r>
             <a:endParaRPr lang="en-US" sz="1200" dirty="0"/>
           </a:p>
+          <a:p>
+            <a:pPr algn="l" indent="0" marL="0">
+              <a:lnSpc>
+                <a:spcPct val="120000"/>
+              </a:lnSpc>
+              <a:buNone/>
+            </a:pPr>
+            <a:r>
+              <a:rPr lang="en-US" sz="1200" dirty="0">
+                <a:solidFill>
+                  <a:srgbClr val="475569"/>
+                </a:solidFill>
+                <a:latin typeface="Segoe UI" pitchFamily="34" charset="0"/>
+                <a:ea typeface="Segoe UI" pitchFamily="34" charset="-122"/>
+                <a:cs typeface="Segoe UI" pitchFamily="34" charset="-120"/>
+              </a:rPr>
+              <a:t>Staff /api/specack is unchanged.</a:t>
+            </a:r>
+            <a:endParaRPr lang="en-US" sz="1200" dirty="0"/>
+          </a:p>
         </p:txBody>
       </p:sp>
       <p:sp>
@@ -8738,12 +8548,12 @@
         </p:nvSpPr>
         <p:spPr>
           <a:xfrm>
-            <a:off x="3400806" y="2848832"/>
-            <a:ext cx="2599182" cy="2074735"/>
+            <a:off x="3400806" y="2753582"/>
+            <a:ext cx="2599182" cy="2265235"/>
           </a:xfrm>
           <a:prstGeom prst="roundRect">
             <a:avLst>
-              <a:gd name="adj" fmla="val 5289"/>
+              <a:gd name="adj" fmla="val 4844"/>
             </a:avLst>
           </a:prstGeom>
           <a:solidFill>
@@ -8773,7 +8583,7 @@
         </p:blipFill>
         <p:spPr>
           <a:xfrm>
-            <a:off x="3638550" y="3132296"/>
+            <a:off x="3638550" y="3037046"/>
             <a:ext cx="265176" cy="265176"/>
           </a:xfrm>
           <a:prstGeom prst="rect">
@@ -8789,7 +8599,7 @@
         </p:nvSpPr>
         <p:spPr>
           <a:xfrm>
-            <a:off x="3638550" y="3589496"/>
+            <a:off x="3638550" y="3494246"/>
             <a:ext cx="2123694" cy="197167"/>
           </a:xfrm>
           <a:prstGeom prst="rect">
@@ -8831,8 +8641,8 @@
         </p:nvSpPr>
         <p:spPr>
           <a:xfrm>
-            <a:off x="3638550" y="3878104"/>
-            <a:ext cx="2123694" cy="902818"/>
+            <a:off x="3638550" y="3782854"/>
+            <a:ext cx="2123694" cy="1093318"/>
           </a:xfrm>
           <a:prstGeom prst="rect">
             <a:avLst/>
@@ -8873,12 +8683,12 @@
         </p:nvSpPr>
         <p:spPr>
           <a:xfrm>
-            <a:off x="6192012" y="2848832"/>
-            <a:ext cx="2599182" cy="2074735"/>
+            <a:off x="6192012" y="2753582"/>
+            <a:ext cx="2599182" cy="2265235"/>
           </a:xfrm>
           <a:prstGeom prst="roundRect">
             <a:avLst>
-              <a:gd name="adj" fmla="val 5289"/>
+              <a:gd name="adj" fmla="val 4844"/>
             </a:avLst>
           </a:prstGeom>
           <a:solidFill>
@@ -8908,7 +8718,7 @@
         </p:blipFill>
         <p:spPr>
           <a:xfrm>
-            <a:off x="6429756" y="3132296"/>
+            <a:off x="6429756" y="3037046"/>
             <a:ext cx="265176" cy="265176"/>
           </a:xfrm>
           <a:prstGeom prst="rect">
@@ -8924,7 +8734,7 @@
         </p:nvSpPr>
         <p:spPr>
           <a:xfrm>
-            <a:off x="6429756" y="3589496"/>
+            <a:off x="6429756" y="3494246"/>
             <a:ext cx="2123694" cy="197167"/>
           </a:xfrm>
           <a:prstGeom prst="rect">
@@ -8966,8 +8776,8 @@
         </p:nvSpPr>
         <p:spPr>
           <a:xfrm>
-            <a:off x="6429756" y="3878104"/>
-            <a:ext cx="2123694" cy="902818"/>
+            <a:off x="6429756" y="3782854"/>
+            <a:ext cx="2123694" cy="1093318"/>
           </a:xfrm>
           <a:prstGeom prst="rect">
             <a:avLst/>
@@ -8994,7 +8804,7 @@
                 <a:ea typeface="Segoe UI" pitchFamily="34" charset="-122"/>
                 <a:cs typeface="Segoe UI" pitchFamily="34" charset="-120"/>
               </a:rPr>
-              <a:t>loe_specimen_sorter_map: sorter id (PK) to LIS user, hospital and workbench. No lab. No server name.</a:t>
+              <a:t>loe_specimen_sorter_map: sorter id (PK) to LIS user, hospital and workbench.</a:t>
             </a:r>
             <a:endParaRPr lang="en-US" sz="1200" dirty="0"/>
           </a:p>
@@ -9008,12 +8818,12 @@
         </p:nvSpPr>
         <p:spPr>
           <a:xfrm>
-            <a:off x="8983218" y="2848832"/>
-            <a:ext cx="2599182" cy="2074735"/>
+            <a:off x="8983218" y="2753582"/>
+            <a:ext cx="2599182" cy="2265235"/>
           </a:xfrm>
           <a:prstGeom prst="roundRect">
             <a:avLst>
-              <a:gd name="adj" fmla="val 5289"/>
+              <a:gd name="adj" fmla="val 4844"/>
             </a:avLst>
           </a:prstGeom>
           <a:solidFill>
@@ -9043,7 +8853,7 @@
         </p:blipFill>
         <p:spPr>
           <a:xfrm>
-            <a:off x="9220962" y="3132296"/>
+            <a:off x="9220962" y="3037046"/>
             <a:ext cx="265176" cy="265176"/>
           </a:xfrm>
           <a:prstGeom prst="rect">
@@ -9059,7 +8869,7 @@
         </p:nvSpPr>
         <p:spPr>
           <a:xfrm>
-            <a:off x="9220962" y="3589496"/>
+            <a:off x="9220962" y="3494246"/>
             <a:ext cx="2123694" cy="197167"/>
           </a:xfrm>
           <a:prstGeom prst="rect">
@@ -9101,8 +8911,8 @@
         </p:nvSpPr>
         <p:spPr>
           <a:xfrm>
-            <a:off x="9220962" y="3878104"/>
-            <a:ext cx="2123694" cy="902818"/>
+            <a:off x="9220962" y="3782854"/>
+            <a:ext cx="2123694" cy="1093318"/>
           </a:xfrm>
           <a:prstGeom prst="rect">
             <a:avLst/>
@@ -10365,7 +10175,7 @@
                 <a:ea typeface="Segoe UI Semibold" pitchFamily="34" charset="-122"/>
                 <a:cs typeface="Segoe UI Semibold" pitchFamily="34" charset="-120"/>
               </a:rPr>
-              <a:t>RETURNED ON DATA.STATUS</a:t>
+              <a:t>RETURNED STATUS</a:t>
             </a:r>
             <a:endParaRPr lang="en-US" sz="900" dirty="0"/>
           </a:p>
@@ -10570,12 +10380,12 @@
         </p:nvSpPr>
         <p:spPr>
           <a:xfrm>
-            <a:off x="609600" y="2203704"/>
-            <a:ext cx="5870448" cy="3364992"/>
+            <a:off x="609600" y="1988820"/>
+            <a:ext cx="5870448" cy="3794760"/>
           </a:xfrm>
           <a:prstGeom prst="roundRect">
             <a:avLst>
-              <a:gd name="adj" fmla="val 3261"/>
+              <a:gd name="adj" fmla="val 2892"/>
             </a:avLst>
           </a:prstGeom>
           <a:solidFill>
@@ -10597,7 +10407,7 @@
         </p:nvSpPr>
         <p:spPr>
           <a:xfrm>
-            <a:off x="847344" y="2423160"/>
+            <a:off x="847344" y="2208276"/>
             <a:ext cx="4754880" cy="182880"/>
           </a:xfrm>
           <a:prstGeom prst="rect">
@@ -10636,7 +10446,7 @@
         </p:nvSpPr>
         <p:spPr>
           <a:xfrm>
-            <a:off x="5657088" y="2423160"/>
+            <a:off x="5657088" y="2208276"/>
             <a:ext cx="585216" cy="182880"/>
           </a:xfrm>
           <a:prstGeom prst="rect">
@@ -10678,8 +10488,8 @@
         </p:nvSpPr>
         <p:spPr>
           <a:xfrm>
-            <a:off x="847344" y="2715768"/>
-            <a:ext cx="5394960" cy="2670048"/>
+            <a:off x="847344" y="2500884"/>
+            <a:ext cx="5394960" cy="3099816"/>
           </a:xfrm>
           <a:prstGeom prst="rect">
             <a:avLst/>
@@ -10780,7 +10590,7 @@
                 <a:ea typeface="Consolas" pitchFamily="34" charset="-122"/>
                 <a:cs typeface="Consolas" pitchFamily="34" charset="-120"/>
               </a:rPr>
-              <a:t>"QHSP2500000012"</a:t>
+              <a:t>"QECAA0032R"</a:t>
             </a:r>
             <a:pPr indent="0" marL="0">
               <a:lnSpc>
@@ -10851,7 +10661,7 @@
                 <a:ea typeface="Consolas" pitchFamily="34" charset="-122"/>
                 <a:cs typeface="Consolas" pitchFamily="34" charset="-120"/>
               </a:rPr>
-              <a:t>"KTH-SORTER-01"</a:t>
+              <a:t>"QEH-SORTER-01"</a:t>
             </a:r>
             <a:pPr indent="0" marL="0">
               <a:lnSpc>
@@ -11185,6 +10995,148 @@
                 <a:cs typeface="Consolas" pitchFamily="34" charset="-120"/>
               </a:rPr>
               <a:t>"REGISTERED"</a:t>
+            </a:r>
+            <a:pPr indent="0" marL="0">
+              <a:lnSpc>
+                <a:spcPct val="125000"/>
+              </a:lnSpc>
+              <a:buNone/>
+            </a:pPr>
+            <a:r>
+              <a:rPr lang="en-US" sz="1125" dirty="0">
+                <a:solidFill>
+                  <a:srgbClr val="E2E8F0"/>
+                </a:solidFill>
+                <a:latin typeface="Consolas" pitchFamily="34" charset="0"/>
+                <a:ea typeface="Consolas" pitchFamily="34" charset="-122"/>
+                <a:cs typeface="Consolas" pitchFamily="34" charset="-120"/>
+              </a:rPr>
+              <a:t>,</a:t>
+            </a:r>
+            <a:endParaRPr lang="en-US" sz="1125" dirty="0"/>
+          </a:p>
+          <a:p>
+            <a:pPr indent="0" marL="0">
+              <a:lnSpc>
+                <a:spcPct val="125000"/>
+              </a:lnSpc>
+              <a:buNone/>
+            </a:pPr>
+            <a:r>
+              <a:rPr lang="en-US" sz="1125" dirty="0">
+                <a:solidFill>
+                  <a:srgbClr val="38BDF8"/>
+                </a:solidFill>
+                <a:latin typeface="Consolas" pitchFamily="34" charset="0"/>
+                <a:ea typeface="Consolas" pitchFamily="34" charset="-122"/>
+                <a:cs typeface="Consolas" pitchFamily="34" charset="-120"/>
+              </a:rPr>
+              <a:t>  "labCode"</a:t>
+            </a:r>
+            <a:pPr indent="0" marL="0">
+              <a:lnSpc>
+                <a:spcPct val="125000"/>
+              </a:lnSpc>
+              <a:buNone/>
+            </a:pPr>
+            <a:r>
+              <a:rPr lang="en-US" sz="1125" dirty="0">
+                <a:solidFill>
+                  <a:srgbClr val="E2E8F0"/>
+                </a:solidFill>
+                <a:latin typeface="Consolas" pitchFamily="34" charset="0"/>
+                <a:ea typeface="Consolas" pitchFamily="34" charset="-122"/>
+                <a:cs typeface="Consolas" pitchFamily="34" charset="-120"/>
+              </a:rPr>
+              <a:t>: </a:t>
+            </a:r>
+            <a:pPr indent="0" marL="0">
+              <a:lnSpc>
+                <a:spcPct val="125000"/>
+              </a:lnSpc>
+              <a:buNone/>
+            </a:pPr>
+            <a:r>
+              <a:rPr lang="en-US" sz="1125" dirty="0">
+                <a:solidFill>
+                  <a:srgbClr val="FBBF24"/>
+                </a:solidFill>
+                <a:latin typeface="Consolas" pitchFamily="34" charset="0"/>
+                <a:ea typeface="Consolas" pitchFamily="34" charset="-122"/>
+                <a:cs typeface="Consolas" pitchFamily="34" charset="-120"/>
+              </a:rPr>
+              <a:t>"CPS"</a:t>
+            </a:r>
+            <a:pPr indent="0" marL="0">
+              <a:lnSpc>
+                <a:spcPct val="125000"/>
+              </a:lnSpc>
+              <a:buNone/>
+            </a:pPr>
+            <a:r>
+              <a:rPr lang="en-US" sz="1125" dirty="0">
+                <a:solidFill>
+                  <a:srgbClr val="E2E8F0"/>
+                </a:solidFill>
+                <a:latin typeface="Consolas" pitchFamily="34" charset="0"/>
+                <a:ea typeface="Consolas" pitchFamily="34" charset="-122"/>
+                <a:cs typeface="Consolas" pitchFamily="34" charset="-120"/>
+              </a:rPr>
+              <a:t>,</a:t>
+            </a:r>
+            <a:endParaRPr lang="en-US" sz="1125" dirty="0"/>
+          </a:p>
+          <a:p>
+            <a:pPr indent="0" marL="0">
+              <a:lnSpc>
+                <a:spcPct val="125000"/>
+              </a:lnSpc>
+              <a:buNone/>
+            </a:pPr>
+            <a:r>
+              <a:rPr lang="en-US" sz="1125" dirty="0">
+                <a:solidFill>
+                  <a:srgbClr val="38BDF8"/>
+                </a:solidFill>
+                <a:latin typeface="Consolas" pitchFamily="34" charset="0"/>
+                <a:ea typeface="Consolas" pitchFamily="34" charset="-122"/>
+                <a:cs typeface="Consolas" pitchFamily="34" charset="-120"/>
+              </a:rPr>
+              <a:t>  "testCode"</a:t>
+            </a:r>
+            <a:pPr indent="0" marL="0">
+              <a:lnSpc>
+                <a:spcPct val="125000"/>
+              </a:lnSpc>
+              <a:buNone/>
+            </a:pPr>
+            <a:r>
+              <a:rPr lang="en-US" sz="1125" dirty="0">
+                <a:solidFill>
+                  <a:srgbClr val="E2E8F0"/>
+                </a:solidFill>
+                <a:latin typeface="Consolas" pitchFamily="34" charset="0"/>
+                <a:ea typeface="Consolas" pitchFamily="34" charset="-122"/>
+                <a:cs typeface="Consolas" pitchFamily="34" charset="-120"/>
+              </a:rPr>
+              <a:t>: </a:t>
+            </a:r>
+            <a:pPr indent="0" marL="0">
+              <a:lnSpc>
+                <a:spcPct val="125000"/>
+              </a:lnSpc>
+              <a:buNone/>
+            </a:pPr>
+            <a:r>
+              <a:rPr lang="en-US" sz="1125" dirty="0">
+                <a:solidFill>
+                  <a:srgbClr val="FBBF24"/>
+                </a:solidFill>
+                <a:latin typeface="Consolas" pitchFamily="34" charset="0"/>
+                <a:ea typeface="Consolas" pitchFamily="34" charset="-122"/>
+                <a:cs typeface="Consolas" pitchFamily="34" charset="-120"/>
+              </a:rPr>
+              <a:t>"LFT"</a:t>
             </a:r>
             <a:endParaRPr lang="en-US" sz="1125" dirty="0"/>
           </a:p>

</xml_diff>

<commit_message>
vault backup: 2026-09-21 17:39:50
</commit_message>
<xml_diff>
--- a/SDLC/Projects/TMP-specimen-sorter-api — Specimen Sorter API/assets/Specimen Sorter API v3.pptx
+++ b/SDLC/Projects/TMP-specimen-sorter-api — Specimen Sorter API/assets/Specimen Sorter API v3.pptx
@@ -9183,7 +9183,7 @@
                 <a:ea typeface="Consolas" pitchFamily="34" charset="-122"/>
                 <a:cs typeface="Consolas" pitchFamily="34" charset="-120"/>
               </a:rPr>
-              <a:t>Checks</a:t>
+              <a:t>All tests</a:t>
             </a:r>
             <a:endParaRPr lang="en-US" sz="1050" dirty="0"/>
           </a:p>
@@ -9200,7 +9200,7 @@
                 <a:ea typeface="Consolas" pitchFamily="34" charset="-122"/>
                 <a:cs typeface="Consolas" pitchFamily="34" charset="-120"/>
               </a:rPr>
-              <a:t>pass?</a:t>
+              <a:t>send-out?</a:t>
             </a:r>
             <a:endParaRPr lang="en-US" sz="1050" dirty="0"/>
           </a:p>
@@ -9267,7 +9267,7 @@
                 <a:ea typeface="Segoe UI" pitchFamily="34" charset="-122"/>
                 <a:cs typeface="Segoe UI" pitchFamily="34" charset="-120"/>
               </a:rPr>
-              <a:t>No</a:t>
+              <a:t>Yes</a:t>
             </a:r>
             <a:endParaRPr lang="en-US" sz="1050" dirty="0"/>
           </a:p>
@@ -9306,48 +9306,6 @@
         </p:nvSpPr>
         <p:spPr>
           <a:xfrm>
-            <a:off x="4733544" y="2084832"/>
-            <a:ext cx="502920" cy="219456"/>
-          </a:xfrm>
-          <a:prstGeom prst="rect">
-            <a:avLst/>
-          </a:prstGeom>
-          <a:noFill/>
-          <a:ln/>
-        </p:spPr>
-        <p:txBody>
-          <a:bodyPr wrap="square" lIns="0" tIns="0" rIns="0" bIns="0" rtlCol="0" anchor="t"/>
-          <a:lstStyle/>
-          <a:p>
-            <a:pPr algn="ctr" indent="0" marL="0">
-              <a:lnSpc>
-                <a:spcPct val="115000"/>
-              </a:lnSpc>
-              <a:buNone/>
-            </a:pPr>
-            <a:r>
-              <a:rPr lang="en-US" sz="1050" b="1" dirty="0">
-                <a:solidFill>
-                  <a:srgbClr val="0284C7"/>
-                </a:solidFill>
-                <a:latin typeface="Segoe UI" pitchFamily="34" charset="0"/>
-                <a:ea typeface="Segoe UI" pitchFamily="34" charset="-122"/>
-                <a:cs typeface="Segoe UI" pitchFamily="34" charset="-120"/>
-              </a:rPr>
-              <a:t>Yes</a:t>
-            </a:r>
-            <a:endParaRPr lang="en-US" sz="1050" dirty="0"/>
-          </a:p>
-        </p:txBody>
-      </p:sp>
-      <p:sp>
-        <p:nvSpPr>
-          <p:cNvPr id="11" name="Text 9"/>
-          <p:cNvSpPr/>
-          <p:nvPr/>
-        </p:nvSpPr>
-        <p:spPr>
-          <a:xfrm>
             <a:off x="5236464" y="1828800"/>
             <a:ext cx="2103120" cy="1280160"/>
           </a:xfrm>
@@ -9379,7 +9337,7 @@
                 <a:ea typeface="Consolas" pitchFamily="34" charset="-122"/>
                 <a:cs typeface="Consolas" pitchFamily="34" charset="-120"/>
               </a:rPr>
-              <a:t>Relabel</a:t>
+              <a:t>Validations</a:t>
             </a:r>
             <a:endParaRPr lang="en-US" sz="1050" dirty="0"/>
           </a:p>
@@ -9396,7 +9354,7 @@
                 <a:ea typeface="Consolas" pitchFamily="34" charset="-122"/>
                 <a:cs typeface="Consolas" pitchFamily="34" charset="-120"/>
               </a:rPr>
-              <a:t>rules?</a:t>
+              <a:t>pass?</a:t>
             </a:r>
             <a:endParaRPr lang="en-US" sz="1050" dirty="0"/>
           </a:p>
@@ -9404,7 +9362,7 @@
       </p:sp>
       <p:sp>
         <p:nvSpPr>
-          <p:cNvPr id="12" name="Shape 10"/>
+          <p:cNvPr id="11" name="Shape 9"/>
           <p:cNvSpPr/>
           <p:nvPr/>
         </p:nvSpPr>
@@ -9429,7 +9387,7 @@
       </p:sp>
       <p:sp>
         <p:nvSpPr>
-          <p:cNvPr id="13" name="Text 11"/>
+          <p:cNvPr id="12" name="Text 10"/>
           <p:cNvSpPr/>
           <p:nvPr/>
         </p:nvSpPr>
@@ -9463,7 +9421,7 @@
                 <a:ea typeface="Segoe UI" pitchFamily="34" charset="-122"/>
                 <a:cs typeface="Segoe UI" pitchFamily="34" charset="-120"/>
               </a:rPr>
-              <a:t>Yes</a:t>
+              <a:t>No</a:t>
             </a:r>
             <a:endParaRPr lang="en-US" sz="1050" dirty="0"/>
           </a:p>
@@ -9471,7 +9429,7 @@
       </p:sp>
       <p:sp>
         <p:nvSpPr>
-          <p:cNvPr id="14" name="Shape 12"/>
+          <p:cNvPr id="13" name="Shape 11"/>
           <p:cNvSpPr/>
           <p:nvPr/>
         </p:nvSpPr>
@@ -9496,7 +9454,7 @@
       </p:sp>
       <p:sp>
         <p:nvSpPr>
-          <p:cNvPr id="15" name="Text 13"/>
+          <p:cNvPr id="14" name="Text 12"/>
           <p:cNvSpPr/>
           <p:nvPr/>
         </p:nvSpPr>
@@ -9530,7 +9488,7 @@
                 <a:ea typeface="Segoe UI" pitchFamily="34" charset="-122"/>
                 <a:cs typeface="Segoe UI" pitchFamily="34" charset="-120"/>
               </a:rPr>
-              <a:t>No</a:t>
+              <a:t>Yes</a:t>
             </a:r>
             <a:endParaRPr lang="en-US" sz="1050" dirty="0"/>
           </a:p>
@@ -9538,7 +9496,7 @@
       </p:sp>
       <p:sp>
         <p:nvSpPr>
-          <p:cNvPr id="16" name="Text 14"/>
+          <p:cNvPr id="15" name="Text 13"/>
           <p:cNvSpPr/>
           <p:nvPr/>
         </p:nvSpPr>
@@ -9575,7 +9533,7 @@
                 <a:ea typeface="Consolas" pitchFamily="34" charset="-122"/>
                 <a:cs typeface="Consolas" pitchFamily="34" charset="-120"/>
               </a:rPr>
-              <a:t>All tests</a:t>
+              <a:t>Relabel</a:t>
             </a:r>
             <a:endParaRPr lang="en-US" sz="1050" dirty="0"/>
           </a:p>
@@ -9592,7 +9550,7 @@
                 <a:ea typeface="Consolas" pitchFamily="34" charset="-122"/>
                 <a:cs typeface="Consolas" pitchFamily="34" charset="-120"/>
               </a:rPr>
-              <a:t>send-out?</a:t>
+              <a:t>rules?</a:t>
             </a:r>
             <a:endParaRPr lang="en-US" sz="1050" dirty="0"/>
           </a:p>
@@ -9600,7 +9558,7 @@
       </p:sp>
       <p:sp>
         <p:nvSpPr>
-          <p:cNvPr id="17" name="Shape 15"/>
+          <p:cNvPr id="16" name="Shape 14"/>
           <p:cNvSpPr/>
           <p:nvPr/>
         </p:nvSpPr>
@@ -9625,7 +9583,7 @@
       </p:sp>
       <p:sp>
         <p:nvSpPr>
-          <p:cNvPr id="18" name="Text 16"/>
+          <p:cNvPr id="17" name="Text 15"/>
           <p:cNvSpPr/>
           <p:nvPr/>
         </p:nvSpPr>
@@ -9667,7 +9625,7 @@
       </p:sp>
       <p:sp>
         <p:nvSpPr>
-          <p:cNvPr id="19" name="Shape 17"/>
+          <p:cNvPr id="18" name="Shape 16"/>
           <p:cNvSpPr/>
           <p:nvPr/>
         </p:nvSpPr>
@@ -9692,7 +9650,7 @@
       </p:sp>
       <p:sp>
         <p:nvSpPr>
-          <p:cNvPr id="20" name="Text 18"/>
+          <p:cNvPr id="19" name="Text 17"/>
           <p:cNvSpPr/>
           <p:nvPr/>
         </p:nvSpPr>
@@ -9734,7 +9692,7 @@
       </p:sp>
       <p:sp>
         <p:nvSpPr>
-          <p:cNvPr id="21" name="Text 19"/>
+          <p:cNvPr id="20" name="Text 18"/>
           <p:cNvSpPr/>
           <p:nvPr/>
         </p:nvSpPr>
@@ -9781,7 +9739,7 @@
       </p:sp>
       <p:sp>
         <p:nvSpPr>
-          <p:cNvPr id="22" name="Shape 20"/>
+          <p:cNvPr id="21" name="Shape 19"/>
           <p:cNvSpPr/>
           <p:nvPr/>
         </p:nvSpPr>
@@ -9808,7 +9766,7 @@
       </p:sp>
       <p:sp>
         <p:nvSpPr>
-          <p:cNvPr id="23" name="Text 21"/>
+          <p:cNvPr id="22" name="Text 20"/>
           <p:cNvSpPr/>
           <p:nvPr/>
         </p:nvSpPr>
@@ -9842,7 +9800,7 @@
                 <a:ea typeface="Segoe UI Semibold" pitchFamily="34" charset="-122"/>
                 <a:cs typeface="Segoe UI Semibold" pitchFamily="34" charset="-120"/>
               </a:rPr>
-              <a:t>FAILURE</a:t>
+              <a:t>SEND_OUT</a:t>
             </a:r>
             <a:endParaRPr lang="en-US" sz="1200" dirty="0"/>
           </a:p>
@@ -9850,7 +9808,7 @@
       </p:sp>
       <p:sp>
         <p:nvSpPr>
-          <p:cNvPr id="24" name="Text 22"/>
+          <p:cNvPr id="23" name="Text 21"/>
           <p:cNvSpPr/>
           <p:nvPr/>
         </p:nvSpPr>
@@ -9884,7 +9842,7 @@
                 <a:ea typeface="Segoe UI" pitchFamily="34" charset="-122"/>
                 <a:cs typeface="Segoe UI" pitchFamily="34" charset="-120"/>
               </a:rPr>
-              <a:t>Unknown sorter, lab, mixed, hard check, 4422</a:t>
+              <a:t>Existing send-out, no print</a:t>
             </a:r>
             <a:endParaRPr lang="en-US" sz="1125" dirty="0"/>
           </a:p>
@@ -9892,7 +9850,7 @@
       </p:sp>
       <p:sp>
         <p:nvSpPr>
-          <p:cNvPr id="25" name="Shape 23"/>
+          <p:cNvPr id="24" name="Shape 22"/>
           <p:cNvSpPr/>
           <p:nvPr/>
         </p:nvSpPr>
@@ -9919,7 +9877,7 @@
       </p:sp>
       <p:sp>
         <p:nvSpPr>
-          <p:cNvPr id="26" name="Text 24"/>
+          <p:cNvPr id="25" name="Text 23"/>
           <p:cNvSpPr/>
           <p:nvPr/>
         </p:nvSpPr>
@@ -9953,7 +9911,7 @@
                 <a:ea typeface="Segoe UI Semibold" pitchFamily="34" charset="-122"/>
                 <a:cs typeface="Segoe UI Semibold" pitchFamily="34" charset="-120"/>
               </a:rPr>
-              <a:t>RELABEL</a:t>
+              <a:t>FAILURE</a:t>
             </a:r>
             <a:endParaRPr lang="en-US" sz="1200" dirty="0"/>
           </a:p>
@@ -9961,7 +9919,7 @@
       </p:sp>
       <p:sp>
         <p:nvSpPr>
-          <p:cNvPr id="27" name="Text 25"/>
+          <p:cNvPr id="26" name="Text 24"/>
           <p:cNvSpPr/>
           <p:nvPr/>
         </p:nvSpPr>
@@ -9995,7 +9953,7 @@
                 <a:ea typeface="Segoe UI" pitchFamily="34" charset="-122"/>
                 <a:cs typeface="Segoe UI" pitchFamily="34" charset="-120"/>
               </a:rPr>
-              <a:t>Multi-group, suffix, DFT time flag</a:t>
+              <a:t>Unknown sorter, lab, mixed, hard check, 4422</a:t>
             </a:r>
             <a:endParaRPr lang="en-US" sz="1125" dirty="0"/>
           </a:p>
@@ -10003,7 +9961,7 @@
       </p:sp>
       <p:sp>
         <p:nvSpPr>
-          <p:cNvPr id="28" name="Shape 26"/>
+          <p:cNvPr id="27" name="Shape 25"/>
           <p:cNvSpPr/>
           <p:nvPr/>
         </p:nvSpPr>
@@ -10030,7 +9988,7 @@
       </p:sp>
       <p:sp>
         <p:nvSpPr>
-          <p:cNvPr id="29" name="Text 27"/>
+          <p:cNvPr id="28" name="Text 26"/>
           <p:cNvSpPr/>
           <p:nvPr/>
         </p:nvSpPr>
@@ -10064,7 +10022,7 @@
                 <a:ea typeface="Segoe UI Semibold" pitchFamily="34" charset="-122"/>
                 <a:cs typeface="Segoe UI Semibold" pitchFamily="34" charset="-120"/>
               </a:rPr>
-              <a:t>SEND_OUT</a:t>
+              <a:t>RELABEL</a:t>
             </a:r>
             <a:endParaRPr lang="en-US" sz="1200" dirty="0"/>
           </a:p>
@@ -10072,7 +10030,7 @@
       </p:sp>
       <p:sp>
         <p:nvSpPr>
-          <p:cNvPr id="30" name="Text 28"/>
+          <p:cNvPr id="29" name="Text 27"/>
           <p:cNvSpPr/>
           <p:nvPr/>
         </p:nvSpPr>
@@ -10106,7 +10064,7 @@
                 <a:ea typeface="Segoe UI" pitchFamily="34" charset="-122"/>
                 <a:cs typeface="Segoe UI" pitchFamily="34" charset="-120"/>
               </a:rPr>
-              <a:t>Existing send-out, no print</a:t>
+              <a:t>Multi-group, suffix, DFT time flag</a:t>
             </a:r>
             <a:endParaRPr lang="en-US" sz="1125" dirty="0"/>
           </a:p>
@@ -10114,7 +10072,7 @@
       </p:sp>
       <p:sp>
         <p:nvSpPr>
-          <p:cNvPr id="31" name="Shape 29"/>
+          <p:cNvPr id="30" name="Shape 28"/>
           <p:cNvSpPr/>
           <p:nvPr/>
         </p:nvSpPr>
@@ -10141,7 +10099,7 @@
       </p:sp>
       <p:sp>
         <p:nvSpPr>
-          <p:cNvPr id="32" name="Text 30"/>
+          <p:cNvPr id="31" name="Text 29"/>
           <p:cNvSpPr/>
           <p:nvPr/>
         </p:nvSpPr>
@@ -10183,7 +10141,7 @@
       </p:sp>
       <p:sp>
         <p:nvSpPr>
-          <p:cNvPr id="33" name="Text 31"/>
+          <p:cNvPr id="32" name="Text 30"/>
           <p:cNvSpPr/>
           <p:nvPr/>
         </p:nvSpPr>
@@ -10222,7 +10180,7 @@
       </p:sp>
       <p:sp>
         <p:nvSpPr>
-          <p:cNvPr id="34" name="Text 32"/>
+          <p:cNvPr id="33" name="Text 31"/>
           <p:cNvSpPr/>
           <p:nvPr/>
         </p:nvSpPr>

</xml_diff>

<commit_message>
vault backup: 2026-09-22 10:59:07
</commit_message>
<xml_diff>
--- a/SDLC/Projects/TMP-specimen-sorter-api — Specimen Sorter API/assets/Specimen Sorter API v3.pptx
+++ b/SDLC/Projects/TMP-specimen-sorter-api — Specimen Sorter API/assets/Specimen Sorter API v3.pptx
@@ -2124,7 +2124,7 @@
                 <a:ea typeface="Segoe UI" pitchFamily="34" charset="-122"/>
                 <a:cs typeface="Segoe UI" pitchFamily="34" charset="-120"/>
               </a:rPr>
-              <a:t>Sorter middleware calls one POST on lis-crs-spec-ack-svc. It sends out or registers the tube by USID, with the checks and packing Specimen Acknowledgement runs today.</a:t>
+              <a:t>Sorter middleware calls one POST on lis-crs-spec-ack-svc. It sends out or registers the tube by USID, with the validations and packing Specimen Acknowledgement runs today.</a:t>
             </a:r>
             <a:endParaRPr lang="en-US" sz="1500" dirty="0"/>
           </a:p>
@@ -6398,7 +6398,7 @@
                 <a:ea typeface="Segoe UI" pitchFamily="34" charset="-122"/>
                 <a:cs typeface="Segoe UI" pitchFamily="34" charset="-120"/>
               </a:rPr>
-              <a:t>Checks and packing: </a:t>
+              <a:t>Result: </a:t>
             </a:r>
             <a:pPr algn="l" indent="0" marL="0">
               <a:lnSpc>
@@ -6415,7 +6415,7 @@
                 <a:ea typeface="Segoe UI" pitchFamily="34" charset="-122"/>
                 <a:cs typeface="Segoe UI" pitchFamily="34" charset="-120"/>
               </a:rPr>
-              <a:t>run on the screen</a:t>
+              <a:t>on screen</a:t>
             </a:r>
             <a:endParaRPr lang="en-US" sz="1200" dirty="0"/>
           </a:p>
@@ -6590,7 +6590,7 @@
                 <a:ea typeface="Segoe UI" pitchFamily="34" charset="-122"/>
                 <a:cs typeface="Segoe UI" pitchFamily="34" charset="-120"/>
               </a:rPr>
-              <a:t>sorter middleware through HA APIM</a:t>
+              <a:t>sorter middleware through LIS API</a:t>
             </a:r>
             <a:endParaRPr lang="en-US" sz="1200" dirty="0"/>
           </a:p>
@@ -7222,7 +7222,7 @@
                           <a:ea typeface="Segoe UI" pitchFamily="34" charset="-122"/>
                           <a:cs typeface="Segoe UI" pitchFamily="34" charset="-120"/>
                         </a:rPr>
-                        <a:t>Retrieve as the mapped user</a:t>
+                        <a:t>Same retrieval path</a:t>
                       </a:r>
                       <a:endParaRPr lang="en-US" sz="1125" dirty="0">
                         <a:latin typeface="Segoe UI" charset="0"/>
@@ -7930,7 +7930,7 @@
                           <a:ea typeface="Segoe UI" pitchFamily="34" charset="-122"/>
                           <a:cs typeface="Segoe UI" pitchFamily="34" charset="-120"/>
                         </a:rPr>
-                        <a:t>Builds Ro, staff pick</a:t>
+                        <a:t>Data conversion, staff pick</a:t>
                       </a:r>
                       <a:endParaRPr lang="en-US" sz="1125" dirty="0">
                         <a:latin typeface="Segoe UI" charset="0"/>
@@ -7980,7 +7980,7 @@
                           <a:ea typeface="Segoe UI" pitchFamily="34" charset="-122"/>
                           <a:cs typeface="Segoe UI" pitchFamily="34" charset="-120"/>
                         </a:rPr>
-                        <a:t>Three print methods</a:t>
+                        <a:t>Three kinds of printouts</a:t>
                       </a:r>
                       <a:endParaRPr lang="en-US" sz="1125" dirty="0">
                         <a:latin typeface="Segoe UI" charset="0"/>
@@ -8514,7 +8514,7 @@
                 <a:ea typeface="Segoe UI" pitchFamily="34" charset="-122"/>
                 <a:cs typeface="Segoe UI" pitchFamily="34" charset="-120"/>
               </a:rPr>
-              <a:t>POST /api/sorter/auto-register on lis-crs-spec-ack-svc.</a:t>
+              <a:t>• POST /api/sorter/auto-register on lis-crs-spec-ack-svc</a:t>
             </a:r>
             <a:endParaRPr lang="en-US" sz="1200" dirty="0"/>
           </a:p>
@@ -8534,7 +8534,7 @@
                 <a:ea typeface="Segoe UI" pitchFamily="34" charset="-122"/>
                 <a:cs typeface="Segoe UI" pitchFamily="34" charset="-120"/>
               </a:rPr>
-              <a:t>Staff /api/specack is unchanged.</a:t>
+              <a:t>• ECPath /api/specack is unchanged</a:t>
             </a:r>
             <a:endParaRPr lang="en-US" sz="1200" dirty="0"/>
           </a:p>
@@ -8669,7 +8669,27 @@
                 <a:ea typeface="Segoe UI" pitchFamily="34" charset="-122"/>
                 <a:cs typeface="Segoe UI" pitchFamily="34" charset="-120"/>
               </a:rPr>
-              <a:t>Retrieve, validation and packing run server-side, then the existing send-out, register, print and PHLC.</a:t>
+              <a:t>• Retrieve, validation, packing on the server</a:t>
+            </a:r>
+            <a:endParaRPr lang="en-US" sz="1200" dirty="0"/>
+          </a:p>
+          <a:p>
+            <a:pPr algn="l" indent="0" marL="0">
+              <a:lnSpc>
+                <a:spcPct val="120000"/>
+              </a:lnSpc>
+              <a:buNone/>
+            </a:pPr>
+            <a:r>
+              <a:rPr lang="en-US" sz="1200" dirty="0">
+                <a:solidFill>
+                  <a:srgbClr val="475569"/>
+                </a:solidFill>
+                <a:latin typeface="Segoe UI" pitchFamily="34" charset="0"/>
+                <a:ea typeface="Segoe UI" pitchFamily="34" charset="-122"/>
+                <a:cs typeface="Segoe UI" pitchFamily="34" charset="-120"/>
+              </a:rPr>
+              <a:t>• Then existng send-out, register, print, PHLC</a:t>
             </a:r>
             <a:endParaRPr lang="en-US" sz="1200" dirty="0"/>
           </a:p>
@@ -8804,7 +8824,27 @@
                 <a:ea typeface="Segoe UI" pitchFamily="34" charset="-122"/>
                 <a:cs typeface="Segoe UI" pitchFamily="34" charset="-120"/>
               </a:rPr>
-              <a:t>loe_specimen_sorter_map: sorter id (PK) to LIS user, hospital and workbench.</a:t>
+              <a:t>• loe_specimen_sorter_map</a:t>
+            </a:r>
+            <a:endParaRPr lang="en-US" sz="1200" dirty="0"/>
+          </a:p>
+          <a:p>
+            <a:pPr algn="l" indent="0" marL="0">
+              <a:lnSpc>
+                <a:spcPct val="120000"/>
+              </a:lnSpc>
+              <a:buNone/>
+            </a:pPr>
+            <a:r>
+              <a:rPr lang="en-US" sz="1200" dirty="0">
+                <a:solidFill>
+                  <a:srgbClr val="475569"/>
+                </a:solidFill>
+                <a:latin typeface="Segoe UI" pitchFamily="34" charset="0"/>
+                <a:ea typeface="Segoe UI" pitchFamily="34" charset="-122"/>
+                <a:cs typeface="Segoe UI" pitchFamily="34" charset="-120"/>
+              </a:rPr>
+              <a:t>• Sorter id (PK) → user, hospital, workbench</a:t>
             </a:r>
             <a:endParaRPr lang="en-US" sz="1200" dirty="0"/>
           </a:p>
@@ -8939,7 +8979,27 @@
                 <a:ea typeface="Segoe UI" pitchFamily="34" charset="-122"/>
                 <a:cs typeface="Segoe UI" pitchFamily="34" charset="-120"/>
               </a:rPr>
-              <a:t>SORT_* actions plus today's REG and SEND_OUT on LOE_AUDIT_TRAIL.</a:t>
+              <a:t>• SORT_* plus REG and SEND_OUT</a:t>
+            </a:r>
+            <a:endParaRPr lang="en-US" sz="1200" dirty="0"/>
+          </a:p>
+          <a:p>
+            <a:pPr algn="l" indent="0" marL="0">
+              <a:lnSpc>
+                <a:spcPct val="120000"/>
+              </a:lnSpc>
+              <a:buNone/>
+            </a:pPr>
+            <a:r>
+              <a:rPr lang="en-US" sz="1200" dirty="0">
+                <a:solidFill>
+                  <a:srgbClr val="475569"/>
+                </a:solidFill>
+                <a:latin typeface="Segoe UI" pitchFamily="34" charset="0"/>
+                <a:ea typeface="Segoe UI" pitchFamily="34" charset="-122"/>
+                <a:cs typeface="Segoe UI" pitchFamily="34" charset="-120"/>
+              </a:rPr>
+              <a:t>• Same today's REG and SEND_OUT on LOE_AUDIT_TRAIL</a:t>
             </a:r>
             <a:endParaRPr lang="en-US" sz="1200" dirty="0"/>
           </a:p>

</xml_diff>

<commit_message>
vault backup: 2026-09-22 11:31:26
</commit_message>
<xml_diff>
--- a/SDLC/Projects/TMP-specimen-sorter-api — Specimen Sorter API/assets/Specimen Sorter API v3.pptx
+++ b/SDLC/Projects/TMP-specimen-sorter-api — Specimen Sorter API/assets/Specimen Sorter API v3.pptx
@@ -866,7 +866,7 @@
           <a:p>
             <a:r>
               <a:rPr lang="en-US" dirty="0"/>
-              <a:t>Likely questions: why not let middleware call the staff register; why hospital can be omitted; why mixed tubes fail; why server name is not on the map.</a:t>
+              <a:t>Likely questions: why not let middleware call the staff register; why hospital sent skips the map; why mixed tubes fail; why user is wkbh_id.</a:t>
             </a:r>
             <a:endParaRPr lang="en-US" dirty="0"/>
           </a:p>
@@ -1482,7 +1482,7 @@
           <a:p>
             <a:r>
               <a:rPr lang="en-US" dirty="0"/>
-              <a:t>The sorter must never use the retrieve GET, because of the hard-coded user. Audit rows carry the map user and the workbench station name.</a:t>
+              <a:t>The sorter must never use the retrieve GET, because of the hard-coded user. Audit rows carry wkbh_id and wkbh_station_name. Hub already has selectWorkbenchsByStationName.</a:t>
             </a:r>
             <a:endParaRPr lang="en-US" dirty="0"/>
           </a:p>
@@ -1570,7 +1570,7 @@
           <a:p>
             <a:r>
               <a:rPr lang="en-US" dirty="0"/>
-              <a:t>Rollback is DROP TABLE. No loesort_key. Location, station name and printer stay on workbench.</a:t>
+              <a:t>No loesort_usercode or loesort_workbench_id. Location and printer stay on workbench. Server name still comes from HospitalService.</a:t>
             </a:r>
             <a:endParaRPr lang="en-US" dirty="0"/>
           </a:p>
@@ -4262,7 +4262,7 @@
                 <a:ea typeface="Segoe UI Semibold" pitchFamily="34" charset="-122"/>
                 <a:cs typeface="Segoe UI Semibold" pitchFamily="34" charset="-120"/>
               </a:rPr>
-              <a:t>Seed the map, open the gateway path, pilot CPS and HMS</a:t>
+              <a:t>Seed workbench, open the gateway path, pilot CPS and HMS</a:t>
             </a:r>
             <a:endParaRPr lang="en-US" sz="2400" dirty="0"/>
           </a:p>
@@ -4276,12 +4276,12 @@
         </p:nvSpPr>
         <p:spPr>
           <a:xfrm>
-            <a:off x="609600" y="2372011"/>
-            <a:ext cx="5335524" cy="3028378"/>
+            <a:off x="609600" y="2539032"/>
+            <a:ext cx="5335524" cy="2694337"/>
           </a:xfrm>
           <a:prstGeom prst="roundRect">
             <a:avLst>
-              <a:gd name="adj" fmla="val 3623"/>
+              <a:gd name="adj" fmla="val 4073"/>
             </a:avLst>
           </a:prstGeom>
           <a:solidFill>
@@ -4311,7 +4311,7 @@
         </p:blipFill>
         <p:spPr>
           <a:xfrm>
-            <a:off x="883920" y="2678335"/>
+            <a:off x="883920" y="2845356"/>
             <a:ext cx="265176" cy="265176"/>
           </a:xfrm>
           <a:prstGeom prst="rect">
@@ -4327,7 +4327,7 @@
         </p:nvSpPr>
         <p:spPr>
           <a:xfrm>
-            <a:off x="1249680" y="2664619"/>
+            <a:off x="1249680" y="2831640"/>
             <a:ext cx="4421124" cy="292608"/>
           </a:xfrm>
           <a:prstGeom prst="rect">
@@ -4369,7 +4369,7 @@
         </p:nvSpPr>
         <p:spPr>
           <a:xfrm>
-            <a:off x="883920" y="3094387"/>
+            <a:off x="883920" y="3261408"/>
             <a:ext cx="228600" cy="228600"/>
           </a:xfrm>
           <a:prstGeom prst="ellipse">
@@ -4414,7 +4414,7 @@
         </p:nvSpPr>
         <p:spPr>
           <a:xfrm>
-            <a:off x="1222248" y="3121819"/>
+            <a:off x="1222248" y="3288840"/>
             <a:ext cx="4448556" cy="196882"/>
           </a:xfrm>
           <a:prstGeom prst="rect">
@@ -4442,7 +4442,7 @@
                 <a:ea typeface="Segoe UI" pitchFamily="34" charset="-122"/>
                 <a:cs typeface="Segoe UI" pitchFamily="34" charset="-120"/>
               </a:rPr>
-              <a:t>Create the sorter LIS user.</a:t>
+              <a:t>Seed workbench: station name = sorter id, user = wkbh_id.</a:t>
             </a:r>
             <a:endParaRPr lang="en-US" sz="1125" dirty="0"/>
           </a:p>
@@ -4456,7 +4456,7 @@
         </p:nvSpPr>
         <p:spPr>
           <a:xfrm>
-            <a:off x="883920" y="3428429"/>
+            <a:off x="883920" y="3595449"/>
             <a:ext cx="228600" cy="228600"/>
           </a:xfrm>
           <a:prstGeom prst="ellipse">
@@ -4501,7 +4501,7 @@
         </p:nvSpPr>
         <p:spPr>
           <a:xfrm>
-            <a:off x="1222248" y="3455861"/>
+            <a:off x="1222248" y="3622881"/>
             <a:ext cx="4448556" cy="196882"/>
           </a:xfrm>
           <a:prstGeom prst="rect">
@@ -4529,7 +4529,7 @@
                 <a:ea typeface="Segoe UI" pitchFamily="34" charset="-122"/>
                 <a:cs typeface="Segoe UI" pitchFamily="34" charset="-120"/>
               </a:rPr>
-              <a:t>Seed a workbench row per lab.</a:t>
+              <a:t>Map row only if hospital can be omitted.</a:t>
             </a:r>
             <a:endParaRPr lang="en-US" sz="1125" dirty="0"/>
           </a:p>
@@ -4543,7 +4543,7 @@
         </p:nvSpPr>
         <p:spPr>
           <a:xfrm>
-            <a:off x="883920" y="3762470"/>
+            <a:off x="883920" y="3929491"/>
             <a:ext cx="228600" cy="228600"/>
           </a:xfrm>
           <a:prstGeom prst="ellipse">
@@ -4588,7 +4588,7 @@
         </p:nvSpPr>
         <p:spPr>
           <a:xfrm>
-            <a:off x="1222248" y="3789902"/>
+            <a:off x="1222248" y="3956923"/>
             <a:ext cx="4448556" cy="196882"/>
           </a:xfrm>
           <a:prstGeom prst="rect">
@@ -4616,7 +4616,7 @@
                 <a:ea typeface="Segoe UI" pitchFamily="34" charset="-122"/>
                 <a:cs typeface="Segoe UI" pitchFamily="34" charset="-120"/>
               </a:rPr>
-              <a:t>Insert the map row: PK sorter id, no lab, no server name.</a:t>
+              <a:t>Deploy lis-crs-spec-ack-svc.</a:t>
             </a:r>
             <a:endParaRPr lang="en-US" sz="1125" dirty="0"/>
           </a:p>
@@ -4630,7 +4630,7 @@
         </p:nvSpPr>
         <p:spPr>
           <a:xfrm>
-            <a:off x="883920" y="4096512"/>
+            <a:off x="883920" y="4263533"/>
             <a:ext cx="228600" cy="228600"/>
           </a:xfrm>
           <a:prstGeom prst="ellipse">
@@ -4675,7 +4675,7 @@
         </p:nvSpPr>
         <p:spPr>
           <a:xfrm>
-            <a:off x="1222248" y="4123944"/>
+            <a:off x="1222248" y="4290965"/>
             <a:ext cx="4448556" cy="196882"/>
           </a:xfrm>
           <a:prstGeom prst="rect">
@@ -4703,7 +4703,7 @@
                 <a:ea typeface="Segoe UI" pitchFamily="34" charset="-122"/>
                 <a:cs typeface="Segoe UI" pitchFamily="34" charset="-120"/>
               </a:rPr>
-              <a:t>Deploy lis-crs-spec-ack-svc.</a:t>
+              <a:t>Publish the APIM product and NetworkPolicy.</a:t>
             </a:r>
             <a:endParaRPr lang="en-US" sz="1125" dirty="0"/>
           </a:p>
@@ -4717,7 +4717,7 @@
         </p:nvSpPr>
         <p:spPr>
           <a:xfrm>
-            <a:off x="883920" y="4430554"/>
+            <a:off x="883920" y="4597575"/>
             <a:ext cx="228600" cy="228600"/>
           </a:xfrm>
           <a:prstGeom prst="ellipse">
@@ -4762,7 +4762,7 @@
         </p:nvSpPr>
         <p:spPr>
           <a:xfrm>
-            <a:off x="1222248" y="4457986"/>
+            <a:off x="1222248" y="4625007"/>
             <a:ext cx="4448556" cy="196882"/>
           </a:xfrm>
           <a:prstGeom prst="rect">
@@ -4790,7 +4790,7 @@
                 <a:ea typeface="Segoe UI" pitchFamily="34" charset="-122"/>
                 <a:cs typeface="Segoe UI" pitchFamily="34" charset="-120"/>
               </a:rPr>
-              <a:t>Publish the APIM product and NetworkPolicy.</a:t>
+              <a:t>Pilot CPS and HMS.</a:t>
             </a:r>
             <a:endParaRPr lang="en-US" sz="1125" dirty="0"/>
           </a:p>
@@ -4798,105 +4798,18 @@
       </p:sp>
       <p:sp>
         <p:nvSpPr>
-          <p:cNvPr id="17" name="Text 14"/>
-          <p:cNvSpPr/>
-          <p:nvPr/>
-        </p:nvSpPr>
-        <p:spPr>
-          <a:xfrm>
-            <a:off x="883920" y="4764595"/>
-            <a:ext cx="228600" cy="228600"/>
-          </a:xfrm>
-          <a:prstGeom prst="ellipse">
-            <a:avLst/>
-          </a:prstGeom>
-          <a:solidFill>
-            <a:srgbClr val="DCFCE7"/>
-          </a:solidFill>
-          <a:ln>
-            <a:solidFill>
-              <a:srgbClr val="DCFCE7"/>
-            </a:solidFill>
-          </a:ln>
-        </p:spPr>
-        <p:txBody>
-          <a:bodyPr wrap="square" lIns="0" tIns="0" rIns="0" bIns="0" rtlCol="0" anchor="ctr"/>
-          <a:lstStyle/>
-          <a:p>
-            <a:pPr algn="ctr" indent="0" marL="0">
-              <a:buNone/>
-            </a:pPr>
-            <a:r>
-              <a:rPr lang="en-US" sz="975" b="1" dirty="0">
-                <a:solidFill>
-                  <a:srgbClr val="15803D"/>
-                </a:solidFill>
-                <a:latin typeface="Segoe UI" pitchFamily="34" charset="0"/>
-                <a:ea typeface="Segoe UI" pitchFamily="34" charset="-122"/>
-                <a:cs typeface="Segoe UI" pitchFamily="34" charset="-120"/>
-              </a:rPr>
-              <a:t>6</a:t>
-            </a:r>
-            <a:endParaRPr lang="en-US" sz="975" dirty="0"/>
-          </a:p>
-        </p:txBody>
-      </p:sp>
-      <p:sp>
-        <p:nvSpPr>
-          <p:cNvPr id="18" name="Text 15"/>
-          <p:cNvSpPr/>
-          <p:nvPr/>
-        </p:nvSpPr>
-        <p:spPr>
-          <a:xfrm>
-            <a:off x="1222248" y="4792028"/>
-            <a:ext cx="4448556" cy="196882"/>
-          </a:xfrm>
-          <a:prstGeom prst="rect">
-            <a:avLst/>
-          </a:prstGeom>
-          <a:noFill/>
-          <a:ln/>
-        </p:spPr>
-        <p:txBody>
-          <a:bodyPr wrap="square" lIns="0" tIns="0" rIns="0" bIns="0" rtlCol="0" anchor="t"/>
-          <a:lstStyle/>
-          <a:p>
-            <a:pPr algn="l" indent="0" marL="0">
-              <a:lnSpc>
-                <a:spcPct val="115000"/>
-              </a:lnSpc>
-              <a:buNone/>
-            </a:pPr>
-            <a:r>
-              <a:rPr lang="en-US" sz="1125" dirty="0">
-                <a:solidFill>
-                  <a:srgbClr val="334155"/>
-                </a:solidFill>
-                <a:latin typeface="Segoe UI" pitchFamily="34" charset="0"/>
-                <a:ea typeface="Segoe UI" pitchFamily="34" charset="-122"/>
-                <a:cs typeface="Segoe UI" pitchFamily="34" charset="-120"/>
-              </a:rPr>
-              <a:t>Pilot CPS and HMS.</a:t>
-            </a:r>
-            <a:endParaRPr lang="en-US" sz="1125" dirty="0"/>
-          </a:p>
-        </p:txBody>
-      </p:sp>
-      <p:sp>
-        <p:nvSpPr>
-          <p:cNvPr id="19" name="Shape 16"/>
-          <p:cNvSpPr/>
-          <p:nvPr/>
-        </p:nvSpPr>
-        <p:spPr>
-          <a:xfrm>
-            <a:off x="6246876" y="2372011"/>
-            <a:ext cx="5335524" cy="3028378"/>
+          <p:cNvPr id="17" name="Shape 14"/>
+          <p:cNvSpPr/>
+          <p:nvPr/>
+        </p:nvSpPr>
+        <p:spPr>
+          <a:xfrm>
+            <a:off x="6246876" y="2539032"/>
+            <a:ext cx="5335524" cy="2694337"/>
           </a:xfrm>
           <a:prstGeom prst="roundRect">
             <a:avLst>
-              <a:gd name="adj" fmla="val 3623"/>
+              <a:gd name="adj" fmla="val 4073"/>
             </a:avLst>
           </a:prstGeom>
           <a:solidFill>
@@ -4912,7 +4825,7 @@
       </p:sp>
       <p:pic>
         <p:nvPicPr>
-          <p:cNvPr id="20" name="Image 1" descr="D:\Github\HA-Notes\LIS\skills\design-review-pptx\assets\icons\png\danger\rotate-left.png">    </p:cNvPr>
+          <p:cNvPr id="18" name="Image 1" descr="D:\Github\HA-Notes\LIS\skills\design-review-pptx\assets\icons\png\danger\rotate-left.png">    </p:cNvPr>
           <p:cNvPicPr>
             <a:picLocks noChangeAspect="1"/>
           </p:cNvPicPr>
@@ -4926,7 +4839,7 @@
         </p:blipFill>
         <p:spPr>
           <a:xfrm>
-            <a:off x="6521196" y="2678335"/>
+            <a:off x="6521196" y="2845356"/>
             <a:ext cx="265176" cy="265176"/>
           </a:xfrm>
           <a:prstGeom prst="rect">
@@ -4936,13 +4849,13 @@
       </p:pic>
       <p:sp>
         <p:nvSpPr>
-          <p:cNvPr id="21" name="Text 17"/>
-          <p:cNvSpPr/>
-          <p:nvPr/>
-        </p:nvSpPr>
-        <p:spPr>
-          <a:xfrm>
-            <a:off x="6886956" y="2664619"/>
+          <p:cNvPr id="19" name="Text 15"/>
+          <p:cNvSpPr/>
+          <p:nvPr/>
+        </p:nvSpPr>
+        <p:spPr>
+          <a:xfrm>
+            <a:off x="6886956" y="2831640"/>
             <a:ext cx="4421124" cy="292608"/>
           </a:xfrm>
           <a:prstGeom prst="rect">
@@ -4978,13 +4891,13 @@
       </p:sp>
       <p:sp>
         <p:nvSpPr>
-          <p:cNvPr id="22" name="Text 18"/>
-          <p:cNvSpPr/>
-          <p:nvPr/>
-        </p:nvSpPr>
-        <p:spPr>
-          <a:xfrm>
-            <a:off x="6521196" y="3094387"/>
+          <p:cNvPr id="20" name="Text 16"/>
+          <p:cNvSpPr/>
+          <p:nvPr/>
+        </p:nvSpPr>
+        <p:spPr>
+          <a:xfrm>
+            <a:off x="6521196" y="3261408"/>
             <a:ext cx="228600" cy="228600"/>
           </a:xfrm>
           <a:prstGeom prst="ellipse">
@@ -5023,13 +4936,13 @@
       </p:sp>
       <p:sp>
         <p:nvSpPr>
-          <p:cNvPr id="23" name="Text 19"/>
-          <p:cNvSpPr/>
-          <p:nvPr/>
-        </p:nvSpPr>
-        <p:spPr>
-          <a:xfrm>
-            <a:off x="6859524" y="3121819"/>
+          <p:cNvPr id="21" name="Text 17"/>
+          <p:cNvSpPr/>
+          <p:nvPr/>
+        </p:nvSpPr>
+        <p:spPr>
+          <a:xfrm>
+            <a:off x="6859524" y="3288840"/>
             <a:ext cx="4448556" cy="196882"/>
           </a:xfrm>
           <a:prstGeom prst="rect">
@@ -5065,13 +4978,13 @@
       </p:sp>
       <p:sp>
         <p:nvSpPr>
-          <p:cNvPr id="24" name="Text 20"/>
-          <p:cNvSpPr/>
-          <p:nvPr/>
-        </p:nvSpPr>
-        <p:spPr>
-          <a:xfrm>
-            <a:off x="6521196" y="3428429"/>
+          <p:cNvPr id="22" name="Text 18"/>
+          <p:cNvSpPr/>
+          <p:nvPr/>
+        </p:nvSpPr>
+        <p:spPr>
+          <a:xfrm>
+            <a:off x="6521196" y="3595449"/>
             <a:ext cx="228600" cy="228600"/>
           </a:xfrm>
           <a:prstGeom prst="ellipse">
@@ -5110,13 +5023,13 @@
       </p:sp>
       <p:sp>
         <p:nvSpPr>
-          <p:cNvPr id="25" name="Text 21"/>
-          <p:cNvSpPr/>
-          <p:nvPr/>
-        </p:nvSpPr>
-        <p:spPr>
-          <a:xfrm>
-            <a:off x="6859524" y="3455861"/>
+          <p:cNvPr id="23" name="Text 19"/>
+          <p:cNvSpPr/>
+          <p:nvPr/>
+        </p:nvSpPr>
+        <p:spPr>
+          <a:xfrm>
+            <a:off x="6859524" y="3622881"/>
             <a:ext cx="4448556" cy="196882"/>
           </a:xfrm>
           <a:prstGeom prst="rect">
@@ -5144,7 +5057,7 @@
                 <a:ea typeface="Segoe UI" pitchFamily="34" charset="-122"/>
                 <a:cs typeface="Segoe UI" pitchFamily="34" charset="-120"/>
               </a:rPr>
-              <a:t>Drop loe_specimen_sorter_map on full rollback.</a:t>
+              <a:t>Drop the map table if it was created.</a:t>
             </a:r>
             <a:endParaRPr lang="en-US" sz="1125" dirty="0"/>
           </a:p>
@@ -5152,13 +5065,13 @@
       </p:sp>
       <p:sp>
         <p:nvSpPr>
-          <p:cNvPr id="26" name="Text 22"/>
-          <p:cNvSpPr/>
-          <p:nvPr/>
-        </p:nvSpPr>
-        <p:spPr>
-          <a:xfrm>
-            <a:off x="6521196" y="3762470"/>
+          <p:cNvPr id="24" name="Text 20"/>
+          <p:cNvSpPr/>
+          <p:nvPr/>
+        </p:nvSpPr>
+        <p:spPr>
+          <a:xfrm>
+            <a:off x="6521196" y="3929491"/>
             <a:ext cx="228600" cy="228600"/>
           </a:xfrm>
           <a:prstGeom prst="ellipse">
@@ -5197,13 +5110,13 @@
       </p:sp>
       <p:sp>
         <p:nvSpPr>
-          <p:cNvPr id="27" name="Text 23"/>
-          <p:cNvSpPr/>
-          <p:nvPr/>
-        </p:nvSpPr>
-        <p:spPr>
-          <a:xfrm>
-            <a:off x="6859524" y="3789902"/>
+          <p:cNvPr id="25" name="Text 21"/>
+          <p:cNvSpPr/>
+          <p:nvPr/>
+        </p:nvSpPr>
+        <p:spPr>
+          <a:xfrm>
+            <a:off x="6859524" y="3956923"/>
             <a:ext cx="4448556" cy="196882"/>
           </a:xfrm>
           <a:prstGeom prst="rect">
@@ -8379,7 +8292,7 @@
                 <a:ea typeface="Segoe UI Semibold" pitchFamily="34" charset="-122"/>
                 <a:cs typeface="Segoe UI Semibold" pitchFamily="34" charset="-120"/>
               </a:rPr>
-              <a:t>One POST, the screen logic behind it, one map table</a:t>
+              <a:t>One POST, the screen logic behind it, workbench first</a:t>
             </a:r>
             <a:endParaRPr lang="en-US" sz="2400" dirty="0"/>
           </a:p>
@@ -8782,7 +8695,7 @@
                 <a:ea typeface="Segoe UI Semibold" pitchFamily="34" charset="-122"/>
                 <a:cs typeface="Segoe UI Semibold" pitchFamily="34" charset="-120"/>
               </a:rPr>
-              <a:t>Sorter map</a:t>
+              <a:t>Workbench first</a:t>
             </a:r>
             <a:endParaRPr lang="en-US" sz="1350" dirty="0"/>
           </a:p>
@@ -8824,7 +8737,7 @@
                 <a:ea typeface="Segoe UI" pitchFamily="34" charset="-122"/>
                 <a:cs typeface="Segoe UI" pitchFamily="34" charset="-120"/>
               </a:rPr>
-              <a:t>• loe_specimen_sorter_map</a:t>
+              <a:t>• sorterId = wkbh_station_name</a:t>
             </a:r>
             <a:endParaRPr lang="en-US" sz="1200" dirty="0"/>
           </a:p>
@@ -8844,7 +8757,27 @@
                 <a:ea typeface="Segoe UI" pitchFamily="34" charset="-122"/>
                 <a:cs typeface="Segoe UI" pitchFamily="34" charset="-120"/>
               </a:rPr>
-              <a:t>• Sorter id (PK) → user, hospital, workbench</a:t>
+              <a:t>• User = wkbh_id</a:t>
+            </a:r>
+            <a:endParaRPr lang="en-US" sz="1200" dirty="0"/>
+          </a:p>
+          <a:p>
+            <a:pPr algn="l" indent="0" marL="0">
+              <a:lnSpc>
+                <a:spcPct val="120000"/>
+              </a:lnSpc>
+              <a:buNone/>
+            </a:pPr>
+            <a:r>
+              <a:rPr lang="en-US" sz="1200" dirty="0">
+                <a:solidFill>
+                  <a:srgbClr val="475569"/>
+                </a:solidFill>
+                <a:latin typeface="Segoe UI" pitchFamily="34" charset="0"/>
+                <a:ea typeface="Segoe UI" pitchFamily="34" charset="-122"/>
+                <a:cs typeface="Segoe UI" pitchFamily="34" charset="-120"/>
+              </a:rPr>
+              <a:t>• Map only if hospital omitted</a:t>
             </a:r>
             <a:endParaRPr lang="en-US" sz="1200" dirty="0"/>
           </a:p>
@@ -8979,7 +8912,7 @@
                 <a:ea typeface="Segoe UI" pitchFamily="34" charset="-122"/>
                 <a:cs typeface="Segoe UI" pitchFamily="34" charset="-120"/>
               </a:rPr>
-              <a:t>• SORT_* plus REG and SEND_OUT</a:t>
+              <a:t>• New SORT_* audits on LOE_AUDIT_TRAIL</a:t>
             </a:r>
             <a:endParaRPr lang="en-US" sz="1200" dirty="0"/>
           </a:p>
@@ -8999,7 +8932,7 @@
                 <a:ea typeface="Segoe UI" pitchFamily="34" charset="-122"/>
                 <a:cs typeface="Segoe UI" pitchFamily="34" charset="-120"/>
               </a:rPr>
-              <a:t>• Same today's REG and SEND_OUT on LOE_AUDIT_TRAIL</a:t>
+              <a:t>• Same today's REG and SEND_OUT</a:t>
             </a:r>
             <a:endParaRPr lang="en-US" sz="1200" dirty="0"/>
           </a:p>
@@ -11188,7 +11121,7 @@
         </p:nvSpPr>
         <p:spPr>
           <a:xfrm>
-            <a:off x="6781800" y="2403729"/>
+            <a:off x="6781800" y="2318004"/>
             <a:ext cx="4800600" cy="884682"/>
           </a:xfrm>
           <a:prstGeom prst="roundRect">
@@ -11223,7 +11156,7 @@
         </p:blipFill>
         <p:spPr>
           <a:xfrm>
-            <a:off x="6982968" y="2632329"/>
+            <a:off x="6982968" y="2546604"/>
             <a:ext cx="219456" cy="219456"/>
           </a:xfrm>
           <a:prstGeom prst="rect">
@@ -11239,7 +11172,7 @@
         </p:nvSpPr>
         <p:spPr>
           <a:xfrm>
-            <a:off x="7293864" y="2604897"/>
+            <a:off x="7293864" y="2519172"/>
             <a:ext cx="4087368" cy="274320"/>
           </a:xfrm>
           <a:prstGeom prst="rect">
@@ -11281,7 +11214,7 @@
         </p:nvSpPr>
         <p:spPr>
           <a:xfrm>
-            <a:off x="6982968" y="2897505"/>
+            <a:off x="6982968" y="2811780"/>
             <a:ext cx="4398264" cy="244602"/>
           </a:xfrm>
           <a:prstGeom prst="rect">
@@ -11309,7 +11242,7 @@
                 <a:ea typeface="Segoe UI" pitchFamily="34" charset="-122"/>
                 <a:cs typeface="Segoe UI" pitchFamily="34" charset="-120"/>
               </a:rPr>
-              <a:t>x-gateway-apikey and x-ha-hospcode. No Hub JWT.</a:t>
+              <a:t>x-gateway-apikey and x-ha-hospcode.</a:t>
             </a:r>
             <a:endParaRPr lang="en-US" sz="1125" dirty="0"/>
           </a:p>
@@ -11323,12 +11256,12 @@
         </p:nvSpPr>
         <p:spPr>
           <a:xfrm>
-            <a:off x="6781800" y="3443859"/>
-            <a:ext cx="4800600" cy="884682"/>
+            <a:off x="6781800" y="3358134"/>
+            <a:ext cx="4800600" cy="1056132"/>
           </a:xfrm>
           <a:prstGeom prst="roundRect">
             <a:avLst>
-              <a:gd name="adj" fmla="val 12403"/>
+              <a:gd name="adj" fmla="val 10390"/>
             </a:avLst>
           </a:prstGeom>
           <a:solidFill>
@@ -11358,7 +11291,7 @@
         </p:blipFill>
         <p:spPr>
           <a:xfrm>
-            <a:off x="6982968" y="3672459"/>
+            <a:off x="6982968" y="3586734"/>
             <a:ext cx="219456" cy="219456"/>
           </a:xfrm>
           <a:prstGeom prst="rect">
@@ -11374,7 +11307,7 @@
         </p:nvSpPr>
         <p:spPr>
           <a:xfrm>
-            <a:off x="7293864" y="3645027"/>
+            <a:off x="7293864" y="3559302"/>
             <a:ext cx="4087368" cy="274320"/>
           </a:xfrm>
           <a:prstGeom prst="rect">
@@ -11402,7 +11335,7 @@
                 <a:ea typeface="Segoe UI Semibold" pitchFamily="34" charset="-122"/>
                 <a:cs typeface="Segoe UI Semibold" pitchFamily="34" charset="-120"/>
               </a:rPr>
-              <a:t>Hospital is optional</a:t>
+              <a:t>Hospital sent skips the map</a:t>
             </a:r>
             <a:endParaRPr lang="en-US" sz="1275" dirty="0"/>
           </a:p>
@@ -11416,8 +11349,8 @@
         </p:nvSpPr>
         <p:spPr>
           <a:xfrm>
-            <a:off x="6982968" y="3937635"/>
-            <a:ext cx="4398264" cy="244602"/>
+            <a:off x="6982968" y="3851910"/>
+            <a:ext cx="4398264" cy="416052"/>
           </a:xfrm>
           <a:prstGeom prst="rect">
             <a:avLst/>
@@ -11444,7 +11377,7 @@
                 <a:ea typeface="Segoe UI" pitchFamily="34" charset="-122"/>
                 <a:cs typeface="Segoe UI" pitchFamily="34" charset="-120"/>
               </a:rPr>
-              <a:t>Omitted: loesort_hosp. Different from the map: Failure.</a:t>
+              <a:t>Sent: workbench only. Omitted: loesort_hosp. Hosp mismatch: Failure.</a:t>
             </a:r>
             <a:endParaRPr lang="en-US" sz="1125" dirty="0"/>
           </a:p>
@@ -11458,7 +11391,7 @@
         </p:nvSpPr>
         <p:spPr>
           <a:xfrm>
-            <a:off x="6781800" y="4483989"/>
+            <a:off x="6781800" y="4569714"/>
             <a:ext cx="4800600" cy="884682"/>
           </a:xfrm>
           <a:prstGeom prst="roundRect">
@@ -11493,7 +11426,7 @@
         </p:blipFill>
         <p:spPr>
           <a:xfrm>
-            <a:off x="6982968" y="4712589"/>
+            <a:off x="6982968" y="4798314"/>
             <a:ext cx="219456" cy="219456"/>
           </a:xfrm>
           <a:prstGeom prst="rect">
@@ -11509,7 +11442,7 @@
         </p:nvSpPr>
         <p:spPr>
           <a:xfrm>
-            <a:off x="7293864" y="4685157"/>
+            <a:off x="7293864" y="4770882"/>
             <a:ext cx="4087368" cy="274320"/>
           </a:xfrm>
           <a:prstGeom prst="rect">
@@ -11551,7 +11484,7 @@
         </p:nvSpPr>
         <p:spPr>
           <a:xfrm>
-            <a:off x="6982968" y="4977765"/>
+            <a:off x="6982968" y="5063490"/>
             <a:ext cx="4398264" cy="244602"/>
           </a:xfrm>
           <a:prstGeom prst="rect">
@@ -11689,7 +11622,7 @@
                 <a:ea typeface="Segoe UI Semibold" pitchFamily="34" charset="-122"/>
                 <a:cs typeface="Segoe UI Semibold" pitchFamily="34" charset="-120"/>
               </a:rPr>
-              <a:t>User and workbench come from the sorter id, not a PC</a:t>
+              <a:t>User and workbench come from station name, not a PC</a:t>
             </a:r>
             <a:endParaRPr lang="en-US" sz="2400" dirty="0"/>
           </a:p>
@@ -12098,7 +12031,7 @@
                 <a:ea typeface="Segoe UI Semibold" pitchFamily="34" charset="-122"/>
                 <a:cs typeface="Segoe UI Semibold" pitchFamily="34" charset="-120"/>
               </a:rPr>
-              <a:t>Sorter id decides</a:t>
+              <a:t>Station name decides</a:t>
             </a:r>
             <a:endParaRPr lang="en-US" sz="1500" dirty="0"/>
           </a:p>
@@ -12157,7 +12090,7 @@
                 <a:ea typeface="Segoe UI" pitchFamily="34" charset="-122"/>
                 <a:cs typeface="Segoe UI" pitchFamily="34" charset="-120"/>
               </a:rPr>
-              <a:t>loesort_usercode on the map</a:t>
+              <a:t>wkbh_id (same as LIS usercode)</a:t>
             </a:r>
             <a:endParaRPr lang="en-US" sz="1200" dirty="0"/>
           </a:p>
@@ -12216,7 +12149,7 @@
                 <a:ea typeface="Segoe UI" pitchFamily="34" charset="-122"/>
                 <a:cs typeface="Segoe UI" pitchFamily="34" charset="-120"/>
               </a:rPr>
-              <a:t>map wkbh_id plus the order's lab</a:t>
+              <a:t>wkbh_station_name = sorterId</a:t>
             </a:r>
             <a:endParaRPr lang="en-US" sz="1200" dirty="0"/>
           </a:p>
@@ -12258,7 +12191,7 @@
                 <a:ea typeface="Segoe UI" pitchFamily="34" charset="-122"/>
                 <a:cs typeface="Segoe UI" pitchFamily="34" charset="-120"/>
               </a:rPr>
-              <a:t>Hospital: </a:t>
+              <a:t>Hospital sent: </a:t>
             </a:r>
             <a:pPr algn="l" indent="0" marL="0">
               <a:lnSpc>
@@ -12275,7 +12208,7 @@
                 <a:ea typeface="Segoe UI" pitchFamily="34" charset="-122"/>
                 <a:cs typeface="Segoe UI" pitchFamily="34" charset="-120"/>
               </a:rPr>
-              <a:t>request value, else loesort_hosp</a:t>
+              <a:t>skip the map</a:t>
             </a:r>
             <a:endParaRPr lang="en-US" sz="1200" dirty="0"/>
           </a:p>
@@ -12317,7 +12250,7 @@
                 <a:ea typeface="Segoe UI" pitchFamily="34" charset="-122"/>
                 <a:cs typeface="Segoe UI" pitchFamily="34" charset="-120"/>
               </a:rPr>
-              <a:t>Server: </a:t>
+              <a:t>Hospital omitted: </a:t>
             </a:r>
             <a:pPr algn="l" indent="0" marL="0">
               <a:lnSpc>
@@ -12334,7 +12267,7 @@
                 <a:ea typeface="Segoe UI" pitchFamily="34" charset="-122"/>
                 <a:cs typeface="Segoe UI" pitchFamily="34" charset="-120"/>
               </a:rPr>
-              <a:t>HospitalService from hosp and lab</a:t>
+              <a:t>loesort_hosp only</a:t>
             </a:r>
             <a:endParaRPr lang="en-US" sz="1200" dirty="0"/>
           </a:p>
@@ -12444,7 +12377,7 @@
                 <a:ea typeface="Segoe UI Semibold" pitchFamily="34" charset="-122"/>
                 <a:cs typeface="Segoe UI Semibold" pitchFamily="34" charset="-120"/>
               </a:rPr>
-              <a:t>Sorter id is the PK. Lab and server stay off the map</a:t>
+              <a:t>Hospital sent: workbench only. Map is hospital fallback</a:t>
             </a:r>
             <a:endParaRPr lang="en-US" sz="2400" dirty="0"/>
           </a:p>
@@ -12465,7 +12398,7 @@
           </p:nvPr>
         </p:nvGraphicFramePr>
         <p:xfrm>
-          <a:off x="609600" y="2002536"/>
+          <a:off x="609600" y="1773936"/>
           <a:ext cx="10972800" cy="914400"/>
         </p:xfrm>
         <a:graphic>
@@ -12647,6 +12580,462 @@
                           <a:ea typeface="Consolas" pitchFamily="34" charset="-122"/>
                           <a:cs typeface="Consolas" pitchFamily="34" charset="-120"/>
                         </a:rPr>
+                        <a:t>wkbh_station_name</a:t>
+                      </a:r>
+                      <a:endParaRPr lang="en-US" sz="1125" dirty="0">
+                        <a:latin typeface="Consolas" charset="0"/>
+                        <a:ea typeface="Consolas" charset="0"/>
+                        <a:cs typeface="Consolas" charset="0"/>
+                      </a:endParaRPr>
+                    </a:p>
+                  </a:txBody>
+                  <a:tcPr marL="201168" marR="201168" marT="54864" marB="54864" anchor="ctr">
+                    <a:lnL w="0" cap="flat" cmpd="sng" algn="ctr">
+                      <a:noFill/>
+                    </a:lnL>
+                    <a:lnR w="0" cap="flat" cmpd="sng" algn="ctr">
+                      <a:noFill/>
+                    </a:lnR>
+                    <a:lnT w="0" cap="flat" cmpd="sng" algn="ctr">
+                      <a:noFill/>
+                    </a:lnT>
+                    <a:lnB w="9525" cap="flat" cmpd="sng" algn="ctr">
+                      <a:solidFill>
+                        <a:srgbClr val="E2E8F0"/>
+                      </a:solidFill>
+                      <a:prstDash val="solid"/>
+                      <a:round/>
+                      <a:headEnd type="none" w="med" len="med"/>
+                      <a:tailEnd type="none" w="med" len="med"/>
+                    </a:lnB>
+                    <a:solidFill>
+                      <a:srgbClr val="FFFFFF"/>
+                    </a:solidFill>
+                  </a:tcPr>
+                </a:tc>
+                <a:tc>
+                  <a:txBody>
+                    <a:bodyPr/>
+                    <a:lstStyle/>
+                    <a:p>
+                      <a:pPr algn="l" indent="0" marL="0">
+                        <a:buNone/>
+                      </a:pPr>
+                      <a:r>
+                        <a:rPr lang="en-US" sz="1125" dirty="0">
+                          <a:solidFill>
+                            <a:srgbClr val="475569"/>
+                          </a:solidFill>
+                          <a:latin typeface="Segoe UI" pitchFamily="34" charset="0"/>
+                          <a:ea typeface="Segoe UI" pitchFamily="34" charset="-122"/>
+                          <a:cs typeface="Segoe UI" pitchFamily="34" charset="-120"/>
+                        </a:rPr>
+                        <a:t>workbench</a:t>
+                      </a:r>
+                      <a:endParaRPr lang="en-US" sz="1125" dirty="0">
+                        <a:latin typeface="Segoe UI" charset="0"/>
+                        <a:ea typeface="Segoe UI" charset="0"/>
+                        <a:cs typeface="Segoe UI" charset="0"/>
+                      </a:endParaRPr>
+                    </a:p>
+                  </a:txBody>
+                  <a:tcPr marL="201168" marR="201168" marT="54864" marB="54864" anchor="ctr">
+                    <a:lnL w="0" cap="flat" cmpd="sng" algn="ctr">
+                      <a:noFill/>
+                    </a:lnL>
+                    <a:lnR w="0" cap="flat" cmpd="sng" algn="ctr">
+                      <a:noFill/>
+                    </a:lnR>
+                    <a:lnT w="0" cap="flat" cmpd="sng" algn="ctr">
+                      <a:noFill/>
+                    </a:lnT>
+                    <a:lnB w="9525" cap="flat" cmpd="sng" algn="ctr">
+                      <a:solidFill>
+                        <a:srgbClr val="E2E8F0"/>
+                      </a:solidFill>
+                      <a:prstDash val="solid"/>
+                      <a:round/>
+                      <a:headEnd type="none" w="med" len="med"/>
+                      <a:tailEnd type="none" w="med" len="med"/>
+                    </a:lnB>
+                    <a:solidFill>
+                      <a:srgbClr val="FFFFFF"/>
+                    </a:solidFill>
+                  </a:tcPr>
+                </a:tc>
+                <a:tc>
+                  <a:txBody>
+                    <a:bodyPr/>
+                    <a:lstStyle/>
+                    <a:p>
+                      <a:pPr algn="l" indent="0" marL="0">
+                        <a:buNone/>
+                      </a:pPr>
+                      <a:r>
+                        <a:rPr lang="en-US" sz="1125" dirty="0">
+                          <a:solidFill>
+                            <a:srgbClr val="475569"/>
+                          </a:solidFill>
+                          <a:latin typeface="Segoe UI" pitchFamily="34" charset="0"/>
+                          <a:ea typeface="Segoe UI" pitchFamily="34" charset="-122"/>
+                          <a:cs typeface="Segoe UI" pitchFamily="34" charset="-120"/>
+                        </a:rPr>
+                        <a:t>Equals request sorterId</a:t>
+                      </a:r>
+                      <a:endParaRPr lang="en-US" sz="1125" dirty="0">
+                        <a:latin typeface="Segoe UI" charset="0"/>
+                        <a:ea typeface="Segoe UI" charset="0"/>
+                        <a:cs typeface="Segoe UI" charset="0"/>
+                      </a:endParaRPr>
+                    </a:p>
+                  </a:txBody>
+                  <a:tcPr marL="201168" marR="201168" marT="54864" marB="54864" anchor="ctr">
+                    <a:lnL w="0" cap="flat" cmpd="sng" algn="ctr">
+                      <a:noFill/>
+                    </a:lnL>
+                    <a:lnR w="0" cap="flat" cmpd="sng" algn="ctr">
+                      <a:noFill/>
+                    </a:lnR>
+                    <a:lnT w="0" cap="flat" cmpd="sng" algn="ctr">
+                      <a:noFill/>
+                    </a:lnT>
+                    <a:lnB w="9525" cap="flat" cmpd="sng" algn="ctr">
+                      <a:solidFill>
+                        <a:srgbClr val="E2E8F0"/>
+                      </a:solidFill>
+                      <a:prstDash val="solid"/>
+                      <a:round/>
+                      <a:headEnd type="none" w="med" len="med"/>
+                      <a:tailEnd type="none" w="med" len="med"/>
+                    </a:lnB>
+                    <a:solidFill>
+                      <a:srgbClr val="FFFFFF"/>
+                    </a:solidFill>
+                  </a:tcPr>
+                </a:tc>
+              </a:tr>
+              <a:tr h="457200">
+                <a:tc>
+                  <a:txBody>
+                    <a:bodyPr/>
+                    <a:lstStyle/>
+                    <a:p>
+                      <a:pPr algn="l" indent="0" marL="0">
+                        <a:buNone/>
+                      </a:pPr>
+                      <a:r>
+                        <a:rPr lang="en-US" sz="1125" dirty="0">
+                          <a:solidFill>
+                            <a:srgbClr val="0284C7"/>
+                          </a:solidFill>
+                          <a:latin typeface="Consolas" pitchFamily="34" charset="0"/>
+                          <a:ea typeface="Consolas" pitchFamily="34" charset="-122"/>
+                          <a:cs typeface="Consolas" pitchFamily="34" charset="-120"/>
+                        </a:rPr>
+                        <a:t>wkbh_id</a:t>
+                      </a:r>
+                      <a:endParaRPr lang="en-US" sz="1125" dirty="0">
+                        <a:latin typeface="Consolas" charset="0"/>
+                        <a:ea typeface="Consolas" charset="0"/>
+                        <a:cs typeface="Consolas" charset="0"/>
+                      </a:endParaRPr>
+                    </a:p>
+                  </a:txBody>
+                  <a:tcPr marL="201168" marR="201168" marT="54864" marB="54864" anchor="ctr">
+                    <a:lnL w="0" cap="flat" cmpd="sng" algn="ctr">
+                      <a:noFill/>
+                    </a:lnL>
+                    <a:lnR w="0" cap="flat" cmpd="sng" algn="ctr">
+                      <a:noFill/>
+                    </a:lnR>
+                    <a:lnT w="0" cap="flat" cmpd="sng" algn="ctr">
+                      <a:noFill/>
+                    </a:lnT>
+                    <a:lnB w="9525" cap="flat" cmpd="sng" algn="ctr">
+                      <a:solidFill>
+                        <a:srgbClr val="E2E8F0"/>
+                      </a:solidFill>
+                      <a:prstDash val="solid"/>
+                      <a:round/>
+                      <a:headEnd type="none" w="med" len="med"/>
+                      <a:tailEnd type="none" w="med" len="med"/>
+                    </a:lnB>
+                    <a:solidFill>
+                      <a:srgbClr val="FFFFFF"/>
+                    </a:solidFill>
+                  </a:tcPr>
+                </a:tc>
+                <a:tc>
+                  <a:txBody>
+                    <a:bodyPr/>
+                    <a:lstStyle/>
+                    <a:p>
+                      <a:pPr algn="l" indent="0" marL="0">
+                        <a:buNone/>
+                      </a:pPr>
+                      <a:r>
+                        <a:rPr lang="en-US" sz="1125" dirty="0">
+                          <a:solidFill>
+                            <a:srgbClr val="475569"/>
+                          </a:solidFill>
+                          <a:latin typeface="Segoe UI" pitchFamily="34" charset="0"/>
+                          <a:ea typeface="Segoe UI" pitchFamily="34" charset="-122"/>
+                          <a:cs typeface="Segoe UI" pitchFamily="34" charset="-120"/>
+                        </a:rPr>
+                        <a:t>workbench</a:t>
+                      </a:r>
+                      <a:endParaRPr lang="en-US" sz="1125" dirty="0">
+                        <a:latin typeface="Segoe UI" charset="0"/>
+                        <a:ea typeface="Segoe UI" charset="0"/>
+                        <a:cs typeface="Segoe UI" charset="0"/>
+                      </a:endParaRPr>
+                    </a:p>
+                  </a:txBody>
+                  <a:tcPr marL="201168" marR="201168" marT="54864" marB="54864" anchor="ctr">
+                    <a:lnL w="0" cap="flat" cmpd="sng" algn="ctr">
+                      <a:noFill/>
+                    </a:lnL>
+                    <a:lnR w="0" cap="flat" cmpd="sng" algn="ctr">
+                      <a:noFill/>
+                    </a:lnR>
+                    <a:lnT w="0" cap="flat" cmpd="sng" algn="ctr">
+                      <a:noFill/>
+                    </a:lnT>
+                    <a:lnB w="9525" cap="flat" cmpd="sng" algn="ctr">
+                      <a:solidFill>
+                        <a:srgbClr val="E2E8F0"/>
+                      </a:solidFill>
+                      <a:prstDash val="solid"/>
+                      <a:round/>
+                      <a:headEnd type="none" w="med" len="med"/>
+                      <a:tailEnd type="none" w="med" len="med"/>
+                    </a:lnB>
+                    <a:solidFill>
+                      <a:srgbClr val="FFFFFF"/>
+                    </a:solidFill>
+                  </a:tcPr>
+                </a:tc>
+                <a:tc>
+                  <a:txBody>
+                    <a:bodyPr/>
+                    <a:lstStyle/>
+                    <a:p>
+                      <a:pPr algn="l" indent="0" marL="0">
+                        <a:buNone/>
+                      </a:pPr>
+                      <a:r>
+                        <a:rPr lang="en-US" sz="1125" dirty="0">
+                          <a:solidFill>
+                            <a:srgbClr val="475569"/>
+                          </a:solidFill>
+                          <a:latin typeface="Segoe UI" pitchFamily="34" charset="0"/>
+                          <a:ea typeface="Segoe UI" pitchFamily="34" charset="-122"/>
+                          <a:cs typeface="Segoe UI" pitchFamily="34" charset="-120"/>
+                        </a:rPr>
+                        <a:t>LIS user; PK with wkbh_labno</a:t>
+                      </a:r>
+                      <a:endParaRPr lang="en-US" sz="1125" dirty="0">
+                        <a:latin typeface="Segoe UI" charset="0"/>
+                        <a:ea typeface="Segoe UI" charset="0"/>
+                        <a:cs typeface="Segoe UI" charset="0"/>
+                      </a:endParaRPr>
+                    </a:p>
+                  </a:txBody>
+                  <a:tcPr marL="201168" marR="201168" marT="54864" marB="54864" anchor="ctr">
+                    <a:lnL w="0" cap="flat" cmpd="sng" algn="ctr">
+                      <a:noFill/>
+                    </a:lnL>
+                    <a:lnR w="0" cap="flat" cmpd="sng" algn="ctr">
+                      <a:noFill/>
+                    </a:lnR>
+                    <a:lnT w="0" cap="flat" cmpd="sng" algn="ctr">
+                      <a:noFill/>
+                    </a:lnT>
+                    <a:lnB w="9525" cap="flat" cmpd="sng" algn="ctr">
+                      <a:solidFill>
+                        <a:srgbClr val="E2E8F0"/>
+                      </a:solidFill>
+                      <a:prstDash val="solid"/>
+                      <a:round/>
+                      <a:headEnd type="none" w="med" len="med"/>
+                      <a:tailEnd type="none" w="med" len="med"/>
+                    </a:lnB>
+                    <a:solidFill>
+                      <a:srgbClr val="FFFFFF"/>
+                    </a:solidFill>
+                  </a:tcPr>
+                </a:tc>
+              </a:tr>
+              <a:tr h="457200">
+                <a:tc>
+                  <a:txBody>
+                    <a:bodyPr/>
+                    <a:lstStyle/>
+                    <a:p>
+                      <a:pPr algn="l" indent="0" marL="0">
+                        <a:buNone/>
+                      </a:pPr>
+                      <a:r>
+                        <a:rPr lang="en-US" sz="1125" dirty="0">
+                          <a:solidFill>
+                            <a:srgbClr val="0284C7"/>
+                          </a:solidFill>
+                          <a:latin typeface="Consolas" pitchFamily="34" charset="0"/>
+                          <a:ea typeface="Consolas" pitchFamily="34" charset="-122"/>
+                          <a:cs typeface="Consolas" pitchFamily="34" charset="-120"/>
+                        </a:rPr>
+                        <a:t>wkbh_hosp</a:t>
+                      </a:r>
+                      <a:endParaRPr lang="en-US" sz="1125" dirty="0">
+                        <a:latin typeface="Consolas" charset="0"/>
+                        <a:ea typeface="Consolas" charset="0"/>
+                        <a:cs typeface="Consolas" charset="0"/>
+                      </a:endParaRPr>
+                    </a:p>
+                  </a:txBody>
+                  <a:tcPr marL="201168" marR="201168" marT="54864" marB="54864" anchor="ctr">
+                    <a:lnL w="0" cap="flat" cmpd="sng" algn="ctr">
+                      <a:noFill/>
+                    </a:lnL>
+                    <a:lnR w="0" cap="flat" cmpd="sng" algn="ctr">
+                      <a:noFill/>
+                    </a:lnR>
+                    <a:lnT w="0" cap="flat" cmpd="sng" algn="ctr">
+                      <a:noFill/>
+                    </a:lnT>
+                    <a:lnB w="9525" cap="flat" cmpd="sng" algn="ctr">
+                      <a:solidFill>
+                        <a:srgbClr val="E2E8F0"/>
+                      </a:solidFill>
+                      <a:prstDash val="solid"/>
+                      <a:round/>
+                      <a:headEnd type="none" w="med" len="med"/>
+                      <a:tailEnd type="none" w="med" len="med"/>
+                    </a:lnB>
+                    <a:solidFill>
+                      <a:srgbClr val="FFFFFF"/>
+                    </a:solidFill>
+                  </a:tcPr>
+                </a:tc>
+                <a:tc>
+                  <a:txBody>
+                    <a:bodyPr/>
+                    <a:lstStyle/>
+                    <a:p>
+                      <a:pPr algn="l" indent="0" marL="0">
+                        <a:buNone/>
+                      </a:pPr>
+                      <a:r>
+                        <a:rPr lang="en-US" sz="1125" dirty="0">
+                          <a:solidFill>
+                            <a:srgbClr val="475569"/>
+                          </a:solidFill>
+                          <a:latin typeface="Segoe UI" pitchFamily="34" charset="0"/>
+                          <a:ea typeface="Segoe UI" pitchFamily="34" charset="-122"/>
+                          <a:cs typeface="Segoe UI" pitchFamily="34" charset="-120"/>
+                        </a:rPr>
+                        <a:t>workbench</a:t>
+                      </a:r>
+                      <a:endParaRPr lang="en-US" sz="1125" dirty="0">
+                        <a:latin typeface="Segoe UI" charset="0"/>
+                        <a:ea typeface="Segoe UI" charset="0"/>
+                        <a:cs typeface="Segoe UI" charset="0"/>
+                      </a:endParaRPr>
+                    </a:p>
+                  </a:txBody>
+                  <a:tcPr marL="201168" marR="201168" marT="54864" marB="54864" anchor="ctr">
+                    <a:lnL w="0" cap="flat" cmpd="sng" algn="ctr">
+                      <a:noFill/>
+                    </a:lnL>
+                    <a:lnR w="0" cap="flat" cmpd="sng" algn="ctr">
+                      <a:noFill/>
+                    </a:lnR>
+                    <a:lnT w="0" cap="flat" cmpd="sng" algn="ctr">
+                      <a:noFill/>
+                    </a:lnT>
+                    <a:lnB w="9525" cap="flat" cmpd="sng" algn="ctr">
+                      <a:solidFill>
+                        <a:srgbClr val="E2E8F0"/>
+                      </a:solidFill>
+                      <a:prstDash val="solid"/>
+                      <a:round/>
+                      <a:headEnd type="none" w="med" len="med"/>
+                      <a:tailEnd type="none" w="med" len="med"/>
+                    </a:lnB>
+                    <a:solidFill>
+                      <a:srgbClr val="FFFFFF"/>
+                    </a:solidFill>
+                  </a:tcPr>
+                </a:tc>
+                <a:tc>
+                  <a:txBody>
+                    <a:bodyPr/>
+                    <a:lstStyle/>
+                    <a:p>
+                      <a:pPr algn="l" indent="0" marL="0">
+                        <a:buNone/>
+                      </a:pPr>
+                      <a:r>
+                        <a:rPr lang="en-US" sz="1125" dirty="0">
+                          <a:solidFill>
+                            <a:srgbClr val="475569"/>
+                          </a:solidFill>
+                          <a:latin typeface="Segoe UI" pitchFamily="34" charset="0"/>
+                          <a:ea typeface="Segoe UI" pitchFamily="34" charset="-122"/>
+                          <a:cs typeface="Segoe UI" pitchFamily="34" charset="-120"/>
+                        </a:rPr>
+                        <a:t>Must match request hospital</a:t>
+                      </a:r>
+                      <a:endParaRPr lang="en-US" sz="1125" dirty="0">
+                        <a:latin typeface="Segoe UI" charset="0"/>
+                        <a:ea typeface="Segoe UI" charset="0"/>
+                        <a:cs typeface="Segoe UI" charset="0"/>
+                      </a:endParaRPr>
+                    </a:p>
+                  </a:txBody>
+                  <a:tcPr marL="201168" marR="201168" marT="54864" marB="54864" anchor="ctr">
+                    <a:lnL w="0" cap="flat" cmpd="sng" algn="ctr">
+                      <a:noFill/>
+                    </a:lnL>
+                    <a:lnR w="0" cap="flat" cmpd="sng" algn="ctr">
+                      <a:noFill/>
+                    </a:lnR>
+                    <a:lnT w="0" cap="flat" cmpd="sng" algn="ctr">
+                      <a:noFill/>
+                    </a:lnT>
+                    <a:lnB w="9525" cap="flat" cmpd="sng" algn="ctr">
+                      <a:solidFill>
+                        <a:srgbClr val="E2E8F0"/>
+                      </a:solidFill>
+                      <a:prstDash val="solid"/>
+                      <a:round/>
+                      <a:headEnd type="none" w="med" len="med"/>
+                      <a:tailEnd type="none" w="med" len="med"/>
+                    </a:lnB>
+                    <a:solidFill>
+                      <a:srgbClr val="FFFFFF"/>
+                    </a:solidFill>
+                  </a:tcPr>
+                </a:tc>
+              </a:tr>
+              <a:tr h="457200">
+                <a:tc>
+                  <a:txBody>
+                    <a:bodyPr/>
+                    <a:lstStyle/>
+                    <a:p>
+                      <a:pPr algn="l" indent="0" marL="0">
+                        <a:buNone/>
+                      </a:pPr>
+                      <a:r>
+                        <a:rPr lang="en-US" sz="1125" dirty="0">
+                          <a:solidFill>
+                            <a:srgbClr val="0284C7"/>
+                          </a:solidFill>
+                          <a:latin typeface="Consolas" pitchFamily="34" charset="0"/>
+                          <a:ea typeface="Consolas" pitchFamily="34" charset="-122"/>
+                          <a:cs typeface="Consolas" pitchFamily="34" charset="-120"/>
+                        </a:rPr>
                         <a:t>loesort_sorter_id</a:t>
                       </a:r>
                       <a:endParaRPr lang="en-US" sz="1125" dirty="0">
@@ -12747,7 +13136,7 @@
                           <a:ea typeface="Segoe UI" pitchFamily="34" charset="-122"/>
                           <a:cs typeface="Segoe UI" pitchFamily="34" charset="-120"/>
                         </a:rPr>
-                        <a:t>Primary key; unique sorter identifier</a:t>
+                        <a:t>Fallback map PK; omit-hospital only</a:t>
                       </a:r>
                       <a:endParaRPr lang="en-US" sz="1125" dirty="0">
                         <a:latin typeface="Segoe UI" charset="0"/>
@@ -12818,14 +13207,8 @@
                     <a:lnT w="0" cap="flat" cmpd="sng" algn="ctr">
                       <a:noFill/>
                     </a:lnT>
-                    <a:lnB w="9525" cap="flat" cmpd="sng" algn="ctr">
-                      <a:solidFill>
-                        <a:srgbClr val="E2E8F0"/>
-                      </a:solidFill>
-                      <a:prstDash val="solid"/>
-                      <a:round/>
-                      <a:headEnd type="none" w="med" len="med"/>
-                      <a:tailEnd type="none" w="med" len="med"/>
+                    <a:lnB w="0" cap="flat" cmpd="sng" algn="ctr">
+                      <a:noFill/>
                     </a:lnB>
                     <a:solidFill>
                       <a:srgbClr val="FFFFFF"/>
@@ -12868,14 +13251,8 @@
                     <a:lnT w="0" cap="flat" cmpd="sng" algn="ctr">
                       <a:noFill/>
                     </a:lnT>
-                    <a:lnB w="9525" cap="flat" cmpd="sng" algn="ctr">
-                      <a:solidFill>
-                        <a:srgbClr val="E2E8F0"/>
-                      </a:solidFill>
-                      <a:prstDash val="solid"/>
-                      <a:round/>
-                      <a:headEnd type="none" w="med" len="med"/>
-                      <a:tailEnd type="none" w="med" len="med"/>
+                    <a:lnB w="0" cap="flat" cmpd="sng" algn="ctr">
+                      <a:noFill/>
                     </a:lnB>
                     <a:solidFill>
                       <a:srgbClr val="FFFFFF"/>
@@ -12899,299 +13276,7 @@
                           <a:ea typeface="Segoe UI" pitchFamily="34" charset="-122"/>
                           <a:cs typeface="Segoe UI" pitchFamily="34" charset="-120"/>
                         </a:rPr>
-                        <a:t>Hospital when the request omits it</a:t>
-                      </a:r>
-                      <a:endParaRPr lang="en-US" sz="1125" dirty="0">
-                        <a:latin typeface="Segoe UI" charset="0"/>
-                        <a:ea typeface="Segoe UI" charset="0"/>
-                        <a:cs typeface="Segoe UI" charset="0"/>
-                      </a:endParaRPr>
-                    </a:p>
-                  </a:txBody>
-                  <a:tcPr marL="201168" marR="201168" marT="54864" marB="54864" anchor="ctr">
-                    <a:lnL w="0" cap="flat" cmpd="sng" algn="ctr">
-                      <a:noFill/>
-                    </a:lnL>
-                    <a:lnR w="0" cap="flat" cmpd="sng" algn="ctr">
-                      <a:noFill/>
-                    </a:lnR>
-                    <a:lnT w="0" cap="flat" cmpd="sng" algn="ctr">
-                      <a:noFill/>
-                    </a:lnT>
-                    <a:lnB w="9525" cap="flat" cmpd="sng" algn="ctr">
-                      <a:solidFill>
-                        <a:srgbClr val="E2E8F0"/>
-                      </a:solidFill>
-                      <a:prstDash val="solid"/>
-                      <a:round/>
-                      <a:headEnd type="none" w="med" len="med"/>
-                      <a:tailEnd type="none" w="med" len="med"/>
-                    </a:lnB>
-                    <a:solidFill>
-                      <a:srgbClr val="FFFFFF"/>
-                    </a:solidFill>
-                  </a:tcPr>
-                </a:tc>
-              </a:tr>
-              <a:tr h="457200">
-                <a:tc>
-                  <a:txBody>
-                    <a:bodyPr/>
-                    <a:lstStyle/>
-                    <a:p>
-                      <a:pPr algn="l" indent="0" marL="0">
-                        <a:buNone/>
-                      </a:pPr>
-                      <a:r>
-                        <a:rPr lang="en-US" sz="1125" dirty="0">
-                          <a:solidFill>
-                            <a:srgbClr val="0284C7"/>
-                          </a:solidFill>
-                          <a:latin typeface="Consolas" pitchFamily="34" charset="0"/>
-                          <a:ea typeface="Consolas" pitchFamily="34" charset="-122"/>
-                          <a:cs typeface="Consolas" pitchFamily="34" charset="-120"/>
-                        </a:rPr>
-                        <a:t>loesort_usercode</a:t>
-                      </a:r>
-                      <a:endParaRPr lang="en-US" sz="1125" dirty="0">
-                        <a:latin typeface="Consolas" charset="0"/>
-                        <a:ea typeface="Consolas" charset="0"/>
-                        <a:cs typeface="Consolas" charset="0"/>
-                      </a:endParaRPr>
-                    </a:p>
-                  </a:txBody>
-                  <a:tcPr marL="201168" marR="201168" marT="54864" marB="54864" anchor="ctr">
-                    <a:lnL w="0" cap="flat" cmpd="sng" algn="ctr">
-                      <a:noFill/>
-                    </a:lnL>
-                    <a:lnR w="0" cap="flat" cmpd="sng" algn="ctr">
-                      <a:noFill/>
-                    </a:lnR>
-                    <a:lnT w="0" cap="flat" cmpd="sng" algn="ctr">
-                      <a:noFill/>
-                    </a:lnT>
-                    <a:lnB w="9525" cap="flat" cmpd="sng" algn="ctr">
-                      <a:solidFill>
-                        <a:srgbClr val="E2E8F0"/>
-                      </a:solidFill>
-                      <a:prstDash val="solid"/>
-                      <a:round/>
-                      <a:headEnd type="none" w="med" len="med"/>
-                      <a:tailEnd type="none" w="med" len="med"/>
-                    </a:lnB>
-                    <a:solidFill>
-                      <a:srgbClr val="FFFFFF"/>
-                    </a:solidFill>
-                  </a:tcPr>
-                </a:tc>
-                <a:tc>
-                  <a:txBody>
-                    <a:bodyPr/>
-                    <a:lstStyle/>
-                    <a:p>
-                      <a:pPr algn="l" indent="0" marL="0">
-                        <a:buNone/>
-                      </a:pPr>
-                      <a:r>
-                        <a:rPr lang="en-US" sz="1125" dirty="0">
-                          <a:solidFill>
-                            <a:srgbClr val="475569"/>
-                          </a:solidFill>
-                          <a:latin typeface="Segoe UI" pitchFamily="34" charset="0"/>
-                          <a:ea typeface="Segoe UI" pitchFamily="34" charset="-122"/>
-                          <a:cs typeface="Segoe UI" pitchFamily="34" charset="-120"/>
-                        </a:rPr>
-                        <a:t>VARCHAR2(12)</a:t>
-                      </a:r>
-                      <a:endParaRPr lang="en-US" sz="1125" dirty="0">
-                        <a:latin typeface="Segoe UI" charset="0"/>
-                        <a:ea typeface="Segoe UI" charset="0"/>
-                        <a:cs typeface="Segoe UI" charset="0"/>
-                      </a:endParaRPr>
-                    </a:p>
-                  </a:txBody>
-                  <a:tcPr marL="201168" marR="201168" marT="54864" marB="54864" anchor="ctr">
-                    <a:lnL w="0" cap="flat" cmpd="sng" algn="ctr">
-                      <a:noFill/>
-                    </a:lnL>
-                    <a:lnR w="0" cap="flat" cmpd="sng" algn="ctr">
-                      <a:noFill/>
-                    </a:lnR>
-                    <a:lnT w="0" cap="flat" cmpd="sng" algn="ctr">
-                      <a:noFill/>
-                    </a:lnT>
-                    <a:lnB w="9525" cap="flat" cmpd="sng" algn="ctr">
-                      <a:solidFill>
-                        <a:srgbClr val="E2E8F0"/>
-                      </a:solidFill>
-                      <a:prstDash val="solid"/>
-                      <a:round/>
-                      <a:headEnd type="none" w="med" len="med"/>
-                      <a:tailEnd type="none" w="med" len="med"/>
-                    </a:lnB>
-                    <a:solidFill>
-                      <a:srgbClr val="FFFFFF"/>
-                    </a:solidFill>
-                  </a:tcPr>
-                </a:tc>
-                <a:tc>
-                  <a:txBody>
-                    <a:bodyPr/>
-                    <a:lstStyle/>
-                    <a:p>
-                      <a:pPr algn="l" indent="0" marL="0">
-                        <a:buNone/>
-                      </a:pPr>
-                      <a:r>
-                        <a:rPr lang="en-US" sz="1125" dirty="0">
-                          <a:solidFill>
-                            <a:srgbClr val="475569"/>
-                          </a:solidFill>
-                          <a:latin typeface="Segoe UI" pitchFamily="34" charset="0"/>
-                          <a:ea typeface="Segoe UI" pitchFamily="34" charset="-122"/>
-                          <a:cs typeface="Segoe UI" pitchFamily="34" charset="-120"/>
-                        </a:rPr>
-                        <a:t>Dedicated sorter LIS user</a:t>
-                      </a:r>
-                      <a:endParaRPr lang="en-US" sz="1125" dirty="0">
-                        <a:latin typeface="Segoe UI" charset="0"/>
-                        <a:ea typeface="Segoe UI" charset="0"/>
-                        <a:cs typeface="Segoe UI" charset="0"/>
-                      </a:endParaRPr>
-                    </a:p>
-                  </a:txBody>
-                  <a:tcPr marL="201168" marR="201168" marT="54864" marB="54864" anchor="ctr">
-                    <a:lnL w="0" cap="flat" cmpd="sng" algn="ctr">
-                      <a:noFill/>
-                    </a:lnL>
-                    <a:lnR w="0" cap="flat" cmpd="sng" algn="ctr">
-                      <a:noFill/>
-                    </a:lnR>
-                    <a:lnT w="0" cap="flat" cmpd="sng" algn="ctr">
-                      <a:noFill/>
-                    </a:lnT>
-                    <a:lnB w="9525" cap="flat" cmpd="sng" algn="ctr">
-                      <a:solidFill>
-                        <a:srgbClr val="E2E8F0"/>
-                      </a:solidFill>
-                      <a:prstDash val="solid"/>
-                      <a:round/>
-                      <a:headEnd type="none" w="med" len="med"/>
-                      <a:tailEnd type="none" w="med" len="med"/>
-                    </a:lnB>
-                    <a:solidFill>
-                      <a:srgbClr val="FFFFFF"/>
-                    </a:solidFill>
-                  </a:tcPr>
-                </a:tc>
-              </a:tr>
-              <a:tr h="457200">
-                <a:tc>
-                  <a:txBody>
-                    <a:bodyPr/>
-                    <a:lstStyle/>
-                    <a:p>
-                      <a:pPr algn="l" indent="0" marL="0">
-                        <a:buNone/>
-                      </a:pPr>
-                      <a:r>
-                        <a:rPr lang="en-US" sz="1125" dirty="0">
-                          <a:solidFill>
-                            <a:srgbClr val="0284C7"/>
-                          </a:solidFill>
-                          <a:latin typeface="Consolas" pitchFamily="34" charset="0"/>
-                          <a:ea typeface="Consolas" pitchFamily="34" charset="-122"/>
-                          <a:cs typeface="Consolas" pitchFamily="34" charset="-120"/>
-                        </a:rPr>
-                        <a:t>loesort_workbench_id</a:t>
-                      </a:r>
-                      <a:endParaRPr lang="en-US" sz="1125" dirty="0">
-                        <a:latin typeface="Consolas" charset="0"/>
-                        <a:ea typeface="Consolas" charset="0"/>
-                        <a:cs typeface="Consolas" charset="0"/>
-                      </a:endParaRPr>
-                    </a:p>
-                  </a:txBody>
-                  <a:tcPr marL="201168" marR="201168" marT="54864" marB="54864" anchor="ctr">
-                    <a:lnL w="0" cap="flat" cmpd="sng" algn="ctr">
-                      <a:noFill/>
-                    </a:lnL>
-                    <a:lnR w="0" cap="flat" cmpd="sng" algn="ctr">
-                      <a:noFill/>
-                    </a:lnR>
-                    <a:lnT w="0" cap="flat" cmpd="sng" algn="ctr">
-                      <a:noFill/>
-                    </a:lnT>
-                    <a:lnB w="0" cap="flat" cmpd="sng" algn="ctr">
-                      <a:noFill/>
-                    </a:lnB>
-                    <a:solidFill>
-                      <a:srgbClr val="FFFFFF"/>
-                    </a:solidFill>
-                  </a:tcPr>
-                </a:tc>
-                <a:tc>
-                  <a:txBody>
-                    <a:bodyPr/>
-                    <a:lstStyle/>
-                    <a:p>
-                      <a:pPr algn="l" indent="0" marL="0">
-                        <a:buNone/>
-                      </a:pPr>
-                      <a:r>
-                        <a:rPr lang="en-US" sz="1125" dirty="0">
-                          <a:solidFill>
-                            <a:srgbClr val="475569"/>
-                          </a:solidFill>
-                          <a:latin typeface="Segoe UI" pitchFamily="34" charset="0"/>
-                          <a:ea typeface="Segoe UI" pitchFamily="34" charset="-122"/>
-                          <a:cs typeface="Segoe UI" pitchFamily="34" charset="-120"/>
-                        </a:rPr>
-                        <a:t>VARCHAR2(8)</a:t>
-                      </a:r>
-                      <a:endParaRPr lang="en-US" sz="1125" dirty="0">
-                        <a:latin typeface="Segoe UI" charset="0"/>
-                        <a:ea typeface="Segoe UI" charset="0"/>
-                        <a:cs typeface="Segoe UI" charset="0"/>
-                      </a:endParaRPr>
-                    </a:p>
-                  </a:txBody>
-                  <a:tcPr marL="201168" marR="201168" marT="54864" marB="54864" anchor="ctr">
-                    <a:lnL w="0" cap="flat" cmpd="sng" algn="ctr">
-                      <a:noFill/>
-                    </a:lnL>
-                    <a:lnR w="0" cap="flat" cmpd="sng" algn="ctr">
-                      <a:noFill/>
-                    </a:lnR>
-                    <a:lnT w="0" cap="flat" cmpd="sng" algn="ctr">
-                      <a:noFill/>
-                    </a:lnT>
-                    <a:lnB w="0" cap="flat" cmpd="sng" algn="ctr">
-                      <a:noFill/>
-                    </a:lnB>
-                    <a:solidFill>
-                      <a:srgbClr val="FFFFFF"/>
-                    </a:solidFill>
-                  </a:tcPr>
-                </a:tc>
-                <a:tc>
-                  <a:txBody>
-                    <a:bodyPr/>
-                    <a:lstStyle/>
-                    <a:p>
-                      <a:pPr algn="l" indent="0" marL="0">
-                        <a:buNone/>
-                      </a:pPr>
-                      <a:r>
-                        <a:rPr lang="en-US" sz="1125" dirty="0">
-                          <a:solidFill>
-                            <a:srgbClr val="475569"/>
-                          </a:solidFill>
-                          <a:latin typeface="Segoe UI" pitchFamily="34" charset="0"/>
-                          <a:ea typeface="Segoe UI" pitchFamily="34" charset="-122"/>
-                          <a:cs typeface="Segoe UI" pitchFamily="34" charset="-120"/>
-                        </a:rPr>
-                        <a:t>Workbench, loaded with the order's lab</a:t>
+                        <a:t>Fallback hospital when request omits it</a:t>
                       </a:r>
                       <a:endParaRPr lang="en-US" sz="1125" dirty="0">
                         <a:latin typeface="Segoe UI" charset="0"/>
@@ -13231,12 +13316,12 @@
         </p:nvSpPr>
         <p:spPr>
           <a:xfrm>
-            <a:off x="609600" y="2002536"/>
-            <a:ext cx="10972800" cy="2286000"/>
+            <a:off x="609600" y="1773936"/>
+            <a:ext cx="10972800" cy="2743200"/>
           </a:xfrm>
           <a:prstGeom prst="roundRect">
             <a:avLst>
-              <a:gd name="adj" fmla="val 4800"/>
+              <a:gd name="adj" fmla="val 4000"/>
             </a:avLst>
           </a:prstGeom>
           <a:solidFill>
@@ -13260,7 +13345,7 @@
         </p:nvSpPr>
         <p:spPr>
           <a:xfrm>
-            <a:off x="609600" y="4562856"/>
+            <a:off x="609600" y="4791456"/>
             <a:ext cx="5335524" cy="1207008"/>
           </a:xfrm>
           <a:prstGeom prst="roundRect">
@@ -13287,7 +13372,7 @@
         </p:nvSpPr>
         <p:spPr>
           <a:xfrm>
-            <a:off x="883920" y="4800600"/>
+            <a:off x="883920" y="5029200"/>
             <a:ext cx="4786884" cy="274320"/>
           </a:xfrm>
           <a:prstGeom prst="rect">
@@ -13329,7 +13414,7 @@
         </p:nvSpPr>
         <p:spPr>
           <a:xfrm>
-            <a:off x="883920" y="5129784"/>
+            <a:off x="883920" y="5358384"/>
             <a:ext cx="4786884" cy="475488"/>
           </a:xfrm>
           <a:prstGeom prst="rect">
@@ -13357,7 +13442,7 @@
                 <a:ea typeface="Segoe UI" pitchFamily="34" charset="-122"/>
                 <a:cs typeface="Segoe UI" pitchFamily="34" charset="-120"/>
               </a:rPr>
-              <a:t>Lab comes from the retrieved order. Seed one workbench row per lab; a missing row is Failure (D12).</a:t>
+              <a:t>Seed one workbench row per lab, same station name and wkbh_id. Missing row is Failure (D12).</a:t>
             </a:r>
             <a:endParaRPr lang="en-US" sz="1200" dirty="0"/>
           </a:p>
@@ -13371,7 +13456,7 @@
         </p:nvSpPr>
         <p:spPr>
           <a:xfrm>
-            <a:off x="6246876" y="4562856"/>
+            <a:off x="6246876" y="4791456"/>
             <a:ext cx="5335524" cy="1207008"/>
           </a:xfrm>
           <a:prstGeom prst="roundRect">
@@ -13398,7 +13483,7 @@
         </p:nvSpPr>
         <p:spPr>
           <a:xfrm>
-            <a:off x="6521196" y="4800600"/>
+            <a:off x="6521196" y="5029200"/>
             <a:ext cx="4786884" cy="274320"/>
           </a:xfrm>
           <a:prstGeom prst="rect">
@@ -13426,7 +13511,7 @@
                 <a:ea typeface="Segoe UI Semibold" pitchFamily="34" charset="-122"/>
                 <a:cs typeface="Segoe UI Semibold" pitchFamily="34" charset="-120"/>
               </a:rPr>
-              <a:t>No server column</a:t>
+              <a:t>Map is optional</a:t>
             </a:r>
             <a:endParaRPr lang="en-US" sz="1350" dirty="0"/>
           </a:p>
@@ -13440,7 +13525,7 @@
         </p:nvSpPr>
         <p:spPr>
           <a:xfrm>
-            <a:off x="6521196" y="5129784"/>
+            <a:off x="6521196" y="5358384"/>
             <a:ext cx="4786884" cy="475488"/>
           </a:xfrm>
           <a:prstGeom prst="rect">
@@ -13468,7 +13553,7 @@
                 <a:ea typeface="Segoe UI" pitchFamily="34" charset="-122"/>
                 <a:cs typeface="Segoe UI" pitchFamily="34" charset="-120"/>
               </a:rPr>
-              <a:t>ServiceParameterVo.serverName comes from HospitalService / LisLabServer, not loesort_server_name (D14).</a:t>
+              <a:t>If every caller sends hospital, do not seed loe_specimen_sorter_map (D15).</a:t>
             </a:r>
             <a:endParaRPr lang="en-US" sz="1200" dirty="0"/>
           </a:p>

</xml_diff>

<commit_message>
vault backup: 2026-09-22 14:09:59
</commit_message>
<xml_diff>
--- a/SDLC/Projects/TMP-specimen-sorter-api — Specimen Sorter API/assets/Specimen Sorter API v3.pptx
+++ b/SDLC/Projects/TMP-specimen-sorter-api — Specimen Sorter API/assets/Specimen Sorter API v3.pptx
@@ -4287,7 +4287,7 @@
                 <a:ea typeface="Segoe UI" pitchFamily="34" charset="-122"/>
                 <a:cs typeface="Segoe UI" pitchFamily="34" charset="-120"/>
               </a:rPr>
-              <a:t>Overnight, valid period, duplicate, private patient, missing collection date, STAR unbox alert: ALS only. Not on the body (R6).</a:t>
+              <a:t>Overnight, valid period, duplicate, private, missing collection date, STAR unbox alert: ALS only (R6).</a:t>
             </a:r>
             <a:endParaRPr lang="en-US" sz="1200" dirty="0"/>
           </a:p>
@@ -5156,49 +5156,7 @@
       </p:sp>
       <p:sp>
         <p:nvSpPr>
-          <p:cNvPr id="23" name="Text 21"/>
-          <p:cNvSpPr/>
-          <p:nvPr/>
-        </p:nvSpPr>
-        <p:spPr>
-          <a:xfrm>
-            <a:off x="2831592" y="4087368"/>
-            <a:ext cx="1737360" cy="365760"/>
-          </a:xfrm>
-          <a:prstGeom prst="rect">
-            <a:avLst/>
-          </a:prstGeom>
-          <a:noFill/>
-          <a:ln/>
-        </p:spPr>
-        <p:txBody>
-          <a:bodyPr wrap="square" lIns="0" tIns="0" rIns="0" bIns="0" rtlCol="0" anchor="t"/>
-          <a:lstStyle/>
-          <a:p>
-            <a:pPr algn="ctr" indent="0" marL="0">
-              <a:lnSpc>
-                <a:spcPct val="115000"/>
-              </a:lnSpc>
-              <a:buNone/>
-            </a:pPr>
-            <a:r>
-              <a:rPr lang="en-US" sz="1125" dirty="0">
-                <a:solidFill>
-                  <a:srgbClr val="475569"/>
-                </a:solidFill>
-                <a:latin typeface="Segoe UI" pitchFamily="34" charset="0"/>
-                <a:ea typeface="Segoe UI" pitchFamily="34" charset="-122"/>
-                <a:cs typeface="Segoe UI" pitchFamily="34" charset="-120"/>
-              </a:rPr>
-              <a:t>Existing send-out, no print</a:t>
-            </a:r>
-            <a:endParaRPr lang="en-US" sz="1125" dirty="0"/>
-          </a:p>
-        </p:txBody>
-      </p:sp>
-      <p:sp>
-        <p:nvSpPr>
-          <p:cNvPr id="24" name="Shape 22"/>
+          <p:cNvPr id="23" name="Shape 21"/>
           <p:cNvSpPr/>
           <p:nvPr/>
         </p:nvSpPr>
@@ -5225,7 +5183,7 @@
       </p:sp>
       <p:sp>
         <p:nvSpPr>
-          <p:cNvPr id="25" name="Text 23"/>
+          <p:cNvPr id="24" name="Text 22"/>
           <p:cNvSpPr/>
           <p:nvPr/>
         </p:nvSpPr>
@@ -5267,49 +5225,7 @@
       </p:sp>
       <p:sp>
         <p:nvSpPr>
-          <p:cNvPr id="26" name="Text 24"/>
-          <p:cNvSpPr/>
-          <p:nvPr/>
-        </p:nvSpPr>
-        <p:spPr>
-          <a:xfrm>
-            <a:off x="5419344" y="4087368"/>
-            <a:ext cx="1737360" cy="365760"/>
-          </a:xfrm>
-          <a:prstGeom prst="rect">
-            <a:avLst/>
-          </a:prstGeom>
-          <a:noFill/>
-          <a:ln/>
-        </p:spPr>
-        <p:txBody>
-          <a:bodyPr wrap="square" lIns="0" tIns="0" rIns="0" bIns="0" rtlCol="0" anchor="t"/>
-          <a:lstStyle/>
-          <a:p>
-            <a:pPr algn="ctr" indent="0" marL="0">
-              <a:lnSpc>
-                <a:spcPct val="115000"/>
-              </a:lnSpc>
-              <a:buNone/>
-            </a:pPr>
-            <a:r>
-              <a:rPr lang="en-US" sz="1125" dirty="0">
-                <a:solidFill>
-                  <a:srgbClr val="475569"/>
-                </a:solidFill>
-                <a:latin typeface="Segoe UI" pitchFamily="34" charset="0"/>
-                <a:ea typeface="Segoe UI" pitchFamily="34" charset="-122"/>
-                <a:cs typeface="Segoe UI" pitchFamily="34" charset="-120"/>
-              </a:rPr>
-              <a:t>Unknown sorter, lab, mixed, hard check, 4422</a:t>
-            </a:r>
-            <a:endParaRPr lang="en-US" sz="1125" dirty="0"/>
-          </a:p>
-        </p:txBody>
-      </p:sp>
-      <p:sp>
-        <p:nvSpPr>
-          <p:cNvPr id="27" name="Shape 25"/>
+          <p:cNvPr id="25" name="Shape 23"/>
           <p:cNvSpPr/>
           <p:nvPr/>
         </p:nvSpPr>
@@ -5336,7 +5252,7 @@
       </p:sp>
       <p:sp>
         <p:nvSpPr>
-          <p:cNvPr id="28" name="Text 26"/>
+          <p:cNvPr id="26" name="Text 24"/>
           <p:cNvSpPr/>
           <p:nvPr/>
         </p:nvSpPr>
@@ -5378,49 +5294,7 @@
       </p:sp>
       <p:sp>
         <p:nvSpPr>
-          <p:cNvPr id="29" name="Text 27"/>
-          <p:cNvSpPr/>
-          <p:nvPr/>
-        </p:nvSpPr>
-        <p:spPr>
-          <a:xfrm>
-            <a:off x="8007096" y="4087368"/>
-            <a:ext cx="1737360" cy="365760"/>
-          </a:xfrm>
-          <a:prstGeom prst="rect">
-            <a:avLst/>
-          </a:prstGeom>
-          <a:noFill/>
-          <a:ln/>
-        </p:spPr>
-        <p:txBody>
-          <a:bodyPr wrap="square" lIns="0" tIns="0" rIns="0" bIns="0" rtlCol="0" anchor="t"/>
-          <a:lstStyle/>
-          <a:p>
-            <a:pPr algn="ctr" indent="0" marL="0">
-              <a:lnSpc>
-                <a:spcPct val="115000"/>
-              </a:lnSpc>
-              <a:buNone/>
-            </a:pPr>
-            <a:r>
-              <a:rPr lang="en-US" sz="1125" dirty="0">
-                <a:solidFill>
-                  <a:srgbClr val="475569"/>
-                </a:solidFill>
-                <a:latin typeface="Segoe UI" pitchFamily="34" charset="0"/>
-                <a:ea typeface="Segoe UI" pitchFamily="34" charset="-122"/>
-                <a:cs typeface="Segoe UI" pitchFamily="34" charset="-120"/>
-              </a:rPr>
-              <a:t>Multi-group, suffix, DFT time flag</a:t>
-            </a:r>
-            <a:endParaRPr lang="en-US" sz="1125" dirty="0"/>
-          </a:p>
-        </p:txBody>
-      </p:sp>
-      <p:sp>
-        <p:nvSpPr>
-          <p:cNvPr id="30" name="Shape 28"/>
+          <p:cNvPr id="27" name="Shape 25"/>
           <p:cNvSpPr/>
           <p:nvPr/>
         </p:nvSpPr>
@@ -5447,7 +5321,7 @@
       </p:sp>
       <p:sp>
         <p:nvSpPr>
-          <p:cNvPr id="31" name="Text 29"/>
+          <p:cNvPr id="28" name="Text 26"/>
           <p:cNvSpPr/>
           <p:nvPr/>
         </p:nvSpPr>
@@ -5489,7 +5363,7 @@
       </p:sp>
       <p:sp>
         <p:nvSpPr>
-          <p:cNvPr id="32" name="Text 30"/>
+          <p:cNvPr id="29" name="Text 27"/>
           <p:cNvSpPr/>
           <p:nvPr/>
         </p:nvSpPr>
@@ -5528,7 +5402,7 @@
       </p:sp>
       <p:sp>
         <p:nvSpPr>
-          <p:cNvPr id="33" name="Text 31"/>
+          <p:cNvPr id="30" name="Text 28"/>
           <p:cNvSpPr/>
           <p:nvPr/>
         </p:nvSpPr>
@@ -17011,49 +16885,7 @@
       </p:sp>
       <p:sp>
         <p:nvSpPr>
-          <p:cNvPr id="23" name="Text 21"/>
-          <p:cNvSpPr/>
-          <p:nvPr/>
-        </p:nvSpPr>
-        <p:spPr>
-          <a:xfrm>
-            <a:off x="2831592" y="4087368"/>
-            <a:ext cx="1737360" cy="365760"/>
-          </a:xfrm>
-          <a:prstGeom prst="rect">
-            <a:avLst/>
-          </a:prstGeom>
-          <a:noFill/>
-          <a:ln/>
-        </p:spPr>
-        <p:txBody>
-          <a:bodyPr wrap="square" lIns="0" tIns="0" rIns="0" bIns="0" rtlCol="0" anchor="t"/>
-          <a:lstStyle/>
-          <a:p>
-            <a:pPr algn="ctr" indent="0" marL="0">
-              <a:lnSpc>
-                <a:spcPct val="115000"/>
-              </a:lnSpc>
-              <a:buNone/>
-            </a:pPr>
-            <a:r>
-              <a:rPr lang="en-US" sz="1125" dirty="0">
-                <a:solidFill>
-                  <a:srgbClr val="475569"/>
-                </a:solidFill>
-                <a:latin typeface="Segoe UI" pitchFamily="34" charset="0"/>
-                <a:ea typeface="Segoe UI" pitchFamily="34" charset="-122"/>
-                <a:cs typeface="Segoe UI" pitchFamily="34" charset="-120"/>
-              </a:rPr>
-              <a:t>Existing send-out, no print</a:t>
-            </a:r>
-            <a:endParaRPr lang="en-US" sz="1125" dirty="0"/>
-          </a:p>
-        </p:txBody>
-      </p:sp>
-      <p:sp>
-        <p:nvSpPr>
-          <p:cNvPr id="24" name="Shape 22"/>
+          <p:cNvPr id="23" name="Shape 21"/>
           <p:cNvSpPr/>
           <p:nvPr/>
         </p:nvSpPr>
@@ -17080,7 +16912,7 @@
       </p:sp>
       <p:sp>
         <p:nvSpPr>
-          <p:cNvPr id="25" name="Text 23"/>
+          <p:cNvPr id="24" name="Text 22"/>
           <p:cNvSpPr/>
           <p:nvPr/>
         </p:nvSpPr>
@@ -17122,49 +16954,7 @@
       </p:sp>
       <p:sp>
         <p:nvSpPr>
-          <p:cNvPr id="26" name="Text 24"/>
-          <p:cNvSpPr/>
-          <p:nvPr/>
-        </p:nvSpPr>
-        <p:spPr>
-          <a:xfrm>
-            <a:off x="5419344" y="4087368"/>
-            <a:ext cx="1737360" cy="365760"/>
-          </a:xfrm>
-          <a:prstGeom prst="rect">
-            <a:avLst/>
-          </a:prstGeom>
-          <a:noFill/>
-          <a:ln/>
-        </p:spPr>
-        <p:txBody>
-          <a:bodyPr wrap="square" lIns="0" tIns="0" rIns="0" bIns="0" rtlCol="0" anchor="t"/>
-          <a:lstStyle/>
-          <a:p>
-            <a:pPr algn="ctr" indent="0" marL="0">
-              <a:lnSpc>
-                <a:spcPct val="115000"/>
-              </a:lnSpc>
-              <a:buNone/>
-            </a:pPr>
-            <a:r>
-              <a:rPr lang="en-US" sz="1125" dirty="0">
-                <a:solidFill>
-                  <a:srgbClr val="475569"/>
-                </a:solidFill>
-                <a:latin typeface="Segoe UI" pitchFamily="34" charset="0"/>
-                <a:ea typeface="Segoe UI" pitchFamily="34" charset="-122"/>
-                <a:cs typeface="Segoe UI" pitchFamily="34" charset="-120"/>
-              </a:rPr>
-              <a:t>Unknown sorter, lab, mixed, hard check, 4422</a:t>
-            </a:r>
-            <a:endParaRPr lang="en-US" sz="1125" dirty="0"/>
-          </a:p>
-        </p:txBody>
-      </p:sp>
-      <p:sp>
-        <p:nvSpPr>
-          <p:cNvPr id="27" name="Shape 25"/>
+          <p:cNvPr id="25" name="Shape 23"/>
           <p:cNvSpPr/>
           <p:nvPr/>
         </p:nvSpPr>
@@ -17191,7 +16981,7 @@
       </p:sp>
       <p:sp>
         <p:nvSpPr>
-          <p:cNvPr id="28" name="Text 26"/>
+          <p:cNvPr id="26" name="Text 24"/>
           <p:cNvSpPr/>
           <p:nvPr/>
         </p:nvSpPr>
@@ -17233,49 +17023,7 @@
       </p:sp>
       <p:sp>
         <p:nvSpPr>
-          <p:cNvPr id="29" name="Text 27"/>
-          <p:cNvSpPr/>
-          <p:nvPr/>
-        </p:nvSpPr>
-        <p:spPr>
-          <a:xfrm>
-            <a:off x="8007096" y="4087368"/>
-            <a:ext cx="1737360" cy="365760"/>
-          </a:xfrm>
-          <a:prstGeom prst="rect">
-            <a:avLst/>
-          </a:prstGeom>
-          <a:noFill/>
-          <a:ln/>
-        </p:spPr>
-        <p:txBody>
-          <a:bodyPr wrap="square" lIns="0" tIns="0" rIns="0" bIns="0" rtlCol="0" anchor="t"/>
-          <a:lstStyle/>
-          <a:p>
-            <a:pPr algn="ctr" indent="0" marL="0">
-              <a:lnSpc>
-                <a:spcPct val="115000"/>
-              </a:lnSpc>
-              <a:buNone/>
-            </a:pPr>
-            <a:r>
-              <a:rPr lang="en-US" sz="1125" dirty="0">
-                <a:solidFill>
-                  <a:srgbClr val="475569"/>
-                </a:solidFill>
-                <a:latin typeface="Segoe UI" pitchFamily="34" charset="0"/>
-                <a:ea typeface="Segoe UI" pitchFamily="34" charset="-122"/>
-                <a:cs typeface="Segoe UI" pitchFamily="34" charset="-120"/>
-              </a:rPr>
-              <a:t>Multi-group, suffix, DFT time flag</a:t>
-            </a:r>
-            <a:endParaRPr lang="en-US" sz="1125" dirty="0"/>
-          </a:p>
-        </p:txBody>
-      </p:sp>
-      <p:sp>
-        <p:nvSpPr>
-          <p:cNvPr id="30" name="Shape 28"/>
+          <p:cNvPr id="27" name="Shape 25"/>
           <p:cNvSpPr/>
           <p:nvPr/>
         </p:nvSpPr>
@@ -17302,7 +17050,7 @@
       </p:sp>
       <p:sp>
         <p:nvSpPr>
-          <p:cNvPr id="31" name="Text 29"/>
+          <p:cNvPr id="28" name="Text 26"/>
           <p:cNvSpPr/>
           <p:nvPr/>
         </p:nvSpPr>
@@ -17344,7 +17092,7 @@
       </p:sp>
       <p:sp>
         <p:nvSpPr>
-          <p:cNvPr id="32" name="Text 30"/>
+          <p:cNvPr id="29" name="Text 27"/>
           <p:cNvSpPr/>
           <p:nvPr/>
         </p:nvSpPr>
@@ -17383,7 +17131,7 @@
       </p:sp>
       <p:sp>
         <p:nvSpPr>
-          <p:cNvPr id="33" name="Text 31"/>
+          <p:cNvPr id="30" name="Text 28"/>
           <p:cNvSpPr/>
           <p:nvPr/>
         </p:nvSpPr>
@@ -18286,49 +18034,7 @@
       </p:sp>
       <p:sp>
         <p:nvSpPr>
-          <p:cNvPr id="23" name="Text 21"/>
-          <p:cNvSpPr/>
-          <p:nvPr/>
-        </p:nvSpPr>
-        <p:spPr>
-          <a:xfrm>
-            <a:off x="2831592" y="4087368"/>
-            <a:ext cx="1737360" cy="365760"/>
-          </a:xfrm>
-          <a:prstGeom prst="rect">
-            <a:avLst/>
-          </a:prstGeom>
-          <a:noFill/>
-          <a:ln/>
-        </p:spPr>
-        <p:txBody>
-          <a:bodyPr wrap="square" lIns="0" tIns="0" rIns="0" bIns="0" rtlCol="0" anchor="t"/>
-          <a:lstStyle/>
-          <a:p>
-            <a:pPr algn="ctr" indent="0" marL="0">
-              <a:lnSpc>
-                <a:spcPct val="115000"/>
-              </a:lnSpc>
-              <a:buNone/>
-            </a:pPr>
-            <a:r>
-              <a:rPr lang="en-US" sz="1125" dirty="0">
-                <a:solidFill>
-                  <a:srgbClr val="475569"/>
-                </a:solidFill>
-                <a:latin typeface="Segoe UI" pitchFamily="34" charset="0"/>
-                <a:ea typeface="Segoe UI" pitchFamily="34" charset="-122"/>
-                <a:cs typeface="Segoe UI" pitchFamily="34" charset="-120"/>
-              </a:rPr>
-              <a:t>Existing send-out, no print</a:t>
-            </a:r>
-            <a:endParaRPr lang="en-US" sz="1125" dirty="0"/>
-          </a:p>
-        </p:txBody>
-      </p:sp>
-      <p:sp>
-        <p:nvSpPr>
-          <p:cNvPr id="24" name="Shape 22"/>
+          <p:cNvPr id="23" name="Shape 21"/>
           <p:cNvSpPr/>
           <p:nvPr/>
         </p:nvSpPr>
@@ -18355,7 +18061,7 @@
       </p:sp>
       <p:sp>
         <p:nvSpPr>
-          <p:cNvPr id="25" name="Text 23"/>
+          <p:cNvPr id="24" name="Text 22"/>
           <p:cNvSpPr/>
           <p:nvPr/>
         </p:nvSpPr>
@@ -18397,49 +18103,7 @@
       </p:sp>
       <p:sp>
         <p:nvSpPr>
-          <p:cNvPr id="26" name="Text 24"/>
-          <p:cNvSpPr/>
-          <p:nvPr/>
-        </p:nvSpPr>
-        <p:spPr>
-          <a:xfrm>
-            <a:off x="5419344" y="4087368"/>
-            <a:ext cx="1737360" cy="365760"/>
-          </a:xfrm>
-          <a:prstGeom prst="rect">
-            <a:avLst/>
-          </a:prstGeom>
-          <a:noFill/>
-          <a:ln/>
-        </p:spPr>
-        <p:txBody>
-          <a:bodyPr wrap="square" lIns="0" tIns="0" rIns="0" bIns="0" rtlCol="0" anchor="t"/>
-          <a:lstStyle/>
-          <a:p>
-            <a:pPr algn="ctr" indent="0" marL="0">
-              <a:lnSpc>
-                <a:spcPct val="115000"/>
-              </a:lnSpc>
-              <a:buNone/>
-            </a:pPr>
-            <a:r>
-              <a:rPr lang="en-US" sz="1125" dirty="0">
-                <a:solidFill>
-                  <a:srgbClr val="475569"/>
-                </a:solidFill>
-                <a:latin typeface="Segoe UI" pitchFamily="34" charset="0"/>
-                <a:ea typeface="Segoe UI" pitchFamily="34" charset="-122"/>
-                <a:cs typeface="Segoe UI" pitchFamily="34" charset="-120"/>
-              </a:rPr>
-              <a:t>Unknown sorter, lab, mixed, hard check, 4422</a:t>
-            </a:r>
-            <a:endParaRPr lang="en-US" sz="1125" dirty="0"/>
-          </a:p>
-        </p:txBody>
-      </p:sp>
-      <p:sp>
-        <p:nvSpPr>
-          <p:cNvPr id="27" name="Shape 25"/>
+          <p:cNvPr id="25" name="Shape 23"/>
           <p:cNvSpPr/>
           <p:nvPr/>
         </p:nvSpPr>
@@ -18466,7 +18130,7 @@
       </p:sp>
       <p:sp>
         <p:nvSpPr>
-          <p:cNvPr id="28" name="Text 26"/>
+          <p:cNvPr id="26" name="Text 24"/>
           <p:cNvSpPr/>
           <p:nvPr/>
         </p:nvSpPr>
@@ -18508,49 +18172,7 @@
       </p:sp>
       <p:sp>
         <p:nvSpPr>
-          <p:cNvPr id="29" name="Text 27"/>
-          <p:cNvSpPr/>
-          <p:nvPr/>
-        </p:nvSpPr>
-        <p:spPr>
-          <a:xfrm>
-            <a:off x="8007096" y="4087368"/>
-            <a:ext cx="1737360" cy="365760"/>
-          </a:xfrm>
-          <a:prstGeom prst="rect">
-            <a:avLst/>
-          </a:prstGeom>
-          <a:noFill/>
-          <a:ln/>
-        </p:spPr>
-        <p:txBody>
-          <a:bodyPr wrap="square" lIns="0" tIns="0" rIns="0" bIns="0" rtlCol="0" anchor="t"/>
-          <a:lstStyle/>
-          <a:p>
-            <a:pPr algn="ctr" indent="0" marL="0">
-              <a:lnSpc>
-                <a:spcPct val="115000"/>
-              </a:lnSpc>
-              <a:buNone/>
-            </a:pPr>
-            <a:r>
-              <a:rPr lang="en-US" sz="1125" dirty="0">
-                <a:solidFill>
-                  <a:srgbClr val="475569"/>
-                </a:solidFill>
-                <a:latin typeface="Segoe UI" pitchFamily="34" charset="0"/>
-                <a:ea typeface="Segoe UI" pitchFamily="34" charset="-122"/>
-                <a:cs typeface="Segoe UI" pitchFamily="34" charset="-120"/>
-              </a:rPr>
-              <a:t>Multi-group, suffix, DFT time flag</a:t>
-            </a:r>
-            <a:endParaRPr lang="en-US" sz="1125" dirty="0"/>
-          </a:p>
-        </p:txBody>
-      </p:sp>
-      <p:sp>
-        <p:nvSpPr>
-          <p:cNvPr id="30" name="Shape 28"/>
+          <p:cNvPr id="27" name="Shape 25"/>
           <p:cNvSpPr/>
           <p:nvPr/>
         </p:nvSpPr>
@@ -18577,7 +18199,7 @@
       </p:sp>
       <p:sp>
         <p:nvSpPr>
-          <p:cNvPr id="31" name="Text 29"/>
+          <p:cNvPr id="28" name="Text 26"/>
           <p:cNvSpPr/>
           <p:nvPr/>
         </p:nvSpPr>
@@ -18619,7 +18241,7 @@
       </p:sp>
       <p:sp>
         <p:nvSpPr>
-          <p:cNvPr id="32" name="Text 30"/>
+          <p:cNvPr id="29" name="Text 27"/>
           <p:cNvSpPr/>
           <p:nvPr/>
         </p:nvSpPr>
@@ -18658,7 +18280,7 @@
       </p:sp>
       <p:sp>
         <p:nvSpPr>
-          <p:cNvPr id="33" name="Text 31"/>
+          <p:cNvPr id="30" name="Text 28"/>
           <p:cNvSpPr/>
           <p:nvPr/>
         </p:nvSpPr>
@@ -20334,49 +19956,7 @@
       </p:sp>
       <p:sp>
         <p:nvSpPr>
-          <p:cNvPr id="23" name="Text 21"/>
-          <p:cNvSpPr/>
-          <p:nvPr/>
-        </p:nvSpPr>
-        <p:spPr>
-          <a:xfrm>
-            <a:off x="2831592" y="4087368"/>
-            <a:ext cx="1737360" cy="365760"/>
-          </a:xfrm>
-          <a:prstGeom prst="rect">
-            <a:avLst/>
-          </a:prstGeom>
-          <a:noFill/>
-          <a:ln/>
-        </p:spPr>
-        <p:txBody>
-          <a:bodyPr wrap="square" lIns="0" tIns="0" rIns="0" bIns="0" rtlCol="0" anchor="t"/>
-          <a:lstStyle/>
-          <a:p>
-            <a:pPr algn="ctr" indent="0" marL="0">
-              <a:lnSpc>
-                <a:spcPct val="115000"/>
-              </a:lnSpc>
-              <a:buNone/>
-            </a:pPr>
-            <a:r>
-              <a:rPr lang="en-US" sz="1125" dirty="0">
-                <a:solidFill>
-                  <a:srgbClr val="475569"/>
-                </a:solidFill>
-                <a:latin typeface="Segoe UI" pitchFamily="34" charset="0"/>
-                <a:ea typeface="Segoe UI" pitchFamily="34" charset="-122"/>
-                <a:cs typeface="Segoe UI" pitchFamily="34" charset="-120"/>
-              </a:rPr>
-              <a:t>Existing send-out, no print</a:t>
-            </a:r>
-            <a:endParaRPr lang="en-US" sz="1125" dirty="0"/>
-          </a:p>
-        </p:txBody>
-      </p:sp>
-      <p:sp>
-        <p:nvSpPr>
-          <p:cNvPr id="24" name="Shape 22"/>
+          <p:cNvPr id="23" name="Shape 21"/>
           <p:cNvSpPr/>
           <p:nvPr/>
         </p:nvSpPr>
@@ -20403,7 +19983,7 @@
       </p:sp>
       <p:sp>
         <p:nvSpPr>
-          <p:cNvPr id="25" name="Text 23"/>
+          <p:cNvPr id="24" name="Text 22"/>
           <p:cNvSpPr/>
           <p:nvPr/>
         </p:nvSpPr>
@@ -20445,49 +20025,7 @@
       </p:sp>
       <p:sp>
         <p:nvSpPr>
-          <p:cNvPr id="26" name="Text 24"/>
-          <p:cNvSpPr/>
-          <p:nvPr/>
-        </p:nvSpPr>
-        <p:spPr>
-          <a:xfrm>
-            <a:off x="5419344" y="4087368"/>
-            <a:ext cx="1737360" cy="365760"/>
-          </a:xfrm>
-          <a:prstGeom prst="rect">
-            <a:avLst/>
-          </a:prstGeom>
-          <a:noFill/>
-          <a:ln/>
-        </p:spPr>
-        <p:txBody>
-          <a:bodyPr wrap="square" lIns="0" tIns="0" rIns="0" bIns="0" rtlCol="0" anchor="t"/>
-          <a:lstStyle/>
-          <a:p>
-            <a:pPr algn="ctr" indent="0" marL="0">
-              <a:lnSpc>
-                <a:spcPct val="115000"/>
-              </a:lnSpc>
-              <a:buNone/>
-            </a:pPr>
-            <a:r>
-              <a:rPr lang="en-US" sz="1125" dirty="0">
-                <a:solidFill>
-                  <a:srgbClr val="475569"/>
-                </a:solidFill>
-                <a:latin typeface="Segoe UI" pitchFamily="34" charset="0"/>
-                <a:ea typeface="Segoe UI" pitchFamily="34" charset="-122"/>
-                <a:cs typeface="Segoe UI" pitchFamily="34" charset="-120"/>
-              </a:rPr>
-              <a:t>Unknown sorter, lab, mixed, hard check, 4422</a:t>
-            </a:r>
-            <a:endParaRPr lang="en-US" sz="1125" dirty="0"/>
-          </a:p>
-        </p:txBody>
-      </p:sp>
-      <p:sp>
-        <p:nvSpPr>
-          <p:cNvPr id="27" name="Shape 25"/>
+          <p:cNvPr id="25" name="Shape 23"/>
           <p:cNvSpPr/>
           <p:nvPr/>
         </p:nvSpPr>
@@ -20514,7 +20052,7 @@
       </p:sp>
       <p:sp>
         <p:nvSpPr>
-          <p:cNvPr id="28" name="Text 26"/>
+          <p:cNvPr id="26" name="Text 24"/>
           <p:cNvSpPr/>
           <p:nvPr/>
         </p:nvSpPr>
@@ -20556,49 +20094,7 @@
       </p:sp>
       <p:sp>
         <p:nvSpPr>
-          <p:cNvPr id="29" name="Text 27"/>
-          <p:cNvSpPr/>
-          <p:nvPr/>
-        </p:nvSpPr>
-        <p:spPr>
-          <a:xfrm>
-            <a:off x="8007096" y="4087368"/>
-            <a:ext cx="1737360" cy="365760"/>
-          </a:xfrm>
-          <a:prstGeom prst="rect">
-            <a:avLst/>
-          </a:prstGeom>
-          <a:noFill/>
-          <a:ln/>
-        </p:spPr>
-        <p:txBody>
-          <a:bodyPr wrap="square" lIns="0" tIns="0" rIns="0" bIns="0" rtlCol="0" anchor="t"/>
-          <a:lstStyle/>
-          <a:p>
-            <a:pPr algn="ctr" indent="0" marL="0">
-              <a:lnSpc>
-                <a:spcPct val="115000"/>
-              </a:lnSpc>
-              <a:buNone/>
-            </a:pPr>
-            <a:r>
-              <a:rPr lang="en-US" sz="1125" dirty="0">
-                <a:solidFill>
-                  <a:srgbClr val="475569"/>
-                </a:solidFill>
-                <a:latin typeface="Segoe UI" pitchFamily="34" charset="0"/>
-                <a:ea typeface="Segoe UI" pitchFamily="34" charset="-122"/>
-                <a:cs typeface="Segoe UI" pitchFamily="34" charset="-120"/>
-              </a:rPr>
-              <a:t>Multi-group, suffix, DFT time flag</a:t>
-            </a:r>
-            <a:endParaRPr lang="en-US" sz="1125" dirty="0"/>
-          </a:p>
-        </p:txBody>
-      </p:sp>
-      <p:sp>
-        <p:nvSpPr>
-          <p:cNvPr id="30" name="Shape 28"/>
+          <p:cNvPr id="27" name="Shape 25"/>
           <p:cNvSpPr/>
           <p:nvPr/>
         </p:nvSpPr>
@@ -20625,7 +20121,7 @@
       </p:sp>
       <p:sp>
         <p:nvSpPr>
-          <p:cNvPr id="31" name="Text 29"/>
+          <p:cNvPr id="28" name="Text 26"/>
           <p:cNvSpPr/>
           <p:nvPr/>
         </p:nvSpPr>
@@ -20667,7 +20163,7 @@
       </p:sp>
       <p:sp>
         <p:nvSpPr>
-          <p:cNvPr id="32" name="Text 30"/>
+          <p:cNvPr id="29" name="Text 27"/>
           <p:cNvSpPr/>
           <p:nvPr/>
         </p:nvSpPr>
@@ -20706,7 +20202,7 @@
       </p:sp>
       <p:sp>
         <p:nvSpPr>
-          <p:cNvPr id="33" name="Text 31"/>
+          <p:cNvPr id="30" name="Text 28"/>
           <p:cNvSpPr/>
           <p:nvPr/>
         </p:nvSpPr>

</xml_diff>

<commit_message>
vault backup: 2026-09-22 14:11:30
</commit_message>
<xml_diff>
--- a/SDLC/Projects/TMP-specimen-sorter-api — Specimen Sorter API/assets/Specimen Sorter API v3.pptx
+++ b/SDLC/Projects/TMP-specimen-sorter-api — Specimen Sorter API/assets/Specimen Sorter API v3.pptx
@@ -5120,8 +5120,8 @@
         </p:nvSpPr>
         <p:spPr>
           <a:xfrm>
-            <a:off x="2831592" y="3803904"/>
-            <a:ext cx="1737360" cy="274320"/>
+            <a:off x="2831592" y="3675888"/>
+            <a:ext cx="1737360" cy="868680"/>
           </a:xfrm>
           <a:prstGeom prst="rect">
             <a:avLst/>
@@ -5189,8 +5189,8 @@
         </p:nvSpPr>
         <p:spPr>
           <a:xfrm>
-            <a:off x="5419344" y="3803904"/>
-            <a:ext cx="1737360" cy="274320"/>
+            <a:off x="5419344" y="3675888"/>
+            <a:ext cx="1737360" cy="868680"/>
           </a:xfrm>
           <a:prstGeom prst="rect">
             <a:avLst/>
@@ -5258,8 +5258,8 @@
         </p:nvSpPr>
         <p:spPr>
           <a:xfrm>
-            <a:off x="8007096" y="3803904"/>
-            <a:ext cx="1737360" cy="274320"/>
+            <a:off x="8007096" y="3675888"/>
+            <a:ext cx="1737360" cy="868680"/>
           </a:xfrm>
           <a:prstGeom prst="rect">
             <a:avLst/>
@@ -16849,8 +16849,8 @@
         </p:nvSpPr>
         <p:spPr>
           <a:xfrm>
-            <a:off x="2831592" y="3803904"/>
-            <a:ext cx="1737360" cy="274320"/>
+            <a:off x="2831592" y="3675888"/>
+            <a:ext cx="1737360" cy="868680"/>
           </a:xfrm>
           <a:prstGeom prst="rect">
             <a:avLst/>
@@ -16918,8 +16918,8 @@
         </p:nvSpPr>
         <p:spPr>
           <a:xfrm>
-            <a:off x="5419344" y="3803904"/>
-            <a:ext cx="1737360" cy="274320"/>
+            <a:off x="5419344" y="3675888"/>
+            <a:ext cx="1737360" cy="868680"/>
           </a:xfrm>
           <a:prstGeom prst="rect">
             <a:avLst/>
@@ -16987,8 +16987,8 @@
         </p:nvSpPr>
         <p:spPr>
           <a:xfrm>
-            <a:off x="8007096" y="3803904"/>
-            <a:ext cx="1737360" cy="274320"/>
+            <a:off x="8007096" y="3675888"/>
+            <a:ext cx="1737360" cy="868680"/>
           </a:xfrm>
           <a:prstGeom prst="rect">
             <a:avLst/>
@@ -17998,8 +17998,8 @@
         </p:nvSpPr>
         <p:spPr>
           <a:xfrm>
-            <a:off x="2831592" y="3803904"/>
-            <a:ext cx="1737360" cy="274320"/>
+            <a:off x="2831592" y="3675888"/>
+            <a:ext cx="1737360" cy="868680"/>
           </a:xfrm>
           <a:prstGeom prst="rect">
             <a:avLst/>
@@ -18067,8 +18067,8 @@
         </p:nvSpPr>
         <p:spPr>
           <a:xfrm>
-            <a:off x="5419344" y="3803904"/>
-            <a:ext cx="1737360" cy="274320"/>
+            <a:off x="5419344" y="3675888"/>
+            <a:ext cx="1737360" cy="868680"/>
           </a:xfrm>
           <a:prstGeom prst="rect">
             <a:avLst/>
@@ -18136,8 +18136,8 @@
         </p:nvSpPr>
         <p:spPr>
           <a:xfrm>
-            <a:off x="8007096" y="3803904"/>
-            <a:ext cx="1737360" cy="274320"/>
+            <a:off x="8007096" y="3675888"/>
+            <a:ext cx="1737360" cy="868680"/>
           </a:xfrm>
           <a:prstGeom prst="rect">
             <a:avLst/>
@@ -19920,8 +19920,8 @@
         </p:nvSpPr>
         <p:spPr>
           <a:xfrm>
-            <a:off x="2831592" y="3803904"/>
-            <a:ext cx="1737360" cy="274320"/>
+            <a:off x="2831592" y="3675888"/>
+            <a:ext cx="1737360" cy="868680"/>
           </a:xfrm>
           <a:prstGeom prst="rect">
             <a:avLst/>
@@ -19989,8 +19989,8 @@
         </p:nvSpPr>
         <p:spPr>
           <a:xfrm>
-            <a:off x="5419344" y="3803904"/>
-            <a:ext cx="1737360" cy="274320"/>
+            <a:off x="5419344" y="3675888"/>
+            <a:ext cx="1737360" cy="868680"/>
           </a:xfrm>
           <a:prstGeom prst="rect">
             <a:avLst/>
@@ -20058,8 +20058,8 @@
         </p:nvSpPr>
         <p:spPr>
           <a:xfrm>
-            <a:off x="8007096" y="3803904"/>
-            <a:ext cx="1737360" cy="274320"/>
+            <a:off x="8007096" y="3675888"/>
+            <a:ext cx="1737360" cy="868680"/>
           </a:xfrm>
           <a:prstGeom prst="rect">
             <a:avLst/>

</xml_diff>

<commit_message>
vault backup: 2026-09-22 14:50:45
</commit_message>
<xml_diff>
--- a/SDLC/Projects/TMP-specimen-sorter-api — Specimen Sorter API/assets/Specimen Sorter API v3.pptx
+++ b/SDLC/Projects/TMP-specimen-sorter-api — Specimen Sorter API/assets/Specimen Sorter API v3.pptx
@@ -2016,7 +2016,7 @@
           <a:p>
             <a:r>
               <a:rPr lang="en-US" dirty="0"/>
-              <a:t>Same join Spec Ack uses today. Lab on the order still scopes the lookup inside the service. No print after SEND_OUT (D11).</a:t>
+              <a:t>Same join Spec Ack uses today. Lab on the order still scopes the lookup inside the service. No print after SEND_OUT.</a:t>
             </a:r>
             <a:endParaRPr lang="en-US" dirty="0"/>
           </a:p>
@@ -3323,7 +3323,7 @@
                           <a:ea typeface="Segoe UI" pitchFamily="34" charset="-122"/>
                           <a:cs typeface="Segoe UI" pitchFamily="34" charset="-120"/>
                         </a:rPr>
-                        <a:t>Ack / collect / request / DOB (R12)</a:t>
+                        <a:t>Ack / collect / request / DOB</a:t>
                       </a:r>
                       <a:endParaRPr lang="en-US" sz="1125" dirty="0">
                         <a:latin typeface="Segoe UI" charset="0"/>
@@ -3475,7 +3475,7 @@
                           <a:ea typeface="Segoe UI" pitchFamily="34" charset="-122"/>
                           <a:cs typeface="Segoe UI" pitchFamily="34" charset="-120"/>
                         </a:rPr>
-                        <a:t>Unmapped doctor, ward, specialty, report dest</a:t>
+                        <a:t>Unmapped doctor, ward, specialty, report destination</a:t>
                       </a:r>
                       <a:endParaRPr lang="en-US" sz="1125" dirty="0">
                         <a:latin typeface="Segoe UI" charset="0"/>
@@ -3779,159 +3779,7 @@
                           <a:ea typeface="Segoe UI" pitchFamily="34" charset="-122"/>
                           <a:cs typeface="Segoe UI" pitchFamily="34" charset="-120"/>
                         </a:rPr>
-                        <a:t>HKID or name does not match GCRS</a:t>
-                      </a:r>
-                      <a:endParaRPr lang="en-US" sz="1125" dirty="0">
-                        <a:latin typeface="Segoe UI" charset="0"/>
-                        <a:ea typeface="Segoe UI" charset="0"/>
-                        <a:cs typeface="Segoe UI" charset="0"/>
-                      </a:endParaRPr>
-                    </a:p>
-                  </a:txBody>
-                  <a:tcPr marL="201168" marR="201168" marT="54864" marB="54864" anchor="ctr">
-                    <a:lnL w="0" cap="flat" cmpd="sng" algn="ctr">
-                      <a:noFill/>
-                    </a:lnL>
-                    <a:lnR w="0" cap="flat" cmpd="sng" algn="ctr">
-                      <a:noFill/>
-                    </a:lnR>
-                    <a:lnT w="0" cap="flat" cmpd="sng" algn="ctr">
-                      <a:noFill/>
-                    </a:lnT>
-                    <a:lnB w="9525" cap="flat" cmpd="sng" algn="ctr">
-                      <a:solidFill>
-                        <a:srgbClr val="E2E8F0"/>
-                      </a:solidFill>
-                      <a:prstDash val="solid"/>
-                      <a:round/>
-                      <a:headEnd type="none" w="med" len="med"/>
-                      <a:tailEnd type="none" w="med" len="med"/>
-                    </a:lnB>
-                    <a:solidFill>
-                      <a:srgbClr val="FFFFFF"/>
-                    </a:solidFill>
-                  </a:tcPr>
-                </a:tc>
-                <a:tc>
-                  <a:txBody>
-                    <a:bodyPr/>
-                    <a:lstStyle/>
-                    <a:p>
-                      <a:pPr algn="l" indent="0" marL="0">
-                        <a:buNone/>
-                      </a:pPr>
-                      <a:r>
-                        <a:rPr lang="en-US" sz="1125" b="1" dirty="0">
-                          <a:solidFill>
-                            <a:srgbClr val="DC2626"/>
-                          </a:solidFill>
-                          <a:latin typeface="Segoe UI" pitchFamily="34" charset="0"/>
-                          <a:ea typeface="Segoe UI" pitchFamily="34" charset="-122"/>
-                          <a:cs typeface="Segoe UI" pitchFamily="34" charset="-120"/>
-                        </a:rPr>
-                        <a:t>FAILURE</a:t>
-                      </a:r>
-                      <a:endParaRPr lang="en-US" sz="1125" dirty="0">
-                        <a:latin typeface="Segoe UI" charset="0"/>
-                        <a:ea typeface="Segoe UI" charset="0"/>
-                        <a:cs typeface="Segoe UI" charset="0"/>
-                      </a:endParaRPr>
-                    </a:p>
-                  </a:txBody>
-                  <a:tcPr marL="201168" marR="201168" marT="54864" marB="54864" anchor="ctr">
-                    <a:lnL w="0" cap="flat" cmpd="sng" algn="ctr">
-                      <a:noFill/>
-                    </a:lnL>
-                    <a:lnR w="0" cap="flat" cmpd="sng" algn="ctr">
-                      <a:noFill/>
-                    </a:lnR>
-                    <a:lnT w="0" cap="flat" cmpd="sng" algn="ctr">
-                      <a:noFill/>
-                    </a:lnT>
-                    <a:lnB w="9525" cap="flat" cmpd="sng" algn="ctr">
-                      <a:solidFill>
-                        <a:srgbClr val="E2E8F0"/>
-                      </a:solidFill>
-                      <a:prstDash val="solid"/>
-                      <a:round/>
-                      <a:headEnd type="none" w="med" len="med"/>
-                      <a:tailEnd type="none" w="med" len="med"/>
-                    </a:lnB>
-                    <a:solidFill>
-                      <a:srgbClr val="FFFFFF"/>
-                    </a:solidFill>
-                  </a:tcPr>
-                </a:tc>
-              </a:tr>
-              <a:tr h="457200">
-                <a:tc>
-                  <a:txBody>
-                    <a:bodyPr/>
-                    <a:lstStyle/>
-                    <a:p>
-                      <a:pPr algn="l" indent="0" marL="0">
-                        <a:buNone/>
-                      </a:pPr>
-                      <a:r>
-                        <a:rPr lang="en-US" sz="1125" dirty="0">
-                          <a:solidFill>
-                            <a:srgbClr val="475569"/>
-                          </a:solidFill>
-                          <a:latin typeface="Segoe UI" pitchFamily="34" charset="0"/>
-                          <a:ea typeface="Segoe UI" pitchFamily="34" charset="-122"/>
-                          <a:cs typeface="Segoe UI" pitchFamily="34" charset="-120"/>
-                        </a:rPr>
-                        <a:t>STAR</a:t>
-                      </a:r>
-                      <a:endParaRPr lang="en-US" sz="1125" dirty="0">
-                        <a:latin typeface="Segoe UI" charset="0"/>
-                        <a:ea typeface="Segoe UI" charset="0"/>
-                        <a:cs typeface="Segoe UI" charset="0"/>
-                      </a:endParaRPr>
-                    </a:p>
-                  </a:txBody>
-                  <a:tcPr marL="201168" marR="201168" marT="54864" marB="54864" anchor="ctr">
-                    <a:lnL w="0" cap="flat" cmpd="sng" algn="ctr">
-                      <a:noFill/>
-                    </a:lnL>
-                    <a:lnR w="0" cap="flat" cmpd="sng" algn="ctr">
-                      <a:noFill/>
-                    </a:lnR>
-                    <a:lnT w="0" cap="flat" cmpd="sng" algn="ctr">
-                      <a:noFill/>
-                    </a:lnT>
-                    <a:lnB w="9525" cap="flat" cmpd="sng" algn="ctr">
-                      <a:solidFill>
-                        <a:srgbClr val="E2E8F0"/>
-                      </a:solidFill>
-                      <a:prstDash val="solid"/>
-                      <a:round/>
-                      <a:headEnd type="none" w="med" len="med"/>
-                      <a:tailEnd type="none" w="med" len="med"/>
-                    </a:lnB>
-                    <a:solidFill>
-                      <a:srgbClr val="FFFFFF"/>
-                    </a:solidFill>
-                  </a:tcPr>
-                </a:tc>
-                <a:tc>
-                  <a:txBody>
-                    <a:bodyPr/>
-                    <a:lstStyle/>
-                    <a:p>
-                      <a:pPr algn="l" indent="0" marL="0">
-                        <a:buNone/>
-                      </a:pPr>
-                      <a:r>
-                        <a:rPr lang="en-US" sz="1125" dirty="0">
-                          <a:solidFill>
-                            <a:srgbClr val="475569"/>
-                          </a:solidFill>
-                          <a:latin typeface="Segoe UI" pitchFamily="34" charset="0"/>
-                          <a:ea typeface="Segoe UI" pitchFamily="34" charset="-122"/>
-                          <a:cs typeface="Segoe UI" pitchFamily="34" charset="-120"/>
-                        </a:rPr>
-                        <a:t>No workbench location — 4422 (D9)</a:t>
+                        <a:t>Patient demogrpahics do not match</a:t>
                       </a:r>
                       <a:endParaRPr lang="en-US" sz="1125" dirty="0">
                         <a:latin typeface="Segoe UI" charset="0"/>
@@ -4052,8 +3900,14 @@
                     <a:lnT w="0" cap="flat" cmpd="sng" algn="ctr">
                       <a:noFill/>
                     </a:lnT>
-                    <a:lnB w="0" cap="flat" cmpd="sng" algn="ctr">
-                      <a:noFill/>
+                    <a:lnB w="9525" cap="flat" cmpd="sng" algn="ctr">
+                      <a:solidFill>
+                        <a:srgbClr val="E2E8F0"/>
+                      </a:solidFill>
+                      <a:prstDash val="solid"/>
+                      <a:round/>
+                      <a:headEnd type="none" w="med" len="med"/>
+                      <a:tailEnd type="none" w="med" len="med"/>
                     </a:lnB>
                     <a:solidFill>
                       <a:srgbClr val="FFFFFF"/>
@@ -4077,7 +3931,7 @@
                           <a:ea typeface="Segoe UI" pitchFamily="34" charset="-122"/>
                           <a:cs typeface="Segoe UI" pitchFamily="34" charset="-120"/>
                         </a:rPr>
-                        <a:t>Local and send-out on one USID (D3)</a:t>
+                        <a:t>Local and send-out on one USID</a:t>
                       </a:r>
                       <a:endParaRPr lang="en-US" sz="1125" dirty="0">
                         <a:latin typeface="Segoe UI" charset="0"/>
@@ -4096,8 +3950,14 @@
                     <a:lnT w="0" cap="flat" cmpd="sng" algn="ctr">
                       <a:noFill/>
                     </a:lnT>
-                    <a:lnB w="0" cap="flat" cmpd="sng" algn="ctr">
-                      <a:noFill/>
+                    <a:lnB w="9525" cap="flat" cmpd="sng" algn="ctr">
+                      <a:solidFill>
+                        <a:srgbClr val="E2E8F0"/>
+                      </a:solidFill>
+                      <a:prstDash val="solid"/>
+                      <a:round/>
+                      <a:headEnd type="none" w="med" len="med"/>
+                      <a:tailEnd type="none" w="med" len="med"/>
                     </a:lnB>
                     <a:solidFill>
                       <a:srgbClr val="FFFFFF"/>
@@ -4140,6 +4000,146 @@
                     <a:lnT w="0" cap="flat" cmpd="sng" algn="ctr">
                       <a:noFill/>
                     </a:lnT>
+                    <a:lnB w="9525" cap="flat" cmpd="sng" algn="ctr">
+                      <a:solidFill>
+                        <a:srgbClr val="E2E8F0"/>
+                      </a:solidFill>
+                      <a:prstDash val="solid"/>
+                      <a:round/>
+                      <a:headEnd type="none" w="med" len="med"/>
+                      <a:tailEnd type="none" w="med" len="med"/>
+                    </a:lnB>
+                    <a:solidFill>
+                      <a:srgbClr val="FFFFFF"/>
+                    </a:solidFill>
+                  </a:tcPr>
+                </a:tc>
+              </a:tr>
+              <a:tr h="457200">
+                <a:tc>
+                  <a:txBody>
+                    <a:bodyPr/>
+                    <a:lstStyle/>
+                    <a:p>
+                      <a:pPr algn="l" indent="0" marL="0">
+                        <a:buNone/>
+                      </a:pPr>
+                      <a:r>
+                        <a:rPr lang="en-US" sz="1125" dirty="0">
+                          <a:solidFill>
+                            <a:srgbClr val="475569"/>
+                          </a:solidFill>
+                          <a:latin typeface="Segoe UI" pitchFamily="34" charset="0"/>
+                          <a:ea typeface="Segoe UI" pitchFamily="34" charset="-122"/>
+                          <a:cs typeface="Segoe UI" pitchFamily="34" charset="-120"/>
+                        </a:rPr>
+                        <a:t>Other error</a:t>
+                      </a:r>
+                      <a:endParaRPr lang="en-US" sz="1125" dirty="0">
+                        <a:latin typeface="Segoe UI" charset="0"/>
+                        <a:ea typeface="Segoe UI" charset="0"/>
+                        <a:cs typeface="Segoe UI" charset="0"/>
+                      </a:endParaRPr>
+                    </a:p>
+                  </a:txBody>
+                  <a:tcPr marL="201168" marR="201168" marT="54864" marB="54864" anchor="ctr">
+                    <a:lnL w="0" cap="flat" cmpd="sng" algn="ctr">
+                      <a:noFill/>
+                    </a:lnL>
+                    <a:lnR w="0" cap="flat" cmpd="sng" algn="ctr">
+                      <a:noFill/>
+                    </a:lnR>
+                    <a:lnT w="0" cap="flat" cmpd="sng" algn="ctr">
+                      <a:noFill/>
+                    </a:lnT>
+                    <a:lnB w="0" cap="flat" cmpd="sng" algn="ctr">
+                      <a:noFill/>
+                    </a:lnB>
+                    <a:solidFill>
+                      <a:srgbClr val="FFFFFF"/>
+                    </a:solidFill>
+                  </a:tcPr>
+                </a:tc>
+                <a:tc>
+                  <a:txBody>
+                    <a:bodyPr/>
+                    <a:lstStyle/>
+                    <a:p>
+                      <a:pPr algn="l" indent="0" marL="0">
+                        <a:buNone/>
+                      </a:pPr>
+                      <a:r>
+                        <a:rPr lang="en-US" sz="1125" dirty="0">
+                          <a:solidFill>
+                            <a:srgbClr val="475569"/>
+                          </a:solidFill>
+                          <a:latin typeface="Segoe UI" pitchFamily="34" charset="0"/>
+                          <a:ea typeface="Segoe UI" pitchFamily="34" charset="-122"/>
+                          <a:cs typeface="Segoe UI" pitchFamily="34" charset="-120"/>
+                        </a:rPr>
+                        <a:t>Unexpected error</a:t>
+                      </a:r>
+                      <a:endParaRPr lang="en-US" sz="1125" dirty="0">
+                        <a:latin typeface="Segoe UI" charset="0"/>
+                        <a:ea typeface="Segoe UI" charset="0"/>
+                        <a:cs typeface="Segoe UI" charset="0"/>
+                      </a:endParaRPr>
+                    </a:p>
+                  </a:txBody>
+                  <a:tcPr marL="201168" marR="201168" marT="54864" marB="54864" anchor="ctr">
+                    <a:lnL w="0" cap="flat" cmpd="sng" algn="ctr">
+                      <a:noFill/>
+                    </a:lnL>
+                    <a:lnR w="0" cap="flat" cmpd="sng" algn="ctr">
+                      <a:noFill/>
+                    </a:lnR>
+                    <a:lnT w="0" cap="flat" cmpd="sng" algn="ctr">
+                      <a:noFill/>
+                    </a:lnT>
+                    <a:lnB w="0" cap="flat" cmpd="sng" algn="ctr">
+                      <a:noFill/>
+                    </a:lnB>
+                    <a:solidFill>
+                      <a:srgbClr val="FFFFFF"/>
+                    </a:solidFill>
+                  </a:tcPr>
+                </a:tc>
+                <a:tc>
+                  <a:txBody>
+                    <a:bodyPr/>
+                    <a:lstStyle/>
+                    <a:p>
+                      <a:pPr algn="l" indent="0" marL="0">
+                        <a:buNone/>
+                      </a:pPr>
+                      <a:r>
+                        <a:rPr lang="en-US" sz="1125" b="1" dirty="0">
+                          <a:solidFill>
+                            <a:srgbClr val="DC2626"/>
+                          </a:solidFill>
+                          <a:latin typeface="Segoe UI" pitchFamily="34" charset="0"/>
+                          <a:ea typeface="Segoe UI" pitchFamily="34" charset="-122"/>
+                          <a:cs typeface="Segoe UI" pitchFamily="34" charset="-120"/>
+                        </a:rPr>
+                        <a:t>FAILURE</a:t>
+                      </a:r>
+                      <a:endParaRPr lang="en-US" sz="1125" dirty="0">
+                        <a:latin typeface="Segoe UI" charset="0"/>
+                        <a:ea typeface="Segoe UI" charset="0"/>
+                        <a:cs typeface="Segoe UI" charset="0"/>
+                      </a:endParaRPr>
+                    </a:p>
+                  </a:txBody>
+                  <a:tcPr marL="201168" marR="201168" marT="54864" marB="54864" anchor="ctr">
+                    <a:lnL w="0" cap="flat" cmpd="sng" algn="ctr">
+                      <a:noFill/>
+                    </a:lnL>
+                    <a:lnR w="0" cap="flat" cmpd="sng" algn="ctr">
+                      <a:noFill/>
+                    </a:lnR>
+                    <a:lnT w="0" cap="flat" cmpd="sng" algn="ctr">
+                      <a:noFill/>
+                    </a:lnT>
                     <a:lnB w="0" cap="flat" cmpd="sng" algn="ctr">
                       <a:noFill/>
                     </a:lnB>
@@ -4287,7 +4287,7 @@
                 <a:ea typeface="Segoe UI" pitchFamily="34" charset="-122"/>
                 <a:cs typeface="Segoe UI" pitchFamily="34" charset="-120"/>
               </a:rPr>
-              <a:t>Overnight, valid period, duplicate, private, missing collection date, STAR unbox alert: ALS only (R6).</a:t>
+              <a:t>Overnight, valid period, duplicate, private, missing collection date, STAR unbox alert: ALS only.</a:t>
             </a:r>
             <a:endParaRPr lang="en-US" sz="1200" dirty="0"/>
           </a:p>
@@ -5370,7 +5370,7 @@
         <p:spPr>
           <a:xfrm>
             <a:off x="883920" y="5669280"/>
-            <a:ext cx="6949440" cy="292608"/>
+            <a:ext cx="10424160" cy="292608"/>
           </a:xfrm>
           <a:prstGeom prst="rect">
             <a:avLst/>
@@ -5397,48 +5397,6 @@
               <a:t>REGISTERED | SEND_OUT | RELABEL | FAILURE</a:t>
             </a:r>
             <a:endParaRPr lang="en-US" sz="1200" dirty="0"/>
-          </a:p>
-        </p:txBody>
-      </p:sp>
-      <p:sp>
-        <p:nvSpPr>
-          <p:cNvPr id="30" name="Text 28"/>
-          <p:cNvSpPr/>
-          <p:nvPr/>
-        </p:nvSpPr>
-        <p:spPr>
-          <a:xfrm>
-            <a:off x="8016240" y="5440680"/>
-            <a:ext cx="3291840" cy="502920"/>
-          </a:xfrm>
-          <a:prstGeom prst="rect">
-            <a:avLst/>
-          </a:prstGeom>
-          <a:noFill/>
-          <a:ln/>
-        </p:spPr>
-        <p:txBody>
-          <a:bodyPr wrap="square" lIns="0" tIns="0" rIns="0" bIns="0" rtlCol="0" anchor="ctr"/>
-          <a:lstStyle/>
-          <a:p>
-            <a:pPr algn="l" indent="0" marL="0">
-              <a:lnSpc>
-                <a:spcPct val="115000"/>
-              </a:lnSpc>
-              <a:buNone/>
-            </a:pPr>
-            <a:r>
-              <a:rPr lang="en-US" sz="1125" dirty="0">
-                <a:solidFill>
-                  <a:srgbClr val="94A3B8"/>
-                </a:solidFill>
-                <a:latin typeface="Segoe UI" pitchFamily="34" charset="0"/>
-                <a:ea typeface="Segoe UI" pitchFamily="34" charset="-122"/>
-                <a:cs typeface="Segoe UI" pitchFamily="34" charset="-120"/>
-              </a:rPr>
-              <a:t>Yes on this node is RELABEL. No write. Not Failure (R3).</a:t>
-            </a:r>
-            <a:endParaRPr lang="en-US" sz="1125" dirty="0"/>
           </a:p>
         </p:txBody>
       </p:sp>
@@ -5560,12 +5518,12 @@
         </p:nvSpPr>
         <p:spPr>
           <a:xfrm>
-            <a:off x="609600" y="2595658"/>
-            <a:ext cx="3505200" cy="2032444"/>
+            <a:off x="609600" y="2488502"/>
+            <a:ext cx="3505200" cy="2246757"/>
           </a:xfrm>
           <a:prstGeom prst="roundRect">
             <a:avLst>
-              <a:gd name="adj" fmla="val 5399"/>
+              <a:gd name="adj" fmla="val 4884"/>
             </a:avLst>
           </a:prstGeom>
           <a:solidFill>
@@ -5587,7 +5545,7 @@
         </p:nvSpPr>
         <p:spPr>
           <a:xfrm>
-            <a:off x="883920" y="2915698"/>
+            <a:off x="883920" y="2808542"/>
             <a:ext cx="310896" cy="310896"/>
           </a:xfrm>
           <a:prstGeom prst="ellipse">
@@ -5632,7 +5590,7 @@
         </p:nvSpPr>
         <p:spPr>
           <a:xfrm>
-            <a:off x="883920" y="3354610"/>
+            <a:off x="883920" y="3247454"/>
             <a:ext cx="2956560" cy="219075"/>
           </a:xfrm>
           <a:prstGeom prst="rect">
@@ -5674,8 +5632,8 @@
         </p:nvSpPr>
         <p:spPr>
           <a:xfrm>
-            <a:off x="883920" y="3665125"/>
-            <a:ext cx="2956560" cy="798385"/>
+            <a:off x="883920" y="3557969"/>
+            <a:ext cx="2956560" cy="1012698"/>
           </a:xfrm>
           <a:prstGeom prst="rect">
             <a:avLst/>
@@ -5702,7 +5660,7 @@
                 <a:ea typeface="Segoe UI" pitchFamily="34" charset="-122"/>
                 <a:cs typeface="Segoe UI" pitchFamily="34" charset="-120"/>
               </a:rPr>
-              <a:t>More than one request test group for the scanned USID (R4a).</a:t>
+              <a:t>• More than one request test group for the scanned USID</a:t>
             </a:r>
             <a:endParaRPr lang="en-US" sz="1350" dirty="0"/>
           </a:p>
@@ -5716,12 +5674,12 @@
         </p:nvSpPr>
         <p:spPr>
           <a:xfrm>
-            <a:off x="4343400" y="2595658"/>
-            <a:ext cx="3505200" cy="2032444"/>
+            <a:off x="4343400" y="2488502"/>
+            <a:ext cx="3505200" cy="2246757"/>
           </a:xfrm>
           <a:prstGeom prst="roundRect">
             <a:avLst>
-              <a:gd name="adj" fmla="val 5399"/>
+              <a:gd name="adj" fmla="val 4884"/>
             </a:avLst>
           </a:prstGeom>
           <a:solidFill>
@@ -5743,7 +5701,7 @@
         </p:nvSpPr>
         <p:spPr>
           <a:xfrm>
-            <a:off x="4617720" y="2915698"/>
+            <a:off x="4617720" y="2808542"/>
             <a:ext cx="310896" cy="310896"/>
           </a:xfrm>
           <a:prstGeom prst="ellipse">
@@ -5788,7 +5746,7 @@
         </p:nvSpPr>
         <p:spPr>
           <a:xfrm>
-            <a:off x="4617720" y="3354610"/>
+            <a:off x="4617720" y="3247454"/>
             <a:ext cx="2956560" cy="219075"/>
           </a:xfrm>
           <a:prstGeom prst="rect">
@@ -5830,8 +5788,8 @@
         </p:nvSpPr>
         <p:spPr>
           <a:xfrm>
-            <a:off x="4617720" y="3665125"/>
-            <a:ext cx="2956560" cy="798385"/>
+            <a:off x="4617720" y="3557969"/>
+            <a:ext cx="2956560" cy="1012698"/>
           </a:xfrm>
           <a:prstGeom prst="rect">
             <a:avLst/>
@@ -5858,10 +5816,50 @@
                 <a:ea typeface="Segoe UI" pitchFamily="34" charset="-122"/>
                 <a:cs typeface="Segoe UI" pitchFamily="34" charset="-120"/>
               </a:rPr>
-              <a:t>More than one specimen on a test, suffix A/B/C, or several DFT specimens for one time flag (R4b, R4c).</a:t>
+              <a:t>• More than one specimen on a test</a:t>
             </a:r>
             <a:endParaRPr lang="en-US" sz="1350" dirty="0"/>
           </a:p>
+          <a:p>
+            <a:pPr algn="l" indent="0" marL="0">
+              <a:lnSpc>
+                <a:spcPct val="120000"/>
+              </a:lnSpc>
+              <a:buNone/>
+            </a:pPr>
+            <a:r>
+              <a:rPr lang="en-US" sz="1350" dirty="0">
+                <a:solidFill>
+                  <a:srgbClr val="475569"/>
+                </a:solidFill>
+                <a:latin typeface="Segoe UI" pitchFamily="34" charset="0"/>
+                <a:ea typeface="Segoe UI" pitchFamily="34" charset="-122"/>
+                <a:cs typeface="Segoe UI" pitchFamily="34" charset="-120"/>
+              </a:rPr>
+              <a:t>• suffix A/B/C</a:t>
+            </a:r>
+            <a:endParaRPr lang="en-US" sz="1350" dirty="0"/>
+          </a:p>
+          <a:p>
+            <a:pPr algn="l" indent="0" marL="0">
+              <a:lnSpc>
+                <a:spcPct val="120000"/>
+              </a:lnSpc>
+              <a:buNone/>
+            </a:pPr>
+            <a:r>
+              <a:rPr lang="en-US" sz="1350" dirty="0">
+                <a:solidFill>
+                  <a:srgbClr val="475569"/>
+                </a:solidFill>
+                <a:latin typeface="Segoe UI" pitchFamily="34" charset="0"/>
+                <a:ea typeface="Segoe UI" pitchFamily="34" charset="-122"/>
+                <a:cs typeface="Segoe UI" pitchFamily="34" charset="-120"/>
+              </a:rPr>
+              <a:t>• several DFT specimens for one time flag</a:t>
+            </a:r>
+            <a:endParaRPr lang="en-US" sz="1350" dirty="0"/>
+          </a:p>
         </p:txBody>
       </p:sp>
       <p:sp>
@@ -5872,12 +5870,12 @@
         </p:nvSpPr>
         <p:spPr>
           <a:xfrm>
-            <a:off x="8077200" y="2595658"/>
-            <a:ext cx="3505200" cy="2032444"/>
+            <a:off x="8077200" y="2488502"/>
+            <a:ext cx="3505200" cy="2246757"/>
           </a:xfrm>
           <a:prstGeom prst="roundRect">
             <a:avLst>
-              <a:gd name="adj" fmla="val 5399"/>
+              <a:gd name="adj" fmla="val 4884"/>
             </a:avLst>
           </a:prstGeom>
           <a:solidFill>
@@ -5899,7 +5897,7 @@
         </p:nvSpPr>
         <p:spPr>
           <a:xfrm>
-            <a:off x="8351520" y="2915698"/>
+            <a:off x="8351520" y="2808542"/>
             <a:ext cx="310896" cy="310896"/>
           </a:xfrm>
           <a:prstGeom prst="ellipse">
@@ -5944,7 +5942,7 @@
         </p:nvSpPr>
         <p:spPr>
           <a:xfrm>
-            <a:off x="8351520" y="3354610"/>
+            <a:off x="8351520" y="3247454"/>
             <a:ext cx="2956560" cy="219075"/>
           </a:xfrm>
           <a:prstGeom prst="rect">
@@ -5986,8 +5984,8 @@
         </p:nvSpPr>
         <p:spPr>
           <a:xfrm>
-            <a:off x="8351520" y="3665125"/>
-            <a:ext cx="2956560" cy="798385"/>
+            <a:off x="8351520" y="3557969"/>
+            <a:ext cx="2956560" cy="1012698"/>
           </a:xfrm>
           <a:prstGeom prst="rect">
             <a:avLst/>
@@ -6014,7 +6012,7 @@
                 <a:ea typeface="Segoe UI" pitchFamily="34" charset="-122"/>
                 <a:cs typeface="Segoe UI" pitchFamily="34" charset="-120"/>
               </a:rPr>
-              <a:t>GCRS force-relabel flag, or auto-gen-only lab. No checkbox. No invented number (R11).</a:t>
+              <a:t>• Force-relabel flag in LOE_TEST_MAP setup</a:t>
             </a:r>
             <a:endParaRPr lang="en-US" sz="1350" dirty="0"/>
           </a:p>
@@ -6028,7 +6026,7 @@
         </p:nvSpPr>
         <p:spPr>
           <a:xfrm>
-            <a:off x="609600" y="4856702"/>
+            <a:off x="609600" y="4963858"/>
             <a:ext cx="10972800" cy="365760"/>
           </a:xfrm>
           <a:prstGeom prst="rect">
@@ -6073,7 +6071,7 @@
                 <a:ea typeface="Segoe UI" pitchFamily="34" charset="-122"/>
                 <a:cs typeface="Segoe UI" pitchFamily="34" charset="-120"/>
               </a:rPr>
-              <a:t>Return RELABEL. No lab request. Partial DFT remainder is Relabel too (Q15).</a:t>
+              <a:t>Return RELABEL. No lab request.</a:t>
             </a:r>
             <a:endParaRPr lang="en-US" sz="1200" dirty="0"/>
           </a:p>
@@ -6987,7 +6985,7 @@
         </p:nvSpPr>
         <p:spPr>
           <a:xfrm>
-            <a:off x="6781800" y="2403729"/>
+            <a:off x="6781800" y="2318004"/>
             <a:ext cx="4800600" cy="884682"/>
           </a:xfrm>
           <a:prstGeom prst="roundRect">
@@ -7022,7 +7020,7 @@
         </p:blipFill>
         <p:spPr>
           <a:xfrm>
-            <a:off x="6982968" y="2632329"/>
+            <a:off x="6982968" y="2546604"/>
             <a:ext cx="219456" cy="219456"/>
           </a:xfrm>
           <a:prstGeom prst="rect">
@@ -7038,7 +7036,7 @@
         </p:nvSpPr>
         <p:spPr>
           <a:xfrm>
-            <a:off x="7293864" y="2604897"/>
+            <a:off x="7293864" y="2519172"/>
             <a:ext cx="4087368" cy="274320"/>
           </a:xfrm>
           <a:prstGeom prst="rect">
@@ -7080,7 +7078,7 @@
         </p:nvSpPr>
         <p:spPr>
           <a:xfrm>
-            <a:off x="6982968" y="2897505"/>
+            <a:off x="6982968" y="2811780"/>
             <a:ext cx="4398264" cy="244602"/>
           </a:xfrm>
           <a:prstGeom prst="rect">
@@ -7122,7 +7120,7 @@
         </p:nvSpPr>
         <p:spPr>
           <a:xfrm>
-            <a:off x="6781800" y="3443859"/>
+            <a:off x="6781800" y="3358134"/>
             <a:ext cx="4800600" cy="884682"/>
           </a:xfrm>
           <a:prstGeom prst="roundRect">
@@ -7157,7 +7155,7 @@
         </p:blipFill>
         <p:spPr>
           <a:xfrm>
-            <a:off x="6982968" y="3672459"/>
+            <a:off x="6982968" y="3586734"/>
             <a:ext cx="219456" cy="219456"/>
           </a:xfrm>
           <a:prstGeom prst="rect">
@@ -7173,7 +7171,7 @@
         </p:nvSpPr>
         <p:spPr>
           <a:xfrm>
-            <a:off x="7293864" y="3645027"/>
+            <a:off x="7293864" y="3559302"/>
             <a:ext cx="4087368" cy="274320"/>
           </a:xfrm>
           <a:prstGeom prst="rect">
@@ -7215,7 +7213,7 @@
         </p:nvSpPr>
         <p:spPr>
           <a:xfrm>
-            <a:off x="6982968" y="3937635"/>
+            <a:off x="6982968" y="3851910"/>
             <a:ext cx="4398264" cy="244602"/>
           </a:xfrm>
           <a:prstGeom prst="rect">
@@ -7257,12 +7255,12 @@
         </p:nvSpPr>
         <p:spPr>
           <a:xfrm>
-            <a:off x="6781800" y="4483989"/>
-            <a:ext cx="4800600" cy="884682"/>
+            <a:off x="6781800" y="4398264"/>
+            <a:ext cx="4800600" cy="1056132"/>
           </a:xfrm>
           <a:prstGeom prst="roundRect">
             <a:avLst>
-              <a:gd name="adj" fmla="val 12403"/>
+              <a:gd name="adj" fmla="val 10390"/>
             </a:avLst>
           </a:prstGeom>
           <a:solidFill>
@@ -7292,7 +7290,7 @@
         </p:blipFill>
         <p:spPr>
           <a:xfrm>
-            <a:off x="6982968" y="4712589"/>
+            <a:off x="6982968" y="4626864"/>
             <a:ext cx="219456" cy="219456"/>
           </a:xfrm>
           <a:prstGeom prst="rect">
@@ -7308,7 +7306,7 @@
         </p:nvSpPr>
         <p:spPr>
           <a:xfrm>
-            <a:off x="7293864" y="4685157"/>
+            <a:off x="7293864" y="4599432"/>
             <a:ext cx="4087368" cy="274320"/>
           </a:xfrm>
           <a:prstGeom prst="rect">
@@ -7336,7 +7334,7 @@
                 <a:ea typeface="Segoe UI Semibold" pitchFamily="34" charset="-122"/>
                 <a:cs typeface="Segoe UI Semibold" pitchFamily="34" charset="-120"/>
               </a:rPr>
-              <a:t>Bin from data.status</a:t>
+              <a:t>Returned status, labCode, testCode</a:t>
             </a:r>
             <a:endParaRPr lang="en-US" sz="1275" dirty="0"/>
           </a:p>
@@ -7350,8 +7348,8 @@
         </p:nvSpPr>
         <p:spPr>
           <a:xfrm>
-            <a:off x="6982968" y="4977765"/>
-            <a:ext cx="4398264" cy="244602"/>
+            <a:off x="6982968" y="4892040"/>
+            <a:ext cx="4398264" cy="416052"/>
           </a:xfrm>
           <a:prstGeom prst="rect">
             <a:avLst/>
@@ -7378,7 +7376,7 @@
                 <a:ea typeface="Segoe UI" pitchFamily="34" charset="-122"/>
                 <a:cs typeface="Segoe UI" pitchFamily="34" charset="-120"/>
               </a:rPr>
-              <a:t>HTTP 200 is not Registered. 500 means retry.</a:t>
+              <a:t>HTTP 200 is not Registered. Bin from status. labCode and testCode are LIS. 500 means retry.</a:t>
             </a:r>
             <a:endParaRPr lang="en-US" sz="1125" dirty="0"/>
           </a:p>
@@ -18248,7 +18246,7 @@
         <p:spPr>
           <a:xfrm>
             <a:off x="883920" y="5669280"/>
-            <a:ext cx="6949440" cy="292608"/>
+            <a:ext cx="10424160" cy="292608"/>
           </a:xfrm>
           <a:prstGeom prst="rect">
             <a:avLst/>
@@ -18275,48 +18273,6 @@
               <a:t>REGISTERED | SEND_OUT | RELABEL | FAILURE</a:t>
             </a:r>
             <a:endParaRPr lang="en-US" sz="1200" dirty="0"/>
-          </a:p>
-        </p:txBody>
-      </p:sp>
-      <p:sp>
-        <p:nvSpPr>
-          <p:cNvPr id="30" name="Text 28"/>
-          <p:cNvSpPr/>
-          <p:nvPr/>
-        </p:nvSpPr>
-        <p:spPr>
-          <a:xfrm>
-            <a:off x="8016240" y="5440680"/>
-            <a:ext cx="3291840" cy="502920"/>
-          </a:xfrm>
-          <a:prstGeom prst="rect">
-            <a:avLst/>
-          </a:prstGeom>
-          <a:noFill/>
-          <a:ln/>
-        </p:spPr>
-        <p:txBody>
-          <a:bodyPr wrap="square" lIns="0" tIns="0" rIns="0" bIns="0" rtlCol="0" anchor="ctr"/>
-          <a:lstStyle/>
-          <a:p>
-            <a:pPr algn="l" indent="0" marL="0">
-              <a:lnSpc>
-                <a:spcPct val="115000"/>
-              </a:lnSpc>
-              <a:buNone/>
-            </a:pPr>
-            <a:r>
-              <a:rPr lang="en-US" sz="1125" dirty="0">
-                <a:solidFill>
-                  <a:srgbClr val="94A3B8"/>
-                </a:solidFill>
-                <a:latin typeface="Segoe UI" pitchFamily="34" charset="0"/>
-                <a:ea typeface="Segoe UI" pitchFamily="34" charset="-122"/>
-                <a:cs typeface="Segoe UI" pitchFamily="34" charset="-120"/>
-              </a:rPr>
-              <a:t>Yes on this node is SEND_OUT. Mixed local plus send-out already failed (D3).</a:t>
-            </a:r>
-            <a:endParaRPr lang="en-US" sz="1125" dirty="0"/>
           </a:p>
         </p:txBody>
       </p:sp>
@@ -18594,7 +18550,7 @@
                 <a:ea typeface="Consolas" pitchFamily="34" charset="-122"/>
                 <a:cs typeface="Consolas" pitchFamily="34" charset="-120"/>
               </a:rPr>
-              <a:t>loereqtst_test_code</a:t>
+              <a:t>LOESEND_HOSP</a:t>
             </a:r>
             <a:pPr indent="0" marL="0">
               <a:lnSpc>
@@ -18628,7 +18584,7 @@
                 <a:ea typeface="Consolas" pitchFamily="34" charset="-122"/>
                 <a:cs typeface="Consolas" pitchFamily="34" charset="-120"/>
               </a:rPr>
-              <a:t>LOESEND_CLUSTER_CODE</a:t>
+              <a:t>&lt;Send Hospital&gt;</a:t>
             </a:r>
             <a:endParaRPr lang="en-US" sz="1125" dirty="0"/>
           </a:p>
@@ -18642,13 +18598,13 @@
             <a:r>
               <a:rPr lang="en-US" sz="1125" dirty="0">
                 <a:solidFill>
-                  <a:srgbClr val="F43F5E"/>
+                  <a:srgbClr val="38BDF8"/>
                 </a:solidFill>
                 <a:latin typeface="Consolas" pitchFamily="34" charset="0"/>
                 <a:ea typeface="Consolas" pitchFamily="34" charset="-122"/>
                 <a:cs typeface="Consolas" pitchFamily="34" charset="-120"/>
               </a:rPr>
-              <a:t>AND send hospital</a:t>
+              <a:t>AND LOESEND_CLUSTER_CODE</a:t>
             </a:r>
             <a:pPr indent="0" marL="0">
               <a:lnSpc>
@@ -18682,7 +18638,7 @@
                 <a:ea typeface="Consolas" pitchFamily="34" charset="-122"/>
                 <a:cs typeface="Consolas" pitchFamily="34" charset="-120"/>
               </a:rPr>
-              <a:t>LOESEND_HOSP</a:t>
+              <a:t>&lt;CMS Test Code&gt;</a:t>
             </a:r>
             <a:endParaRPr lang="en-US" sz="1125" dirty="0"/>
           </a:p>
@@ -18817,7 +18773,7 @@
                 <a:ea typeface="Segoe UI" pitchFamily="34" charset="-122"/>
                 <a:cs typeface="Segoe UI" pitchFamily="34" charset="-120"/>
               </a:rPr>
-              <a:t>In-process sendOutSpecimen. Status SEND_OUT. No worksheet.</a:t>
+              <a:t>In-process sendOutSpecimen. Status SEND_OUT.</a:t>
             </a:r>
             <a:endParaRPr lang="en-US" sz="1125" dirty="0"/>
           </a:p>
@@ -18952,7 +18908,7 @@
                 <a:ea typeface="Segoe UI" pitchFamily="34" charset="-122"/>
                 <a:cs typeface="Segoe UI" pitchFamily="34" charset="-120"/>
               </a:rPr>
-              <a:t>Some send-out, some local. FAILURE. Do not split (D3).</a:t>
+              <a:t>Some send-out, some local. FAILURE. Do not split.</a:t>
             </a:r>
             <a:endParaRPr lang="en-US" sz="1125" dirty="0"/>
           </a:p>
@@ -20170,7 +20126,7 @@
         <p:spPr>
           <a:xfrm>
             <a:off x="883920" y="5669280"/>
-            <a:ext cx="6949440" cy="292608"/>
+            <a:ext cx="10424160" cy="292608"/>
           </a:xfrm>
           <a:prstGeom prst="rect">
             <a:avLst/>
@@ -20197,48 +20153,6 @@
               <a:t>REGISTERED | SEND_OUT | RELABEL | FAILURE</a:t>
             </a:r>
             <a:endParaRPr lang="en-US" sz="1200" dirty="0"/>
-          </a:p>
-        </p:txBody>
-      </p:sp>
-      <p:sp>
-        <p:nvSpPr>
-          <p:cNvPr id="30" name="Text 28"/>
-          <p:cNvSpPr/>
-          <p:nvPr/>
-        </p:nvSpPr>
-        <p:spPr>
-          <a:xfrm>
-            <a:off x="8016240" y="5440680"/>
-            <a:ext cx="3291840" cy="502920"/>
-          </a:xfrm>
-          <a:prstGeom prst="rect">
-            <a:avLst/>
-          </a:prstGeom>
-          <a:noFill/>
-          <a:ln/>
-        </p:spPr>
-        <p:txBody>
-          <a:bodyPr wrap="square" lIns="0" tIns="0" rIns="0" bIns="0" rtlCol="0" anchor="ctr"/>
-          <a:lstStyle/>
-          <a:p>
-            <a:pPr algn="l" indent="0" marL="0">
-              <a:lnSpc>
-                <a:spcPct val="115000"/>
-              </a:lnSpc>
-              <a:buNone/>
-            </a:pPr>
-            <a:r>
-              <a:rPr lang="en-US" sz="1125" dirty="0">
-                <a:solidFill>
-                  <a:srgbClr val="94A3B8"/>
-                </a:solidFill>
-                <a:latin typeface="Segoe UI" pitchFamily="34" charset="0"/>
-                <a:ea typeface="Segoe UI" pitchFamily="34" charset="-122"/>
-                <a:cs typeface="Segoe UI" pitchFamily="34" charset="-120"/>
-              </a:rPr>
-              <a:t>No on this node is FAILURE. Soft alerts stay on ALS.</a:t>
-            </a:r>
-            <a:endParaRPr lang="en-US" sz="1125" dirty="0"/>
           </a:p>
         </p:txBody>
       </p:sp>

</xml_diff>

<commit_message>
vault backup: 2026-09-22 15:03:36
</commit_message>
<xml_diff>
--- a/SDLC/Projects/TMP-specimen-sorter-api — Specimen Sorter API/assets/Specimen Sorter API v3.pptx
+++ b/SDLC/Projects/TMP-specimen-sorter-api — Specimen Sorter API/assets/Specimen Sorter API v3.pptx
@@ -7728,66 +7728,7 @@
       </p:sp>
       <p:sp>
         <p:nvSpPr>
-          <p:cNvPr id="9" name="Text 7"/>
-          <p:cNvSpPr/>
-          <p:nvPr/>
-        </p:nvSpPr>
-        <p:spPr>
-          <a:xfrm>
-            <a:off x="883920" y="4123944"/>
-            <a:ext cx="4786884" cy="208788"/>
-          </a:xfrm>
-          <a:prstGeom prst="rect">
-            <a:avLst/>
-          </a:prstGeom>
-          <a:noFill/>
-          <a:ln/>
-        </p:spPr>
-        <p:txBody>
-          <a:bodyPr wrap="square" lIns="0" tIns="0" rIns="0" bIns="0" rtlCol="0" anchor="t"/>
-          <a:lstStyle/>
-          <a:p>
-            <a:pPr algn="l" indent="0" marL="0">
-              <a:lnSpc>
-                <a:spcPct val="115000"/>
-              </a:lnSpc>
-              <a:buNone/>
-            </a:pPr>
-            <a:r>
-              <a:rPr lang="en-US" sz="1200" b="1" dirty="0">
-                <a:solidFill>
-                  <a:srgbClr val="334155"/>
-                </a:solidFill>
-                <a:latin typeface="Segoe UI" pitchFamily="34" charset="0"/>
-                <a:ea typeface="Segoe UI" pitchFamily="34" charset="-122"/>
-                <a:cs typeface="Segoe UI" pitchFamily="34" charset="-120"/>
-              </a:rPr>
-              <a:t>Retrieve GET: </a:t>
-            </a:r>
-            <a:pPr algn="l" indent="0" marL="0">
-              <a:lnSpc>
-                <a:spcPct val="115000"/>
-              </a:lnSpc>
-              <a:buNone/>
-            </a:pPr>
-            <a:r>
-              <a:rPr lang="en-US" sz="1200" dirty="0">
-                <a:solidFill>
-                  <a:srgbClr val="334155"/>
-                </a:solidFill>
-                <a:latin typeface="Segoe UI" pitchFamily="34" charset="0"/>
-                <a:ea typeface="Segoe UI" pitchFamily="34" charset="-122"/>
-                <a:cs typeface="Segoe UI" pitchFamily="34" charset="-120"/>
-              </a:rPr>
-              <a:t>hard-codes user ltc611</a:t>
-            </a:r>
-            <a:endParaRPr lang="en-US" sz="1200" dirty="0"/>
-          </a:p>
-        </p:txBody>
-      </p:sp>
-      <p:sp>
-        <p:nvSpPr>
-          <p:cNvPr id="10" name="Shape 8"/>
+          <p:cNvPr id="9" name="Shape 7"/>
           <p:cNvSpPr/>
           <p:nvPr/>
         </p:nvSpPr>
@@ -7814,7 +7755,7 @@
       </p:sp>
       <p:sp>
         <p:nvSpPr>
-          <p:cNvPr id="11" name="Text 9"/>
+          <p:cNvPr id="10" name="Text 8"/>
           <p:cNvSpPr/>
           <p:nvPr/>
         </p:nvSpPr>
@@ -7861,7 +7802,7 @@
       </p:sp>
       <p:sp>
         <p:nvSpPr>
-          <p:cNvPr id="12" name="Text 10"/>
+          <p:cNvPr id="11" name="Text 9"/>
           <p:cNvSpPr/>
           <p:nvPr/>
         </p:nvSpPr>
@@ -7903,7 +7844,7 @@
       </p:sp>
       <p:sp>
         <p:nvSpPr>
-          <p:cNvPr id="13" name="Text 11"/>
+          <p:cNvPr id="12" name="Text 10"/>
           <p:cNvSpPr/>
           <p:nvPr/>
         </p:nvSpPr>
@@ -7962,7 +7903,7 @@
       </p:sp>
       <p:sp>
         <p:nvSpPr>
-          <p:cNvPr id="14" name="Text 12"/>
+          <p:cNvPr id="13" name="Text 11"/>
           <p:cNvSpPr/>
           <p:nvPr/>
         </p:nvSpPr>
@@ -8021,7 +7962,7 @@
       </p:sp>
       <p:sp>
         <p:nvSpPr>
-          <p:cNvPr id="15" name="Text 13"/>
+          <p:cNvPr id="14" name="Text 12"/>
           <p:cNvSpPr/>
           <p:nvPr/>
         </p:nvSpPr>
@@ -8080,7 +8021,7 @@
       </p:sp>
       <p:sp>
         <p:nvSpPr>
-          <p:cNvPr id="16" name="Text 14"/>
+          <p:cNvPr id="15" name="Text 13"/>
           <p:cNvSpPr/>
           <p:nvPr/>
         </p:nvSpPr>
@@ -8131,7 +8072,7 @@
                 <a:ea typeface="Segoe UI" pitchFamily="34" charset="-122"/>
                 <a:cs typeface="Segoe UI" pitchFamily="34" charset="-120"/>
               </a:rPr>
-              <a:t>loesort_hosp only</a:t>
+              <a:t>Map hospital by loesort_hosp</a:t>
             </a:r>
             <a:endParaRPr lang="en-US" sz="1200" dirty="0"/>
           </a:p>
@@ -8271,10 +8212,61 @@
               <a:tblPr/>
               <a:tblGrid>
                 <a:gridCol w="3108960"/>
-                <a:gridCol w="2377440"/>
-                <a:gridCol w="5486400"/>
+                <a:gridCol w="2560320"/>
+                <a:gridCol w="1645920"/>
+                <a:gridCol w="3657600"/>
               </a:tblGrid>
               <a:tr h="457200">
+                <a:tc>
+                  <a:txBody>
+                    <a:bodyPr/>
+                    <a:lstStyle/>
+                    <a:p>
+                      <a:pPr algn="l" indent="0" marL="0">
+                        <a:buNone/>
+                      </a:pPr>
+                      <a:r>
+                        <a:rPr lang="en-US" sz="1125" b="1" dirty="0">
+                          <a:solidFill>
+                            <a:srgbClr val="0F172A"/>
+                          </a:solidFill>
+                          <a:latin typeface="Segoe UI" pitchFamily="34" charset="0"/>
+                          <a:ea typeface="Segoe UI" pitchFamily="34" charset="-122"/>
+                          <a:cs typeface="Segoe UI" pitchFamily="34" charset="-120"/>
+                        </a:rPr>
+                        <a:t>Table</a:t>
+                      </a:r>
+                      <a:endParaRPr lang="en-US" sz="1125" dirty="0">
+                        <a:latin typeface="Segoe UI" charset="0"/>
+                        <a:ea typeface="Segoe UI" charset="0"/>
+                        <a:cs typeface="Segoe UI" charset="0"/>
+                      </a:endParaRPr>
+                    </a:p>
+                  </a:txBody>
+                  <a:tcPr marL="201168" marR="201168" marT="54864" marB="54864" anchor="ctr">
+                    <a:lnL w="0" cap="flat" cmpd="sng" algn="ctr">
+                      <a:noFill/>
+                    </a:lnL>
+                    <a:lnR w="0" cap="flat" cmpd="sng" algn="ctr">
+                      <a:noFill/>
+                    </a:lnR>
+                    <a:lnT w="0" cap="flat" cmpd="sng" algn="ctr">
+                      <a:noFill/>
+                    </a:lnT>
+                    <a:lnB w="19050" cap="flat" cmpd="sng" algn="ctr">
+                      <a:solidFill>
+                        <a:srgbClr val="CBD5E1"/>
+                      </a:solidFill>
+                      <a:prstDash val="solid"/>
+                      <a:round/>
+                      <a:headEnd type="none" w="med" len="med"/>
+                      <a:tailEnd type="none" w="med" len="med"/>
+                    </a:lnB>
+                    <a:solidFill>
+                      <a:srgbClr val="F1F5F9"/>
+                    </a:solidFill>
+                  </a:tcPr>
+                </a:tc>
                 <a:tc>
                   <a:txBody>
                     <a:bodyPr/>
@@ -8444,6 +8436,56 @@
                           <a:ea typeface="Consolas" pitchFamily="34" charset="-122"/>
                           <a:cs typeface="Consolas" pitchFamily="34" charset="-120"/>
                         </a:rPr>
+                        <a:t>workbench</a:t>
+                      </a:r>
+                      <a:endParaRPr lang="en-US" sz="1125" dirty="0">
+                        <a:latin typeface="Consolas" charset="0"/>
+                        <a:ea typeface="Consolas" charset="0"/>
+                        <a:cs typeface="Consolas" charset="0"/>
+                      </a:endParaRPr>
+                    </a:p>
+                  </a:txBody>
+                  <a:tcPr marL="201168" marR="201168" marT="54864" marB="54864" anchor="ctr">
+                    <a:lnL w="0" cap="flat" cmpd="sng" algn="ctr">
+                      <a:noFill/>
+                    </a:lnL>
+                    <a:lnR w="0" cap="flat" cmpd="sng" algn="ctr">
+                      <a:noFill/>
+                    </a:lnR>
+                    <a:lnT w="0" cap="flat" cmpd="sng" algn="ctr">
+                      <a:noFill/>
+                    </a:lnT>
+                    <a:lnB w="9525" cap="flat" cmpd="sng" algn="ctr">
+                      <a:solidFill>
+                        <a:srgbClr val="E2E8F0"/>
+                      </a:solidFill>
+                      <a:prstDash val="solid"/>
+                      <a:round/>
+                      <a:headEnd type="none" w="med" len="med"/>
+                      <a:tailEnd type="none" w="med" len="med"/>
+                    </a:lnB>
+                    <a:solidFill>
+                      <a:srgbClr val="FFFFFF"/>
+                    </a:solidFill>
+                  </a:tcPr>
+                </a:tc>
+                <a:tc>
+                  <a:txBody>
+                    <a:bodyPr/>
+                    <a:lstStyle/>
+                    <a:p>
+                      <a:pPr algn="l" indent="0" marL="0">
+                        <a:buNone/>
+                      </a:pPr>
+                      <a:r>
+                        <a:rPr lang="en-US" sz="1125" dirty="0">
+                          <a:solidFill>
+                            <a:srgbClr val="0284C7"/>
+                          </a:solidFill>
+                          <a:latin typeface="Consolas" pitchFamily="34" charset="0"/>
+                          <a:ea typeface="Consolas" pitchFamily="34" charset="-122"/>
+                          <a:cs typeface="Consolas" pitchFamily="34" charset="-120"/>
+                        </a:rPr>
                         <a:t>wkbh_station_name</a:t>
                       </a:r>
                       <a:endParaRPr lang="en-US" sz="1125" dirty="0">
@@ -8494,7 +8536,7 @@
                           <a:ea typeface="Segoe UI" pitchFamily="34" charset="-122"/>
                           <a:cs typeface="Segoe UI" pitchFamily="34" charset="-120"/>
                         </a:rPr>
-                        <a:t>workbench</a:t>
+                        <a:t>varchar(255)</a:t>
                       </a:r>
                       <a:endParaRPr lang="en-US" sz="1125" dirty="0">
                         <a:latin typeface="Segoe UI" charset="0"/>
@@ -8596,6 +8638,56 @@
                           <a:ea typeface="Consolas" pitchFamily="34" charset="-122"/>
                           <a:cs typeface="Consolas" pitchFamily="34" charset="-120"/>
                         </a:rPr>
+                        <a:t>workbench</a:t>
+                      </a:r>
+                      <a:endParaRPr lang="en-US" sz="1125" dirty="0">
+                        <a:latin typeface="Consolas" charset="0"/>
+                        <a:ea typeface="Consolas" charset="0"/>
+                        <a:cs typeface="Consolas" charset="0"/>
+                      </a:endParaRPr>
+                    </a:p>
+                  </a:txBody>
+                  <a:tcPr marL="201168" marR="201168" marT="54864" marB="54864" anchor="ctr">
+                    <a:lnL w="0" cap="flat" cmpd="sng" algn="ctr">
+                      <a:noFill/>
+                    </a:lnL>
+                    <a:lnR w="0" cap="flat" cmpd="sng" algn="ctr">
+                      <a:noFill/>
+                    </a:lnR>
+                    <a:lnT w="0" cap="flat" cmpd="sng" algn="ctr">
+                      <a:noFill/>
+                    </a:lnT>
+                    <a:lnB w="9525" cap="flat" cmpd="sng" algn="ctr">
+                      <a:solidFill>
+                        <a:srgbClr val="E2E8F0"/>
+                      </a:solidFill>
+                      <a:prstDash val="solid"/>
+                      <a:round/>
+                      <a:headEnd type="none" w="med" len="med"/>
+                      <a:tailEnd type="none" w="med" len="med"/>
+                    </a:lnB>
+                    <a:solidFill>
+                      <a:srgbClr val="FFFFFF"/>
+                    </a:solidFill>
+                  </a:tcPr>
+                </a:tc>
+                <a:tc>
+                  <a:txBody>
+                    <a:bodyPr/>
+                    <a:lstStyle/>
+                    <a:p>
+                      <a:pPr algn="l" indent="0" marL="0">
+                        <a:buNone/>
+                      </a:pPr>
+                      <a:r>
+                        <a:rPr lang="en-US" sz="1125" dirty="0">
+                          <a:solidFill>
+                            <a:srgbClr val="0284C7"/>
+                          </a:solidFill>
+                          <a:latin typeface="Consolas" pitchFamily="34" charset="0"/>
+                          <a:ea typeface="Consolas" pitchFamily="34" charset="-122"/>
+                          <a:cs typeface="Consolas" pitchFamily="34" charset="-120"/>
+                        </a:rPr>
                         <a:t>wkbh_id</a:t>
                       </a:r>
                       <a:endParaRPr lang="en-US" sz="1125" dirty="0">
@@ -8646,7 +8738,7 @@
                           <a:ea typeface="Segoe UI" pitchFamily="34" charset="-122"/>
                           <a:cs typeface="Segoe UI" pitchFamily="34" charset="-120"/>
                         </a:rPr>
-                        <a:t>workbench</a:t>
+                        <a:t>char(8)</a:t>
                       </a:r>
                       <a:endParaRPr lang="en-US" sz="1125" dirty="0">
                         <a:latin typeface="Segoe UI" charset="0"/>
@@ -8748,6 +8840,56 @@
                           <a:ea typeface="Consolas" pitchFamily="34" charset="-122"/>
                           <a:cs typeface="Consolas" pitchFamily="34" charset="-120"/>
                         </a:rPr>
+                        <a:t>workbench</a:t>
+                      </a:r>
+                      <a:endParaRPr lang="en-US" sz="1125" dirty="0">
+                        <a:latin typeface="Consolas" charset="0"/>
+                        <a:ea typeface="Consolas" charset="0"/>
+                        <a:cs typeface="Consolas" charset="0"/>
+                      </a:endParaRPr>
+                    </a:p>
+                  </a:txBody>
+                  <a:tcPr marL="201168" marR="201168" marT="54864" marB="54864" anchor="ctr">
+                    <a:lnL w="0" cap="flat" cmpd="sng" algn="ctr">
+                      <a:noFill/>
+                    </a:lnL>
+                    <a:lnR w="0" cap="flat" cmpd="sng" algn="ctr">
+                      <a:noFill/>
+                    </a:lnR>
+                    <a:lnT w="0" cap="flat" cmpd="sng" algn="ctr">
+                      <a:noFill/>
+                    </a:lnT>
+                    <a:lnB w="9525" cap="flat" cmpd="sng" algn="ctr">
+                      <a:solidFill>
+                        <a:srgbClr val="E2E8F0"/>
+                      </a:solidFill>
+                      <a:prstDash val="solid"/>
+                      <a:round/>
+                      <a:headEnd type="none" w="med" len="med"/>
+                      <a:tailEnd type="none" w="med" len="med"/>
+                    </a:lnB>
+                    <a:solidFill>
+                      <a:srgbClr val="FFFFFF"/>
+                    </a:solidFill>
+                  </a:tcPr>
+                </a:tc>
+                <a:tc>
+                  <a:txBody>
+                    <a:bodyPr/>
+                    <a:lstStyle/>
+                    <a:p>
+                      <a:pPr algn="l" indent="0" marL="0">
+                        <a:buNone/>
+                      </a:pPr>
+                      <a:r>
+                        <a:rPr lang="en-US" sz="1125" dirty="0">
+                          <a:solidFill>
+                            <a:srgbClr val="0284C7"/>
+                          </a:solidFill>
+                          <a:latin typeface="Consolas" pitchFamily="34" charset="0"/>
+                          <a:ea typeface="Consolas" pitchFamily="34" charset="-122"/>
+                          <a:cs typeface="Consolas" pitchFamily="34" charset="-120"/>
+                        </a:rPr>
                         <a:t>wkbh_hosp</a:t>
                       </a:r>
                       <a:endParaRPr lang="en-US" sz="1125" dirty="0">
@@ -8798,7 +8940,7 @@
                           <a:ea typeface="Segoe UI" pitchFamily="34" charset="-122"/>
                           <a:cs typeface="Segoe UI" pitchFamily="34" charset="-120"/>
                         </a:rPr>
-                        <a:t>workbench</a:t>
+                        <a:t>char(12)</a:t>
                       </a:r>
                       <a:endParaRPr lang="en-US" sz="1125" dirty="0">
                         <a:latin typeface="Segoe UI" charset="0"/>
@@ -8900,6 +9042,56 @@
                           <a:ea typeface="Consolas" pitchFamily="34" charset="-122"/>
                           <a:cs typeface="Consolas" pitchFamily="34" charset="-120"/>
                         </a:rPr>
+                        <a:t>loe_specimen_sorter_map</a:t>
+                      </a:r>
+                      <a:endParaRPr lang="en-US" sz="1125" dirty="0">
+                        <a:latin typeface="Consolas" charset="0"/>
+                        <a:ea typeface="Consolas" charset="0"/>
+                        <a:cs typeface="Consolas" charset="0"/>
+                      </a:endParaRPr>
+                    </a:p>
+                  </a:txBody>
+                  <a:tcPr marL="201168" marR="201168" marT="54864" marB="54864" anchor="ctr">
+                    <a:lnL w="0" cap="flat" cmpd="sng" algn="ctr">
+                      <a:noFill/>
+                    </a:lnL>
+                    <a:lnR w="0" cap="flat" cmpd="sng" algn="ctr">
+                      <a:noFill/>
+                    </a:lnR>
+                    <a:lnT w="0" cap="flat" cmpd="sng" algn="ctr">
+                      <a:noFill/>
+                    </a:lnT>
+                    <a:lnB w="9525" cap="flat" cmpd="sng" algn="ctr">
+                      <a:solidFill>
+                        <a:srgbClr val="E2E8F0"/>
+                      </a:solidFill>
+                      <a:prstDash val="solid"/>
+                      <a:round/>
+                      <a:headEnd type="none" w="med" len="med"/>
+                      <a:tailEnd type="none" w="med" len="med"/>
+                    </a:lnB>
+                    <a:solidFill>
+                      <a:srgbClr val="FFFFFF"/>
+                    </a:solidFill>
+                  </a:tcPr>
+                </a:tc>
+                <a:tc>
+                  <a:txBody>
+                    <a:bodyPr/>
+                    <a:lstStyle/>
+                    <a:p>
+                      <a:pPr algn="l" indent="0" marL="0">
+                        <a:buNone/>
+                      </a:pPr>
+                      <a:r>
+                        <a:rPr lang="en-US" sz="1125" dirty="0">
+                          <a:solidFill>
+                            <a:srgbClr val="0284C7"/>
+                          </a:solidFill>
+                          <a:latin typeface="Consolas" pitchFamily="34" charset="0"/>
+                          <a:ea typeface="Consolas" pitchFamily="34" charset="-122"/>
+                          <a:cs typeface="Consolas" pitchFamily="34" charset="-120"/>
+                        </a:rPr>
                         <a:t>loesort_sorter_id</a:t>
                       </a:r>
                       <a:endParaRPr lang="en-US" sz="1125" dirty="0">
@@ -9035,6 +9227,50 @@
                 </a:tc>
               </a:tr>
               <a:tr h="457200">
+                <a:tc>
+                  <a:txBody>
+                    <a:bodyPr/>
+                    <a:lstStyle/>
+                    <a:p>
+                      <a:pPr algn="l" indent="0" marL="0">
+                        <a:buNone/>
+                      </a:pPr>
+                      <a:r>
+                        <a:rPr lang="en-US" sz="1125" dirty="0">
+                          <a:solidFill>
+                            <a:srgbClr val="0284C7"/>
+                          </a:solidFill>
+                          <a:latin typeface="Consolas" pitchFamily="34" charset="0"/>
+                          <a:ea typeface="Consolas" pitchFamily="34" charset="-122"/>
+                          <a:cs typeface="Consolas" pitchFamily="34" charset="-120"/>
+                        </a:rPr>
+                        <a:t>loe_specimen_sorter_map</a:t>
+                      </a:r>
+                      <a:endParaRPr lang="en-US" sz="1125" dirty="0">
+                        <a:latin typeface="Consolas" charset="0"/>
+                        <a:ea typeface="Consolas" charset="0"/>
+                        <a:cs typeface="Consolas" charset="0"/>
+                      </a:endParaRPr>
+                    </a:p>
+                  </a:txBody>
+                  <a:tcPr marL="201168" marR="201168" marT="54864" marB="54864" anchor="ctr">
+                    <a:lnL w="0" cap="flat" cmpd="sng" algn="ctr">
+                      <a:noFill/>
+                    </a:lnL>
+                    <a:lnR w="0" cap="flat" cmpd="sng" algn="ctr">
+                      <a:noFill/>
+                    </a:lnR>
+                    <a:lnT w="0" cap="flat" cmpd="sng" algn="ctr">
+                      <a:noFill/>
+                    </a:lnT>
+                    <a:lnB w="0" cap="flat" cmpd="sng" algn="ctr">
+                      <a:noFill/>
+                    </a:lnB>
+                    <a:solidFill>
+                      <a:srgbClr val="FFFFFF"/>
+                    </a:solidFill>
+                  </a:tcPr>
+                </a:tc>
                 <a:tc>
                   <a:txBody>
                     <a:bodyPr/>

</xml_diff>

<commit_message>
vault backup: 2026-09-22 15:19:00
</commit_message>
<xml_diff>
--- a/SDLC/Projects/TMP-specimen-sorter-api — Specimen Sorter API/assets/Specimen Sorter API v3.pptx
+++ b/SDLC/Projects/TMP-specimen-sorter-api — Specimen Sorter API/assets/Specimen Sorter API v3.pptx
@@ -8182,7 +8182,7 @@
                 <a:ea typeface="Segoe UI Semibold" pitchFamily="34" charset="-122"/>
                 <a:cs typeface="Segoe UI Semibold" pitchFamily="34" charset="-120"/>
               </a:rPr>
-              <a:t>Hospital sent: workbench only. Map is hospital fallback</a:t>
+              <a:t>Derive Hospital is missing. Sorter ID is defined in workbench</a:t>
             </a:r>
             <a:endParaRPr lang="en-US" sz="2400" dirty="0"/>
           </a:p>
@@ -8203,7 +8203,7 @@
           </p:nvPr>
         </p:nvGraphicFramePr>
         <p:xfrm>
-          <a:off x="609600" y="1773936"/>
+          <a:off x="609600" y="1453896"/>
           <a:ext cx="10972800" cy="914400"/>
         </p:xfrm>
         <a:graphic>
@@ -8436,7 +8436,7 @@
                           <a:ea typeface="Consolas" pitchFamily="34" charset="-122"/>
                           <a:cs typeface="Consolas" pitchFamily="34" charset="-120"/>
                         </a:rPr>
-                        <a:t>workbench</a:t>
+                        <a:t>loe_specimen_sorter_map</a:t>
                       </a:r>
                       <a:endParaRPr lang="en-US" sz="1125" dirty="0">
                         <a:latin typeface="Consolas" charset="0"/>
@@ -8486,7 +8486,7 @@
                           <a:ea typeface="Consolas" pitchFamily="34" charset="-122"/>
                           <a:cs typeface="Consolas" pitchFamily="34" charset="-120"/>
                         </a:rPr>
-                        <a:t>wkbh_station_name</a:t>
+                        <a:t>loesort_sorter_id</a:t>
                       </a:r>
                       <a:endParaRPr lang="en-US" sz="1125" dirty="0">
                         <a:latin typeface="Consolas" charset="0"/>
@@ -8536,7 +8536,7 @@
                           <a:ea typeface="Segoe UI" pitchFamily="34" charset="-122"/>
                           <a:cs typeface="Segoe UI" pitchFamily="34" charset="-120"/>
                         </a:rPr>
-                        <a:t>varchar(255)</a:t>
+                        <a:t>VARCHAR2(64)</a:t>
                       </a:r>
                       <a:endParaRPr lang="en-US" sz="1125" dirty="0">
                         <a:latin typeface="Segoe UI" charset="0"/>
@@ -8586,7 +8586,209 @@
                           <a:ea typeface="Segoe UI" pitchFamily="34" charset="-122"/>
                           <a:cs typeface="Segoe UI" pitchFamily="34" charset="-120"/>
                         </a:rPr>
-                        <a:t>Equals request sorterId</a:t>
+                        <a:t>Fallback map PK</a:t>
+                      </a:r>
+                      <a:endParaRPr lang="en-US" sz="1125" dirty="0">
+                        <a:latin typeface="Segoe UI" charset="0"/>
+                        <a:ea typeface="Segoe UI" charset="0"/>
+                        <a:cs typeface="Segoe UI" charset="0"/>
+                      </a:endParaRPr>
+                    </a:p>
+                  </a:txBody>
+                  <a:tcPr marL="201168" marR="201168" marT="54864" marB="54864" anchor="ctr">
+                    <a:lnL w="0" cap="flat" cmpd="sng" algn="ctr">
+                      <a:noFill/>
+                    </a:lnL>
+                    <a:lnR w="0" cap="flat" cmpd="sng" algn="ctr">
+                      <a:noFill/>
+                    </a:lnR>
+                    <a:lnT w="0" cap="flat" cmpd="sng" algn="ctr">
+                      <a:noFill/>
+                    </a:lnT>
+                    <a:lnB w="9525" cap="flat" cmpd="sng" algn="ctr">
+                      <a:solidFill>
+                        <a:srgbClr val="E2E8F0"/>
+                      </a:solidFill>
+                      <a:prstDash val="solid"/>
+                      <a:round/>
+                      <a:headEnd type="none" w="med" len="med"/>
+                      <a:tailEnd type="none" w="med" len="med"/>
+                    </a:lnB>
+                    <a:solidFill>
+                      <a:srgbClr val="FFFFFF"/>
+                    </a:solidFill>
+                  </a:tcPr>
+                </a:tc>
+              </a:tr>
+              <a:tr h="457200">
+                <a:tc>
+                  <a:txBody>
+                    <a:bodyPr/>
+                    <a:lstStyle/>
+                    <a:p>
+                      <a:pPr algn="l" indent="0" marL="0">
+                        <a:buNone/>
+                      </a:pPr>
+                      <a:r>
+                        <a:rPr lang="en-US" sz="1125" dirty="0">
+                          <a:solidFill>
+                            <a:srgbClr val="0284C7"/>
+                          </a:solidFill>
+                          <a:latin typeface="Consolas" pitchFamily="34" charset="0"/>
+                          <a:ea typeface="Consolas" pitchFamily="34" charset="-122"/>
+                          <a:cs typeface="Consolas" pitchFamily="34" charset="-120"/>
+                        </a:rPr>
+                        <a:t>loe_specimen_sorter_map</a:t>
+                      </a:r>
+                      <a:endParaRPr lang="en-US" sz="1125" dirty="0">
+                        <a:latin typeface="Consolas" charset="0"/>
+                        <a:ea typeface="Consolas" charset="0"/>
+                        <a:cs typeface="Consolas" charset="0"/>
+                      </a:endParaRPr>
+                    </a:p>
+                  </a:txBody>
+                  <a:tcPr marL="201168" marR="201168" marT="54864" marB="54864" anchor="ctr">
+                    <a:lnL w="0" cap="flat" cmpd="sng" algn="ctr">
+                      <a:noFill/>
+                    </a:lnL>
+                    <a:lnR w="0" cap="flat" cmpd="sng" algn="ctr">
+                      <a:noFill/>
+                    </a:lnR>
+                    <a:lnT w="0" cap="flat" cmpd="sng" algn="ctr">
+                      <a:noFill/>
+                    </a:lnT>
+                    <a:lnB w="9525" cap="flat" cmpd="sng" algn="ctr">
+                      <a:solidFill>
+                        <a:srgbClr val="E2E8F0"/>
+                      </a:solidFill>
+                      <a:prstDash val="solid"/>
+                      <a:round/>
+                      <a:headEnd type="none" w="med" len="med"/>
+                      <a:tailEnd type="none" w="med" len="med"/>
+                    </a:lnB>
+                    <a:solidFill>
+                      <a:srgbClr val="FFFFFF"/>
+                    </a:solidFill>
+                  </a:tcPr>
+                </a:tc>
+                <a:tc>
+                  <a:txBody>
+                    <a:bodyPr/>
+                    <a:lstStyle/>
+                    <a:p>
+                      <a:pPr algn="l" indent="0" marL="0">
+                        <a:buNone/>
+                      </a:pPr>
+                      <a:r>
+                        <a:rPr lang="en-US" sz="1125" dirty="0">
+                          <a:solidFill>
+                            <a:srgbClr val="0284C7"/>
+                          </a:solidFill>
+                          <a:latin typeface="Consolas" pitchFamily="34" charset="0"/>
+                          <a:ea typeface="Consolas" pitchFamily="34" charset="-122"/>
+                          <a:cs typeface="Consolas" pitchFamily="34" charset="-120"/>
+                        </a:rPr>
+                        <a:t>loesort_hosp</a:t>
+                      </a:r>
+                      <a:endParaRPr lang="en-US" sz="1125" dirty="0">
+                        <a:latin typeface="Consolas" charset="0"/>
+                        <a:ea typeface="Consolas" charset="0"/>
+                        <a:cs typeface="Consolas" charset="0"/>
+                      </a:endParaRPr>
+                    </a:p>
+                  </a:txBody>
+                  <a:tcPr marL="201168" marR="201168" marT="54864" marB="54864" anchor="ctr">
+                    <a:lnL w="0" cap="flat" cmpd="sng" algn="ctr">
+                      <a:noFill/>
+                    </a:lnL>
+                    <a:lnR w="0" cap="flat" cmpd="sng" algn="ctr">
+                      <a:noFill/>
+                    </a:lnR>
+                    <a:lnT w="0" cap="flat" cmpd="sng" algn="ctr">
+                      <a:noFill/>
+                    </a:lnT>
+                    <a:lnB w="9525" cap="flat" cmpd="sng" algn="ctr">
+                      <a:solidFill>
+                        <a:srgbClr val="E2E8F0"/>
+                      </a:solidFill>
+                      <a:prstDash val="solid"/>
+                      <a:round/>
+                      <a:headEnd type="none" w="med" len="med"/>
+                      <a:tailEnd type="none" w="med" len="med"/>
+                    </a:lnB>
+                    <a:solidFill>
+                      <a:srgbClr val="FFFFFF"/>
+                    </a:solidFill>
+                  </a:tcPr>
+                </a:tc>
+                <a:tc>
+                  <a:txBody>
+                    <a:bodyPr/>
+                    <a:lstStyle/>
+                    <a:p>
+                      <a:pPr algn="l" indent="0" marL="0">
+                        <a:buNone/>
+                      </a:pPr>
+                      <a:r>
+                        <a:rPr lang="en-US" sz="1125" dirty="0">
+                          <a:solidFill>
+                            <a:srgbClr val="475569"/>
+                          </a:solidFill>
+                          <a:latin typeface="Segoe UI" pitchFamily="34" charset="0"/>
+                          <a:ea typeface="Segoe UI" pitchFamily="34" charset="-122"/>
+                          <a:cs typeface="Segoe UI" pitchFamily="34" charset="-120"/>
+                        </a:rPr>
+                        <a:t>VARCHAR2(8)</a:t>
+                      </a:r>
+                      <a:endParaRPr lang="en-US" sz="1125" dirty="0">
+                        <a:latin typeface="Segoe UI" charset="0"/>
+                        <a:ea typeface="Segoe UI" charset="0"/>
+                        <a:cs typeface="Segoe UI" charset="0"/>
+                      </a:endParaRPr>
+                    </a:p>
+                  </a:txBody>
+                  <a:tcPr marL="201168" marR="201168" marT="54864" marB="54864" anchor="ctr">
+                    <a:lnL w="0" cap="flat" cmpd="sng" algn="ctr">
+                      <a:noFill/>
+                    </a:lnL>
+                    <a:lnR w="0" cap="flat" cmpd="sng" algn="ctr">
+                      <a:noFill/>
+                    </a:lnR>
+                    <a:lnT w="0" cap="flat" cmpd="sng" algn="ctr">
+                      <a:noFill/>
+                    </a:lnT>
+                    <a:lnB w="9525" cap="flat" cmpd="sng" algn="ctr">
+                      <a:solidFill>
+                        <a:srgbClr val="E2E8F0"/>
+                      </a:solidFill>
+                      <a:prstDash val="solid"/>
+                      <a:round/>
+                      <a:headEnd type="none" w="med" len="med"/>
+                      <a:tailEnd type="none" w="med" len="med"/>
+                    </a:lnB>
+                    <a:solidFill>
+                      <a:srgbClr val="FFFFFF"/>
+                    </a:solidFill>
+                  </a:tcPr>
+                </a:tc>
+                <a:tc>
+                  <a:txBody>
+                    <a:bodyPr/>
+                    <a:lstStyle/>
+                    <a:p>
+                      <a:pPr algn="l" indent="0" marL="0">
+                        <a:buNone/>
+                      </a:pPr>
+                      <a:r>
+                        <a:rPr lang="en-US" sz="1125" dirty="0">
+                          <a:solidFill>
+                            <a:srgbClr val="475569"/>
+                          </a:solidFill>
+                          <a:latin typeface="Segoe UI" pitchFamily="34" charset="0"/>
+                          <a:ea typeface="Segoe UI" pitchFamily="34" charset="-122"/>
+                          <a:cs typeface="Segoe UI" pitchFamily="34" charset="-120"/>
+                        </a:rPr>
+                        <a:t>Fallback hospital when request omits it</a:t>
                       </a:r>
                       <a:endParaRPr lang="en-US" sz="1125" dirty="0">
                         <a:latin typeface="Segoe UI" charset="0"/>
@@ -8688,7 +8890,7 @@
                           <a:ea typeface="Consolas" pitchFamily="34" charset="-122"/>
                           <a:cs typeface="Consolas" pitchFamily="34" charset="-120"/>
                         </a:rPr>
-                        <a:t>wkbh_id</a:t>
+                        <a:t>wkbh_station_name</a:t>
                       </a:r>
                       <a:endParaRPr lang="en-US" sz="1125" dirty="0">
                         <a:latin typeface="Consolas" charset="0"/>
@@ -8738,7 +8940,7 @@
                           <a:ea typeface="Segoe UI" pitchFamily="34" charset="-122"/>
                           <a:cs typeface="Segoe UI" pitchFamily="34" charset="-120"/>
                         </a:rPr>
-                        <a:t>char(8)</a:t>
+                        <a:t>varchar(255)</a:t>
                       </a:r>
                       <a:endParaRPr lang="en-US" sz="1125" dirty="0">
                         <a:latin typeface="Segoe UI" charset="0"/>
@@ -8788,7 +8990,7 @@
                           <a:ea typeface="Segoe UI" pitchFamily="34" charset="-122"/>
                           <a:cs typeface="Segoe UI" pitchFamily="34" charset="-120"/>
                         </a:rPr>
-                        <a:t>LIS user; PK with wkbh_labno</a:t>
+                        <a:t>Workbench from sorterId</a:t>
                       </a:r>
                       <a:endParaRPr lang="en-US" sz="1125" dirty="0">
                         <a:latin typeface="Segoe UI" charset="0"/>
@@ -8890,6 +9092,404 @@
                           <a:ea typeface="Consolas" pitchFamily="34" charset="-122"/>
                           <a:cs typeface="Consolas" pitchFamily="34" charset="-120"/>
                         </a:rPr>
+                        <a:t>wkbh_id</a:t>
+                      </a:r>
+                      <a:endParaRPr lang="en-US" sz="1125" dirty="0">
+                        <a:latin typeface="Consolas" charset="0"/>
+                        <a:ea typeface="Consolas" charset="0"/>
+                        <a:cs typeface="Consolas" charset="0"/>
+                      </a:endParaRPr>
+                    </a:p>
+                  </a:txBody>
+                  <a:tcPr marL="201168" marR="201168" marT="54864" marB="54864" anchor="ctr">
+                    <a:lnL w="0" cap="flat" cmpd="sng" algn="ctr">
+                      <a:noFill/>
+                    </a:lnL>
+                    <a:lnR w="0" cap="flat" cmpd="sng" algn="ctr">
+                      <a:noFill/>
+                    </a:lnR>
+                    <a:lnT w="0" cap="flat" cmpd="sng" algn="ctr">
+                      <a:noFill/>
+                    </a:lnT>
+                    <a:lnB w="9525" cap="flat" cmpd="sng" algn="ctr">
+                      <a:solidFill>
+                        <a:srgbClr val="E2E8F0"/>
+                      </a:solidFill>
+                      <a:prstDash val="solid"/>
+                      <a:round/>
+                      <a:headEnd type="none" w="med" len="med"/>
+                      <a:tailEnd type="none" w="med" len="med"/>
+                    </a:lnB>
+                    <a:solidFill>
+                      <a:srgbClr val="FFFFFF"/>
+                    </a:solidFill>
+                  </a:tcPr>
+                </a:tc>
+                <a:tc>
+                  <a:txBody>
+                    <a:bodyPr/>
+                    <a:lstStyle/>
+                    <a:p>
+                      <a:pPr algn="l" indent="0" marL="0">
+                        <a:buNone/>
+                      </a:pPr>
+                      <a:r>
+                        <a:rPr lang="en-US" sz="1125" dirty="0">
+                          <a:solidFill>
+                            <a:srgbClr val="475569"/>
+                          </a:solidFill>
+                          <a:latin typeface="Segoe UI" pitchFamily="34" charset="0"/>
+                          <a:ea typeface="Segoe UI" pitchFamily="34" charset="-122"/>
+                          <a:cs typeface="Segoe UI" pitchFamily="34" charset="-120"/>
+                        </a:rPr>
+                        <a:t>char(8)</a:t>
+                      </a:r>
+                      <a:endParaRPr lang="en-US" sz="1125" dirty="0">
+                        <a:latin typeface="Segoe UI" charset="0"/>
+                        <a:ea typeface="Segoe UI" charset="0"/>
+                        <a:cs typeface="Segoe UI" charset="0"/>
+                      </a:endParaRPr>
+                    </a:p>
+                  </a:txBody>
+                  <a:tcPr marL="201168" marR="201168" marT="54864" marB="54864" anchor="ctr">
+                    <a:lnL w="0" cap="flat" cmpd="sng" algn="ctr">
+                      <a:noFill/>
+                    </a:lnL>
+                    <a:lnR w="0" cap="flat" cmpd="sng" algn="ctr">
+                      <a:noFill/>
+                    </a:lnR>
+                    <a:lnT w="0" cap="flat" cmpd="sng" algn="ctr">
+                      <a:noFill/>
+                    </a:lnT>
+                    <a:lnB w="9525" cap="flat" cmpd="sng" algn="ctr">
+                      <a:solidFill>
+                        <a:srgbClr val="E2E8F0"/>
+                      </a:solidFill>
+                      <a:prstDash val="solid"/>
+                      <a:round/>
+                      <a:headEnd type="none" w="med" len="med"/>
+                      <a:tailEnd type="none" w="med" len="med"/>
+                    </a:lnB>
+                    <a:solidFill>
+                      <a:srgbClr val="FFFFFF"/>
+                    </a:solidFill>
+                  </a:tcPr>
+                </a:tc>
+                <a:tc>
+                  <a:txBody>
+                    <a:bodyPr/>
+                    <a:lstStyle/>
+                    <a:p>
+                      <a:pPr algn="l" indent="0" marL="0">
+                        <a:buNone/>
+                      </a:pPr>
+                      <a:r>
+                        <a:rPr lang="en-US" sz="1125" dirty="0">
+                          <a:solidFill>
+                            <a:srgbClr val="475569"/>
+                          </a:solidFill>
+                          <a:latin typeface="Segoe UI" pitchFamily="34" charset="0"/>
+                          <a:ea typeface="Segoe UI" pitchFamily="34" charset="-122"/>
+                          <a:cs typeface="Segoe UI" pitchFamily="34" charset="-120"/>
+                        </a:rPr>
+                        <a:t>User from that workbench row</a:t>
+                      </a:r>
+                      <a:endParaRPr lang="en-US" sz="1125" dirty="0">
+                        <a:latin typeface="Segoe UI" charset="0"/>
+                        <a:ea typeface="Segoe UI" charset="0"/>
+                        <a:cs typeface="Segoe UI" charset="0"/>
+                      </a:endParaRPr>
+                    </a:p>
+                  </a:txBody>
+                  <a:tcPr marL="201168" marR="201168" marT="54864" marB="54864" anchor="ctr">
+                    <a:lnL w="0" cap="flat" cmpd="sng" algn="ctr">
+                      <a:noFill/>
+                    </a:lnL>
+                    <a:lnR w="0" cap="flat" cmpd="sng" algn="ctr">
+                      <a:noFill/>
+                    </a:lnR>
+                    <a:lnT w="0" cap="flat" cmpd="sng" algn="ctr">
+                      <a:noFill/>
+                    </a:lnT>
+                    <a:lnB w="9525" cap="flat" cmpd="sng" algn="ctr">
+                      <a:solidFill>
+                        <a:srgbClr val="E2E8F0"/>
+                      </a:solidFill>
+                      <a:prstDash val="solid"/>
+                      <a:round/>
+                      <a:headEnd type="none" w="med" len="med"/>
+                      <a:tailEnd type="none" w="med" len="med"/>
+                    </a:lnB>
+                    <a:solidFill>
+                      <a:srgbClr val="FFFFFF"/>
+                    </a:solidFill>
+                  </a:tcPr>
+                </a:tc>
+              </a:tr>
+              <a:tr h="457200">
+                <a:tc>
+                  <a:txBody>
+                    <a:bodyPr/>
+                    <a:lstStyle/>
+                    <a:p>
+                      <a:pPr algn="l" indent="0" marL="0">
+                        <a:buNone/>
+                      </a:pPr>
+                      <a:r>
+                        <a:rPr lang="en-US" sz="1125" b="1" dirty="0">
+                          <a:solidFill>
+                            <a:srgbClr val="0284C7"/>
+                          </a:solidFill>
+                          <a:latin typeface="Consolas" pitchFamily="34" charset="0"/>
+                          <a:ea typeface="Consolas" pitchFamily="34" charset="-122"/>
+                          <a:cs typeface="Consolas" pitchFamily="34" charset="-120"/>
+                        </a:rPr>
+                        <a:t>labuser</a:t>
+                      </a:r>
+                      <a:endParaRPr lang="en-US" sz="1125" dirty="0">
+                        <a:latin typeface="Consolas" charset="0"/>
+                        <a:ea typeface="Consolas" charset="0"/>
+                        <a:cs typeface="Consolas" charset="0"/>
+                      </a:endParaRPr>
+                    </a:p>
+                  </a:txBody>
+                  <a:tcPr marL="201168" marR="201168" marT="54864" marB="54864" anchor="ctr">
+                    <a:lnL w="0" cap="flat" cmpd="sng" algn="ctr">
+                      <a:noFill/>
+                    </a:lnL>
+                    <a:lnR w="0" cap="flat" cmpd="sng" algn="ctr">
+                      <a:noFill/>
+                    </a:lnR>
+                    <a:lnT w="0" cap="flat" cmpd="sng" algn="ctr">
+                      <a:noFill/>
+                    </a:lnT>
+                    <a:lnB w="9525" cap="flat" cmpd="sng" algn="ctr">
+                      <a:solidFill>
+                        <a:srgbClr val="E2E8F0"/>
+                      </a:solidFill>
+                      <a:prstDash val="solid"/>
+                      <a:round/>
+                      <a:headEnd type="none" w="med" len="med"/>
+                      <a:tailEnd type="none" w="med" len="med"/>
+                    </a:lnB>
+                    <a:solidFill>
+                      <a:srgbClr val="FFFFFF"/>
+                    </a:solidFill>
+                  </a:tcPr>
+                </a:tc>
+                <a:tc>
+                  <a:txBody>
+                    <a:bodyPr/>
+                    <a:lstStyle/>
+                    <a:p>
+                      <a:pPr algn="l" indent="0" marL="0">
+                        <a:buNone/>
+                      </a:pPr>
+                      <a:r>
+                        <a:rPr lang="en-US" sz="1125" b="1" dirty="0">
+                          <a:solidFill>
+                            <a:srgbClr val="0284C7"/>
+                          </a:solidFill>
+                          <a:latin typeface="Consolas" pitchFamily="34" charset="0"/>
+                          <a:ea typeface="Consolas" pitchFamily="34" charset="-122"/>
+                          <a:cs typeface="Consolas" pitchFamily="34" charset="-120"/>
+                        </a:rPr>
+                        <a:t>labuser_code</a:t>
+                      </a:r>
+                      <a:endParaRPr lang="en-US" sz="1125" dirty="0">
+                        <a:latin typeface="Consolas" charset="0"/>
+                        <a:ea typeface="Consolas" charset="0"/>
+                        <a:cs typeface="Consolas" charset="0"/>
+                      </a:endParaRPr>
+                    </a:p>
+                  </a:txBody>
+                  <a:tcPr marL="201168" marR="201168" marT="54864" marB="54864" anchor="ctr">
+                    <a:lnL w="0" cap="flat" cmpd="sng" algn="ctr">
+                      <a:noFill/>
+                    </a:lnL>
+                    <a:lnR w="0" cap="flat" cmpd="sng" algn="ctr">
+                      <a:noFill/>
+                    </a:lnR>
+                    <a:lnT w="0" cap="flat" cmpd="sng" algn="ctr">
+                      <a:noFill/>
+                    </a:lnT>
+                    <a:lnB w="9525" cap="flat" cmpd="sng" algn="ctr">
+                      <a:solidFill>
+                        <a:srgbClr val="E2E8F0"/>
+                      </a:solidFill>
+                      <a:prstDash val="solid"/>
+                      <a:round/>
+                      <a:headEnd type="none" w="med" len="med"/>
+                      <a:tailEnd type="none" w="med" len="med"/>
+                    </a:lnB>
+                    <a:solidFill>
+                      <a:srgbClr val="FFFFFF"/>
+                    </a:solidFill>
+                  </a:tcPr>
+                </a:tc>
+                <a:tc>
+                  <a:txBody>
+                    <a:bodyPr/>
+                    <a:lstStyle/>
+                    <a:p>
+                      <a:pPr algn="l" indent="0" marL="0">
+                        <a:buNone/>
+                      </a:pPr>
+                      <a:r>
+                        <a:rPr lang="en-US" sz="1125" b="1" dirty="0">
+                          <a:solidFill>
+                            <a:srgbClr val="0284C7"/>
+                          </a:solidFill>
+                          <a:latin typeface="Segoe UI" pitchFamily="34" charset="0"/>
+                          <a:ea typeface="Segoe UI" pitchFamily="34" charset="-122"/>
+                          <a:cs typeface="Segoe UI" pitchFamily="34" charset="-120"/>
+                        </a:rPr>
+                        <a:t>char(12)</a:t>
+                      </a:r>
+                      <a:endParaRPr lang="en-US" sz="1125" dirty="0">
+                        <a:latin typeface="Segoe UI" charset="0"/>
+                        <a:ea typeface="Segoe UI" charset="0"/>
+                        <a:cs typeface="Segoe UI" charset="0"/>
+                      </a:endParaRPr>
+                    </a:p>
+                  </a:txBody>
+                  <a:tcPr marL="201168" marR="201168" marT="54864" marB="54864" anchor="ctr">
+                    <a:lnL w="0" cap="flat" cmpd="sng" algn="ctr">
+                      <a:noFill/>
+                    </a:lnL>
+                    <a:lnR w="0" cap="flat" cmpd="sng" algn="ctr">
+                      <a:noFill/>
+                    </a:lnR>
+                    <a:lnT w="0" cap="flat" cmpd="sng" algn="ctr">
+                      <a:noFill/>
+                    </a:lnT>
+                    <a:lnB w="9525" cap="flat" cmpd="sng" algn="ctr">
+                      <a:solidFill>
+                        <a:srgbClr val="E2E8F0"/>
+                      </a:solidFill>
+                      <a:prstDash val="solid"/>
+                      <a:round/>
+                      <a:headEnd type="none" w="med" len="med"/>
+                      <a:tailEnd type="none" w="med" len="med"/>
+                    </a:lnB>
+                    <a:solidFill>
+                      <a:srgbClr val="FFFFFF"/>
+                    </a:solidFill>
+                  </a:tcPr>
+                </a:tc>
+                <a:tc>
+                  <a:txBody>
+                    <a:bodyPr/>
+                    <a:lstStyle/>
+                    <a:p>
+                      <a:pPr algn="l" indent="0" marL="0">
+                        <a:buNone/>
+                      </a:pPr>
+                      <a:r>
+                        <a:rPr lang="en-US" sz="1125" b="1" dirty="0">
+                          <a:solidFill>
+                            <a:srgbClr val="0284C7"/>
+                          </a:solidFill>
+                          <a:latin typeface="Segoe UI" pitchFamily="34" charset="0"/>
+                          <a:ea typeface="Segoe UI" pitchFamily="34" charset="-122"/>
+                          <a:cs typeface="Segoe UI" pitchFamily="34" charset="-120"/>
+                        </a:rPr>
+                        <a:t>Same value as wkbh_id</a:t>
+                      </a:r>
+                      <a:endParaRPr lang="en-US" sz="1125" dirty="0">
+                        <a:latin typeface="Segoe UI" charset="0"/>
+                        <a:ea typeface="Segoe UI" charset="0"/>
+                        <a:cs typeface="Segoe UI" charset="0"/>
+                      </a:endParaRPr>
+                    </a:p>
+                  </a:txBody>
+                  <a:tcPr marL="201168" marR="201168" marT="54864" marB="54864" anchor="ctr">
+                    <a:lnL w="0" cap="flat" cmpd="sng" algn="ctr">
+                      <a:noFill/>
+                    </a:lnL>
+                    <a:lnR w="0" cap="flat" cmpd="sng" algn="ctr">
+                      <a:noFill/>
+                    </a:lnR>
+                    <a:lnT w="0" cap="flat" cmpd="sng" algn="ctr">
+                      <a:noFill/>
+                    </a:lnT>
+                    <a:lnB w="9525" cap="flat" cmpd="sng" algn="ctr">
+                      <a:solidFill>
+                        <a:srgbClr val="E2E8F0"/>
+                      </a:solidFill>
+                      <a:prstDash val="solid"/>
+                      <a:round/>
+                      <a:headEnd type="none" w="med" len="med"/>
+                      <a:tailEnd type="none" w="med" len="med"/>
+                    </a:lnB>
+                    <a:solidFill>
+                      <a:srgbClr val="FFFFFF"/>
+                    </a:solidFill>
+                  </a:tcPr>
+                </a:tc>
+              </a:tr>
+              <a:tr h="457200">
+                <a:tc>
+                  <a:txBody>
+                    <a:bodyPr/>
+                    <a:lstStyle/>
+                    <a:p>
+                      <a:pPr algn="l" indent="0" marL="0">
+                        <a:buNone/>
+                      </a:pPr>
+                      <a:r>
+                        <a:rPr lang="en-US" sz="1125" dirty="0">
+                          <a:solidFill>
+                            <a:srgbClr val="0284C7"/>
+                          </a:solidFill>
+                          <a:latin typeface="Consolas" pitchFamily="34" charset="0"/>
+                          <a:ea typeface="Consolas" pitchFamily="34" charset="-122"/>
+                          <a:cs typeface="Consolas" pitchFamily="34" charset="-120"/>
+                        </a:rPr>
+                        <a:t>workbench</a:t>
+                      </a:r>
+                      <a:endParaRPr lang="en-US" sz="1125" dirty="0">
+                        <a:latin typeface="Consolas" charset="0"/>
+                        <a:ea typeface="Consolas" charset="0"/>
+                        <a:cs typeface="Consolas" charset="0"/>
+                      </a:endParaRPr>
+                    </a:p>
+                  </a:txBody>
+                  <a:tcPr marL="201168" marR="201168" marT="54864" marB="54864" anchor="ctr">
+                    <a:lnL w="0" cap="flat" cmpd="sng" algn="ctr">
+                      <a:noFill/>
+                    </a:lnL>
+                    <a:lnR w="0" cap="flat" cmpd="sng" algn="ctr">
+                      <a:noFill/>
+                    </a:lnR>
+                    <a:lnT w="0" cap="flat" cmpd="sng" algn="ctr">
+                      <a:noFill/>
+                    </a:lnT>
+                    <a:lnB w="0" cap="flat" cmpd="sng" algn="ctr">
+                      <a:noFill/>
+                    </a:lnB>
+                    <a:solidFill>
+                      <a:srgbClr val="FFFFFF"/>
+                    </a:solidFill>
+                  </a:tcPr>
+                </a:tc>
+                <a:tc>
+                  <a:txBody>
+                    <a:bodyPr/>
+                    <a:lstStyle/>
+                    <a:p>
+                      <a:pPr algn="l" indent="0" marL="0">
+                        <a:buNone/>
+                      </a:pPr>
+                      <a:r>
+                        <a:rPr lang="en-US" sz="1125" dirty="0">
+                          <a:solidFill>
+                            <a:srgbClr val="0284C7"/>
+                          </a:solidFill>
+                          <a:latin typeface="Consolas" pitchFamily="34" charset="0"/>
+                          <a:ea typeface="Consolas" pitchFamily="34" charset="-122"/>
+                          <a:cs typeface="Consolas" pitchFamily="34" charset="-120"/>
+                        </a:rPr>
                         <a:t>wkbh_hosp</a:t>
                       </a:r>
                       <a:endParaRPr lang="en-US" sz="1125" dirty="0">
@@ -8909,14 +9509,8 @@
                     <a:lnT w="0" cap="flat" cmpd="sng" algn="ctr">
                       <a:noFill/>
                     </a:lnT>
-                    <a:lnB w="9525" cap="flat" cmpd="sng" algn="ctr">
-                      <a:solidFill>
-                        <a:srgbClr val="E2E8F0"/>
-                      </a:solidFill>
-                      <a:prstDash val="solid"/>
-                      <a:round/>
-                      <a:headEnd type="none" w="med" len="med"/>
-                      <a:tailEnd type="none" w="med" len="med"/>
+                    <a:lnB w="0" cap="flat" cmpd="sng" algn="ctr">
+                      <a:noFill/>
                     </a:lnB>
                     <a:solidFill>
                       <a:srgbClr val="FFFFFF"/>
@@ -8959,14 +9553,8 @@
                     <a:lnT w="0" cap="flat" cmpd="sng" algn="ctr">
                       <a:noFill/>
                     </a:lnT>
-                    <a:lnB w="9525" cap="flat" cmpd="sng" algn="ctr">
-                      <a:solidFill>
-                        <a:srgbClr val="E2E8F0"/>
-                      </a:solidFill>
-                      <a:prstDash val="solid"/>
-                      <a:round/>
-                      <a:headEnd type="none" w="med" len="med"/>
-                      <a:tailEnd type="none" w="med" len="med"/>
+                    <a:lnB w="0" cap="flat" cmpd="sng" algn="ctr">
+                      <a:noFill/>
                     </a:lnB>
                     <a:solidFill>
                       <a:srgbClr val="FFFFFF"/>
@@ -9009,392 +9597,6 @@
                     <a:lnT w="0" cap="flat" cmpd="sng" algn="ctr">
                       <a:noFill/>
                     </a:lnT>
-                    <a:lnB w="9525" cap="flat" cmpd="sng" algn="ctr">
-                      <a:solidFill>
-                        <a:srgbClr val="E2E8F0"/>
-                      </a:solidFill>
-                      <a:prstDash val="solid"/>
-                      <a:round/>
-                      <a:headEnd type="none" w="med" len="med"/>
-                      <a:tailEnd type="none" w="med" len="med"/>
-                    </a:lnB>
-                    <a:solidFill>
-                      <a:srgbClr val="FFFFFF"/>
-                    </a:solidFill>
-                  </a:tcPr>
-                </a:tc>
-              </a:tr>
-              <a:tr h="457200">
-                <a:tc>
-                  <a:txBody>
-                    <a:bodyPr/>
-                    <a:lstStyle/>
-                    <a:p>
-                      <a:pPr algn="l" indent="0" marL="0">
-                        <a:buNone/>
-                      </a:pPr>
-                      <a:r>
-                        <a:rPr lang="en-US" sz="1125" dirty="0">
-                          <a:solidFill>
-                            <a:srgbClr val="0284C7"/>
-                          </a:solidFill>
-                          <a:latin typeface="Consolas" pitchFamily="34" charset="0"/>
-                          <a:ea typeface="Consolas" pitchFamily="34" charset="-122"/>
-                          <a:cs typeface="Consolas" pitchFamily="34" charset="-120"/>
-                        </a:rPr>
-                        <a:t>loe_specimen_sorter_map</a:t>
-                      </a:r>
-                      <a:endParaRPr lang="en-US" sz="1125" dirty="0">
-                        <a:latin typeface="Consolas" charset="0"/>
-                        <a:ea typeface="Consolas" charset="0"/>
-                        <a:cs typeface="Consolas" charset="0"/>
-                      </a:endParaRPr>
-                    </a:p>
-                  </a:txBody>
-                  <a:tcPr marL="201168" marR="201168" marT="54864" marB="54864" anchor="ctr">
-                    <a:lnL w="0" cap="flat" cmpd="sng" algn="ctr">
-                      <a:noFill/>
-                    </a:lnL>
-                    <a:lnR w="0" cap="flat" cmpd="sng" algn="ctr">
-                      <a:noFill/>
-                    </a:lnR>
-                    <a:lnT w="0" cap="flat" cmpd="sng" algn="ctr">
-                      <a:noFill/>
-                    </a:lnT>
-                    <a:lnB w="9525" cap="flat" cmpd="sng" algn="ctr">
-                      <a:solidFill>
-                        <a:srgbClr val="E2E8F0"/>
-                      </a:solidFill>
-                      <a:prstDash val="solid"/>
-                      <a:round/>
-                      <a:headEnd type="none" w="med" len="med"/>
-                      <a:tailEnd type="none" w="med" len="med"/>
-                    </a:lnB>
-                    <a:solidFill>
-                      <a:srgbClr val="FFFFFF"/>
-                    </a:solidFill>
-                  </a:tcPr>
-                </a:tc>
-                <a:tc>
-                  <a:txBody>
-                    <a:bodyPr/>
-                    <a:lstStyle/>
-                    <a:p>
-                      <a:pPr algn="l" indent="0" marL="0">
-                        <a:buNone/>
-                      </a:pPr>
-                      <a:r>
-                        <a:rPr lang="en-US" sz="1125" dirty="0">
-                          <a:solidFill>
-                            <a:srgbClr val="0284C7"/>
-                          </a:solidFill>
-                          <a:latin typeface="Consolas" pitchFamily="34" charset="0"/>
-                          <a:ea typeface="Consolas" pitchFamily="34" charset="-122"/>
-                          <a:cs typeface="Consolas" pitchFamily="34" charset="-120"/>
-                        </a:rPr>
-                        <a:t>loesort_sorter_id</a:t>
-                      </a:r>
-                      <a:endParaRPr lang="en-US" sz="1125" dirty="0">
-                        <a:latin typeface="Consolas" charset="0"/>
-                        <a:ea typeface="Consolas" charset="0"/>
-                        <a:cs typeface="Consolas" charset="0"/>
-                      </a:endParaRPr>
-                    </a:p>
-                  </a:txBody>
-                  <a:tcPr marL="201168" marR="201168" marT="54864" marB="54864" anchor="ctr">
-                    <a:lnL w="0" cap="flat" cmpd="sng" algn="ctr">
-                      <a:noFill/>
-                    </a:lnL>
-                    <a:lnR w="0" cap="flat" cmpd="sng" algn="ctr">
-                      <a:noFill/>
-                    </a:lnR>
-                    <a:lnT w="0" cap="flat" cmpd="sng" algn="ctr">
-                      <a:noFill/>
-                    </a:lnT>
-                    <a:lnB w="9525" cap="flat" cmpd="sng" algn="ctr">
-                      <a:solidFill>
-                        <a:srgbClr val="E2E8F0"/>
-                      </a:solidFill>
-                      <a:prstDash val="solid"/>
-                      <a:round/>
-                      <a:headEnd type="none" w="med" len="med"/>
-                      <a:tailEnd type="none" w="med" len="med"/>
-                    </a:lnB>
-                    <a:solidFill>
-                      <a:srgbClr val="FFFFFF"/>
-                    </a:solidFill>
-                  </a:tcPr>
-                </a:tc>
-                <a:tc>
-                  <a:txBody>
-                    <a:bodyPr/>
-                    <a:lstStyle/>
-                    <a:p>
-                      <a:pPr algn="l" indent="0" marL="0">
-                        <a:buNone/>
-                      </a:pPr>
-                      <a:r>
-                        <a:rPr lang="en-US" sz="1125" dirty="0">
-                          <a:solidFill>
-                            <a:srgbClr val="475569"/>
-                          </a:solidFill>
-                          <a:latin typeface="Segoe UI" pitchFamily="34" charset="0"/>
-                          <a:ea typeface="Segoe UI" pitchFamily="34" charset="-122"/>
-                          <a:cs typeface="Segoe UI" pitchFamily="34" charset="-120"/>
-                        </a:rPr>
-                        <a:t>VARCHAR2(64)</a:t>
-                      </a:r>
-                      <a:endParaRPr lang="en-US" sz="1125" dirty="0">
-                        <a:latin typeface="Segoe UI" charset="0"/>
-                        <a:ea typeface="Segoe UI" charset="0"/>
-                        <a:cs typeface="Segoe UI" charset="0"/>
-                      </a:endParaRPr>
-                    </a:p>
-                  </a:txBody>
-                  <a:tcPr marL="201168" marR="201168" marT="54864" marB="54864" anchor="ctr">
-                    <a:lnL w="0" cap="flat" cmpd="sng" algn="ctr">
-                      <a:noFill/>
-                    </a:lnL>
-                    <a:lnR w="0" cap="flat" cmpd="sng" algn="ctr">
-                      <a:noFill/>
-                    </a:lnR>
-                    <a:lnT w="0" cap="flat" cmpd="sng" algn="ctr">
-                      <a:noFill/>
-                    </a:lnT>
-                    <a:lnB w="9525" cap="flat" cmpd="sng" algn="ctr">
-                      <a:solidFill>
-                        <a:srgbClr val="E2E8F0"/>
-                      </a:solidFill>
-                      <a:prstDash val="solid"/>
-                      <a:round/>
-                      <a:headEnd type="none" w="med" len="med"/>
-                      <a:tailEnd type="none" w="med" len="med"/>
-                    </a:lnB>
-                    <a:solidFill>
-                      <a:srgbClr val="FFFFFF"/>
-                    </a:solidFill>
-                  </a:tcPr>
-                </a:tc>
-                <a:tc>
-                  <a:txBody>
-                    <a:bodyPr/>
-                    <a:lstStyle/>
-                    <a:p>
-                      <a:pPr algn="l" indent="0" marL="0">
-                        <a:buNone/>
-                      </a:pPr>
-                      <a:r>
-                        <a:rPr lang="en-US" sz="1125" dirty="0">
-                          <a:solidFill>
-                            <a:srgbClr val="475569"/>
-                          </a:solidFill>
-                          <a:latin typeface="Segoe UI" pitchFamily="34" charset="0"/>
-                          <a:ea typeface="Segoe UI" pitchFamily="34" charset="-122"/>
-                          <a:cs typeface="Segoe UI" pitchFamily="34" charset="-120"/>
-                        </a:rPr>
-                        <a:t>Fallback map PK; omit-hospital only</a:t>
-                      </a:r>
-                      <a:endParaRPr lang="en-US" sz="1125" dirty="0">
-                        <a:latin typeface="Segoe UI" charset="0"/>
-                        <a:ea typeface="Segoe UI" charset="0"/>
-                        <a:cs typeface="Segoe UI" charset="0"/>
-                      </a:endParaRPr>
-                    </a:p>
-                  </a:txBody>
-                  <a:tcPr marL="201168" marR="201168" marT="54864" marB="54864" anchor="ctr">
-                    <a:lnL w="0" cap="flat" cmpd="sng" algn="ctr">
-                      <a:noFill/>
-                    </a:lnL>
-                    <a:lnR w="0" cap="flat" cmpd="sng" algn="ctr">
-                      <a:noFill/>
-                    </a:lnR>
-                    <a:lnT w="0" cap="flat" cmpd="sng" algn="ctr">
-                      <a:noFill/>
-                    </a:lnT>
-                    <a:lnB w="9525" cap="flat" cmpd="sng" algn="ctr">
-                      <a:solidFill>
-                        <a:srgbClr val="E2E8F0"/>
-                      </a:solidFill>
-                      <a:prstDash val="solid"/>
-                      <a:round/>
-                      <a:headEnd type="none" w="med" len="med"/>
-                      <a:tailEnd type="none" w="med" len="med"/>
-                    </a:lnB>
-                    <a:solidFill>
-                      <a:srgbClr val="FFFFFF"/>
-                    </a:solidFill>
-                  </a:tcPr>
-                </a:tc>
-              </a:tr>
-              <a:tr h="457200">
-                <a:tc>
-                  <a:txBody>
-                    <a:bodyPr/>
-                    <a:lstStyle/>
-                    <a:p>
-                      <a:pPr algn="l" indent="0" marL="0">
-                        <a:buNone/>
-                      </a:pPr>
-                      <a:r>
-                        <a:rPr lang="en-US" sz="1125" dirty="0">
-                          <a:solidFill>
-                            <a:srgbClr val="0284C7"/>
-                          </a:solidFill>
-                          <a:latin typeface="Consolas" pitchFamily="34" charset="0"/>
-                          <a:ea typeface="Consolas" pitchFamily="34" charset="-122"/>
-                          <a:cs typeface="Consolas" pitchFamily="34" charset="-120"/>
-                        </a:rPr>
-                        <a:t>loe_specimen_sorter_map</a:t>
-                      </a:r>
-                      <a:endParaRPr lang="en-US" sz="1125" dirty="0">
-                        <a:latin typeface="Consolas" charset="0"/>
-                        <a:ea typeface="Consolas" charset="0"/>
-                        <a:cs typeface="Consolas" charset="0"/>
-                      </a:endParaRPr>
-                    </a:p>
-                  </a:txBody>
-                  <a:tcPr marL="201168" marR="201168" marT="54864" marB="54864" anchor="ctr">
-                    <a:lnL w="0" cap="flat" cmpd="sng" algn="ctr">
-                      <a:noFill/>
-                    </a:lnL>
-                    <a:lnR w="0" cap="flat" cmpd="sng" algn="ctr">
-                      <a:noFill/>
-                    </a:lnR>
-                    <a:lnT w="0" cap="flat" cmpd="sng" algn="ctr">
-                      <a:noFill/>
-                    </a:lnT>
-                    <a:lnB w="0" cap="flat" cmpd="sng" algn="ctr">
-                      <a:noFill/>
-                    </a:lnB>
-                    <a:solidFill>
-                      <a:srgbClr val="FFFFFF"/>
-                    </a:solidFill>
-                  </a:tcPr>
-                </a:tc>
-                <a:tc>
-                  <a:txBody>
-                    <a:bodyPr/>
-                    <a:lstStyle/>
-                    <a:p>
-                      <a:pPr algn="l" indent="0" marL="0">
-                        <a:buNone/>
-                      </a:pPr>
-                      <a:r>
-                        <a:rPr lang="en-US" sz="1125" dirty="0">
-                          <a:solidFill>
-                            <a:srgbClr val="0284C7"/>
-                          </a:solidFill>
-                          <a:latin typeface="Consolas" pitchFamily="34" charset="0"/>
-                          <a:ea typeface="Consolas" pitchFamily="34" charset="-122"/>
-                          <a:cs typeface="Consolas" pitchFamily="34" charset="-120"/>
-                        </a:rPr>
-                        <a:t>loesort_hosp</a:t>
-                      </a:r>
-                      <a:endParaRPr lang="en-US" sz="1125" dirty="0">
-                        <a:latin typeface="Consolas" charset="0"/>
-                        <a:ea typeface="Consolas" charset="0"/>
-                        <a:cs typeface="Consolas" charset="0"/>
-                      </a:endParaRPr>
-                    </a:p>
-                  </a:txBody>
-                  <a:tcPr marL="201168" marR="201168" marT="54864" marB="54864" anchor="ctr">
-                    <a:lnL w="0" cap="flat" cmpd="sng" algn="ctr">
-                      <a:noFill/>
-                    </a:lnL>
-                    <a:lnR w="0" cap="flat" cmpd="sng" algn="ctr">
-                      <a:noFill/>
-                    </a:lnR>
-                    <a:lnT w="0" cap="flat" cmpd="sng" algn="ctr">
-                      <a:noFill/>
-                    </a:lnT>
-                    <a:lnB w="0" cap="flat" cmpd="sng" algn="ctr">
-                      <a:noFill/>
-                    </a:lnB>
-                    <a:solidFill>
-                      <a:srgbClr val="FFFFFF"/>
-                    </a:solidFill>
-                  </a:tcPr>
-                </a:tc>
-                <a:tc>
-                  <a:txBody>
-                    <a:bodyPr/>
-                    <a:lstStyle/>
-                    <a:p>
-                      <a:pPr algn="l" indent="0" marL="0">
-                        <a:buNone/>
-                      </a:pPr>
-                      <a:r>
-                        <a:rPr lang="en-US" sz="1125" dirty="0">
-                          <a:solidFill>
-                            <a:srgbClr val="475569"/>
-                          </a:solidFill>
-                          <a:latin typeface="Segoe UI" pitchFamily="34" charset="0"/>
-                          <a:ea typeface="Segoe UI" pitchFamily="34" charset="-122"/>
-                          <a:cs typeface="Segoe UI" pitchFamily="34" charset="-120"/>
-                        </a:rPr>
-                        <a:t>VARCHAR2(8)</a:t>
-                      </a:r>
-                      <a:endParaRPr lang="en-US" sz="1125" dirty="0">
-                        <a:latin typeface="Segoe UI" charset="0"/>
-                        <a:ea typeface="Segoe UI" charset="0"/>
-                        <a:cs typeface="Segoe UI" charset="0"/>
-                      </a:endParaRPr>
-                    </a:p>
-                  </a:txBody>
-                  <a:tcPr marL="201168" marR="201168" marT="54864" marB="54864" anchor="ctr">
-                    <a:lnL w="0" cap="flat" cmpd="sng" algn="ctr">
-                      <a:noFill/>
-                    </a:lnL>
-                    <a:lnR w="0" cap="flat" cmpd="sng" algn="ctr">
-                      <a:noFill/>
-                    </a:lnR>
-                    <a:lnT w="0" cap="flat" cmpd="sng" algn="ctr">
-                      <a:noFill/>
-                    </a:lnT>
-                    <a:lnB w="0" cap="flat" cmpd="sng" algn="ctr">
-                      <a:noFill/>
-                    </a:lnB>
-                    <a:solidFill>
-                      <a:srgbClr val="FFFFFF"/>
-                    </a:solidFill>
-                  </a:tcPr>
-                </a:tc>
-                <a:tc>
-                  <a:txBody>
-                    <a:bodyPr/>
-                    <a:lstStyle/>
-                    <a:p>
-                      <a:pPr algn="l" indent="0" marL="0">
-                        <a:buNone/>
-                      </a:pPr>
-                      <a:r>
-                        <a:rPr lang="en-US" sz="1125" dirty="0">
-                          <a:solidFill>
-                            <a:srgbClr val="475569"/>
-                          </a:solidFill>
-                          <a:latin typeface="Segoe UI" pitchFamily="34" charset="0"/>
-                          <a:ea typeface="Segoe UI" pitchFamily="34" charset="-122"/>
-                          <a:cs typeface="Segoe UI" pitchFamily="34" charset="-120"/>
-                        </a:rPr>
-                        <a:t>Fallback hospital when request omits it</a:t>
-                      </a:r>
-                      <a:endParaRPr lang="en-US" sz="1125" dirty="0">
-                        <a:latin typeface="Segoe UI" charset="0"/>
-                        <a:ea typeface="Segoe UI" charset="0"/>
-                        <a:cs typeface="Segoe UI" charset="0"/>
-                      </a:endParaRPr>
-                    </a:p>
-                  </a:txBody>
-                  <a:tcPr marL="201168" marR="201168" marT="54864" marB="54864" anchor="ctr">
-                    <a:lnL w="0" cap="flat" cmpd="sng" algn="ctr">
-                      <a:noFill/>
-                    </a:lnL>
-                    <a:lnR w="0" cap="flat" cmpd="sng" algn="ctr">
-                      <a:noFill/>
-                    </a:lnR>
-                    <a:lnT w="0" cap="flat" cmpd="sng" algn="ctr">
-                      <a:noFill/>
-                    </a:lnT>
                     <a:lnB w="0" cap="flat" cmpd="sng" algn="ctr">
                       <a:noFill/>
                     </a:lnB>
@@ -9416,12 +9618,12 @@
         </p:nvSpPr>
         <p:spPr>
           <a:xfrm>
-            <a:off x="609600" y="1773936"/>
-            <a:ext cx="10972800" cy="2743200"/>
+            <a:off x="609600" y="1453896"/>
+            <a:ext cx="10972800" cy="3200400"/>
           </a:xfrm>
           <a:prstGeom prst="roundRect">
             <a:avLst>
-              <a:gd name="adj" fmla="val 4000"/>
+              <a:gd name="adj" fmla="val 3429"/>
             </a:avLst>
           </a:prstGeom>
           <a:solidFill>
@@ -9445,12 +9647,12 @@
         </p:nvSpPr>
         <p:spPr>
           <a:xfrm>
-            <a:off x="609600" y="4791456"/>
-            <a:ext cx="5335524" cy="1207008"/>
+            <a:off x="609600" y="4928616"/>
+            <a:ext cx="5335524" cy="1389888"/>
           </a:xfrm>
           <a:prstGeom prst="roundRect">
             <a:avLst>
-              <a:gd name="adj" fmla="val 9091"/>
+              <a:gd name="adj" fmla="val 7895"/>
             </a:avLst>
           </a:prstGeom>
           <a:solidFill>
@@ -9472,7 +9674,7 @@
         </p:nvSpPr>
         <p:spPr>
           <a:xfrm>
-            <a:off x="883920" y="5029200"/>
+            <a:off x="883920" y="5166360"/>
             <a:ext cx="4786884" cy="274320"/>
           </a:xfrm>
           <a:prstGeom prst="rect">
@@ -9500,7 +9702,7 @@
                 <a:ea typeface="Segoe UI Semibold" pitchFamily="34" charset="-122"/>
                 <a:cs typeface="Segoe UI Semibold" pitchFamily="34" charset="-120"/>
               </a:rPr>
-              <a:t>One sorter, more than one lab</a:t>
+              <a:t>Hospital mapping</a:t>
             </a:r>
             <a:endParaRPr lang="en-US" sz="1350" dirty="0"/>
           </a:p>
@@ -9514,8 +9716,8 @@
         </p:nvSpPr>
         <p:spPr>
           <a:xfrm>
-            <a:off x="883920" y="5358384"/>
-            <a:ext cx="4786884" cy="475488"/>
+            <a:off x="883920" y="5495544"/>
+            <a:ext cx="4786884" cy="658368"/>
           </a:xfrm>
           <a:prstGeom prst="rect">
             <a:avLst/>
@@ -9542,7 +9744,7 @@
                 <a:ea typeface="Segoe UI" pitchFamily="34" charset="-122"/>
                 <a:cs typeface="Segoe UI" pitchFamily="34" charset="-120"/>
               </a:rPr>
-              <a:t>Seed one workbench row per lab, same station name and wkbh_id. Missing row is Failure (D12).</a:t>
+              <a:t>Omitted hospital: loesort_sorter_id → loesort_hosp. Hospital sent: skip the map. Do not seed the map if every caller sends hospital (D15).</a:t>
             </a:r>
             <a:endParaRPr lang="en-US" sz="1200" dirty="0"/>
           </a:p>
@@ -9556,12 +9758,12 @@
         </p:nvSpPr>
         <p:spPr>
           <a:xfrm>
-            <a:off x="6246876" y="4791456"/>
-            <a:ext cx="5335524" cy="1207008"/>
+            <a:off x="6246876" y="4928616"/>
+            <a:ext cx="5335524" cy="1389888"/>
           </a:xfrm>
           <a:prstGeom prst="roundRect">
             <a:avLst>
-              <a:gd name="adj" fmla="val 9091"/>
+              <a:gd name="adj" fmla="val 7895"/>
             </a:avLst>
           </a:prstGeom>
           <a:solidFill>
@@ -9583,7 +9785,7 @@
         </p:nvSpPr>
         <p:spPr>
           <a:xfrm>
-            <a:off x="6521196" y="5029200"/>
+            <a:off x="6521196" y="5166360"/>
             <a:ext cx="4786884" cy="274320"/>
           </a:xfrm>
           <a:prstGeom prst="rect">
@@ -9611,7 +9813,7 @@
                 <a:ea typeface="Segoe UI Semibold" pitchFamily="34" charset="-122"/>
                 <a:cs typeface="Segoe UI Semibold" pitchFamily="34" charset="-120"/>
               </a:rPr>
-              <a:t>Map is optional</a:t>
+              <a:t>Workbench then user</a:t>
             </a:r>
             <a:endParaRPr lang="en-US" sz="1350" dirty="0"/>
           </a:p>
@@ -9625,8 +9827,8 @@
         </p:nvSpPr>
         <p:spPr>
           <a:xfrm>
-            <a:off x="6521196" y="5358384"/>
-            <a:ext cx="4786884" cy="475488"/>
+            <a:off x="6521196" y="5495544"/>
+            <a:ext cx="4786884" cy="658368"/>
           </a:xfrm>
           <a:prstGeom prst="rect">
             <a:avLst/>
@@ -9653,7 +9855,7 @@
                 <a:ea typeface="Segoe UI" pitchFamily="34" charset="-122"/>
                 <a:cs typeface="Segoe UI" pitchFamily="34" charset="-120"/>
               </a:rPr>
-              <a:t>If every caller sends hospital, do not seed loe_specimen_sorter_map (D15).</a:t>
+              <a:t>sorterId finds wkbh_station_name. User is wkbh_id on that row, same as labuser_code. One workbench row per lab (D12).</a:t>
             </a:r>
             <a:endParaRPr lang="en-US" sz="1200" dirty="0"/>
           </a:p>

</xml_diff>

<commit_message>
vault backup: 2026-09-22 15:27:02
</commit_message>
<xml_diff>
--- a/SDLC/Projects/TMP-specimen-sorter-api — Specimen Sorter API/assets/Specimen Sorter API v3.pptx
+++ b/SDLC/Projects/TMP-specimen-sorter-api — Specimen Sorter API/assets/Specimen Sorter API v3.pptx
@@ -1136,7 +1136,7 @@
           <a:p>
             <a:r>
               <a:rPr lang="en-US" dirty="0"/>
-              <a:t>A late worksheet does not change a status already returned (D4). Print failure is an ALS warning, nothing more.</a:t>
+              <a:t>A late worksheet does not change a status already returned. Print failure is an ALS warning, nothing more.</a:t>
             </a:r>
             <a:endParaRPr lang="en-US" dirty="0"/>
           </a:p>
@@ -1840,7 +1840,7 @@
           <a:p>
             <a:r>
               <a:rPr lang="en-US" dirty="0"/>
-              <a:t>A tube with both local and send-out tests fails rather than splitting (D3). Relabel is not reported as Failure.</a:t>
+              <a:t>A tube with both local and send-out tests fails rather than splitting. Relabel is not reported as Failure.</a:t>
             </a:r>
             <a:endParaRPr lang="en-US" dirty="0"/>
           </a:p>
@@ -8890,7 +8890,7 @@
                           <a:ea typeface="Consolas" pitchFamily="34" charset="-122"/>
                           <a:cs typeface="Consolas" pitchFamily="34" charset="-120"/>
                         </a:rPr>
-                        <a:t>wkbh_station_name</a:t>
+                        <a:t>wkbh_hosp</a:t>
                       </a:r>
                       <a:endParaRPr lang="en-US" sz="1125" dirty="0">
                         <a:latin typeface="Consolas" charset="0"/>
@@ -8940,7 +8940,7 @@
                           <a:ea typeface="Segoe UI" pitchFamily="34" charset="-122"/>
                           <a:cs typeface="Segoe UI" pitchFamily="34" charset="-120"/>
                         </a:rPr>
-                        <a:t>varchar(255)</a:t>
+                        <a:t>char(12)</a:t>
                       </a:r>
                       <a:endParaRPr lang="en-US" sz="1125" dirty="0">
                         <a:latin typeface="Segoe UI" charset="0"/>
@@ -8990,7 +8990,7 @@
                           <a:ea typeface="Segoe UI" pitchFamily="34" charset="-122"/>
                           <a:cs typeface="Segoe UI" pitchFamily="34" charset="-120"/>
                         </a:rPr>
-                        <a:t>Workbench from sorterId</a:t>
+                        <a:t>Must match request hospital</a:t>
                       </a:r>
                       <a:endParaRPr lang="en-US" sz="1125" dirty="0">
                         <a:latin typeface="Segoe UI" charset="0"/>
@@ -9092,7 +9092,7 @@
                           <a:ea typeface="Consolas" pitchFamily="34" charset="-122"/>
                           <a:cs typeface="Consolas" pitchFamily="34" charset="-120"/>
                         </a:rPr>
-                        <a:t>wkbh_id</a:t>
+                        <a:t>wkbh_station_name</a:t>
                       </a:r>
                       <a:endParaRPr lang="en-US" sz="1125" dirty="0">
                         <a:latin typeface="Consolas" charset="0"/>
@@ -9142,7 +9142,7 @@
                           <a:ea typeface="Segoe UI" pitchFamily="34" charset="-122"/>
                           <a:cs typeface="Segoe UI" pitchFamily="34" charset="-120"/>
                         </a:rPr>
-                        <a:t>char(8)</a:t>
+                        <a:t>varchar(255)</a:t>
                       </a:r>
                       <a:endParaRPr lang="en-US" sz="1125" dirty="0">
                         <a:latin typeface="Segoe UI" charset="0"/>
@@ -9192,209 +9192,7 @@
                           <a:ea typeface="Segoe UI" pitchFamily="34" charset="-122"/>
                           <a:cs typeface="Segoe UI" pitchFamily="34" charset="-120"/>
                         </a:rPr>
-                        <a:t>User from that workbench row</a:t>
-                      </a:r>
-                      <a:endParaRPr lang="en-US" sz="1125" dirty="0">
-                        <a:latin typeface="Segoe UI" charset="0"/>
-                        <a:ea typeface="Segoe UI" charset="0"/>
-                        <a:cs typeface="Segoe UI" charset="0"/>
-                      </a:endParaRPr>
-                    </a:p>
-                  </a:txBody>
-                  <a:tcPr marL="201168" marR="201168" marT="54864" marB="54864" anchor="ctr">
-                    <a:lnL w="0" cap="flat" cmpd="sng" algn="ctr">
-                      <a:noFill/>
-                    </a:lnL>
-                    <a:lnR w="0" cap="flat" cmpd="sng" algn="ctr">
-                      <a:noFill/>
-                    </a:lnR>
-                    <a:lnT w="0" cap="flat" cmpd="sng" algn="ctr">
-                      <a:noFill/>
-                    </a:lnT>
-                    <a:lnB w="9525" cap="flat" cmpd="sng" algn="ctr">
-                      <a:solidFill>
-                        <a:srgbClr val="E2E8F0"/>
-                      </a:solidFill>
-                      <a:prstDash val="solid"/>
-                      <a:round/>
-                      <a:headEnd type="none" w="med" len="med"/>
-                      <a:tailEnd type="none" w="med" len="med"/>
-                    </a:lnB>
-                    <a:solidFill>
-                      <a:srgbClr val="FFFFFF"/>
-                    </a:solidFill>
-                  </a:tcPr>
-                </a:tc>
-              </a:tr>
-              <a:tr h="457200">
-                <a:tc>
-                  <a:txBody>
-                    <a:bodyPr/>
-                    <a:lstStyle/>
-                    <a:p>
-                      <a:pPr algn="l" indent="0" marL="0">
-                        <a:buNone/>
-                      </a:pPr>
-                      <a:r>
-                        <a:rPr lang="en-US" sz="1125" b="1" dirty="0">
-                          <a:solidFill>
-                            <a:srgbClr val="0284C7"/>
-                          </a:solidFill>
-                          <a:latin typeface="Consolas" pitchFamily="34" charset="0"/>
-                          <a:ea typeface="Consolas" pitchFamily="34" charset="-122"/>
-                          <a:cs typeface="Consolas" pitchFamily="34" charset="-120"/>
-                        </a:rPr>
-                        <a:t>labuser</a:t>
-                      </a:r>
-                      <a:endParaRPr lang="en-US" sz="1125" dirty="0">
-                        <a:latin typeface="Consolas" charset="0"/>
-                        <a:ea typeface="Consolas" charset="0"/>
-                        <a:cs typeface="Consolas" charset="0"/>
-                      </a:endParaRPr>
-                    </a:p>
-                  </a:txBody>
-                  <a:tcPr marL="201168" marR="201168" marT="54864" marB="54864" anchor="ctr">
-                    <a:lnL w="0" cap="flat" cmpd="sng" algn="ctr">
-                      <a:noFill/>
-                    </a:lnL>
-                    <a:lnR w="0" cap="flat" cmpd="sng" algn="ctr">
-                      <a:noFill/>
-                    </a:lnR>
-                    <a:lnT w="0" cap="flat" cmpd="sng" algn="ctr">
-                      <a:noFill/>
-                    </a:lnT>
-                    <a:lnB w="9525" cap="flat" cmpd="sng" algn="ctr">
-                      <a:solidFill>
-                        <a:srgbClr val="E2E8F0"/>
-                      </a:solidFill>
-                      <a:prstDash val="solid"/>
-                      <a:round/>
-                      <a:headEnd type="none" w="med" len="med"/>
-                      <a:tailEnd type="none" w="med" len="med"/>
-                    </a:lnB>
-                    <a:solidFill>
-                      <a:srgbClr val="FFFFFF"/>
-                    </a:solidFill>
-                  </a:tcPr>
-                </a:tc>
-                <a:tc>
-                  <a:txBody>
-                    <a:bodyPr/>
-                    <a:lstStyle/>
-                    <a:p>
-                      <a:pPr algn="l" indent="0" marL="0">
-                        <a:buNone/>
-                      </a:pPr>
-                      <a:r>
-                        <a:rPr lang="en-US" sz="1125" b="1" dirty="0">
-                          <a:solidFill>
-                            <a:srgbClr val="0284C7"/>
-                          </a:solidFill>
-                          <a:latin typeface="Consolas" pitchFamily="34" charset="0"/>
-                          <a:ea typeface="Consolas" pitchFamily="34" charset="-122"/>
-                          <a:cs typeface="Consolas" pitchFamily="34" charset="-120"/>
-                        </a:rPr>
-                        <a:t>labuser_code</a:t>
-                      </a:r>
-                      <a:endParaRPr lang="en-US" sz="1125" dirty="0">
-                        <a:latin typeface="Consolas" charset="0"/>
-                        <a:ea typeface="Consolas" charset="0"/>
-                        <a:cs typeface="Consolas" charset="0"/>
-                      </a:endParaRPr>
-                    </a:p>
-                  </a:txBody>
-                  <a:tcPr marL="201168" marR="201168" marT="54864" marB="54864" anchor="ctr">
-                    <a:lnL w="0" cap="flat" cmpd="sng" algn="ctr">
-                      <a:noFill/>
-                    </a:lnL>
-                    <a:lnR w="0" cap="flat" cmpd="sng" algn="ctr">
-                      <a:noFill/>
-                    </a:lnR>
-                    <a:lnT w="0" cap="flat" cmpd="sng" algn="ctr">
-                      <a:noFill/>
-                    </a:lnT>
-                    <a:lnB w="9525" cap="flat" cmpd="sng" algn="ctr">
-                      <a:solidFill>
-                        <a:srgbClr val="E2E8F0"/>
-                      </a:solidFill>
-                      <a:prstDash val="solid"/>
-                      <a:round/>
-                      <a:headEnd type="none" w="med" len="med"/>
-                      <a:tailEnd type="none" w="med" len="med"/>
-                    </a:lnB>
-                    <a:solidFill>
-                      <a:srgbClr val="FFFFFF"/>
-                    </a:solidFill>
-                  </a:tcPr>
-                </a:tc>
-                <a:tc>
-                  <a:txBody>
-                    <a:bodyPr/>
-                    <a:lstStyle/>
-                    <a:p>
-                      <a:pPr algn="l" indent="0" marL="0">
-                        <a:buNone/>
-                      </a:pPr>
-                      <a:r>
-                        <a:rPr lang="en-US" sz="1125" b="1" dirty="0">
-                          <a:solidFill>
-                            <a:srgbClr val="0284C7"/>
-                          </a:solidFill>
-                          <a:latin typeface="Segoe UI" pitchFamily="34" charset="0"/>
-                          <a:ea typeface="Segoe UI" pitchFamily="34" charset="-122"/>
-                          <a:cs typeface="Segoe UI" pitchFamily="34" charset="-120"/>
-                        </a:rPr>
-                        <a:t>char(12)</a:t>
-                      </a:r>
-                      <a:endParaRPr lang="en-US" sz="1125" dirty="0">
-                        <a:latin typeface="Segoe UI" charset="0"/>
-                        <a:ea typeface="Segoe UI" charset="0"/>
-                        <a:cs typeface="Segoe UI" charset="0"/>
-                      </a:endParaRPr>
-                    </a:p>
-                  </a:txBody>
-                  <a:tcPr marL="201168" marR="201168" marT="54864" marB="54864" anchor="ctr">
-                    <a:lnL w="0" cap="flat" cmpd="sng" algn="ctr">
-                      <a:noFill/>
-                    </a:lnL>
-                    <a:lnR w="0" cap="flat" cmpd="sng" algn="ctr">
-                      <a:noFill/>
-                    </a:lnR>
-                    <a:lnT w="0" cap="flat" cmpd="sng" algn="ctr">
-                      <a:noFill/>
-                    </a:lnT>
-                    <a:lnB w="9525" cap="flat" cmpd="sng" algn="ctr">
-                      <a:solidFill>
-                        <a:srgbClr val="E2E8F0"/>
-                      </a:solidFill>
-                      <a:prstDash val="solid"/>
-                      <a:round/>
-                      <a:headEnd type="none" w="med" len="med"/>
-                      <a:tailEnd type="none" w="med" len="med"/>
-                    </a:lnB>
-                    <a:solidFill>
-                      <a:srgbClr val="FFFFFF"/>
-                    </a:solidFill>
-                  </a:tcPr>
-                </a:tc>
-                <a:tc>
-                  <a:txBody>
-                    <a:bodyPr/>
-                    <a:lstStyle/>
-                    <a:p>
-                      <a:pPr algn="l" indent="0" marL="0">
-                        <a:buNone/>
-                      </a:pPr>
-                      <a:r>
-                        <a:rPr lang="en-US" sz="1125" b="1" dirty="0">
-                          <a:solidFill>
-                            <a:srgbClr val="0284C7"/>
-                          </a:solidFill>
-                          <a:latin typeface="Segoe UI" pitchFamily="34" charset="0"/>
-                          <a:ea typeface="Segoe UI" pitchFamily="34" charset="-122"/>
-                          <a:cs typeface="Segoe UI" pitchFamily="34" charset="-120"/>
-                        </a:rPr>
-                        <a:t>Same value as wkbh_id</a:t>
+                        <a:t>Workbench from sorterId</a:t>
                       </a:r>
                       <a:endParaRPr lang="en-US" sz="1125" dirty="0">
                         <a:latin typeface="Segoe UI" charset="0"/>
@@ -9465,8 +9263,14 @@
                     <a:lnT w="0" cap="flat" cmpd="sng" algn="ctr">
                       <a:noFill/>
                     </a:lnT>
-                    <a:lnB w="0" cap="flat" cmpd="sng" algn="ctr">
-                      <a:noFill/>
+                    <a:lnB w="9525" cap="flat" cmpd="sng" algn="ctr">
+                      <a:solidFill>
+                        <a:srgbClr val="E2E8F0"/>
+                      </a:solidFill>
+                      <a:prstDash val="solid"/>
+                      <a:round/>
+                      <a:headEnd type="none" w="med" len="med"/>
+                      <a:tailEnd type="none" w="med" len="med"/>
                     </a:lnB>
                     <a:solidFill>
                       <a:srgbClr val="FFFFFF"/>
@@ -9490,7 +9294,203 @@
                           <a:ea typeface="Consolas" pitchFamily="34" charset="-122"/>
                           <a:cs typeface="Consolas" pitchFamily="34" charset="-120"/>
                         </a:rPr>
-                        <a:t>wkbh_hosp</a:t>
+                        <a:t>wkbh_id</a:t>
+                      </a:r>
+                      <a:endParaRPr lang="en-US" sz="1125" dirty="0">
+                        <a:latin typeface="Consolas" charset="0"/>
+                        <a:ea typeface="Consolas" charset="0"/>
+                        <a:cs typeface="Consolas" charset="0"/>
+                      </a:endParaRPr>
+                    </a:p>
+                  </a:txBody>
+                  <a:tcPr marL="201168" marR="201168" marT="54864" marB="54864" anchor="ctr">
+                    <a:lnL w="0" cap="flat" cmpd="sng" algn="ctr">
+                      <a:noFill/>
+                    </a:lnL>
+                    <a:lnR w="0" cap="flat" cmpd="sng" algn="ctr">
+                      <a:noFill/>
+                    </a:lnR>
+                    <a:lnT w="0" cap="flat" cmpd="sng" algn="ctr">
+                      <a:noFill/>
+                    </a:lnT>
+                    <a:lnB w="9525" cap="flat" cmpd="sng" algn="ctr">
+                      <a:solidFill>
+                        <a:srgbClr val="E2E8F0"/>
+                      </a:solidFill>
+                      <a:prstDash val="solid"/>
+                      <a:round/>
+                      <a:headEnd type="none" w="med" len="med"/>
+                      <a:tailEnd type="none" w="med" len="med"/>
+                    </a:lnB>
+                    <a:solidFill>
+                      <a:srgbClr val="FFFFFF"/>
+                    </a:solidFill>
+                  </a:tcPr>
+                </a:tc>
+                <a:tc>
+                  <a:txBody>
+                    <a:bodyPr/>
+                    <a:lstStyle/>
+                    <a:p>
+                      <a:pPr algn="l" indent="0" marL="0">
+                        <a:buNone/>
+                      </a:pPr>
+                      <a:r>
+                        <a:rPr lang="en-US" sz="1125" dirty="0">
+                          <a:solidFill>
+                            <a:srgbClr val="475569"/>
+                          </a:solidFill>
+                          <a:latin typeface="Segoe UI" pitchFamily="34" charset="0"/>
+                          <a:ea typeface="Segoe UI" pitchFamily="34" charset="-122"/>
+                          <a:cs typeface="Segoe UI" pitchFamily="34" charset="-120"/>
+                        </a:rPr>
+                        <a:t>char(8)</a:t>
+                      </a:r>
+                      <a:endParaRPr lang="en-US" sz="1125" dirty="0">
+                        <a:latin typeface="Segoe UI" charset="0"/>
+                        <a:ea typeface="Segoe UI" charset="0"/>
+                        <a:cs typeface="Segoe UI" charset="0"/>
+                      </a:endParaRPr>
+                    </a:p>
+                  </a:txBody>
+                  <a:tcPr marL="201168" marR="201168" marT="54864" marB="54864" anchor="ctr">
+                    <a:lnL w="0" cap="flat" cmpd="sng" algn="ctr">
+                      <a:noFill/>
+                    </a:lnL>
+                    <a:lnR w="0" cap="flat" cmpd="sng" algn="ctr">
+                      <a:noFill/>
+                    </a:lnR>
+                    <a:lnT w="0" cap="flat" cmpd="sng" algn="ctr">
+                      <a:noFill/>
+                    </a:lnT>
+                    <a:lnB w="9525" cap="flat" cmpd="sng" algn="ctr">
+                      <a:solidFill>
+                        <a:srgbClr val="E2E8F0"/>
+                      </a:solidFill>
+                      <a:prstDash val="solid"/>
+                      <a:round/>
+                      <a:headEnd type="none" w="med" len="med"/>
+                      <a:tailEnd type="none" w="med" len="med"/>
+                    </a:lnB>
+                    <a:solidFill>
+                      <a:srgbClr val="FFFFFF"/>
+                    </a:solidFill>
+                  </a:tcPr>
+                </a:tc>
+                <a:tc>
+                  <a:txBody>
+                    <a:bodyPr/>
+                    <a:lstStyle/>
+                    <a:p>
+                      <a:pPr algn="l" indent="0" marL="0">
+                        <a:buNone/>
+                      </a:pPr>
+                      <a:r>
+                        <a:rPr lang="en-US" sz="1125" dirty="0">
+                          <a:solidFill>
+                            <a:srgbClr val="475569"/>
+                          </a:solidFill>
+                          <a:latin typeface="Segoe UI" pitchFamily="34" charset="0"/>
+                          <a:ea typeface="Segoe UI" pitchFamily="34" charset="-122"/>
+                          <a:cs typeface="Segoe UI" pitchFamily="34" charset="-120"/>
+                        </a:rPr>
+                        <a:t>User from that workbench row</a:t>
+                      </a:r>
+                      <a:endParaRPr lang="en-US" sz="1125" dirty="0">
+                        <a:latin typeface="Segoe UI" charset="0"/>
+                        <a:ea typeface="Segoe UI" charset="0"/>
+                        <a:cs typeface="Segoe UI" charset="0"/>
+                      </a:endParaRPr>
+                    </a:p>
+                  </a:txBody>
+                  <a:tcPr marL="201168" marR="201168" marT="54864" marB="54864" anchor="ctr">
+                    <a:lnL w="0" cap="flat" cmpd="sng" algn="ctr">
+                      <a:noFill/>
+                    </a:lnL>
+                    <a:lnR w="0" cap="flat" cmpd="sng" algn="ctr">
+                      <a:noFill/>
+                    </a:lnR>
+                    <a:lnT w="0" cap="flat" cmpd="sng" algn="ctr">
+                      <a:noFill/>
+                    </a:lnT>
+                    <a:lnB w="9525" cap="flat" cmpd="sng" algn="ctr">
+                      <a:solidFill>
+                        <a:srgbClr val="E2E8F0"/>
+                      </a:solidFill>
+                      <a:prstDash val="solid"/>
+                      <a:round/>
+                      <a:headEnd type="none" w="med" len="med"/>
+                      <a:tailEnd type="none" w="med" len="med"/>
+                    </a:lnB>
+                    <a:solidFill>
+                      <a:srgbClr val="FFFFFF"/>
+                    </a:solidFill>
+                  </a:tcPr>
+                </a:tc>
+              </a:tr>
+              <a:tr h="457200">
+                <a:tc>
+                  <a:txBody>
+                    <a:bodyPr/>
+                    <a:lstStyle/>
+                    <a:p>
+                      <a:pPr algn="l" indent="0" marL="0">
+                        <a:buNone/>
+                      </a:pPr>
+                      <a:r>
+                        <a:rPr lang="en-US" sz="1125" dirty="0">
+                          <a:solidFill>
+                            <a:srgbClr val="0284C7"/>
+                          </a:solidFill>
+                          <a:latin typeface="Consolas" pitchFamily="34" charset="0"/>
+                          <a:ea typeface="Consolas" pitchFamily="34" charset="-122"/>
+                          <a:cs typeface="Consolas" pitchFamily="34" charset="-120"/>
+                        </a:rPr>
+                        <a:t>labuser</a:t>
+                      </a:r>
+                      <a:endParaRPr lang="en-US" sz="1125" dirty="0">
+                        <a:latin typeface="Consolas" charset="0"/>
+                        <a:ea typeface="Consolas" charset="0"/>
+                        <a:cs typeface="Consolas" charset="0"/>
+                      </a:endParaRPr>
+                    </a:p>
+                  </a:txBody>
+                  <a:tcPr marL="201168" marR="201168" marT="54864" marB="54864" anchor="ctr">
+                    <a:lnL w="0" cap="flat" cmpd="sng" algn="ctr">
+                      <a:noFill/>
+                    </a:lnL>
+                    <a:lnR w="0" cap="flat" cmpd="sng" algn="ctr">
+                      <a:noFill/>
+                    </a:lnR>
+                    <a:lnT w="0" cap="flat" cmpd="sng" algn="ctr">
+                      <a:noFill/>
+                    </a:lnT>
+                    <a:lnB w="0" cap="flat" cmpd="sng" algn="ctr">
+                      <a:noFill/>
+                    </a:lnB>
+                    <a:solidFill>
+                      <a:srgbClr val="FFFFFF"/>
+                    </a:solidFill>
+                  </a:tcPr>
+                </a:tc>
+                <a:tc>
+                  <a:txBody>
+                    <a:bodyPr/>
+                    <a:lstStyle/>
+                    <a:p>
+                      <a:pPr algn="l" indent="0" marL="0">
+                        <a:buNone/>
+                      </a:pPr>
+                      <a:r>
+                        <a:rPr lang="en-US" sz="1125" dirty="0">
+                          <a:solidFill>
+                            <a:srgbClr val="0284C7"/>
+                          </a:solidFill>
+                          <a:latin typeface="Consolas" pitchFamily="34" charset="0"/>
+                          <a:ea typeface="Consolas" pitchFamily="34" charset="-122"/>
+                          <a:cs typeface="Consolas" pitchFamily="34" charset="-120"/>
+                        </a:rPr>
+                        <a:t>labuser_code</a:t>
                       </a:r>
                       <a:endParaRPr lang="en-US" sz="1125" dirty="0">
                         <a:latin typeface="Consolas" charset="0"/>
@@ -9578,7 +9578,7 @@
                           <a:ea typeface="Segoe UI" pitchFamily="34" charset="-122"/>
                           <a:cs typeface="Segoe UI" pitchFamily="34" charset="-120"/>
                         </a:rPr>
-                        <a:t>Must match request hospital</a:t>
+                        <a:t>Same value as wkbh_id</a:t>
                       </a:r>
                       <a:endParaRPr lang="en-US" sz="1125" dirty="0">
                         <a:latin typeface="Segoe UI" charset="0"/>
@@ -9744,7 +9744,7 @@
                 <a:ea typeface="Segoe UI" pitchFamily="34" charset="-122"/>
                 <a:cs typeface="Segoe UI" pitchFamily="34" charset="-120"/>
               </a:rPr>
-              <a:t>Omitted hospital: loesort_sorter_id → loesort_hosp. Hospital sent: skip the map. Do not seed the map if every caller sends hospital (D15).</a:t>
+              <a:t>Omitted hospital: loesort_sorter_id → loesort_hosp. Hospital sent: skip the map. Do not seed the map if every caller sends hospital.</a:t>
             </a:r>
             <a:endParaRPr lang="en-US" sz="1200" dirty="0"/>
           </a:p>
@@ -9855,7 +9855,7 @@
                 <a:ea typeface="Segoe UI" pitchFamily="34" charset="-122"/>
                 <a:cs typeface="Segoe UI" pitchFamily="34" charset="-120"/>
               </a:rPr>
-              <a:t>sorterId finds wkbh_station_name. User is wkbh_id on that row, same as labuser_code. One workbench row per lab (D12).</a:t>
+              <a:t>sorterId finds wkbh_station_name. User is wkbh_id on that row, same as labuser_code. One workbench row per lab.</a:t>
             </a:r>
             <a:endParaRPr lang="en-US" sz="1200" dirty="0"/>
           </a:p>

</xml_diff>

<commit_message>
vault backup: 2026-09-22 15:36:55
</commit_message>
<xml_diff>
--- a/SDLC/Projects/TMP-specimen-sorter-api — Specimen Sorter API/assets/Specimen Sorter API v3.pptx
+++ b/SDLC/Projects/TMP-specimen-sorter-api — Specimen Sorter API/assets/Specimen Sorter API v3.pptx
@@ -23,10 +23,9 @@
     <p:sldId id="271" r:id="rId17"/>
     <p:sldId id="272" r:id="rId18"/>
     <p:sldId id="273" r:id="rId19"/>
-    <p:sldId id="274" r:id="rId20"/>
   </p:sldIdLst>
   <p:notesMasterIdLst>
-    <p:notesMasterId r:id="rId21"/>
+    <p:notesMasterId r:id="rId20"/>
   </p:notesMasterIdLst>
   <p:sldSz cx="12192000" cy="6858000"/>
   <p:notesSz cx="6858000" cy="12192000"/>
@@ -1224,7 +1223,7 @@
           <a:p>
             <a:r>
               <a:rPr lang="en-US" dirty="0"/>
-              <a:t>Print sits outside the 4 second budget, which is why it runs after the response.</a:t>
+              <a:t>Confirm the Audit Trail filter shows SORT_* before the pilot, or staff cannot find the sorter's attempts.</a:t>
             </a:r>
             <a:endParaRPr lang="en-US" dirty="0"/>
           </a:p>
@@ -1312,7 +1311,7 @@
           <a:p>
             <a:r>
               <a:rPr lang="en-US" dirty="0"/>
-              <a:t>Confirm the Audit Trail filter shows SORT_* before the pilot, or staff cannot find the sorter's attempts.</a:t>
+              <a:t>Likely questions: why not let middleware call the staff register; why hospital sent skips the map; why mixed tubes fail; why user is wkbh_id.</a:t>
             </a:r>
             <a:endParaRPr lang="en-US" dirty="0"/>
           </a:p>
@@ -1336,94 +1335,6 @@
             <a:fld id="{F7021451-1387-4CA6-816F-3879F97B5CBC}" type="slidenum">
               <a:rPr lang="en-US"/>
               <a:t>18</a:t>
-            </a:fld>
-            <a:endParaRPr lang="en-US"/>
-          </a:p>
-        </p:txBody>
-      </p:sp>
-    </p:spTree>
-    <p:extLst>
-      <p:ext uri="{BB962C8B-B14F-4D97-AF65-F5344CB8AC3E}">
-        <p14:creationId xmlns:p14="http://schemas.microsoft.com/office/powerpoint/2010/main" val="1024086991"/>
-      </p:ext>
-    </p:extLst>
-  </p:cSld>
-  <p:clrMapOvr>
-    <a:masterClrMapping/>
-  </p:clrMapOvr>
-</p:notes>
-</file>
-
-<file path=ppt/notesSlides/notesSlide19.xml><?xml version="1.0" encoding="utf-8"?>
-<p:notes xmlns:a="http://schemas.openxmlformats.org/drawingml/2006/main" xmlns:r="http://schemas.openxmlformats.org/officeDocument/2006/relationships" xmlns:p="http://schemas.openxmlformats.org/presentationml/2006/main">
-  <p:cSld>
-    <p:spTree>
-      <p:nvGrpSpPr>
-        <p:cNvPr id="1" name=""/>
-        <p:cNvGrpSpPr/>
-        <p:nvPr/>
-      </p:nvGrpSpPr>
-      <p:grpSpPr>
-        <a:xfrm>
-          <a:off x="0" y="0"/>
-          <a:ext cx="0" cy="0"/>
-          <a:chOff x="0" y="0"/>
-          <a:chExt cx="0" cy="0"/>
-        </a:xfrm>
-      </p:grpSpPr>
-      <p:sp>
-        <p:nvSpPr>
-          <p:cNvPr id="2" name="Slide Image Placeholder 1"/>
-          <p:cNvSpPr>
-            <a:spLocks noGrp="1" noRot="1" noChangeAspect="1"/>
-          </p:cNvSpPr>
-          <p:nvPr>
-            <p:ph type="sldImg"/>
-          </p:nvPr>
-        </p:nvSpPr>
-        <p:spPr/>
-      </p:sp>
-      <p:sp>
-        <p:nvSpPr>
-          <p:cNvPr id="3" name="Notes Placeholder 2"/>
-          <p:cNvSpPr>
-            <a:spLocks noGrp="1"/>
-          </p:cNvSpPr>
-          <p:nvPr>
-            <p:ph type="body" idx="1"/>
-          </p:nvPr>
-        </p:nvSpPr>
-        <p:spPr/>
-        <p:txBody>
-          <a:bodyPr/>
-          <a:lstStyle/>
-          <a:p>
-            <a:r>
-              <a:rPr lang="en-US" dirty="0"/>
-              <a:t>Likely questions: why not let middleware call the staff register; why hospital sent skips the map; why mixed tubes fail; why user is wkbh_id.</a:t>
-            </a:r>
-            <a:endParaRPr lang="en-US" dirty="0"/>
-          </a:p>
-        </p:txBody>
-      </p:sp>
-      <p:sp>
-        <p:nvSpPr>
-          <p:cNvPr id="4" name="Slide Number Placeholder 3"/>
-          <p:cNvSpPr>
-            <a:spLocks noGrp="1"/>
-          </p:cNvSpPr>
-          <p:nvPr>
-            <p:ph type="sldNum" sz="quarter" idx="10"/>
-          </p:nvPr>
-        </p:nvSpPr>
-        <p:spPr/>
-        <p:txBody>
-          <a:bodyPr/>
-          <a:lstStyle/>
-          <a:p>
-            <a:fld id="{F7021451-1387-4CA6-816F-3879F97B5CBC}" type="slidenum">
-              <a:rPr lang="en-US"/>
-              <a:t>19</a:t>
             </a:fld>
             <a:endParaRPr lang="en-US"/>
           </a:p>
@@ -8738,7 +8649,7 @@
                           <a:ea typeface="Segoe UI" pitchFamily="34" charset="-122"/>
                           <a:cs typeface="Segoe UI" pitchFamily="34" charset="-120"/>
                         </a:rPr>
-                        <a:t>VARCHAR2(8)</a:t>
+                        <a:t>VARCHAR2(3)</a:t>
                       </a:r>
                       <a:endParaRPr lang="en-US" sz="1125" dirty="0">
                         <a:latin typeface="Segoe UI" charset="0"/>
@@ -9744,7 +9655,47 @@
                 <a:ea typeface="Segoe UI" pitchFamily="34" charset="-122"/>
                 <a:cs typeface="Segoe UI" pitchFamily="34" charset="-120"/>
               </a:rPr>
-              <a:t>Omitted hospital: loesort_sorter_id → loesort_hosp. Hospital sent: skip the map. Do not seed the map if every caller sends hospital.</a:t>
+              <a:t>• Omitted hospital: loesort_sorter_id → loesort_hosp</a:t>
+            </a:r>
+            <a:endParaRPr lang="en-US" sz="1200" dirty="0"/>
+          </a:p>
+          <a:p>
+            <a:pPr algn="l" indent="0" marL="0">
+              <a:lnSpc>
+                <a:spcPct val="115000"/>
+              </a:lnSpc>
+              <a:buNone/>
+            </a:pPr>
+            <a:r>
+              <a:rPr lang="en-US" sz="1200" dirty="0">
+                <a:solidFill>
+                  <a:srgbClr val="475569"/>
+                </a:solidFill>
+                <a:latin typeface="Segoe UI" pitchFamily="34" charset="0"/>
+                <a:ea typeface="Segoe UI" pitchFamily="34" charset="-122"/>
+                <a:cs typeface="Segoe UI" pitchFamily="34" charset="-120"/>
+              </a:rPr>
+              <a:t>• Hospital sent: skip the map</a:t>
+            </a:r>
+            <a:endParaRPr lang="en-US" sz="1200" dirty="0"/>
+          </a:p>
+          <a:p>
+            <a:pPr algn="l" indent="0" marL="0">
+              <a:lnSpc>
+                <a:spcPct val="115000"/>
+              </a:lnSpc>
+              <a:buNone/>
+            </a:pPr>
+            <a:r>
+              <a:rPr lang="en-US" sz="1200" dirty="0">
+                <a:solidFill>
+                  <a:srgbClr val="475569"/>
+                </a:solidFill>
+                <a:latin typeface="Segoe UI" pitchFamily="34" charset="0"/>
+                <a:ea typeface="Segoe UI" pitchFamily="34" charset="-122"/>
+                <a:cs typeface="Segoe UI" pitchFamily="34" charset="-120"/>
+              </a:rPr>
+              <a:t>• Do not seed the map if every caller sends hospital.</a:t>
             </a:r>
             <a:endParaRPr lang="en-US" sz="1200" dirty="0"/>
           </a:p>
@@ -9855,7 +9806,27 @@
                 <a:ea typeface="Segoe UI" pitchFamily="34" charset="-122"/>
                 <a:cs typeface="Segoe UI" pitchFamily="34" charset="-120"/>
               </a:rPr>
-              <a:t>sorterId finds wkbh_station_name. User is wkbh_id on that row, same as labuser_code. One workbench row per lab.</a:t>
+              <a:t>• sorterId finds wkbh_station_name</a:t>
+            </a:r>
+            <a:endParaRPr lang="en-US" sz="1200" dirty="0"/>
+          </a:p>
+          <a:p>
+            <a:pPr algn="l" indent="0" marL="0">
+              <a:lnSpc>
+                <a:spcPct val="115000"/>
+              </a:lnSpc>
+              <a:buNone/>
+            </a:pPr>
+            <a:r>
+              <a:rPr lang="en-US" sz="1200" dirty="0">
+                <a:solidFill>
+                  <a:srgbClr val="475569"/>
+                </a:solidFill>
+                <a:latin typeface="Segoe UI" pitchFamily="34" charset="0"/>
+                <a:ea typeface="Segoe UI" pitchFamily="34" charset="-122"/>
+                <a:cs typeface="Segoe UI" pitchFamily="34" charset="-120"/>
+              </a:rPr>
+              <a:t>• User code is wkbh_id on that row, same as labuser_code</a:t>
             </a:r>
             <a:endParaRPr lang="en-US" sz="1200" dirty="0"/>
           </a:p>
@@ -10471,7 +10442,7 @@
                           <a:ea typeface="Segoe UI" pitchFamily="34" charset="-122"/>
                           <a:cs typeface="Segoe UI" pitchFamily="34" charset="-120"/>
                         </a:rPr>
-                        <a:t>Send-out, tracking, SORT_SO and SEND_OUT</a:t>
+                        <a:t>Send-out, tracking logs, SORT_SO and SEND_OUT</a:t>
                       </a:r>
                       <a:endParaRPr lang="en-US" sz="1125" dirty="0">
                         <a:latin typeface="Segoe UI" charset="0"/>
@@ -11083,7 +11054,7 @@
                 <a:ea typeface="Segoe UI Semibold" pitchFamily="34" charset="-122"/>
                 <a:cs typeface="Segoe UI Semibold" pitchFamily="34" charset="-120"/>
               </a:rPr>
-              <a:t>05. NON-FUNCTIONAL</a:t>
+              <a:t>06. PROMOTION AND FALLBACK</a:t>
             </a:r>
             <a:endParaRPr lang="en-US" sz="1050" dirty="0"/>
           </a:p>
@@ -11122,7 +11093,7 @@
                 <a:ea typeface="Segoe UI Semibold" pitchFamily="34" charset="-122"/>
                 <a:cs typeface="Segoe UI Semibold" pitchFamily="34" charset="-120"/>
               </a:rPr>
-              <a:t>One synchronous call per tube</a:t>
+              <a:t>Seed workbench, open the gateway path, pilot CPS and HMS</a:t>
             </a:r>
             <a:endParaRPr lang="en-US" sz="2400" dirty="0"/>
           </a:p>
@@ -11136,12 +11107,12 @@
         </p:nvSpPr>
         <p:spPr>
           <a:xfrm>
-            <a:off x="609600" y="3051810"/>
-            <a:ext cx="3505200" cy="1668780"/>
+            <a:off x="609600" y="2539032"/>
+            <a:ext cx="5335524" cy="2694337"/>
           </a:xfrm>
           <a:prstGeom prst="roundRect">
             <a:avLst>
-              <a:gd name="adj" fmla="val 6575"/>
+              <a:gd name="adj" fmla="val 4073"/>
             </a:avLst>
           </a:prstGeom>
           <a:solidFill>
@@ -11155,16 +11126,40 @@
           </a:ln>
         </p:spPr>
       </p:sp>
-      <p:sp>
-        <p:nvSpPr>
-          <p:cNvPr id="5" name="Text 3"/>
-          <p:cNvSpPr/>
-          <p:nvPr/>
-        </p:nvSpPr>
-        <p:spPr>
-          <a:xfrm>
-            <a:off x="701040" y="3362706"/>
-            <a:ext cx="3322320" cy="548640"/>
+      <p:pic>
+        <p:nvPicPr>
+          <p:cNvPr id="5" name="Image 0" descr="D:\Github\HA-Notes\LIS\skills\design-review-pptx\assets\icons\png\success\cloud-arrow-up.png">    </p:cNvPr>
+          <p:cNvPicPr>
+            <a:picLocks noChangeAspect="1"/>
+          </p:cNvPicPr>
+          <p:nvPr/>
+        </p:nvPicPr>
+        <p:blipFill>
+          <a:blip r:embed="rId1"/>
+          <a:stretch>
+            <a:fillRect/>
+          </a:stretch>
+        </p:blipFill>
+        <p:spPr>
+          <a:xfrm>
+            <a:off x="883920" y="2845356"/>
+            <a:ext cx="265176" cy="265176"/>
+          </a:xfrm>
+          <a:prstGeom prst="rect">
+            <a:avLst/>
+          </a:prstGeom>
+        </p:spPr>
+      </p:pic>
+      <p:sp>
+        <p:nvSpPr>
+          <p:cNvPr id="6" name="Text 3"/>
+          <p:cNvSpPr/>
+          <p:nvPr/>
+        </p:nvSpPr>
+        <p:spPr>
+          <a:xfrm>
+            <a:off x="1249680" y="2831640"/>
+            <a:ext cx="4421124" cy="292608"/>
           </a:xfrm>
           <a:prstGeom prst="rect">
             <a:avLst/>
@@ -11176,37 +11171,82 @@
           <a:bodyPr wrap="square" lIns="0" tIns="0" rIns="0" bIns="0" rtlCol="0" anchor="ctr"/>
           <a:lstStyle/>
           <a:p>
-            <a:pPr algn="ctr" indent="0" marL="0">
+            <a:pPr algn="l" indent="0" marL="0">
               <a:lnSpc>
                 <a:spcPct val="115000"/>
               </a:lnSpc>
               <a:buNone/>
             </a:pPr>
             <a:r>
-              <a:rPr lang="en-US" sz="3900" dirty="0">
-                <a:solidFill>
-                  <a:srgbClr val="0284C7"/>
+              <a:rPr lang="en-US" sz="1500" dirty="0">
+                <a:solidFill>
+                  <a:srgbClr val="0F172A"/>
                 </a:solidFill>
                 <a:latin typeface="Segoe UI Semibold" pitchFamily="34" charset="0"/>
                 <a:ea typeface="Segoe UI Semibold" pitchFamily="34" charset="-122"/>
                 <a:cs typeface="Segoe UI Semibold" pitchFamily="34" charset="-120"/>
               </a:rPr>
-              <a:t>&lt; 4 s</a:t>
-            </a:r>
-            <a:endParaRPr lang="en-US" sz="3900" dirty="0"/>
-          </a:p>
-        </p:txBody>
-      </p:sp>
-      <p:sp>
-        <p:nvSpPr>
-          <p:cNvPr id="6" name="Text 4"/>
-          <p:cNvSpPr/>
-          <p:nvPr/>
-        </p:nvSpPr>
-        <p:spPr>
-          <a:xfrm>
-            <a:off x="792480" y="3938778"/>
-            <a:ext cx="3139440" cy="237744"/>
+              <a:t>Promotion</a:t>
+            </a:r>
+            <a:endParaRPr lang="en-US" sz="1500" dirty="0"/>
+          </a:p>
+        </p:txBody>
+      </p:sp>
+      <p:sp>
+        <p:nvSpPr>
+          <p:cNvPr id="7" name="Text 4"/>
+          <p:cNvSpPr/>
+          <p:nvPr/>
+        </p:nvSpPr>
+        <p:spPr>
+          <a:xfrm>
+            <a:off x="883920" y="3261408"/>
+            <a:ext cx="228600" cy="228600"/>
+          </a:xfrm>
+          <a:prstGeom prst="ellipse">
+            <a:avLst/>
+          </a:prstGeom>
+          <a:solidFill>
+            <a:srgbClr val="DCFCE7"/>
+          </a:solidFill>
+          <a:ln>
+            <a:solidFill>
+              <a:srgbClr val="DCFCE7"/>
+            </a:solidFill>
+          </a:ln>
+        </p:spPr>
+        <p:txBody>
+          <a:bodyPr wrap="square" lIns="0" tIns="0" rIns="0" bIns="0" rtlCol="0" anchor="ctr"/>
+          <a:lstStyle/>
+          <a:p>
+            <a:pPr algn="ctr" indent="0" marL="0">
+              <a:buNone/>
+            </a:pPr>
+            <a:r>
+              <a:rPr lang="en-US" sz="975" b="1" dirty="0">
+                <a:solidFill>
+                  <a:srgbClr val="15803D"/>
+                </a:solidFill>
+                <a:latin typeface="Segoe UI" pitchFamily="34" charset="0"/>
+                <a:ea typeface="Segoe UI" pitchFamily="34" charset="-122"/>
+                <a:cs typeface="Segoe UI" pitchFamily="34" charset="-120"/>
+              </a:rPr>
+              <a:t>1</a:t>
+            </a:r>
+            <a:endParaRPr lang="en-US" sz="975" dirty="0"/>
+          </a:p>
+        </p:txBody>
+      </p:sp>
+      <p:sp>
+        <p:nvSpPr>
+          <p:cNvPr id="8" name="Text 5"/>
+          <p:cNvSpPr/>
+          <p:nvPr/>
+        </p:nvSpPr>
+        <p:spPr>
+          <a:xfrm>
+            <a:off x="1222248" y="3288840"/>
+            <a:ext cx="4448556" cy="196882"/>
           </a:xfrm>
           <a:prstGeom prst="rect">
             <a:avLst/>
@@ -11218,14 +11258,14 @@
           <a:bodyPr wrap="square" lIns="0" tIns="0" rIns="0" bIns="0" rtlCol="0" anchor="t"/>
           <a:lstStyle/>
           <a:p>
-            <a:pPr algn="ctr" indent="0" marL="0">
+            <a:pPr algn="l" indent="0" marL="0">
               <a:lnSpc>
                 <a:spcPct val="115000"/>
               </a:lnSpc>
               <a:buNone/>
             </a:pPr>
             <a:r>
-              <a:rPr lang="en-US" sz="1200" b="1" dirty="0">
+              <a:rPr lang="en-US" sz="1125" dirty="0">
                 <a:solidFill>
                   <a:srgbClr val="334155"/>
                 </a:solidFill>
@@ -11233,22 +11273,67 @@
                 <a:ea typeface="Segoe UI" pitchFamily="34" charset="-122"/>
                 <a:cs typeface="Segoe UI" pitchFamily="34" charset="-120"/>
               </a:rPr>
-              <a:t>p95 response</a:t>
-            </a:r>
-            <a:endParaRPr lang="en-US" sz="1200" dirty="0"/>
-          </a:p>
-        </p:txBody>
-      </p:sp>
-      <p:sp>
-        <p:nvSpPr>
-          <p:cNvPr id="7" name="Text 5"/>
-          <p:cNvSpPr/>
-          <p:nvPr/>
-        </p:nvSpPr>
-        <p:spPr>
-          <a:xfrm>
-            <a:off x="792480" y="4194810"/>
-            <a:ext cx="3139440" cy="205740"/>
+              <a:t>Seed workbench: station name = sorter id, user = wkbh_id.</a:t>
+            </a:r>
+            <a:endParaRPr lang="en-US" sz="1125" dirty="0"/>
+          </a:p>
+        </p:txBody>
+      </p:sp>
+      <p:sp>
+        <p:nvSpPr>
+          <p:cNvPr id="9" name="Text 6"/>
+          <p:cNvSpPr/>
+          <p:nvPr/>
+        </p:nvSpPr>
+        <p:spPr>
+          <a:xfrm>
+            <a:off x="883920" y="3595449"/>
+            <a:ext cx="228600" cy="228600"/>
+          </a:xfrm>
+          <a:prstGeom prst="ellipse">
+            <a:avLst/>
+          </a:prstGeom>
+          <a:solidFill>
+            <a:srgbClr val="DCFCE7"/>
+          </a:solidFill>
+          <a:ln>
+            <a:solidFill>
+              <a:srgbClr val="DCFCE7"/>
+            </a:solidFill>
+          </a:ln>
+        </p:spPr>
+        <p:txBody>
+          <a:bodyPr wrap="square" lIns="0" tIns="0" rIns="0" bIns="0" rtlCol="0" anchor="ctr"/>
+          <a:lstStyle/>
+          <a:p>
+            <a:pPr algn="ctr" indent="0" marL="0">
+              <a:buNone/>
+            </a:pPr>
+            <a:r>
+              <a:rPr lang="en-US" sz="975" b="1" dirty="0">
+                <a:solidFill>
+                  <a:srgbClr val="15803D"/>
+                </a:solidFill>
+                <a:latin typeface="Segoe UI" pitchFamily="34" charset="0"/>
+                <a:ea typeface="Segoe UI" pitchFamily="34" charset="-122"/>
+                <a:cs typeface="Segoe UI" pitchFamily="34" charset="-120"/>
+              </a:rPr>
+              <a:t>2</a:t>
+            </a:r>
+            <a:endParaRPr lang="en-US" sz="975" dirty="0"/>
+          </a:p>
+        </p:txBody>
+      </p:sp>
+      <p:sp>
+        <p:nvSpPr>
+          <p:cNvPr id="10" name="Text 7"/>
+          <p:cNvSpPr/>
+          <p:nvPr/>
+        </p:nvSpPr>
+        <p:spPr>
+          <a:xfrm>
+            <a:off x="1222248" y="3622881"/>
+            <a:ext cx="4448556" cy="196882"/>
           </a:xfrm>
           <a:prstGeom prst="rect">
             <a:avLst/>
@@ -11260,41 +11345,302 @@
           <a:bodyPr wrap="square" lIns="0" tIns="0" rIns="0" bIns="0" rtlCol="0" anchor="t"/>
           <a:lstStyle/>
           <a:p>
-            <a:pPr algn="ctr" indent="0" marL="0">
+            <a:pPr algn="l" indent="0" marL="0">
               <a:lnSpc>
                 <a:spcPct val="115000"/>
               </a:lnSpc>
               <a:buNone/>
             </a:pPr>
             <a:r>
-              <a:rPr lang="en-US" sz="1050" dirty="0">
-                <a:solidFill>
-                  <a:srgbClr val="64748B"/>
+              <a:rPr lang="en-US" sz="1125" dirty="0">
+                <a:solidFill>
+                  <a:srgbClr val="334155"/>
                 </a:solidFill>
                 <a:latin typeface="Segoe UI" pitchFamily="34" charset="0"/>
                 <a:ea typeface="Segoe UI" pitchFamily="34" charset="-122"/>
                 <a:cs typeface="Segoe UI" pitchFamily="34" charset="-120"/>
               </a:rPr>
-              <a:t>Through audit commit, print excluded</a:t>
-            </a:r>
-            <a:endParaRPr lang="en-US" sz="1050" dirty="0"/>
-          </a:p>
-        </p:txBody>
-      </p:sp>
-      <p:sp>
-        <p:nvSpPr>
-          <p:cNvPr id="8" name="Shape 6"/>
-          <p:cNvSpPr/>
-          <p:nvPr/>
-        </p:nvSpPr>
-        <p:spPr>
-          <a:xfrm>
-            <a:off x="4343400" y="3051810"/>
-            <a:ext cx="3505200" cy="1668780"/>
+              <a:t>Map row only if hospital can be omitted.</a:t>
+            </a:r>
+            <a:endParaRPr lang="en-US" sz="1125" dirty="0"/>
+          </a:p>
+        </p:txBody>
+      </p:sp>
+      <p:sp>
+        <p:nvSpPr>
+          <p:cNvPr id="11" name="Text 8"/>
+          <p:cNvSpPr/>
+          <p:nvPr/>
+        </p:nvSpPr>
+        <p:spPr>
+          <a:xfrm>
+            <a:off x="883920" y="3929491"/>
+            <a:ext cx="228600" cy="228600"/>
+          </a:xfrm>
+          <a:prstGeom prst="ellipse">
+            <a:avLst/>
+          </a:prstGeom>
+          <a:solidFill>
+            <a:srgbClr val="DCFCE7"/>
+          </a:solidFill>
+          <a:ln>
+            <a:solidFill>
+              <a:srgbClr val="DCFCE7"/>
+            </a:solidFill>
+          </a:ln>
+        </p:spPr>
+        <p:txBody>
+          <a:bodyPr wrap="square" lIns="0" tIns="0" rIns="0" bIns="0" rtlCol="0" anchor="ctr"/>
+          <a:lstStyle/>
+          <a:p>
+            <a:pPr algn="ctr" indent="0" marL="0">
+              <a:buNone/>
+            </a:pPr>
+            <a:r>
+              <a:rPr lang="en-US" sz="975" b="1" dirty="0">
+                <a:solidFill>
+                  <a:srgbClr val="15803D"/>
+                </a:solidFill>
+                <a:latin typeface="Segoe UI" pitchFamily="34" charset="0"/>
+                <a:ea typeface="Segoe UI" pitchFamily="34" charset="-122"/>
+                <a:cs typeface="Segoe UI" pitchFamily="34" charset="-120"/>
+              </a:rPr>
+              <a:t>3</a:t>
+            </a:r>
+            <a:endParaRPr lang="en-US" sz="975" dirty="0"/>
+          </a:p>
+        </p:txBody>
+      </p:sp>
+      <p:sp>
+        <p:nvSpPr>
+          <p:cNvPr id="12" name="Text 9"/>
+          <p:cNvSpPr/>
+          <p:nvPr/>
+        </p:nvSpPr>
+        <p:spPr>
+          <a:xfrm>
+            <a:off x="1222248" y="3956923"/>
+            <a:ext cx="4448556" cy="196882"/>
+          </a:xfrm>
+          <a:prstGeom prst="rect">
+            <a:avLst/>
+          </a:prstGeom>
+          <a:noFill/>
+          <a:ln/>
+        </p:spPr>
+        <p:txBody>
+          <a:bodyPr wrap="square" lIns="0" tIns="0" rIns="0" bIns="0" rtlCol="0" anchor="t"/>
+          <a:lstStyle/>
+          <a:p>
+            <a:pPr algn="l" indent="0" marL="0">
+              <a:lnSpc>
+                <a:spcPct val="115000"/>
+              </a:lnSpc>
+              <a:buNone/>
+            </a:pPr>
+            <a:r>
+              <a:rPr lang="en-US" sz="1125" dirty="0">
+                <a:solidFill>
+                  <a:srgbClr val="334155"/>
+                </a:solidFill>
+                <a:latin typeface="Segoe UI" pitchFamily="34" charset="0"/>
+                <a:ea typeface="Segoe UI" pitchFamily="34" charset="-122"/>
+                <a:cs typeface="Segoe UI" pitchFamily="34" charset="-120"/>
+              </a:rPr>
+              <a:t>Deploy lis-crs-spec-ack-svc.</a:t>
+            </a:r>
+            <a:endParaRPr lang="en-US" sz="1125" dirty="0"/>
+          </a:p>
+        </p:txBody>
+      </p:sp>
+      <p:sp>
+        <p:nvSpPr>
+          <p:cNvPr id="13" name="Text 10"/>
+          <p:cNvSpPr/>
+          <p:nvPr/>
+        </p:nvSpPr>
+        <p:spPr>
+          <a:xfrm>
+            <a:off x="883920" y="4263533"/>
+            <a:ext cx="228600" cy="228600"/>
+          </a:xfrm>
+          <a:prstGeom prst="ellipse">
+            <a:avLst/>
+          </a:prstGeom>
+          <a:solidFill>
+            <a:srgbClr val="DCFCE7"/>
+          </a:solidFill>
+          <a:ln>
+            <a:solidFill>
+              <a:srgbClr val="DCFCE7"/>
+            </a:solidFill>
+          </a:ln>
+        </p:spPr>
+        <p:txBody>
+          <a:bodyPr wrap="square" lIns="0" tIns="0" rIns="0" bIns="0" rtlCol="0" anchor="ctr"/>
+          <a:lstStyle/>
+          <a:p>
+            <a:pPr algn="ctr" indent="0" marL="0">
+              <a:buNone/>
+            </a:pPr>
+            <a:r>
+              <a:rPr lang="en-US" sz="975" b="1" dirty="0">
+                <a:solidFill>
+                  <a:srgbClr val="15803D"/>
+                </a:solidFill>
+                <a:latin typeface="Segoe UI" pitchFamily="34" charset="0"/>
+                <a:ea typeface="Segoe UI" pitchFamily="34" charset="-122"/>
+                <a:cs typeface="Segoe UI" pitchFamily="34" charset="-120"/>
+              </a:rPr>
+              <a:t>4</a:t>
+            </a:r>
+            <a:endParaRPr lang="en-US" sz="975" dirty="0"/>
+          </a:p>
+        </p:txBody>
+      </p:sp>
+      <p:sp>
+        <p:nvSpPr>
+          <p:cNvPr id="14" name="Text 11"/>
+          <p:cNvSpPr/>
+          <p:nvPr/>
+        </p:nvSpPr>
+        <p:spPr>
+          <a:xfrm>
+            <a:off x="1222248" y="4290965"/>
+            <a:ext cx="4448556" cy="196882"/>
+          </a:xfrm>
+          <a:prstGeom prst="rect">
+            <a:avLst/>
+          </a:prstGeom>
+          <a:noFill/>
+          <a:ln/>
+        </p:spPr>
+        <p:txBody>
+          <a:bodyPr wrap="square" lIns="0" tIns="0" rIns="0" bIns="0" rtlCol="0" anchor="t"/>
+          <a:lstStyle/>
+          <a:p>
+            <a:pPr algn="l" indent="0" marL="0">
+              <a:lnSpc>
+                <a:spcPct val="115000"/>
+              </a:lnSpc>
+              <a:buNone/>
+            </a:pPr>
+            <a:r>
+              <a:rPr lang="en-US" sz="1125" dirty="0">
+                <a:solidFill>
+                  <a:srgbClr val="334155"/>
+                </a:solidFill>
+                <a:latin typeface="Segoe UI" pitchFamily="34" charset="0"/>
+                <a:ea typeface="Segoe UI" pitchFamily="34" charset="-122"/>
+                <a:cs typeface="Segoe UI" pitchFamily="34" charset="-120"/>
+              </a:rPr>
+              <a:t>Publish the APIM product and NetworkPolicy.</a:t>
+            </a:r>
+            <a:endParaRPr lang="en-US" sz="1125" dirty="0"/>
+          </a:p>
+        </p:txBody>
+      </p:sp>
+      <p:sp>
+        <p:nvSpPr>
+          <p:cNvPr id="15" name="Text 12"/>
+          <p:cNvSpPr/>
+          <p:nvPr/>
+        </p:nvSpPr>
+        <p:spPr>
+          <a:xfrm>
+            <a:off x="883920" y="4597575"/>
+            <a:ext cx="228600" cy="228600"/>
+          </a:xfrm>
+          <a:prstGeom prst="ellipse">
+            <a:avLst/>
+          </a:prstGeom>
+          <a:solidFill>
+            <a:srgbClr val="DCFCE7"/>
+          </a:solidFill>
+          <a:ln>
+            <a:solidFill>
+              <a:srgbClr val="DCFCE7"/>
+            </a:solidFill>
+          </a:ln>
+        </p:spPr>
+        <p:txBody>
+          <a:bodyPr wrap="square" lIns="0" tIns="0" rIns="0" bIns="0" rtlCol="0" anchor="ctr"/>
+          <a:lstStyle/>
+          <a:p>
+            <a:pPr algn="ctr" indent="0" marL="0">
+              <a:buNone/>
+            </a:pPr>
+            <a:r>
+              <a:rPr lang="en-US" sz="975" b="1" dirty="0">
+                <a:solidFill>
+                  <a:srgbClr val="15803D"/>
+                </a:solidFill>
+                <a:latin typeface="Segoe UI" pitchFamily="34" charset="0"/>
+                <a:ea typeface="Segoe UI" pitchFamily="34" charset="-122"/>
+                <a:cs typeface="Segoe UI" pitchFamily="34" charset="-120"/>
+              </a:rPr>
+              <a:t>5</a:t>
+            </a:r>
+            <a:endParaRPr lang="en-US" sz="975" dirty="0"/>
+          </a:p>
+        </p:txBody>
+      </p:sp>
+      <p:sp>
+        <p:nvSpPr>
+          <p:cNvPr id="16" name="Text 13"/>
+          <p:cNvSpPr/>
+          <p:nvPr/>
+        </p:nvSpPr>
+        <p:spPr>
+          <a:xfrm>
+            <a:off x="1222248" y="4625007"/>
+            <a:ext cx="4448556" cy="196882"/>
+          </a:xfrm>
+          <a:prstGeom prst="rect">
+            <a:avLst/>
+          </a:prstGeom>
+          <a:noFill/>
+          <a:ln/>
+        </p:spPr>
+        <p:txBody>
+          <a:bodyPr wrap="square" lIns="0" tIns="0" rIns="0" bIns="0" rtlCol="0" anchor="t"/>
+          <a:lstStyle/>
+          <a:p>
+            <a:pPr algn="l" indent="0" marL="0">
+              <a:lnSpc>
+                <a:spcPct val="115000"/>
+              </a:lnSpc>
+              <a:buNone/>
+            </a:pPr>
+            <a:r>
+              <a:rPr lang="en-US" sz="1125" dirty="0">
+                <a:solidFill>
+                  <a:srgbClr val="334155"/>
+                </a:solidFill>
+                <a:latin typeface="Segoe UI" pitchFamily="34" charset="0"/>
+                <a:ea typeface="Segoe UI" pitchFamily="34" charset="-122"/>
+                <a:cs typeface="Segoe UI" pitchFamily="34" charset="-120"/>
+              </a:rPr>
+              <a:t>Pilot CPS and HMS.</a:t>
+            </a:r>
+            <a:endParaRPr lang="en-US" sz="1125" dirty="0"/>
+          </a:p>
+        </p:txBody>
+      </p:sp>
+      <p:sp>
+        <p:nvSpPr>
+          <p:cNvPr id="17" name="Shape 14"/>
+          <p:cNvSpPr/>
+          <p:nvPr/>
+        </p:nvSpPr>
+        <p:spPr>
+          <a:xfrm>
+            <a:off x="6246876" y="2539032"/>
+            <a:ext cx="5335524" cy="2694337"/>
           </a:xfrm>
           <a:prstGeom prst="roundRect">
             <a:avLst>
-              <a:gd name="adj" fmla="val 6575"/>
+              <a:gd name="adj" fmla="val 4073"/>
             </a:avLst>
           </a:prstGeom>
           <a:solidFill>
@@ -11308,16 +11654,40 @@
           </a:ln>
         </p:spPr>
       </p:sp>
-      <p:sp>
-        <p:nvSpPr>
-          <p:cNvPr id="9" name="Text 7"/>
-          <p:cNvSpPr/>
-          <p:nvPr/>
-        </p:nvSpPr>
-        <p:spPr>
-          <a:xfrm>
-            <a:off x="4434840" y="3362706"/>
-            <a:ext cx="3322320" cy="548640"/>
+      <p:pic>
+        <p:nvPicPr>
+          <p:cNvPr id="18" name="Image 1" descr="D:\Github\HA-Notes\LIS\skills\design-review-pptx\assets\icons\png\danger\rotate-left.png">    </p:cNvPr>
+          <p:cNvPicPr>
+            <a:picLocks noChangeAspect="1"/>
+          </p:cNvPicPr>
+          <p:nvPr/>
+        </p:nvPicPr>
+        <p:blipFill>
+          <a:blip r:embed="rId2"/>
+          <a:stretch>
+            <a:fillRect/>
+          </a:stretch>
+        </p:blipFill>
+        <p:spPr>
+          <a:xfrm>
+            <a:off x="6521196" y="2845356"/>
+            <a:ext cx="265176" cy="265176"/>
+          </a:xfrm>
+          <a:prstGeom prst="rect">
+            <a:avLst/>
+          </a:prstGeom>
+        </p:spPr>
+      </p:pic>
+      <p:sp>
+        <p:nvSpPr>
+          <p:cNvPr id="19" name="Text 15"/>
+          <p:cNvSpPr/>
+          <p:nvPr/>
+        </p:nvSpPr>
+        <p:spPr>
+          <a:xfrm>
+            <a:off x="6886956" y="2831640"/>
+            <a:ext cx="4421124" cy="292608"/>
           </a:xfrm>
           <a:prstGeom prst="rect">
             <a:avLst/>
@@ -11329,37 +11699,82 @@
           <a:bodyPr wrap="square" lIns="0" tIns="0" rIns="0" bIns="0" rtlCol="0" anchor="ctr"/>
           <a:lstStyle/>
           <a:p>
-            <a:pPr algn="ctr" indent="0" marL="0">
+            <a:pPr algn="l" indent="0" marL="0">
               <a:lnSpc>
                 <a:spcPct val="115000"/>
               </a:lnSpc>
               <a:buNone/>
             </a:pPr>
             <a:r>
-              <a:rPr lang="en-US" sz="3900" dirty="0">
-                <a:solidFill>
-                  <a:srgbClr val="0284C7"/>
+              <a:rPr lang="en-US" sz="1500" dirty="0">
+                <a:solidFill>
+                  <a:srgbClr val="0F172A"/>
                 </a:solidFill>
                 <a:latin typeface="Segoe UI Semibold" pitchFamily="34" charset="0"/>
                 <a:ea typeface="Segoe UI Semibold" pitchFamily="34" charset="-122"/>
                 <a:cs typeface="Segoe UI Semibold" pitchFamily="34" charset="-120"/>
               </a:rPr>
-              <a:t>~20/min</a:t>
-            </a:r>
-            <a:endParaRPr lang="en-US" sz="3900" dirty="0"/>
-          </a:p>
-        </p:txBody>
-      </p:sp>
-      <p:sp>
-        <p:nvSpPr>
-          <p:cNvPr id="10" name="Text 8"/>
-          <p:cNvSpPr/>
-          <p:nvPr/>
-        </p:nvSpPr>
-        <p:spPr>
-          <a:xfrm>
-            <a:off x="4526280" y="3938778"/>
-            <a:ext cx="3139440" cy="237744"/>
+              <a:t>Fallback</a:t>
+            </a:r>
+            <a:endParaRPr lang="en-US" sz="1500" dirty="0"/>
+          </a:p>
+        </p:txBody>
+      </p:sp>
+      <p:sp>
+        <p:nvSpPr>
+          <p:cNvPr id="20" name="Text 16"/>
+          <p:cNvSpPr/>
+          <p:nvPr/>
+        </p:nvSpPr>
+        <p:spPr>
+          <a:xfrm>
+            <a:off x="6521196" y="3261408"/>
+            <a:ext cx="228600" cy="228600"/>
+          </a:xfrm>
+          <a:prstGeom prst="ellipse">
+            <a:avLst/>
+          </a:prstGeom>
+          <a:solidFill>
+            <a:srgbClr val="FEE2E2"/>
+          </a:solidFill>
+          <a:ln>
+            <a:solidFill>
+              <a:srgbClr val="FEE2E2"/>
+            </a:solidFill>
+          </a:ln>
+        </p:spPr>
+        <p:txBody>
+          <a:bodyPr wrap="square" lIns="0" tIns="0" rIns="0" bIns="0" rtlCol="0" anchor="ctr"/>
+          <a:lstStyle/>
+          <a:p>
+            <a:pPr algn="ctr" indent="0" marL="0">
+              <a:buNone/>
+            </a:pPr>
+            <a:r>
+              <a:rPr lang="en-US" sz="975" b="1" dirty="0">
+                <a:solidFill>
+                  <a:srgbClr val="B91C1C"/>
+                </a:solidFill>
+                <a:latin typeface="Segoe UI" pitchFamily="34" charset="0"/>
+                <a:ea typeface="Segoe UI" pitchFamily="34" charset="-122"/>
+                <a:cs typeface="Segoe UI" pitchFamily="34" charset="-120"/>
+              </a:rPr>
+              <a:t>1</a:t>
+            </a:r>
+            <a:endParaRPr lang="en-US" sz="975" dirty="0"/>
+          </a:p>
+        </p:txBody>
+      </p:sp>
+      <p:sp>
+        <p:nvSpPr>
+          <p:cNvPr id="21" name="Text 17"/>
+          <p:cNvSpPr/>
+          <p:nvPr/>
+        </p:nvSpPr>
+        <p:spPr>
+          <a:xfrm>
+            <a:off x="6859524" y="3288840"/>
+            <a:ext cx="4448556" cy="196882"/>
           </a:xfrm>
           <a:prstGeom prst="rect">
             <a:avLst/>
@@ -11371,14 +11786,14 @@
           <a:bodyPr wrap="square" lIns="0" tIns="0" rIns="0" bIns="0" rtlCol="0" anchor="t"/>
           <a:lstStyle/>
           <a:p>
-            <a:pPr algn="ctr" indent="0" marL="0">
+            <a:pPr algn="l" indent="0" marL="0">
               <a:lnSpc>
                 <a:spcPct val="115000"/>
               </a:lnSpc>
               <a:buNone/>
             </a:pPr>
             <a:r>
-              <a:rPr lang="en-US" sz="1200" b="1" dirty="0">
+              <a:rPr lang="en-US" sz="1125" dirty="0">
                 <a:solidFill>
                   <a:srgbClr val="334155"/>
                 </a:solidFill>
@@ -11386,22 +11801,67 @@
                 <a:ea typeface="Segoe UI" pitchFamily="34" charset="-122"/>
                 <a:cs typeface="Segoe UI" pitchFamily="34" charset="-120"/>
               </a:rPr>
-              <a:t>Per lab in v1</a:t>
-            </a:r>
-            <a:endParaRPr lang="en-US" sz="1200" dirty="0"/>
-          </a:p>
-        </p:txBody>
-      </p:sp>
-      <p:sp>
-        <p:nvSpPr>
-          <p:cNvPr id="11" name="Text 9"/>
-          <p:cNvSpPr/>
-          <p:nvPr/>
-        </p:nvSpPr>
-        <p:spPr>
-          <a:xfrm>
-            <a:off x="4526280" y="4194810"/>
-            <a:ext cx="3139440" cy="205740"/>
+              <a:t>Stop the middleware. Staff Spec Ack is unchanged.</a:t>
+            </a:r>
+            <a:endParaRPr lang="en-US" sz="1125" dirty="0"/>
+          </a:p>
+        </p:txBody>
+      </p:sp>
+      <p:sp>
+        <p:nvSpPr>
+          <p:cNvPr id="22" name="Text 18"/>
+          <p:cNvSpPr/>
+          <p:nvPr/>
+        </p:nvSpPr>
+        <p:spPr>
+          <a:xfrm>
+            <a:off x="6521196" y="3595449"/>
+            <a:ext cx="228600" cy="228600"/>
+          </a:xfrm>
+          <a:prstGeom prst="ellipse">
+            <a:avLst/>
+          </a:prstGeom>
+          <a:solidFill>
+            <a:srgbClr val="FEE2E2"/>
+          </a:solidFill>
+          <a:ln>
+            <a:solidFill>
+              <a:srgbClr val="FEE2E2"/>
+            </a:solidFill>
+          </a:ln>
+        </p:spPr>
+        <p:txBody>
+          <a:bodyPr wrap="square" lIns="0" tIns="0" rIns="0" bIns="0" rtlCol="0" anchor="ctr"/>
+          <a:lstStyle/>
+          <a:p>
+            <a:pPr algn="ctr" indent="0" marL="0">
+              <a:buNone/>
+            </a:pPr>
+            <a:r>
+              <a:rPr lang="en-US" sz="975" b="1" dirty="0">
+                <a:solidFill>
+                  <a:srgbClr val="B91C1C"/>
+                </a:solidFill>
+                <a:latin typeface="Segoe UI" pitchFamily="34" charset="0"/>
+                <a:ea typeface="Segoe UI" pitchFamily="34" charset="-122"/>
+                <a:cs typeface="Segoe UI" pitchFamily="34" charset="-120"/>
+              </a:rPr>
+              <a:t>2</a:t>
+            </a:r>
+            <a:endParaRPr lang="en-US" sz="975" dirty="0"/>
+          </a:p>
+        </p:txBody>
+      </p:sp>
+      <p:sp>
+        <p:nvSpPr>
+          <p:cNvPr id="23" name="Text 19"/>
+          <p:cNvSpPr/>
+          <p:nvPr/>
+        </p:nvSpPr>
+        <p:spPr>
+          <a:xfrm>
+            <a:off x="6859524" y="3622881"/>
+            <a:ext cx="4448556" cy="196882"/>
           </a:xfrm>
           <a:prstGeom prst="rect">
             <a:avLst/>
@@ -11413,64 +11873,82 @@
           <a:bodyPr wrap="square" lIns="0" tIns="0" rIns="0" bIns="0" rtlCol="0" anchor="t"/>
           <a:lstStyle/>
           <a:p>
-            <a:pPr algn="ctr" indent="0" marL="0">
+            <a:pPr algn="l" indent="0" marL="0">
               <a:lnSpc>
                 <a:spcPct val="115000"/>
               </a:lnSpc>
               <a:buNone/>
             </a:pPr>
             <a:r>
-              <a:rPr lang="en-US" sz="1050" dirty="0">
-                <a:solidFill>
-                  <a:srgbClr val="64748B"/>
+              <a:rPr lang="en-US" sz="1125" dirty="0">
+                <a:solidFill>
+                  <a:srgbClr val="334155"/>
                 </a:solidFill>
                 <a:latin typeface="Segoe UI" pitchFamily="34" charset="0"/>
                 <a:ea typeface="Segoe UI" pitchFamily="34" charset="-122"/>
                 <a:cs typeface="Segoe UI" pitchFamily="34" charset="-120"/>
               </a:rPr>
-              <a:t>One call per tube, sync</a:t>
-            </a:r>
-            <a:endParaRPr lang="en-US" sz="1050" dirty="0"/>
-          </a:p>
-        </p:txBody>
-      </p:sp>
-      <p:sp>
-        <p:nvSpPr>
-          <p:cNvPr id="12" name="Shape 10"/>
-          <p:cNvSpPr/>
-          <p:nvPr/>
-        </p:nvSpPr>
-        <p:spPr>
-          <a:xfrm>
-            <a:off x="8077200" y="3051810"/>
-            <a:ext cx="3505200" cy="1668780"/>
-          </a:xfrm>
-          <a:prstGeom prst="roundRect">
-            <a:avLst>
-              <a:gd name="adj" fmla="val 6575"/>
-            </a:avLst>
+              <a:t>Drop the map table if it was created.</a:t>
+            </a:r>
+            <a:endParaRPr lang="en-US" sz="1125" dirty="0"/>
+          </a:p>
+        </p:txBody>
+      </p:sp>
+      <p:sp>
+        <p:nvSpPr>
+          <p:cNvPr id="24" name="Text 20"/>
+          <p:cNvSpPr/>
+          <p:nvPr/>
+        </p:nvSpPr>
+        <p:spPr>
+          <a:xfrm>
+            <a:off x="6521196" y="3929491"/>
+            <a:ext cx="228600" cy="228600"/>
+          </a:xfrm>
+          <a:prstGeom prst="ellipse">
+            <a:avLst/>
           </a:prstGeom>
           <a:solidFill>
-            <a:srgbClr val="FFFFFF"/>
+            <a:srgbClr val="FEE2E2"/>
           </a:solidFill>
-          <a:ln w="9525">
+          <a:ln>
             <a:solidFill>
-              <a:srgbClr val="E2E8F0"/>
+              <a:srgbClr val="FEE2E2"/>
             </a:solidFill>
-            <a:prstDash val="solid"/>
           </a:ln>
         </p:spPr>
-      </p:sp>
-      <p:sp>
-        <p:nvSpPr>
-          <p:cNvPr id="13" name="Text 11"/>
-          <p:cNvSpPr/>
-          <p:nvPr/>
-        </p:nvSpPr>
-        <p:spPr>
-          <a:xfrm>
-            <a:off x="8168640" y="3362706"/>
-            <a:ext cx="3322320" cy="548640"/>
+        <p:txBody>
+          <a:bodyPr wrap="square" lIns="0" tIns="0" rIns="0" bIns="0" rtlCol="0" anchor="ctr"/>
+          <a:lstStyle/>
+          <a:p>
+            <a:pPr algn="ctr" indent="0" marL="0">
+              <a:buNone/>
+            </a:pPr>
+            <a:r>
+              <a:rPr lang="en-US" sz="975" b="1" dirty="0">
+                <a:solidFill>
+                  <a:srgbClr val="B91C1C"/>
+                </a:solidFill>
+                <a:latin typeface="Segoe UI" pitchFamily="34" charset="0"/>
+                <a:ea typeface="Segoe UI" pitchFamily="34" charset="-122"/>
+                <a:cs typeface="Segoe UI" pitchFamily="34" charset="-120"/>
+              </a:rPr>
+              <a:t>3</a:t>
+            </a:r>
+            <a:endParaRPr lang="en-US" sz="975" dirty="0"/>
+          </a:p>
+        </p:txBody>
+      </p:sp>
+      <p:sp>
+        <p:nvSpPr>
+          <p:cNvPr id="25" name="Text 21"/>
+          <p:cNvSpPr/>
+          <p:nvPr/>
+        </p:nvSpPr>
+        <p:spPr>
+          <a:xfrm>
+            <a:off x="6859524" y="3956923"/>
+            <a:ext cx="4448556" cy="196882"/>
           </a:xfrm>
           <a:prstGeom prst="rect">
             <a:avLst/>
@@ -11479,59 +11957,17 @@
           <a:ln/>
         </p:spPr>
         <p:txBody>
-          <a:bodyPr wrap="square" lIns="0" tIns="0" rIns="0" bIns="0" rtlCol="0" anchor="ctr"/>
-          <a:lstStyle/>
-          <a:p>
-            <a:pPr algn="ctr" indent="0" marL="0">
+          <a:bodyPr wrap="square" lIns="0" tIns="0" rIns="0" bIns="0" rtlCol="0" anchor="t"/>
+          <a:lstStyle/>
+          <a:p>
+            <a:pPr algn="l" indent="0" marL="0">
               <a:lnSpc>
                 <a:spcPct val="115000"/>
               </a:lnSpc>
               <a:buNone/>
             </a:pPr>
             <a:r>
-              <a:rPr lang="en-US" sz="3900" dirty="0">
-                <a:solidFill>
-                  <a:srgbClr val="0284C7"/>
-                </a:solidFill>
-                <a:latin typeface="Segoe UI Semibold" pitchFamily="34" charset="0"/>
-                <a:ea typeface="Segoe UI Semibold" pitchFamily="34" charset="-122"/>
-                <a:cs typeface="Segoe UI Semibold" pitchFamily="34" charset="-120"/>
-              </a:rPr>
-              <a:t>CPS, HMS</a:t>
-            </a:r>
-            <a:endParaRPr lang="en-US" sz="3900" dirty="0"/>
-          </a:p>
-        </p:txBody>
-      </p:sp>
-      <p:sp>
-        <p:nvSpPr>
-          <p:cNvPr id="14" name="Text 12"/>
-          <p:cNvSpPr/>
-          <p:nvPr/>
-        </p:nvSpPr>
-        <p:spPr>
-          <a:xfrm>
-            <a:off x="8260080" y="3938778"/>
-            <a:ext cx="3139440" cy="237744"/>
-          </a:xfrm>
-          <a:prstGeom prst="rect">
-            <a:avLst/>
-          </a:prstGeom>
-          <a:noFill/>
-          <a:ln/>
-        </p:spPr>
-        <p:txBody>
-          <a:bodyPr wrap="square" lIns="0" tIns="0" rIns="0" bIns="0" rtlCol="0" anchor="t"/>
-          <a:lstStyle/>
-          <a:p>
-            <a:pPr algn="ctr" indent="0" marL="0">
-              <a:lnSpc>
-                <a:spcPct val="115000"/>
-              </a:lnSpc>
-              <a:buNone/>
-            </a:pPr>
-            <a:r>
-              <a:rPr lang="en-US" sz="1200" b="1" dirty="0">
+              <a:rPr lang="en-US" sz="1125" dirty="0">
                 <a:solidFill>
                   <a:srgbClr val="334155"/>
                 </a:solidFill>
@@ -11539,51 +11975,9 @@
                 <a:ea typeface="Segoe UI" pitchFamily="34" charset="-122"/>
                 <a:cs typeface="Segoe UI" pitchFamily="34" charset="-120"/>
               </a:rPr>
-              <a:t>Labs on the order</a:t>
-            </a:r>
-            <a:endParaRPr lang="en-US" sz="1200" dirty="0"/>
-          </a:p>
-        </p:txBody>
-      </p:sp>
-      <p:sp>
-        <p:nvSpPr>
-          <p:cNvPr id="15" name="Text 13"/>
-          <p:cNvSpPr/>
-          <p:nvPr/>
-        </p:nvSpPr>
-        <p:spPr>
-          <a:xfrm>
-            <a:off x="8260080" y="4194810"/>
-            <a:ext cx="3139440" cy="205740"/>
-          </a:xfrm>
-          <a:prstGeom prst="rect">
-            <a:avLst/>
-          </a:prstGeom>
-          <a:noFill/>
-          <a:ln/>
-        </p:spPr>
-        <p:txBody>
-          <a:bodyPr wrap="square" lIns="0" tIns="0" rIns="0" bIns="0" rtlCol="0" anchor="t"/>
-          <a:lstStyle/>
-          <a:p>
-            <a:pPr algn="ctr" indent="0" marL="0">
-              <a:lnSpc>
-                <a:spcPct val="115000"/>
-              </a:lnSpc>
-              <a:buNone/>
-            </a:pPr>
-            <a:r>
-              <a:rPr lang="en-US" sz="1050" dirty="0">
-                <a:solidFill>
-                  <a:srgbClr val="64748B"/>
-                </a:solidFill>
-                <a:latin typeface="Segoe UI" pitchFamily="34" charset="0"/>
-                <a:ea typeface="Segoe UI" pitchFamily="34" charset="-122"/>
-                <a:cs typeface="Segoe UI" pitchFamily="34" charset="-120"/>
-              </a:rPr>
-              <a:t>APS, BBS and MBS return Failure</a:t>
-            </a:r>
-            <a:endParaRPr lang="en-US" sz="1050" dirty="0"/>
+              <a:t>No conversion of historical requests.</a:t>
+            </a:r>
+            <a:endParaRPr lang="en-US" sz="1125" dirty="0"/>
           </a:p>
         </p:txBody>
       </p:sp>
@@ -11598,998 +11992,6 @@
 <file path=ppt/slides/slide18.xml><?xml version="1.0" encoding="utf-8"?>
 <p:sld xmlns:a="http://schemas.openxmlformats.org/drawingml/2006/main" xmlns:r="http://schemas.openxmlformats.org/officeDocument/2006/relationships" xmlns:p="http://schemas.openxmlformats.org/presentationml/2006/main">
   <p:cSld name="Slide 18">
-    <p:bg>
-      <p:bgPr>
-        <a:solidFill>
-          <a:srgbClr val="F8FAFC"/>
-        </a:solidFill>
-      </p:bgPr>
-    </p:bg>
-    <p:spTree>
-      <p:nvGrpSpPr>
-        <p:cNvPr id="1" name=""/>
-        <p:cNvGrpSpPr/>
-        <p:nvPr/>
-      </p:nvGrpSpPr>
-      <p:grpSpPr>
-        <a:xfrm>
-          <a:off x="0" y="0"/>
-          <a:ext cx="0" cy="0"/>
-          <a:chOff x="0" y="0"/>
-          <a:chExt cx="0" cy="0"/>
-        </a:xfrm>
-      </p:grpSpPr>
-      <p:sp>
-        <p:nvSpPr>
-          <p:cNvPr id="2" name="Text 0"/>
-          <p:cNvSpPr/>
-          <p:nvPr/>
-        </p:nvSpPr>
-        <p:spPr>
-          <a:xfrm>
-            <a:off x="609600" y="457200"/>
-            <a:ext cx="10972800" cy="228600"/>
-          </a:xfrm>
-          <a:prstGeom prst="rect">
-            <a:avLst/>
-          </a:prstGeom>
-          <a:noFill/>
-          <a:ln/>
-        </p:spPr>
-        <p:txBody>
-          <a:bodyPr wrap="square" lIns="0" tIns="0" rIns="0" bIns="0" rtlCol="0" anchor="ctr"/>
-          <a:lstStyle/>
-          <a:p>
-            <a:pPr indent="0" marL="0">
-              <a:buNone/>
-            </a:pPr>
-            <a:r>
-              <a:rPr lang="en-US" sz="1050" spc="150" kern="0" dirty="0">
-                <a:solidFill>
-                  <a:srgbClr val="0284C7"/>
-                </a:solidFill>
-                <a:latin typeface="Segoe UI Semibold" pitchFamily="34" charset="0"/>
-                <a:ea typeface="Segoe UI Semibold" pitchFamily="34" charset="-122"/>
-                <a:cs typeface="Segoe UI Semibold" pitchFamily="34" charset="-120"/>
-              </a:rPr>
-              <a:t>06. PROMOTION AND FALLBACK</a:t>
-            </a:r>
-            <a:endParaRPr lang="en-US" sz="1050" dirty="0"/>
-          </a:p>
-        </p:txBody>
-      </p:sp>
-      <p:sp>
-        <p:nvSpPr>
-          <p:cNvPr id="3" name="Text 1"/>
-          <p:cNvSpPr/>
-          <p:nvPr/>
-        </p:nvSpPr>
-        <p:spPr>
-          <a:xfrm>
-            <a:off x="609600" y="722376"/>
-            <a:ext cx="10972800" cy="457200"/>
-          </a:xfrm>
-          <a:prstGeom prst="rect">
-            <a:avLst/>
-          </a:prstGeom>
-          <a:noFill/>
-          <a:ln/>
-        </p:spPr>
-        <p:txBody>
-          <a:bodyPr wrap="square" lIns="0" tIns="0" rIns="0" bIns="0" rtlCol="0" anchor="ctr"/>
-          <a:lstStyle/>
-          <a:p>
-            <a:pPr indent="0" marL="0">
-              <a:buNone/>
-            </a:pPr>
-            <a:r>
-              <a:rPr lang="en-US" sz="2400" dirty="0">
-                <a:solidFill>
-                  <a:srgbClr val="0F172A"/>
-                </a:solidFill>
-                <a:latin typeface="Segoe UI Semibold" pitchFamily="34" charset="0"/>
-                <a:ea typeface="Segoe UI Semibold" pitchFamily="34" charset="-122"/>
-                <a:cs typeface="Segoe UI Semibold" pitchFamily="34" charset="-120"/>
-              </a:rPr>
-              <a:t>Seed workbench, open the gateway path, pilot CPS and HMS</a:t>
-            </a:r>
-            <a:endParaRPr lang="en-US" sz="2400" dirty="0"/>
-          </a:p>
-        </p:txBody>
-      </p:sp>
-      <p:sp>
-        <p:nvSpPr>
-          <p:cNvPr id="4" name="Shape 2"/>
-          <p:cNvSpPr/>
-          <p:nvPr/>
-        </p:nvSpPr>
-        <p:spPr>
-          <a:xfrm>
-            <a:off x="609600" y="2539032"/>
-            <a:ext cx="5335524" cy="2694337"/>
-          </a:xfrm>
-          <a:prstGeom prst="roundRect">
-            <a:avLst>
-              <a:gd name="adj" fmla="val 4073"/>
-            </a:avLst>
-          </a:prstGeom>
-          <a:solidFill>
-            <a:srgbClr val="FFFFFF"/>
-          </a:solidFill>
-          <a:ln w="9525">
-            <a:solidFill>
-              <a:srgbClr val="E2E8F0"/>
-            </a:solidFill>
-            <a:prstDash val="solid"/>
-          </a:ln>
-        </p:spPr>
-      </p:sp>
-      <p:pic>
-        <p:nvPicPr>
-          <p:cNvPr id="5" name="Image 0" descr="D:\Github\HA-Notes\LIS\skills\design-review-pptx\assets\icons\png\success\cloud-arrow-up.png">    </p:cNvPr>
-          <p:cNvPicPr>
-            <a:picLocks noChangeAspect="1"/>
-          </p:cNvPicPr>
-          <p:nvPr/>
-        </p:nvPicPr>
-        <p:blipFill>
-          <a:blip r:embed="rId1"/>
-          <a:stretch>
-            <a:fillRect/>
-          </a:stretch>
-        </p:blipFill>
-        <p:spPr>
-          <a:xfrm>
-            <a:off x="883920" y="2845356"/>
-            <a:ext cx="265176" cy="265176"/>
-          </a:xfrm>
-          <a:prstGeom prst="rect">
-            <a:avLst/>
-          </a:prstGeom>
-        </p:spPr>
-      </p:pic>
-      <p:sp>
-        <p:nvSpPr>
-          <p:cNvPr id="6" name="Text 3"/>
-          <p:cNvSpPr/>
-          <p:nvPr/>
-        </p:nvSpPr>
-        <p:spPr>
-          <a:xfrm>
-            <a:off x="1249680" y="2831640"/>
-            <a:ext cx="4421124" cy="292608"/>
-          </a:xfrm>
-          <a:prstGeom prst="rect">
-            <a:avLst/>
-          </a:prstGeom>
-          <a:noFill/>
-          <a:ln/>
-        </p:spPr>
-        <p:txBody>
-          <a:bodyPr wrap="square" lIns="0" tIns="0" rIns="0" bIns="0" rtlCol="0" anchor="ctr"/>
-          <a:lstStyle/>
-          <a:p>
-            <a:pPr algn="l" indent="0" marL="0">
-              <a:lnSpc>
-                <a:spcPct val="115000"/>
-              </a:lnSpc>
-              <a:buNone/>
-            </a:pPr>
-            <a:r>
-              <a:rPr lang="en-US" sz="1500" dirty="0">
-                <a:solidFill>
-                  <a:srgbClr val="0F172A"/>
-                </a:solidFill>
-                <a:latin typeface="Segoe UI Semibold" pitchFamily="34" charset="0"/>
-                <a:ea typeface="Segoe UI Semibold" pitchFamily="34" charset="-122"/>
-                <a:cs typeface="Segoe UI Semibold" pitchFamily="34" charset="-120"/>
-              </a:rPr>
-              <a:t>Promotion</a:t>
-            </a:r>
-            <a:endParaRPr lang="en-US" sz="1500" dirty="0"/>
-          </a:p>
-        </p:txBody>
-      </p:sp>
-      <p:sp>
-        <p:nvSpPr>
-          <p:cNvPr id="7" name="Text 4"/>
-          <p:cNvSpPr/>
-          <p:nvPr/>
-        </p:nvSpPr>
-        <p:spPr>
-          <a:xfrm>
-            <a:off x="883920" y="3261408"/>
-            <a:ext cx="228600" cy="228600"/>
-          </a:xfrm>
-          <a:prstGeom prst="ellipse">
-            <a:avLst/>
-          </a:prstGeom>
-          <a:solidFill>
-            <a:srgbClr val="DCFCE7"/>
-          </a:solidFill>
-          <a:ln>
-            <a:solidFill>
-              <a:srgbClr val="DCFCE7"/>
-            </a:solidFill>
-          </a:ln>
-        </p:spPr>
-        <p:txBody>
-          <a:bodyPr wrap="square" lIns="0" tIns="0" rIns="0" bIns="0" rtlCol="0" anchor="ctr"/>
-          <a:lstStyle/>
-          <a:p>
-            <a:pPr algn="ctr" indent="0" marL="0">
-              <a:buNone/>
-            </a:pPr>
-            <a:r>
-              <a:rPr lang="en-US" sz="975" b="1" dirty="0">
-                <a:solidFill>
-                  <a:srgbClr val="15803D"/>
-                </a:solidFill>
-                <a:latin typeface="Segoe UI" pitchFamily="34" charset="0"/>
-                <a:ea typeface="Segoe UI" pitchFamily="34" charset="-122"/>
-                <a:cs typeface="Segoe UI" pitchFamily="34" charset="-120"/>
-              </a:rPr>
-              <a:t>1</a:t>
-            </a:r>
-            <a:endParaRPr lang="en-US" sz="975" dirty="0"/>
-          </a:p>
-        </p:txBody>
-      </p:sp>
-      <p:sp>
-        <p:nvSpPr>
-          <p:cNvPr id="8" name="Text 5"/>
-          <p:cNvSpPr/>
-          <p:nvPr/>
-        </p:nvSpPr>
-        <p:spPr>
-          <a:xfrm>
-            <a:off x="1222248" y="3288840"/>
-            <a:ext cx="4448556" cy="196882"/>
-          </a:xfrm>
-          <a:prstGeom prst="rect">
-            <a:avLst/>
-          </a:prstGeom>
-          <a:noFill/>
-          <a:ln/>
-        </p:spPr>
-        <p:txBody>
-          <a:bodyPr wrap="square" lIns="0" tIns="0" rIns="0" bIns="0" rtlCol="0" anchor="t"/>
-          <a:lstStyle/>
-          <a:p>
-            <a:pPr algn="l" indent="0" marL="0">
-              <a:lnSpc>
-                <a:spcPct val="115000"/>
-              </a:lnSpc>
-              <a:buNone/>
-            </a:pPr>
-            <a:r>
-              <a:rPr lang="en-US" sz="1125" dirty="0">
-                <a:solidFill>
-                  <a:srgbClr val="334155"/>
-                </a:solidFill>
-                <a:latin typeface="Segoe UI" pitchFamily="34" charset="0"/>
-                <a:ea typeface="Segoe UI" pitchFamily="34" charset="-122"/>
-                <a:cs typeface="Segoe UI" pitchFamily="34" charset="-120"/>
-              </a:rPr>
-              <a:t>Seed workbench: station name = sorter id, user = wkbh_id.</a:t>
-            </a:r>
-            <a:endParaRPr lang="en-US" sz="1125" dirty="0"/>
-          </a:p>
-        </p:txBody>
-      </p:sp>
-      <p:sp>
-        <p:nvSpPr>
-          <p:cNvPr id="9" name="Text 6"/>
-          <p:cNvSpPr/>
-          <p:nvPr/>
-        </p:nvSpPr>
-        <p:spPr>
-          <a:xfrm>
-            <a:off x="883920" y="3595449"/>
-            <a:ext cx="228600" cy="228600"/>
-          </a:xfrm>
-          <a:prstGeom prst="ellipse">
-            <a:avLst/>
-          </a:prstGeom>
-          <a:solidFill>
-            <a:srgbClr val="DCFCE7"/>
-          </a:solidFill>
-          <a:ln>
-            <a:solidFill>
-              <a:srgbClr val="DCFCE7"/>
-            </a:solidFill>
-          </a:ln>
-        </p:spPr>
-        <p:txBody>
-          <a:bodyPr wrap="square" lIns="0" tIns="0" rIns="0" bIns="0" rtlCol="0" anchor="ctr"/>
-          <a:lstStyle/>
-          <a:p>
-            <a:pPr algn="ctr" indent="0" marL="0">
-              <a:buNone/>
-            </a:pPr>
-            <a:r>
-              <a:rPr lang="en-US" sz="975" b="1" dirty="0">
-                <a:solidFill>
-                  <a:srgbClr val="15803D"/>
-                </a:solidFill>
-                <a:latin typeface="Segoe UI" pitchFamily="34" charset="0"/>
-                <a:ea typeface="Segoe UI" pitchFamily="34" charset="-122"/>
-                <a:cs typeface="Segoe UI" pitchFamily="34" charset="-120"/>
-              </a:rPr>
-              <a:t>2</a:t>
-            </a:r>
-            <a:endParaRPr lang="en-US" sz="975" dirty="0"/>
-          </a:p>
-        </p:txBody>
-      </p:sp>
-      <p:sp>
-        <p:nvSpPr>
-          <p:cNvPr id="10" name="Text 7"/>
-          <p:cNvSpPr/>
-          <p:nvPr/>
-        </p:nvSpPr>
-        <p:spPr>
-          <a:xfrm>
-            <a:off x="1222248" y="3622881"/>
-            <a:ext cx="4448556" cy="196882"/>
-          </a:xfrm>
-          <a:prstGeom prst="rect">
-            <a:avLst/>
-          </a:prstGeom>
-          <a:noFill/>
-          <a:ln/>
-        </p:spPr>
-        <p:txBody>
-          <a:bodyPr wrap="square" lIns="0" tIns="0" rIns="0" bIns="0" rtlCol="0" anchor="t"/>
-          <a:lstStyle/>
-          <a:p>
-            <a:pPr algn="l" indent="0" marL="0">
-              <a:lnSpc>
-                <a:spcPct val="115000"/>
-              </a:lnSpc>
-              <a:buNone/>
-            </a:pPr>
-            <a:r>
-              <a:rPr lang="en-US" sz="1125" dirty="0">
-                <a:solidFill>
-                  <a:srgbClr val="334155"/>
-                </a:solidFill>
-                <a:latin typeface="Segoe UI" pitchFamily="34" charset="0"/>
-                <a:ea typeface="Segoe UI" pitchFamily="34" charset="-122"/>
-                <a:cs typeface="Segoe UI" pitchFamily="34" charset="-120"/>
-              </a:rPr>
-              <a:t>Map row only if hospital can be omitted.</a:t>
-            </a:r>
-            <a:endParaRPr lang="en-US" sz="1125" dirty="0"/>
-          </a:p>
-        </p:txBody>
-      </p:sp>
-      <p:sp>
-        <p:nvSpPr>
-          <p:cNvPr id="11" name="Text 8"/>
-          <p:cNvSpPr/>
-          <p:nvPr/>
-        </p:nvSpPr>
-        <p:spPr>
-          <a:xfrm>
-            <a:off x="883920" y="3929491"/>
-            <a:ext cx="228600" cy="228600"/>
-          </a:xfrm>
-          <a:prstGeom prst="ellipse">
-            <a:avLst/>
-          </a:prstGeom>
-          <a:solidFill>
-            <a:srgbClr val="DCFCE7"/>
-          </a:solidFill>
-          <a:ln>
-            <a:solidFill>
-              <a:srgbClr val="DCFCE7"/>
-            </a:solidFill>
-          </a:ln>
-        </p:spPr>
-        <p:txBody>
-          <a:bodyPr wrap="square" lIns="0" tIns="0" rIns="0" bIns="0" rtlCol="0" anchor="ctr"/>
-          <a:lstStyle/>
-          <a:p>
-            <a:pPr algn="ctr" indent="0" marL="0">
-              <a:buNone/>
-            </a:pPr>
-            <a:r>
-              <a:rPr lang="en-US" sz="975" b="1" dirty="0">
-                <a:solidFill>
-                  <a:srgbClr val="15803D"/>
-                </a:solidFill>
-                <a:latin typeface="Segoe UI" pitchFamily="34" charset="0"/>
-                <a:ea typeface="Segoe UI" pitchFamily="34" charset="-122"/>
-                <a:cs typeface="Segoe UI" pitchFamily="34" charset="-120"/>
-              </a:rPr>
-              <a:t>3</a:t>
-            </a:r>
-            <a:endParaRPr lang="en-US" sz="975" dirty="0"/>
-          </a:p>
-        </p:txBody>
-      </p:sp>
-      <p:sp>
-        <p:nvSpPr>
-          <p:cNvPr id="12" name="Text 9"/>
-          <p:cNvSpPr/>
-          <p:nvPr/>
-        </p:nvSpPr>
-        <p:spPr>
-          <a:xfrm>
-            <a:off x="1222248" y="3956923"/>
-            <a:ext cx="4448556" cy="196882"/>
-          </a:xfrm>
-          <a:prstGeom prst="rect">
-            <a:avLst/>
-          </a:prstGeom>
-          <a:noFill/>
-          <a:ln/>
-        </p:spPr>
-        <p:txBody>
-          <a:bodyPr wrap="square" lIns="0" tIns="0" rIns="0" bIns="0" rtlCol="0" anchor="t"/>
-          <a:lstStyle/>
-          <a:p>
-            <a:pPr algn="l" indent="0" marL="0">
-              <a:lnSpc>
-                <a:spcPct val="115000"/>
-              </a:lnSpc>
-              <a:buNone/>
-            </a:pPr>
-            <a:r>
-              <a:rPr lang="en-US" sz="1125" dirty="0">
-                <a:solidFill>
-                  <a:srgbClr val="334155"/>
-                </a:solidFill>
-                <a:latin typeface="Segoe UI" pitchFamily="34" charset="0"/>
-                <a:ea typeface="Segoe UI" pitchFamily="34" charset="-122"/>
-                <a:cs typeface="Segoe UI" pitchFamily="34" charset="-120"/>
-              </a:rPr>
-              <a:t>Deploy lis-crs-spec-ack-svc.</a:t>
-            </a:r>
-            <a:endParaRPr lang="en-US" sz="1125" dirty="0"/>
-          </a:p>
-        </p:txBody>
-      </p:sp>
-      <p:sp>
-        <p:nvSpPr>
-          <p:cNvPr id="13" name="Text 10"/>
-          <p:cNvSpPr/>
-          <p:nvPr/>
-        </p:nvSpPr>
-        <p:spPr>
-          <a:xfrm>
-            <a:off x="883920" y="4263533"/>
-            <a:ext cx="228600" cy="228600"/>
-          </a:xfrm>
-          <a:prstGeom prst="ellipse">
-            <a:avLst/>
-          </a:prstGeom>
-          <a:solidFill>
-            <a:srgbClr val="DCFCE7"/>
-          </a:solidFill>
-          <a:ln>
-            <a:solidFill>
-              <a:srgbClr val="DCFCE7"/>
-            </a:solidFill>
-          </a:ln>
-        </p:spPr>
-        <p:txBody>
-          <a:bodyPr wrap="square" lIns="0" tIns="0" rIns="0" bIns="0" rtlCol="0" anchor="ctr"/>
-          <a:lstStyle/>
-          <a:p>
-            <a:pPr algn="ctr" indent="0" marL="0">
-              <a:buNone/>
-            </a:pPr>
-            <a:r>
-              <a:rPr lang="en-US" sz="975" b="1" dirty="0">
-                <a:solidFill>
-                  <a:srgbClr val="15803D"/>
-                </a:solidFill>
-                <a:latin typeface="Segoe UI" pitchFamily="34" charset="0"/>
-                <a:ea typeface="Segoe UI" pitchFamily="34" charset="-122"/>
-                <a:cs typeface="Segoe UI" pitchFamily="34" charset="-120"/>
-              </a:rPr>
-              <a:t>4</a:t>
-            </a:r>
-            <a:endParaRPr lang="en-US" sz="975" dirty="0"/>
-          </a:p>
-        </p:txBody>
-      </p:sp>
-      <p:sp>
-        <p:nvSpPr>
-          <p:cNvPr id="14" name="Text 11"/>
-          <p:cNvSpPr/>
-          <p:nvPr/>
-        </p:nvSpPr>
-        <p:spPr>
-          <a:xfrm>
-            <a:off x="1222248" y="4290965"/>
-            <a:ext cx="4448556" cy="196882"/>
-          </a:xfrm>
-          <a:prstGeom prst="rect">
-            <a:avLst/>
-          </a:prstGeom>
-          <a:noFill/>
-          <a:ln/>
-        </p:spPr>
-        <p:txBody>
-          <a:bodyPr wrap="square" lIns="0" tIns="0" rIns="0" bIns="0" rtlCol="0" anchor="t"/>
-          <a:lstStyle/>
-          <a:p>
-            <a:pPr algn="l" indent="0" marL="0">
-              <a:lnSpc>
-                <a:spcPct val="115000"/>
-              </a:lnSpc>
-              <a:buNone/>
-            </a:pPr>
-            <a:r>
-              <a:rPr lang="en-US" sz="1125" dirty="0">
-                <a:solidFill>
-                  <a:srgbClr val="334155"/>
-                </a:solidFill>
-                <a:latin typeface="Segoe UI" pitchFamily="34" charset="0"/>
-                <a:ea typeface="Segoe UI" pitchFamily="34" charset="-122"/>
-                <a:cs typeface="Segoe UI" pitchFamily="34" charset="-120"/>
-              </a:rPr>
-              <a:t>Publish the APIM product and NetworkPolicy.</a:t>
-            </a:r>
-            <a:endParaRPr lang="en-US" sz="1125" dirty="0"/>
-          </a:p>
-        </p:txBody>
-      </p:sp>
-      <p:sp>
-        <p:nvSpPr>
-          <p:cNvPr id="15" name="Text 12"/>
-          <p:cNvSpPr/>
-          <p:nvPr/>
-        </p:nvSpPr>
-        <p:spPr>
-          <a:xfrm>
-            <a:off x="883920" y="4597575"/>
-            <a:ext cx="228600" cy="228600"/>
-          </a:xfrm>
-          <a:prstGeom prst="ellipse">
-            <a:avLst/>
-          </a:prstGeom>
-          <a:solidFill>
-            <a:srgbClr val="DCFCE7"/>
-          </a:solidFill>
-          <a:ln>
-            <a:solidFill>
-              <a:srgbClr val="DCFCE7"/>
-            </a:solidFill>
-          </a:ln>
-        </p:spPr>
-        <p:txBody>
-          <a:bodyPr wrap="square" lIns="0" tIns="0" rIns="0" bIns="0" rtlCol="0" anchor="ctr"/>
-          <a:lstStyle/>
-          <a:p>
-            <a:pPr algn="ctr" indent="0" marL="0">
-              <a:buNone/>
-            </a:pPr>
-            <a:r>
-              <a:rPr lang="en-US" sz="975" b="1" dirty="0">
-                <a:solidFill>
-                  <a:srgbClr val="15803D"/>
-                </a:solidFill>
-                <a:latin typeface="Segoe UI" pitchFamily="34" charset="0"/>
-                <a:ea typeface="Segoe UI" pitchFamily="34" charset="-122"/>
-                <a:cs typeface="Segoe UI" pitchFamily="34" charset="-120"/>
-              </a:rPr>
-              <a:t>5</a:t>
-            </a:r>
-            <a:endParaRPr lang="en-US" sz="975" dirty="0"/>
-          </a:p>
-        </p:txBody>
-      </p:sp>
-      <p:sp>
-        <p:nvSpPr>
-          <p:cNvPr id="16" name="Text 13"/>
-          <p:cNvSpPr/>
-          <p:nvPr/>
-        </p:nvSpPr>
-        <p:spPr>
-          <a:xfrm>
-            <a:off x="1222248" y="4625007"/>
-            <a:ext cx="4448556" cy="196882"/>
-          </a:xfrm>
-          <a:prstGeom prst="rect">
-            <a:avLst/>
-          </a:prstGeom>
-          <a:noFill/>
-          <a:ln/>
-        </p:spPr>
-        <p:txBody>
-          <a:bodyPr wrap="square" lIns="0" tIns="0" rIns="0" bIns="0" rtlCol="0" anchor="t"/>
-          <a:lstStyle/>
-          <a:p>
-            <a:pPr algn="l" indent="0" marL="0">
-              <a:lnSpc>
-                <a:spcPct val="115000"/>
-              </a:lnSpc>
-              <a:buNone/>
-            </a:pPr>
-            <a:r>
-              <a:rPr lang="en-US" sz="1125" dirty="0">
-                <a:solidFill>
-                  <a:srgbClr val="334155"/>
-                </a:solidFill>
-                <a:latin typeface="Segoe UI" pitchFamily="34" charset="0"/>
-                <a:ea typeface="Segoe UI" pitchFamily="34" charset="-122"/>
-                <a:cs typeface="Segoe UI" pitchFamily="34" charset="-120"/>
-              </a:rPr>
-              <a:t>Pilot CPS and HMS.</a:t>
-            </a:r>
-            <a:endParaRPr lang="en-US" sz="1125" dirty="0"/>
-          </a:p>
-        </p:txBody>
-      </p:sp>
-      <p:sp>
-        <p:nvSpPr>
-          <p:cNvPr id="17" name="Shape 14"/>
-          <p:cNvSpPr/>
-          <p:nvPr/>
-        </p:nvSpPr>
-        <p:spPr>
-          <a:xfrm>
-            <a:off x="6246876" y="2539032"/>
-            <a:ext cx="5335524" cy="2694337"/>
-          </a:xfrm>
-          <a:prstGeom prst="roundRect">
-            <a:avLst>
-              <a:gd name="adj" fmla="val 4073"/>
-            </a:avLst>
-          </a:prstGeom>
-          <a:solidFill>
-            <a:srgbClr val="FFFFFF"/>
-          </a:solidFill>
-          <a:ln w="9525">
-            <a:solidFill>
-              <a:srgbClr val="E2E8F0"/>
-            </a:solidFill>
-            <a:prstDash val="solid"/>
-          </a:ln>
-        </p:spPr>
-      </p:sp>
-      <p:pic>
-        <p:nvPicPr>
-          <p:cNvPr id="18" name="Image 1" descr="D:\Github\HA-Notes\LIS\skills\design-review-pptx\assets\icons\png\danger\rotate-left.png">    </p:cNvPr>
-          <p:cNvPicPr>
-            <a:picLocks noChangeAspect="1"/>
-          </p:cNvPicPr>
-          <p:nvPr/>
-        </p:nvPicPr>
-        <p:blipFill>
-          <a:blip r:embed="rId2"/>
-          <a:stretch>
-            <a:fillRect/>
-          </a:stretch>
-        </p:blipFill>
-        <p:spPr>
-          <a:xfrm>
-            <a:off x="6521196" y="2845356"/>
-            <a:ext cx="265176" cy="265176"/>
-          </a:xfrm>
-          <a:prstGeom prst="rect">
-            <a:avLst/>
-          </a:prstGeom>
-        </p:spPr>
-      </p:pic>
-      <p:sp>
-        <p:nvSpPr>
-          <p:cNvPr id="19" name="Text 15"/>
-          <p:cNvSpPr/>
-          <p:nvPr/>
-        </p:nvSpPr>
-        <p:spPr>
-          <a:xfrm>
-            <a:off x="6886956" y="2831640"/>
-            <a:ext cx="4421124" cy="292608"/>
-          </a:xfrm>
-          <a:prstGeom prst="rect">
-            <a:avLst/>
-          </a:prstGeom>
-          <a:noFill/>
-          <a:ln/>
-        </p:spPr>
-        <p:txBody>
-          <a:bodyPr wrap="square" lIns="0" tIns="0" rIns="0" bIns="0" rtlCol="0" anchor="ctr"/>
-          <a:lstStyle/>
-          <a:p>
-            <a:pPr algn="l" indent="0" marL="0">
-              <a:lnSpc>
-                <a:spcPct val="115000"/>
-              </a:lnSpc>
-              <a:buNone/>
-            </a:pPr>
-            <a:r>
-              <a:rPr lang="en-US" sz="1500" dirty="0">
-                <a:solidFill>
-                  <a:srgbClr val="0F172A"/>
-                </a:solidFill>
-                <a:latin typeface="Segoe UI Semibold" pitchFamily="34" charset="0"/>
-                <a:ea typeface="Segoe UI Semibold" pitchFamily="34" charset="-122"/>
-                <a:cs typeface="Segoe UI Semibold" pitchFamily="34" charset="-120"/>
-              </a:rPr>
-              <a:t>Fallback</a:t>
-            </a:r>
-            <a:endParaRPr lang="en-US" sz="1500" dirty="0"/>
-          </a:p>
-        </p:txBody>
-      </p:sp>
-      <p:sp>
-        <p:nvSpPr>
-          <p:cNvPr id="20" name="Text 16"/>
-          <p:cNvSpPr/>
-          <p:nvPr/>
-        </p:nvSpPr>
-        <p:spPr>
-          <a:xfrm>
-            <a:off x="6521196" y="3261408"/>
-            <a:ext cx="228600" cy="228600"/>
-          </a:xfrm>
-          <a:prstGeom prst="ellipse">
-            <a:avLst/>
-          </a:prstGeom>
-          <a:solidFill>
-            <a:srgbClr val="FEE2E2"/>
-          </a:solidFill>
-          <a:ln>
-            <a:solidFill>
-              <a:srgbClr val="FEE2E2"/>
-            </a:solidFill>
-          </a:ln>
-        </p:spPr>
-        <p:txBody>
-          <a:bodyPr wrap="square" lIns="0" tIns="0" rIns="0" bIns="0" rtlCol="0" anchor="ctr"/>
-          <a:lstStyle/>
-          <a:p>
-            <a:pPr algn="ctr" indent="0" marL="0">
-              <a:buNone/>
-            </a:pPr>
-            <a:r>
-              <a:rPr lang="en-US" sz="975" b="1" dirty="0">
-                <a:solidFill>
-                  <a:srgbClr val="B91C1C"/>
-                </a:solidFill>
-                <a:latin typeface="Segoe UI" pitchFamily="34" charset="0"/>
-                <a:ea typeface="Segoe UI" pitchFamily="34" charset="-122"/>
-                <a:cs typeface="Segoe UI" pitchFamily="34" charset="-120"/>
-              </a:rPr>
-              <a:t>1</a:t>
-            </a:r>
-            <a:endParaRPr lang="en-US" sz="975" dirty="0"/>
-          </a:p>
-        </p:txBody>
-      </p:sp>
-      <p:sp>
-        <p:nvSpPr>
-          <p:cNvPr id="21" name="Text 17"/>
-          <p:cNvSpPr/>
-          <p:nvPr/>
-        </p:nvSpPr>
-        <p:spPr>
-          <a:xfrm>
-            <a:off x="6859524" y="3288840"/>
-            <a:ext cx="4448556" cy="196882"/>
-          </a:xfrm>
-          <a:prstGeom prst="rect">
-            <a:avLst/>
-          </a:prstGeom>
-          <a:noFill/>
-          <a:ln/>
-        </p:spPr>
-        <p:txBody>
-          <a:bodyPr wrap="square" lIns="0" tIns="0" rIns="0" bIns="0" rtlCol="0" anchor="t"/>
-          <a:lstStyle/>
-          <a:p>
-            <a:pPr algn="l" indent="0" marL="0">
-              <a:lnSpc>
-                <a:spcPct val="115000"/>
-              </a:lnSpc>
-              <a:buNone/>
-            </a:pPr>
-            <a:r>
-              <a:rPr lang="en-US" sz="1125" dirty="0">
-                <a:solidFill>
-                  <a:srgbClr val="334155"/>
-                </a:solidFill>
-                <a:latin typeface="Segoe UI" pitchFamily="34" charset="0"/>
-                <a:ea typeface="Segoe UI" pitchFamily="34" charset="-122"/>
-                <a:cs typeface="Segoe UI" pitchFamily="34" charset="-120"/>
-              </a:rPr>
-              <a:t>Stop the middleware. Staff Spec Ack is unchanged.</a:t>
-            </a:r>
-            <a:endParaRPr lang="en-US" sz="1125" dirty="0"/>
-          </a:p>
-        </p:txBody>
-      </p:sp>
-      <p:sp>
-        <p:nvSpPr>
-          <p:cNvPr id="22" name="Text 18"/>
-          <p:cNvSpPr/>
-          <p:nvPr/>
-        </p:nvSpPr>
-        <p:spPr>
-          <a:xfrm>
-            <a:off x="6521196" y="3595449"/>
-            <a:ext cx="228600" cy="228600"/>
-          </a:xfrm>
-          <a:prstGeom prst="ellipse">
-            <a:avLst/>
-          </a:prstGeom>
-          <a:solidFill>
-            <a:srgbClr val="FEE2E2"/>
-          </a:solidFill>
-          <a:ln>
-            <a:solidFill>
-              <a:srgbClr val="FEE2E2"/>
-            </a:solidFill>
-          </a:ln>
-        </p:spPr>
-        <p:txBody>
-          <a:bodyPr wrap="square" lIns="0" tIns="0" rIns="0" bIns="0" rtlCol="0" anchor="ctr"/>
-          <a:lstStyle/>
-          <a:p>
-            <a:pPr algn="ctr" indent="0" marL="0">
-              <a:buNone/>
-            </a:pPr>
-            <a:r>
-              <a:rPr lang="en-US" sz="975" b="1" dirty="0">
-                <a:solidFill>
-                  <a:srgbClr val="B91C1C"/>
-                </a:solidFill>
-                <a:latin typeface="Segoe UI" pitchFamily="34" charset="0"/>
-                <a:ea typeface="Segoe UI" pitchFamily="34" charset="-122"/>
-                <a:cs typeface="Segoe UI" pitchFamily="34" charset="-120"/>
-              </a:rPr>
-              <a:t>2</a:t>
-            </a:r>
-            <a:endParaRPr lang="en-US" sz="975" dirty="0"/>
-          </a:p>
-        </p:txBody>
-      </p:sp>
-      <p:sp>
-        <p:nvSpPr>
-          <p:cNvPr id="23" name="Text 19"/>
-          <p:cNvSpPr/>
-          <p:nvPr/>
-        </p:nvSpPr>
-        <p:spPr>
-          <a:xfrm>
-            <a:off x="6859524" y="3622881"/>
-            <a:ext cx="4448556" cy="196882"/>
-          </a:xfrm>
-          <a:prstGeom prst="rect">
-            <a:avLst/>
-          </a:prstGeom>
-          <a:noFill/>
-          <a:ln/>
-        </p:spPr>
-        <p:txBody>
-          <a:bodyPr wrap="square" lIns="0" tIns="0" rIns="0" bIns="0" rtlCol="0" anchor="t"/>
-          <a:lstStyle/>
-          <a:p>
-            <a:pPr algn="l" indent="0" marL="0">
-              <a:lnSpc>
-                <a:spcPct val="115000"/>
-              </a:lnSpc>
-              <a:buNone/>
-            </a:pPr>
-            <a:r>
-              <a:rPr lang="en-US" sz="1125" dirty="0">
-                <a:solidFill>
-                  <a:srgbClr val="334155"/>
-                </a:solidFill>
-                <a:latin typeface="Segoe UI" pitchFamily="34" charset="0"/>
-                <a:ea typeface="Segoe UI" pitchFamily="34" charset="-122"/>
-                <a:cs typeface="Segoe UI" pitchFamily="34" charset="-120"/>
-              </a:rPr>
-              <a:t>Drop the map table if it was created.</a:t>
-            </a:r>
-            <a:endParaRPr lang="en-US" sz="1125" dirty="0"/>
-          </a:p>
-        </p:txBody>
-      </p:sp>
-      <p:sp>
-        <p:nvSpPr>
-          <p:cNvPr id="24" name="Text 20"/>
-          <p:cNvSpPr/>
-          <p:nvPr/>
-        </p:nvSpPr>
-        <p:spPr>
-          <a:xfrm>
-            <a:off x="6521196" y="3929491"/>
-            <a:ext cx="228600" cy="228600"/>
-          </a:xfrm>
-          <a:prstGeom prst="ellipse">
-            <a:avLst/>
-          </a:prstGeom>
-          <a:solidFill>
-            <a:srgbClr val="FEE2E2"/>
-          </a:solidFill>
-          <a:ln>
-            <a:solidFill>
-              <a:srgbClr val="FEE2E2"/>
-            </a:solidFill>
-          </a:ln>
-        </p:spPr>
-        <p:txBody>
-          <a:bodyPr wrap="square" lIns="0" tIns="0" rIns="0" bIns="0" rtlCol="0" anchor="ctr"/>
-          <a:lstStyle/>
-          <a:p>
-            <a:pPr algn="ctr" indent="0" marL="0">
-              <a:buNone/>
-            </a:pPr>
-            <a:r>
-              <a:rPr lang="en-US" sz="975" b="1" dirty="0">
-                <a:solidFill>
-                  <a:srgbClr val="B91C1C"/>
-                </a:solidFill>
-                <a:latin typeface="Segoe UI" pitchFamily="34" charset="0"/>
-                <a:ea typeface="Segoe UI" pitchFamily="34" charset="-122"/>
-                <a:cs typeface="Segoe UI" pitchFamily="34" charset="-120"/>
-              </a:rPr>
-              <a:t>3</a:t>
-            </a:r>
-            <a:endParaRPr lang="en-US" sz="975" dirty="0"/>
-          </a:p>
-        </p:txBody>
-      </p:sp>
-      <p:sp>
-        <p:nvSpPr>
-          <p:cNvPr id="25" name="Text 21"/>
-          <p:cNvSpPr/>
-          <p:nvPr/>
-        </p:nvSpPr>
-        <p:spPr>
-          <a:xfrm>
-            <a:off x="6859524" y="3956923"/>
-            <a:ext cx="4448556" cy="196882"/>
-          </a:xfrm>
-          <a:prstGeom prst="rect">
-            <a:avLst/>
-          </a:prstGeom>
-          <a:noFill/>
-          <a:ln/>
-        </p:spPr>
-        <p:txBody>
-          <a:bodyPr wrap="square" lIns="0" tIns="0" rIns="0" bIns="0" rtlCol="0" anchor="t"/>
-          <a:lstStyle/>
-          <a:p>
-            <a:pPr algn="l" indent="0" marL="0">
-              <a:lnSpc>
-                <a:spcPct val="115000"/>
-              </a:lnSpc>
-              <a:buNone/>
-            </a:pPr>
-            <a:r>
-              <a:rPr lang="en-US" sz="1125" dirty="0">
-                <a:solidFill>
-                  <a:srgbClr val="334155"/>
-                </a:solidFill>
-                <a:latin typeface="Segoe UI" pitchFamily="34" charset="0"/>
-                <a:ea typeface="Segoe UI" pitchFamily="34" charset="-122"/>
-                <a:cs typeface="Segoe UI" pitchFamily="34" charset="-120"/>
-              </a:rPr>
-              <a:t>No conversion of historical requests.</a:t>
-            </a:r>
-            <a:endParaRPr lang="en-US" sz="1125" dirty="0"/>
-          </a:p>
-        </p:txBody>
-      </p:sp>
-    </p:spTree>
-  </p:cSld>
-  <p:clrMapOvr>
-    <a:masterClrMapping/>
-  </p:clrMapOvr>
-</p:sld>
-</file>
-
-<file path=ppt/slides/slide19.xml><?xml version="1.0" encoding="utf-8"?>
-<p:sld xmlns:a="http://schemas.openxmlformats.org/drawingml/2006/main" xmlns:r="http://schemas.openxmlformats.org/officeDocument/2006/relationships" xmlns:p="http://schemas.openxmlformats.org/presentationml/2006/main">
-  <p:cSld name="Slide 19">
     <p:bg>
       <p:bgPr>
         <a:solidFill>

</xml_diff>

<commit_message>
vault backup: 2026-09-22 15:48:50
</commit_message>
<xml_diff>
--- a/SDLC/Projects/TMP-specimen-sorter-api — Specimen Sorter API/assets/Specimen Sorter API v3.pptx
+++ b/SDLC/Projects/TMP-specimen-sorter-api — Specimen Sorter API/assets/Specimen Sorter API v3.pptx
@@ -23,9 +23,10 @@
     <p:sldId id="271" r:id="rId17"/>
     <p:sldId id="272" r:id="rId18"/>
     <p:sldId id="273" r:id="rId19"/>
+    <p:sldId id="274" r:id="rId20"/>
   </p:sldIdLst>
   <p:notesMasterIdLst>
-    <p:notesMasterId r:id="rId20"/>
+    <p:notesMasterId r:id="rId21"/>
   </p:notesMasterIdLst>
   <p:sldSz cx="12192000" cy="6858000"/>
   <p:notesSz cx="6858000" cy="12192000"/>
@@ -1135,7 +1136,7 @@
           <a:p>
             <a:r>
               <a:rPr lang="en-US" dirty="0"/>
-              <a:t>A late worksheet does not change a status already returned. Print failure is an ALS warning, nothing more.</a:t>
+              <a:t>SORT_* plus today's REG and SEND_OUT sit on LOE_AUDIT_TRAIL. Confirm the Audit Trail filter shows SORT_* before the pilot.</a:t>
             </a:r>
             <a:endParaRPr lang="en-US" dirty="0"/>
           </a:p>
@@ -1223,7 +1224,7 @@
           <a:p>
             <a:r>
               <a:rPr lang="en-US" dirty="0"/>
-              <a:t>Confirm the Audit Trail filter shows SORT_* before the pilot, or staff cannot find the sorter's attempts.</a:t>
+              <a:t>Print sits outside the response. A late worksheet does not change a status already returned.</a:t>
             </a:r>
             <a:endParaRPr lang="en-US" dirty="0"/>
           </a:p>
@@ -1311,7 +1312,7 @@
           <a:p>
             <a:r>
               <a:rPr lang="en-US" dirty="0"/>
-              <a:t>Likely questions: why not let middleware call the staff register; why hospital sent skips the map; why mixed tubes fail; why user is wkbh_id.</a:t>
+              <a:t>Confirm the Audit Trail filter shows SORT_* before the pilot, or staff cannot find the sorter's attempts.</a:t>
             </a:r>
             <a:endParaRPr lang="en-US" dirty="0"/>
           </a:p>
@@ -1335,6 +1336,94 @@
             <a:fld id="{F7021451-1387-4CA6-816F-3879F97B5CBC}" type="slidenum">
               <a:rPr lang="en-US"/>
               <a:t>18</a:t>
+            </a:fld>
+            <a:endParaRPr lang="en-US"/>
+          </a:p>
+        </p:txBody>
+      </p:sp>
+    </p:spTree>
+    <p:extLst>
+      <p:ext uri="{BB962C8B-B14F-4D97-AF65-F5344CB8AC3E}">
+        <p14:creationId xmlns:p14="http://schemas.microsoft.com/office/powerpoint/2010/main" val="1024086991"/>
+      </p:ext>
+    </p:extLst>
+  </p:cSld>
+  <p:clrMapOvr>
+    <a:masterClrMapping/>
+  </p:clrMapOvr>
+</p:notes>
+</file>
+
+<file path=ppt/notesSlides/notesSlide19.xml><?xml version="1.0" encoding="utf-8"?>
+<p:notes xmlns:a="http://schemas.openxmlformats.org/drawingml/2006/main" xmlns:r="http://schemas.openxmlformats.org/officeDocument/2006/relationships" xmlns:p="http://schemas.openxmlformats.org/presentationml/2006/main">
+  <p:cSld>
+    <p:spTree>
+      <p:nvGrpSpPr>
+        <p:cNvPr id="1" name=""/>
+        <p:cNvGrpSpPr/>
+        <p:nvPr/>
+      </p:nvGrpSpPr>
+      <p:grpSpPr>
+        <a:xfrm>
+          <a:off x="0" y="0"/>
+          <a:ext cx="0" cy="0"/>
+          <a:chOff x="0" y="0"/>
+          <a:chExt cx="0" cy="0"/>
+        </a:xfrm>
+      </p:grpSpPr>
+      <p:sp>
+        <p:nvSpPr>
+          <p:cNvPr id="2" name="Slide Image Placeholder 1"/>
+          <p:cNvSpPr>
+            <a:spLocks noGrp="1" noRot="1" noChangeAspect="1"/>
+          </p:cNvSpPr>
+          <p:nvPr>
+            <p:ph type="sldImg"/>
+          </p:nvPr>
+        </p:nvSpPr>
+        <p:spPr/>
+      </p:sp>
+      <p:sp>
+        <p:nvSpPr>
+          <p:cNvPr id="3" name="Notes Placeholder 2"/>
+          <p:cNvSpPr>
+            <a:spLocks noGrp="1"/>
+          </p:cNvSpPr>
+          <p:nvPr>
+            <p:ph type="body" idx="1"/>
+          </p:nvPr>
+        </p:nvSpPr>
+        <p:spPr/>
+        <p:txBody>
+          <a:bodyPr/>
+          <a:lstStyle/>
+          <a:p>
+            <a:r>
+              <a:rPr lang="en-US" dirty="0"/>
+              <a:t>Likely questions: why not let middleware call the staff register; why hospital sent skips the map; why mixed tubes fail; why user is wkbh_id.</a:t>
+            </a:r>
+            <a:endParaRPr lang="en-US" dirty="0"/>
+          </a:p>
+        </p:txBody>
+      </p:sp>
+      <p:sp>
+        <p:nvSpPr>
+          <p:cNvPr id="4" name="Slide Number Placeholder 3"/>
+          <p:cNvSpPr>
+            <a:spLocks noGrp="1"/>
+          </p:cNvSpPr>
+          <p:nvPr>
+            <p:ph type="sldNum" sz="quarter" idx="10"/>
+          </p:nvPr>
+        </p:nvSpPr>
+        <p:spPr/>
+        <p:txBody>
+          <a:bodyPr/>
+          <a:lstStyle/>
+          <a:p>
+            <a:fld id="{F7021451-1387-4CA6-816F-3879F97B5CBC}" type="slidenum">
+              <a:rPr lang="en-US"/>
+              <a:t>19</a:t>
             </a:fld>
             <a:endParaRPr lang="en-US"/>
           </a:p>
@@ -9936,7 +10025,7 @@
                 <a:ea typeface="Segoe UI Semibold" pitchFamily="34" charset="-122"/>
                 <a:cs typeface="Segoe UI Semibold" pitchFamily="34" charset="-120"/>
               </a:rPr>
-              <a:t>Only REGISTERED prints, and only after the response</a:t>
+              <a:t>Each status writes an audit action</a:t>
             </a:r>
             <a:endParaRPr lang="en-US" sz="2400" dirty="0"/>
           </a:p>
@@ -9965,10 +10054,10 @@
             <a:tbl>
               <a:tblPr/>
               <a:tblGrid>
-                <a:gridCol w="1920240"/>
-                <a:gridCol w="3566160"/>
-                <a:gridCol w="3566160"/>
-                <a:gridCol w="1920240"/>
+                <a:gridCol w="2103120"/>
+                <a:gridCol w="3108960"/>
+                <a:gridCol w="3291840"/>
+                <a:gridCol w="2468880"/>
               </a:tblGrid>
               <a:tr h="457200">
                 <a:tc>
@@ -10088,7 +10177,7 @@
                           <a:ea typeface="Segoe UI" pitchFamily="34" charset="-122"/>
                           <a:cs typeface="Segoe UI" pitchFamily="34" charset="-120"/>
                         </a:rPr>
-                        <a:t>Worksheet and PHLC</a:t>
+                        <a:t>Audit Action</a:t>
                       </a:r>
                       <a:endParaRPr lang="en-US" sz="1125" dirty="0">
                         <a:latin typeface="Segoe UI" charset="0"/>
@@ -10240,7 +10329,7 @@
                           <a:ea typeface="Segoe UI" pitchFamily="34" charset="-122"/>
                           <a:cs typeface="Segoe UI" pitchFamily="34" charset="-120"/>
                         </a:rPr>
-                        <a:t>Lab request, SORT_REG and REG</a:t>
+                        <a:t>Lab request</a:t>
                       </a:r>
                       <a:endParaRPr lang="en-US" sz="1125" dirty="0">
                         <a:latin typeface="Segoe UI" charset="0"/>
@@ -10284,18 +10373,18 @@
                       <a:r>
                         <a:rPr lang="en-US" sz="1125" dirty="0">
                           <a:solidFill>
-                            <a:srgbClr val="475569"/>
+                            <a:srgbClr val="0284C7"/>
                           </a:solidFill>
-                          <a:latin typeface="Segoe UI" pitchFamily="34" charset="0"/>
-                          <a:ea typeface="Segoe UI" pitchFamily="34" charset="-122"/>
-                          <a:cs typeface="Segoe UI" pitchFamily="34" charset="-120"/>
+                          <a:latin typeface="Consolas" pitchFamily="34" charset="0"/>
+                          <a:ea typeface="Consolas" pitchFamily="34" charset="-122"/>
+                          <a:cs typeface="Consolas" pitchFamily="34" charset="-120"/>
                         </a:rPr>
-                        <a:t>All worksheets, then PHLC, after return</a:t>
+                        <a:t>SORT_REG and REG</a:t>
                       </a:r>
                       <a:endParaRPr lang="en-US" sz="1125" dirty="0">
-                        <a:latin typeface="Segoe UI" charset="0"/>
-                        <a:ea typeface="Segoe UI" charset="0"/>
-                        <a:cs typeface="Segoe UI" charset="0"/>
+                        <a:latin typeface="Consolas" charset="0"/>
+                        <a:ea typeface="Consolas" charset="0"/>
+                        <a:cs typeface="Consolas" charset="0"/>
                       </a:endParaRPr>
                     </a:p>
                   </a:txBody>
@@ -10442,7 +10531,7 @@
                           <a:ea typeface="Segoe UI" pitchFamily="34" charset="-122"/>
                           <a:cs typeface="Segoe UI" pitchFamily="34" charset="-120"/>
                         </a:rPr>
-                        <a:t>Send-out, tracking logs, SORT_SO and SEND_OUT</a:t>
+                        <a:t>Send-out, tracking logs</a:t>
                       </a:r>
                       <a:endParaRPr lang="en-US" sz="1125" dirty="0">
                         <a:latin typeface="Segoe UI" charset="0"/>
@@ -10486,18 +10575,18 @@
                       <a:r>
                         <a:rPr lang="en-US" sz="1125" dirty="0">
                           <a:solidFill>
-                            <a:srgbClr val="64748B"/>
+                            <a:srgbClr val="0284C7"/>
                           </a:solidFill>
-                          <a:latin typeface="Segoe UI" pitchFamily="34" charset="0"/>
-                          <a:ea typeface="Segoe UI" pitchFamily="34" charset="-122"/>
-                          <a:cs typeface="Segoe UI" pitchFamily="34" charset="-120"/>
+                          <a:latin typeface="Consolas" pitchFamily="34" charset="0"/>
+                          <a:ea typeface="Consolas" pitchFamily="34" charset="-122"/>
+                          <a:cs typeface="Consolas" pitchFamily="34" charset="-120"/>
                         </a:rPr>
-                        <a:t>None</a:t>
+                        <a:t>SORT_SO and SEND_OUT</a:t>
                       </a:r>
                       <a:endParaRPr lang="en-US" sz="1125" dirty="0">
-                        <a:latin typeface="Segoe UI" charset="0"/>
-                        <a:ea typeface="Segoe UI" charset="0"/>
-                        <a:cs typeface="Segoe UI" charset="0"/>
+                        <a:latin typeface="Consolas" charset="0"/>
+                        <a:ea typeface="Consolas" charset="0"/>
+                        <a:cs typeface="Consolas" charset="0"/>
                       </a:endParaRPr>
                     </a:p>
                   </a:txBody>
@@ -10638,13 +10727,13 @@
                       <a:r>
                         <a:rPr lang="en-US" sz="1125" dirty="0">
                           <a:solidFill>
-                            <a:srgbClr val="475569"/>
+                            <a:srgbClr val="64748B"/>
                           </a:solidFill>
                           <a:latin typeface="Segoe UI" pitchFamily="34" charset="0"/>
                           <a:ea typeface="Segoe UI" pitchFamily="34" charset="-122"/>
                           <a:cs typeface="Segoe UI" pitchFamily="34" charset="-120"/>
                         </a:rPr>
-                        <a:t>SORT_RELABEL only</a:t>
+                        <a:t>None</a:t>
                       </a:r>
                       <a:endParaRPr lang="en-US" sz="1125" dirty="0">
                         <a:latin typeface="Segoe UI" charset="0"/>
@@ -10688,18 +10777,18 @@
                       <a:r>
                         <a:rPr lang="en-US" sz="1125" dirty="0">
                           <a:solidFill>
-                            <a:srgbClr val="64748B"/>
+                            <a:srgbClr val="0284C7"/>
                           </a:solidFill>
-                          <a:latin typeface="Segoe UI" pitchFamily="34" charset="0"/>
-                          <a:ea typeface="Segoe UI" pitchFamily="34" charset="-122"/>
-                          <a:cs typeface="Segoe UI" pitchFamily="34" charset="-120"/>
+                          <a:latin typeface="Consolas" pitchFamily="34" charset="0"/>
+                          <a:ea typeface="Consolas" pitchFamily="34" charset="-122"/>
+                          <a:cs typeface="Consolas" pitchFamily="34" charset="-120"/>
                         </a:rPr>
-                        <a:t>None</a:t>
+                        <a:t>SORT_RELABEL</a:t>
                       </a:r>
                       <a:endParaRPr lang="en-US" sz="1125" dirty="0">
-                        <a:latin typeface="Segoe UI" charset="0"/>
-                        <a:ea typeface="Segoe UI" charset="0"/>
-                        <a:cs typeface="Segoe UI" charset="0"/>
+                        <a:latin typeface="Consolas" charset="0"/>
+                        <a:ea typeface="Consolas" charset="0"/>
+                        <a:cs typeface="Consolas" charset="0"/>
                       </a:endParaRPr>
                     </a:p>
                   </a:txBody>
@@ -10834,13 +10923,13 @@
                       <a:r>
                         <a:rPr lang="en-US" sz="1125" dirty="0">
                           <a:solidFill>
-                            <a:srgbClr val="475569"/>
+                            <a:srgbClr val="64748B"/>
                           </a:solidFill>
                           <a:latin typeface="Segoe UI" pitchFamily="34" charset="0"/>
                           <a:ea typeface="Segoe UI" pitchFamily="34" charset="-122"/>
                           <a:cs typeface="Segoe UI" pitchFamily="34" charset="-120"/>
                         </a:rPr>
-                        <a:t>SORT_FAIL with message code</a:t>
+                        <a:t>None</a:t>
                       </a:r>
                       <a:endParaRPr lang="en-US" sz="1125" dirty="0">
                         <a:latin typeface="Segoe UI" charset="0"/>
@@ -10878,18 +10967,18 @@
                       <a:r>
                         <a:rPr lang="en-US" sz="1125" dirty="0">
                           <a:solidFill>
-                            <a:srgbClr val="64748B"/>
+                            <a:srgbClr val="0284C7"/>
                           </a:solidFill>
-                          <a:latin typeface="Segoe UI" pitchFamily="34" charset="0"/>
-                          <a:ea typeface="Segoe UI" pitchFamily="34" charset="-122"/>
-                          <a:cs typeface="Segoe UI" pitchFamily="34" charset="-120"/>
+                          <a:latin typeface="Consolas" pitchFamily="34" charset="0"/>
+                          <a:ea typeface="Consolas" pitchFamily="34" charset="-122"/>
+                          <a:cs typeface="Consolas" pitchFamily="34" charset="-120"/>
                         </a:rPr>
-                        <a:t>None</a:t>
+                        <a:t>SORT_FAIL with message code</a:t>
                       </a:r>
                       <a:endParaRPr lang="en-US" sz="1125" dirty="0">
-                        <a:latin typeface="Segoe UI" charset="0"/>
-                        <a:ea typeface="Segoe UI" charset="0"/>
-                        <a:cs typeface="Segoe UI" charset="0"/>
+                        <a:latin typeface="Consolas" charset="0"/>
+                        <a:ea typeface="Consolas" charset="0"/>
+                        <a:cs typeface="Consolas" charset="0"/>
                       </a:endParaRPr>
                     </a:p>
                   </a:txBody>
@@ -11054,7 +11143,7 @@
                 <a:ea typeface="Segoe UI Semibold" pitchFamily="34" charset="-122"/>
                 <a:cs typeface="Segoe UI Semibold" pitchFamily="34" charset="-120"/>
               </a:rPr>
-              <a:t>06. PROMOTION AND FALLBACK</a:t>
+              <a:t>04D. WORKSHEET AND PHLC</a:t>
             </a:r>
             <a:endParaRPr lang="en-US" sz="1050" dirty="0"/>
           </a:p>
@@ -11093,7 +11182,7 @@
                 <a:ea typeface="Segoe UI Semibold" pitchFamily="34" charset="-122"/>
                 <a:cs typeface="Segoe UI Semibold" pitchFamily="34" charset="-120"/>
               </a:rPr>
-              <a:t>Seed workbench, open the gateway path, pilot CPS and HMS</a:t>
+              <a:t>Only REGISTERED prints, and only after the response</a:t>
             </a:r>
             <a:endParaRPr lang="en-US" sz="2400" dirty="0"/>
           </a:p>
@@ -11107,12 +11196,12 @@
         </p:nvSpPr>
         <p:spPr>
           <a:xfrm>
-            <a:off x="609600" y="2539032"/>
-            <a:ext cx="5335524" cy="2694337"/>
+            <a:off x="609600" y="2586514"/>
+            <a:ext cx="5335524" cy="2050732"/>
           </a:xfrm>
           <a:prstGeom prst="roundRect">
             <a:avLst>
-              <a:gd name="adj" fmla="val 4073"/>
+              <a:gd name="adj" fmla="val 5351"/>
             </a:avLst>
           </a:prstGeom>
           <a:solidFill>
@@ -11128,7 +11217,7 @@
       </p:sp>
       <p:pic>
         <p:nvPicPr>
-          <p:cNvPr id="5" name="Image 0" descr="D:\Github\HA-Notes\LIS\skills\design-review-pptx\assets\icons\png\success\cloud-arrow-up.png">    </p:cNvPr>
+          <p:cNvPr id="5" name="Image 0" descr="D:\Github\HA-Notes\LIS\skills\design-review-pptx\assets\icons\png\accent\list-check.png">    </p:cNvPr>
           <p:cNvPicPr>
             <a:picLocks noChangeAspect="1"/>
           </p:cNvPicPr>
@@ -11142,7 +11231,7 @@
         </p:blipFill>
         <p:spPr>
           <a:xfrm>
-            <a:off x="883920" y="2845356"/>
+            <a:off x="883920" y="2906554"/>
             <a:ext cx="265176" cy="265176"/>
           </a:xfrm>
           <a:prstGeom prst="rect">
@@ -11158,8 +11247,8 @@
         </p:nvSpPr>
         <p:spPr>
           <a:xfrm>
-            <a:off x="1249680" y="2831640"/>
-            <a:ext cx="4421124" cy="292608"/>
+            <a:off x="883920" y="3363754"/>
+            <a:ext cx="4786884" cy="219075"/>
           </a:xfrm>
           <a:prstGeom prst="rect">
             <a:avLst/>
@@ -11168,12 +11257,12 @@
           <a:ln/>
         </p:spPr>
         <p:txBody>
-          <a:bodyPr wrap="square" lIns="0" tIns="0" rIns="0" bIns="0" rtlCol="0" anchor="ctr"/>
+          <a:bodyPr wrap="square" lIns="0" tIns="0" rIns="0" bIns="0" rtlCol="0" anchor="t"/>
           <a:lstStyle/>
           <a:p>
             <a:pPr algn="l" indent="0" marL="0">
               <a:lnSpc>
-                <a:spcPct val="115000"/>
+                <a:spcPct val="110000"/>
               </a:lnSpc>
               <a:buNone/>
             </a:pPr>
@@ -11186,7 +11275,7 @@
                 <a:ea typeface="Segoe UI Semibold" pitchFamily="34" charset="-122"/>
                 <a:cs typeface="Segoe UI Semibold" pitchFamily="34" charset="-120"/>
               </a:rPr>
-              <a:t>Promotion</a:t>
+              <a:t>Worksheets</a:t>
             </a:r>
             <a:endParaRPr lang="en-US" sz="1500" dirty="0"/>
           </a:p>
@@ -11200,447 +11289,94 @@
         </p:nvSpPr>
         <p:spPr>
           <a:xfrm>
-            <a:off x="883920" y="3261408"/>
-            <a:ext cx="228600" cy="228600"/>
-          </a:xfrm>
-          <a:prstGeom prst="ellipse">
-            <a:avLst/>
-          </a:prstGeom>
-          <a:solidFill>
-            <a:srgbClr val="DCFCE7"/>
-          </a:solidFill>
-          <a:ln>
-            <a:solidFill>
-              <a:srgbClr val="DCFCE7"/>
-            </a:solidFill>
-          </a:ln>
-        </p:spPr>
-        <p:txBody>
-          <a:bodyPr wrap="square" lIns="0" tIns="0" rIns="0" bIns="0" rtlCol="0" anchor="ctr"/>
-          <a:lstStyle/>
-          <a:p>
-            <a:pPr algn="ctr" indent="0" marL="0">
-              <a:buNone/>
-            </a:pPr>
-            <a:r>
-              <a:rPr lang="en-US" sz="975" b="1" dirty="0">
-                <a:solidFill>
-                  <a:srgbClr val="15803D"/>
+            <a:off x="883920" y="3674269"/>
+            <a:ext cx="4786884" cy="798385"/>
+          </a:xfrm>
+          <a:prstGeom prst="rect">
+            <a:avLst/>
+          </a:prstGeom>
+          <a:noFill/>
+          <a:ln/>
+        </p:spPr>
+        <p:txBody>
+          <a:bodyPr wrap="square" lIns="0" tIns="0" rIns="0" bIns="0" rtlCol="0" anchor="t"/>
+          <a:lstStyle/>
+          <a:p>
+            <a:pPr algn="l" indent="0" marL="0">
+              <a:lnSpc>
+                <a:spcPct val="120000"/>
+              </a:lnSpc>
+              <a:buNone/>
+            </a:pPr>
+            <a:r>
+              <a:rPr lang="en-US" sz="1350" dirty="0">
+                <a:solidFill>
+                  <a:srgbClr val="475569"/>
                 </a:solidFill>
                 <a:latin typeface="Segoe UI" pitchFamily="34" charset="0"/>
                 <a:ea typeface="Segoe UI" pitchFamily="34" charset="-122"/>
                 <a:cs typeface="Segoe UI" pitchFamily="34" charset="-120"/>
               </a:rPr>
-              <a:t>1</a:t>
-            </a:r>
-            <a:endParaRPr lang="en-US" sz="975" dirty="0"/>
-          </a:p>
-        </p:txBody>
-      </p:sp>
-      <p:sp>
-        <p:nvSpPr>
-          <p:cNvPr id="8" name="Text 5"/>
-          <p:cNvSpPr/>
-          <p:nvPr/>
-        </p:nvSpPr>
-        <p:spPr>
-          <a:xfrm>
-            <a:off x="1222248" y="3288840"/>
-            <a:ext cx="4448556" cy="196882"/>
-          </a:xfrm>
-          <a:prstGeom prst="rect">
-            <a:avLst/>
-          </a:prstGeom>
-          <a:noFill/>
-          <a:ln/>
-        </p:spPr>
-        <p:txBody>
-          <a:bodyPr wrap="square" lIns="0" tIns="0" rIns="0" bIns="0" rtlCol="0" anchor="t"/>
-          <a:lstStyle/>
+              <a:t>• All worksheets after return</a:t>
+            </a:r>
+            <a:endParaRPr lang="en-US" sz="1350" dirty="0"/>
+          </a:p>
           <a:p>
             <a:pPr algn="l" indent="0" marL="0">
               <a:lnSpc>
-                <a:spcPct val="115000"/>
+                <a:spcPct val="120000"/>
               </a:lnSpc>
               <a:buNone/>
             </a:pPr>
             <a:r>
-              <a:rPr lang="en-US" sz="1125" dirty="0">
-                <a:solidFill>
-                  <a:srgbClr val="334155"/>
+              <a:rPr lang="en-US" sz="1350" dirty="0">
+                <a:solidFill>
+                  <a:srgbClr val="475569"/>
                 </a:solidFill>
                 <a:latin typeface="Segoe UI" pitchFamily="34" charset="0"/>
                 <a:ea typeface="Segoe UI" pitchFamily="34" charset="-122"/>
                 <a:cs typeface="Segoe UI" pitchFamily="34" charset="-120"/>
               </a:rPr>
-              <a:t>Seed workbench: station name = sorter id, user = wkbh_id.</a:t>
-            </a:r>
-            <a:endParaRPr lang="en-US" sz="1125" dirty="0"/>
-          </a:p>
-        </p:txBody>
-      </p:sp>
-      <p:sp>
-        <p:nvSpPr>
-          <p:cNvPr id="9" name="Text 6"/>
-          <p:cNvSpPr/>
-          <p:nvPr/>
-        </p:nvSpPr>
-        <p:spPr>
-          <a:xfrm>
-            <a:off x="883920" y="3595449"/>
-            <a:ext cx="228600" cy="228600"/>
-          </a:xfrm>
-          <a:prstGeom prst="ellipse">
-            <a:avLst/>
-          </a:prstGeom>
-          <a:solidFill>
-            <a:srgbClr val="DCFCE7"/>
-          </a:solidFill>
-          <a:ln>
-            <a:solidFill>
-              <a:srgbClr val="DCFCE7"/>
-            </a:solidFill>
-          </a:ln>
-        </p:spPr>
-        <p:txBody>
-          <a:bodyPr wrap="square" lIns="0" tIns="0" rIns="0" bIns="0" rtlCol="0" anchor="ctr"/>
-          <a:lstStyle/>
-          <a:p>
-            <a:pPr algn="ctr" indent="0" marL="0">
-              <a:buNone/>
-            </a:pPr>
-            <a:r>
-              <a:rPr lang="en-US" sz="975" b="1" dirty="0">
-                <a:solidFill>
-                  <a:srgbClr val="15803D"/>
+              <a:t>• Worksheet, send-out and SH Ro</a:t>
+            </a:r>
+            <a:endParaRPr lang="en-US" sz="1350" dirty="0"/>
+          </a:p>
+          <a:p>
+            <a:pPr algn="l" indent="0" marL="0">
+              <a:lnSpc>
+                <a:spcPct val="120000"/>
+              </a:lnSpc>
+              <a:buNone/>
+            </a:pPr>
+            <a:r>
+              <a:rPr lang="en-US" sz="1350" dirty="0">
+                <a:solidFill>
+                  <a:srgbClr val="475569"/>
                 </a:solidFill>
                 <a:latin typeface="Segoe UI" pitchFamily="34" charset="0"/>
                 <a:ea typeface="Segoe UI" pitchFamily="34" charset="-122"/>
                 <a:cs typeface="Segoe UI" pitchFamily="34" charset="-120"/>
               </a:rPr>
-              <a:t>2</a:t>
-            </a:r>
-            <a:endParaRPr lang="en-US" sz="975" dirty="0"/>
-          </a:p>
-        </p:txBody>
-      </p:sp>
-      <p:sp>
-        <p:nvSpPr>
-          <p:cNvPr id="10" name="Text 7"/>
-          <p:cNvSpPr/>
-          <p:nvPr/>
-        </p:nvSpPr>
-        <p:spPr>
-          <a:xfrm>
-            <a:off x="1222248" y="3622881"/>
-            <a:ext cx="4448556" cy="196882"/>
-          </a:xfrm>
-          <a:prstGeom prst="rect">
-            <a:avLst/>
-          </a:prstGeom>
-          <a:noFill/>
-          <a:ln/>
-        </p:spPr>
-        <p:txBody>
-          <a:bodyPr wrap="square" lIns="0" tIns="0" rIns="0" bIns="0" rtlCol="0" anchor="t"/>
-          <a:lstStyle/>
-          <a:p>
-            <a:pPr algn="l" indent="0" marL="0">
-              <a:lnSpc>
-                <a:spcPct val="115000"/>
-              </a:lnSpc>
-              <a:buNone/>
-            </a:pPr>
-            <a:r>
-              <a:rPr lang="en-US" sz="1125" dirty="0">
-                <a:solidFill>
-                  <a:srgbClr val="334155"/>
-                </a:solidFill>
-                <a:latin typeface="Segoe UI" pitchFamily="34" charset="0"/>
-                <a:ea typeface="Segoe UI" pitchFamily="34" charset="-122"/>
-                <a:cs typeface="Segoe UI" pitchFamily="34" charset="-120"/>
-              </a:rPr>
-              <a:t>Map row only if hospital can be omitted.</a:t>
-            </a:r>
-            <a:endParaRPr lang="en-US" sz="1125" dirty="0"/>
-          </a:p>
-        </p:txBody>
-      </p:sp>
-      <p:sp>
-        <p:nvSpPr>
-          <p:cNvPr id="11" name="Text 8"/>
-          <p:cNvSpPr/>
-          <p:nvPr/>
-        </p:nvSpPr>
-        <p:spPr>
-          <a:xfrm>
-            <a:off x="883920" y="3929491"/>
-            <a:ext cx="228600" cy="228600"/>
-          </a:xfrm>
-          <a:prstGeom prst="ellipse">
-            <a:avLst/>
-          </a:prstGeom>
-          <a:solidFill>
-            <a:srgbClr val="DCFCE7"/>
-          </a:solidFill>
-          <a:ln>
-            <a:solidFill>
-              <a:srgbClr val="DCFCE7"/>
-            </a:solidFill>
-          </a:ln>
-        </p:spPr>
-        <p:txBody>
-          <a:bodyPr wrap="square" lIns="0" tIns="0" rIns="0" bIns="0" rtlCol="0" anchor="ctr"/>
-          <a:lstStyle/>
-          <a:p>
-            <a:pPr algn="ctr" indent="0" marL="0">
-              <a:buNone/>
-            </a:pPr>
-            <a:r>
-              <a:rPr lang="en-US" sz="975" b="1" dirty="0">
-                <a:solidFill>
-                  <a:srgbClr val="15803D"/>
-                </a:solidFill>
-                <a:latin typeface="Segoe UI" pitchFamily="34" charset="0"/>
-                <a:ea typeface="Segoe UI" pitchFamily="34" charset="-122"/>
-                <a:cs typeface="Segoe UI" pitchFamily="34" charset="-120"/>
-              </a:rPr>
-              <a:t>3</a:t>
-            </a:r>
-            <a:endParaRPr lang="en-US" sz="975" dirty="0"/>
-          </a:p>
-        </p:txBody>
-      </p:sp>
-      <p:sp>
-        <p:nvSpPr>
-          <p:cNvPr id="12" name="Text 9"/>
-          <p:cNvSpPr/>
-          <p:nvPr/>
-        </p:nvSpPr>
-        <p:spPr>
-          <a:xfrm>
-            <a:off x="1222248" y="3956923"/>
-            <a:ext cx="4448556" cy="196882"/>
-          </a:xfrm>
-          <a:prstGeom prst="rect">
-            <a:avLst/>
-          </a:prstGeom>
-          <a:noFill/>
-          <a:ln/>
-        </p:spPr>
-        <p:txBody>
-          <a:bodyPr wrap="square" lIns="0" tIns="0" rIns="0" bIns="0" rtlCol="0" anchor="t"/>
-          <a:lstStyle/>
-          <a:p>
-            <a:pPr algn="l" indent="0" marL="0">
-              <a:lnSpc>
-                <a:spcPct val="115000"/>
-              </a:lnSpc>
-              <a:buNone/>
-            </a:pPr>
-            <a:r>
-              <a:rPr lang="en-US" sz="1125" dirty="0">
-                <a:solidFill>
-                  <a:srgbClr val="334155"/>
-                </a:solidFill>
-                <a:latin typeface="Segoe UI" pitchFamily="34" charset="0"/>
-                <a:ea typeface="Segoe UI" pitchFamily="34" charset="-122"/>
-                <a:cs typeface="Segoe UI" pitchFamily="34" charset="-120"/>
-              </a:rPr>
-              <a:t>Deploy lis-crs-spec-ack-svc.</a:t>
-            </a:r>
-            <a:endParaRPr lang="en-US" sz="1125" dirty="0"/>
-          </a:p>
-        </p:txBody>
-      </p:sp>
-      <p:sp>
-        <p:nvSpPr>
-          <p:cNvPr id="13" name="Text 10"/>
-          <p:cNvSpPr/>
-          <p:nvPr/>
-        </p:nvSpPr>
-        <p:spPr>
-          <a:xfrm>
-            <a:off x="883920" y="4263533"/>
-            <a:ext cx="228600" cy="228600"/>
-          </a:xfrm>
-          <a:prstGeom prst="ellipse">
-            <a:avLst/>
-          </a:prstGeom>
-          <a:solidFill>
-            <a:srgbClr val="DCFCE7"/>
-          </a:solidFill>
-          <a:ln>
-            <a:solidFill>
-              <a:srgbClr val="DCFCE7"/>
-            </a:solidFill>
-          </a:ln>
-        </p:spPr>
-        <p:txBody>
-          <a:bodyPr wrap="square" lIns="0" tIns="0" rIns="0" bIns="0" rtlCol="0" anchor="ctr"/>
-          <a:lstStyle/>
-          <a:p>
-            <a:pPr algn="ctr" indent="0" marL="0">
-              <a:buNone/>
-            </a:pPr>
-            <a:r>
-              <a:rPr lang="en-US" sz="975" b="1" dirty="0">
-                <a:solidFill>
-                  <a:srgbClr val="15803D"/>
-                </a:solidFill>
-                <a:latin typeface="Segoe UI" pitchFamily="34" charset="0"/>
-                <a:ea typeface="Segoe UI" pitchFamily="34" charset="-122"/>
-                <a:cs typeface="Segoe UI" pitchFamily="34" charset="-120"/>
-              </a:rPr>
-              <a:t>4</a:t>
-            </a:r>
-            <a:endParaRPr lang="en-US" sz="975" dirty="0"/>
-          </a:p>
-        </p:txBody>
-      </p:sp>
-      <p:sp>
-        <p:nvSpPr>
-          <p:cNvPr id="14" name="Text 11"/>
-          <p:cNvSpPr/>
-          <p:nvPr/>
-        </p:nvSpPr>
-        <p:spPr>
-          <a:xfrm>
-            <a:off x="1222248" y="4290965"/>
-            <a:ext cx="4448556" cy="196882"/>
-          </a:xfrm>
-          <a:prstGeom prst="rect">
-            <a:avLst/>
-          </a:prstGeom>
-          <a:noFill/>
-          <a:ln/>
-        </p:spPr>
-        <p:txBody>
-          <a:bodyPr wrap="square" lIns="0" tIns="0" rIns="0" bIns="0" rtlCol="0" anchor="t"/>
-          <a:lstStyle/>
-          <a:p>
-            <a:pPr algn="l" indent="0" marL="0">
-              <a:lnSpc>
-                <a:spcPct val="115000"/>
-              </a:lnSpc>
-              <a:buNone/>
-            </a:pPr>
-            <a:r>
-              <a:rPr lang="en-US" sz="1125" dirty="0">
-                <a:solidFill>
-                  <a:srgbClr val="334155"/>
-                </a:solidFill>
-                <a:latin typeface="Segoe UI" pitchFamily="34" charset="0"/>
-                <a:ea typeface="Segoe UI" pitchFamily="34" charset="-122"/>
-                <a:cs typeface="Segoe UI" pitchFamily="34" charset="-120"/>
-              </a:rPr>
-              <a:t>Publish the APIM product and NetworkPolicy.</a:t>
-            </a:r>
-            <a:endParaRPr lang="en-US" sz="1125" dirty="0"/>
-          </a:p>
-        </p:txBody>
-      </p:sp>
-      <p:sp>
-        <p:nvSpPr>
-          <p:cNvPr id="15" name="Text 12"/>
-          <p:cNvSpPr/>
-          <p:nvPr/>
-        </p:nvSpPr>
-        <p:spPr>
-          <a:xfrm>
-            <a:off x="883920" y="4597575"/>
-            <a:ext cx="228600" cy="228600"/>
-          </a:xfrm>
-          <a:prstGeom prst="ellipse">
-            <a:avLst/>
-          </a:prstGeom>
-          <a:solidFill>
-            <a:srgbClr val="DCFCE7"/>
-          </a:solidFill>
-          <a:ln>
-            <a:solidFill>
-              <a:srgbClr val="DCFCE7"/>
-            </a:solidFill>
-          </a:ln>
-        </p:spPr>
-        <p:txBody>
-          <a:bodyPr wrap="square" lIns="0" tIns="0" rIns="0" bIns="0" rtlCol="0" anchor="ctr"/>
-          <a:lstStyle/>
-          <a:p>
-            <a:pPr algn="ctr" indent="0" marL="0">
-              <a:buNone/>
-            </a:pPr>
-            <a:r>
-              <a:rPr lang="en-US" sz="975" b="1" dirty="0">
-                <a:solidFill>
-                  <a:srgbClr val="15803D"/>
-                </a:solidFill>
-                <a:latin typeface="Segoe UI" pitchFamily="34" charset="0"/>
-                <a:ea typeface="Segoe UI" pitchFamily="34" charset="-122"/>
-                <a:cs typeface="Segoe UI" pitchFamily="34" charset="-120"/>
-              </a:rPr>
-              <a:t>5</a:t>
-            </a:r>
-            <a:endParaRPr lang="en-US" sz="975" dirty="0"/>
-          </a:p>
-        </p:txBody>
-      </p:sp>
-      <p:sp>
-        <p:nvSpPr>
-          <p:cNvPr id="16" name="Text 13"/>
-          <p:cNvSpPr/>
-          <p:nvPr/>
-        </p:nvSpPr>
-        <p:spPr>
-          <a:xfrm>
-            <a:off x="1222248" y="4625007"/>
-            <a:ext cx="4448556" cy="196882"/>
-          </a:xfrm>
-          <a:prstGeom prst="rect">
-            <a:avLst/>
-          </a:prstGeom>
-          <a:noFill/>
-          <a:ln/>
-        </p:spPr>
-        <p:txBody>
-          <a:bodyPr wrap="square" lIns="0" tIns="0" rIns="0" bIns="0" rtlCol="0" anchor="t"/>
-          <a:lstStyle/>
-          <a:p>
-            <a:pPr algn="l" indent="0" marL="0">
-              <a:lnSpc>
-                <a:spcPct val="115000"/>
-              </a:lnSpc>
-              <a:buNone/>
-            </a:pPr>
-            <a:r>
-              <a:rPr lang="en-US" sz="1125" dirty="0">
-                <a:solidFill>
-                  <a:srgbClr val="334155"/>
-                </a:solidFill>
-                <a:latin typeface="Segoe UI" pitchFamily="34" charset="0"/>
-                <a:ea typeface="Segoe UI" pitchFamily="34" charset="-122"/>
-                <a:cs typeface="Segoe UI" pitchFamily="34" charset="-120"/>
-              </a:rPr>
-              <a:t>Pilot CPS and HMS.</a:t>
-            </a:r>
-            <a:endParaRPr lang="en-US" sz="1125" dirty="0"/>
-          </a:p>
-        </p:txBody>
-      </p:sp>
-      <p:sp>
-        <p:nvSpPr>
-          <p:cNvPr id="17" name="Shape 14"/>
-          <p:cNvSpPr/>
-          <p:nvPr/>
-        </p:nvSpPr>
-        <p:spPr>
-          <a:xfrm>
-            <a:off x="6246876" y="2539032"/>
-            <a:ext cx="5335524" cy="2694337"/>
+              <a:t>• REGISTERED only</a:t>
+            </a:r>
+            <a:endParaRPr lang="en-US" sz="1350" dirty="0"/>
+          </a:p>
+        </p:txBody>
+      </p:sp>
+      <p:sp>
+        <p:nvSpPr>
+          <p:cNvPr id="8" name="Shape 5"/>
+          <p:cNvSpPr/>
+          <p:nvPr/>
+        </p:nvSpPr>
+        <p:spPr>
+          <a:xfrm>
+            <a:off x="6246876" y="2586514"/>
+            <a:ext cx="5335524" cy="2050732"/>
           </a:xfrm>
           <a:prstGeom prst="roundRect">
             <a:avLst>
-              <a:gd name="adj" fmla="val 4073"/>
+              <a:gd name="adj" fmla="val 5351"/>
             </a:avLst>
           </a:prstGeom>
           <a:solidFill>
@@ -11656,7 +11392,7 @@
       </p:sp>
       <p:pic>
         <p:nvPicPr>
-          <p:cNvPr id="18" name="Image 1" descr="D:\Github\HA-Notes\LIS\skills\design-review-pptx\assets\icons\png\danger\rotate-left.png">    </p:cNvPr>
+          <p:cNvPr id="9" name="Image 1" descr="D:\Github\HA-Notes\LIS\skills\design-review-pptx\assets\icons\png\accent\clipboard-check.png">    </p:cNvPr>
           <p:cNvPicPr>
             <a:picLocks noChangeAspect="1"/>
           </p:cNvPicPr>
@@ -11670,7 +11406,7 @@
         </p:blipFill>
         <p:spPr>
           <a:xfrm>
-            <a:off x="6521196" y="2845356"/>
+            <a:off x="6521196" y="2906554"/>
             <a:ext cx="265176" cy="265176"/>
           </a:xfrm>
           <a:prstGeom prst="rect">
@@ -11680,14 +11416,14 @@
       </p:pic>
       <p:sp>
         <p:nvSpPr>
-          <p:cNvPr id="19" name="Text 15"/>
-          <p:cNvSpPr/>
-          <p:nvPr/>
-        </p:nvSpPr>
-        <p:spPr>
-          <a:xfrm>
-            <a:off x="6886956" y="2831640"/>
-            <a:ext cx="4421124" cy="292608"/>
+          <p:cNvPr id="10" name="Text 6"/>
+          <p:cNvSpPr/>
+          <p:nvPr/>
+        </p:nvSpPr>
+        <p:spPr>
+          <a:xfrm>
+            <a:off x="6521196" y="3363754"/>
+            <a:ext cx="4786884" cy="219075"/>
           </a:xfrm>
           <a:prstGeom prst="rect">
             <a:avLst/>
@@ -11696,12 +11432,12 @@
           <a:ln/>
         </p:spPr>
         <p:txBody>
-          <a:bodyPr wrap="square" lIns="0" tIns="0" rIns="0" bIns="0" rtlCol="0" anchor="ctr"/>
+          <a:bodyPr wrap="square" lIns="0" tIns="0" rIns="0" bIns="0" rtlCol="0" anchor="t"/>
           <a:lstStyle/>
           <a:p>
             <a:pPr algn="l" indent="0" marL="0">
               <a:lnSpc>
-                <a:spcPct val="115000"/>
+                <a:spcPct val="110000"/>
               </a:lnSpc>
               <a:buNone/>
             </a:pPr>
@@ -11714,7 +11450,7 @@
                 <a:ea typeface="Segoe UI Semibold" pitchFamily="34" charset="-122"/>
                 <a:cs typeface="Segoe UI Semibold" pitchFamily="34" charset="-120"/>
               </a:rPr>
-              <a:t>Fallback</a:t>
+              <a:t>PHLC electronic order</a:t>
             </a:r>
             <a:endParaRPr lang="en-US" sz="1500" dirty="0"/>
           </a:p>
@@ -11722,262 +11458,122 @@
       </p:sp>
       <p:sp>
         <p:nvSpPr>
-          <p:cNvPr id="20" name="Text 16"/>
-          <p:cNvSpPr/>
-          <p:nvPr/>
-        </p:nvSpPr>
-        <p:spPr>
-          <a:xfrm>
-            <a:off x="6521196" y="3261408"/>
-            <a:ext cx="228600" cy="228600"/>
-          </a:xfrm>
-          <a:prstGeom prst="ellipse">
-            <a:avLst/>
-          </a:prstGeom>
-          <a:solidFill>
-            <a:srgbClr val="FEE2E2"/>
-          </a:solidFill>
-          <a:ln>
-            <a:solidFill>
-              <a:srgbClr val="FEE2E2"/>
-            </a:solidFill>
-          </a:ln>
-        </p:spPr>
-        <p:txBody>
-          <a:bodyPr wrap="square" lIns="0" tIns="0" rIns="0" bIns="0" rtlCol="0" anchor="ctr"/>
-          <a:lstStyle/>
-          <a:p>
-            <a:pPr algn="ctr" indent="0" marL="0">
-              <a:buNone/>
-            </a:pPr>
-            <a:r>
-              <a:rPr lang="en-US" sz="975" b="1" dirty="0">
-                <a:solidFill>
-                  <a:srgbClr val="B91C1C"/>
+          <p:cNvPr id="11" name="Text 7"/>
+          <p:cNvSpPr/>
+          <p:nvPr/>
+        </p:nvSpPr>
+        <p:spPr>
+          <a:xfrm>
+            <a:off x="6521196" y="3674269"/>
+            <a:ext cx="4786884" cy="798385"/>
+          </a:xfrm>
+          <a:prstGeom prst="rect">
+            <a:avLst/>
+          </a:prstGeom>
+          <a:noFill/>
+          <a:ln/>
+        </p:spPr>
+        <p:txBody>
+          <a:bodyPr wrap="square" lIns="0" tIns="0" rIns="0" bIns="0" rtlCol="0" anchor="t"/>
+          <a:lstStyle/>
+          <a:p>
+            <a:pPr algn="l" indent="0" marL="0">
+              <a:lnSpc>
+                <a:spcPct val="120000"/>
+              </a:lnSpc>
+              <a:buNone/>
+            </a:pPr>
+            <a:r>
+              <a:rPr lang="en-US" sz="1350" dirty="0">
+                <a:solidFill>
+                  <a:srgbClr val="475569"/>
                 </a:solidFill>
                 <a:latin typeface="Segoe UI" pitchFamily="34" charset="0"/>
                 <a:ea typeface="Segoe UI" pitchFamily="34" charset="-122"/>
                 <a:cs typeface="Segoe UI" pitchFamily="34" charset="-120"/>
               </a:rPr>
-              <a:t>1</a:t>
-            </a:r>
-            <a:endParaRPr lang="en-US" sz="975" dirty="0"/>
-          </a:p>
-        </p:txBody>
-      </p:sp>
-      <p:sp>
-        <p:nvSpPr>
-          <p:cNvPr id="21" name="Text 17"/>
-          <p:cNvSpPr/>
-          <p:nvPr/>
-        </p:nvSpPr>
-        <p:spPr>
-          <a:xfrm>
-            <a:off x="6859524" y="3288840"/>
-            <a:ext cx="4448556" cy="196882"/>
-          </a:xfrm>
-          <a:prstGeom prst="rect">
-            <a:avLst/>
-          </a:prstGeom>
-          <a:noFill/>
-          <a:ln/>
-        </p:spPr>
-        <p:txBody>
-          <a:bodyPr wrap="square" lIns="0" tIns="0" rIns="0" bIns="0" rtlCol="0" anchor="t"/>
-          <a:lstStyle/>
+              <a:t>• createPhlcLabOrder after return</a:t>
+            </a:r>
+            <a:endParaRPr lang="en-US" sz="1350" dirty="0"/>
+          </a:p>
           <a:p>
             <a:pPr algn="l" indent="0" marL="0">
               <a:lnSpc>
-                <a:spcPct val="115000"/>
+                <a:spcPct val="120000"/>
               </a:lnSpc>
               <a:buNone/>
             </a:pPr>
             <a:r>
-              <a:rPr lang="en-US" sz="1125" dirty="0">
-                <a:solidFill>
-                  <a:srgbClr val="334155"/>
+              <a:rPr lang="en-US" sz="1350" dirty="0">
+                <a:solidFill>
+                  <a:srgbClr val="475569"/>
                 </a:solidFill>
                 <a:latin typeface="Segoe UI" pitchFamily="34" charset="0"/>
                 <a:ea typeface="Segoe UI" pitchFamily="34" charset="-122"/>
                 <a:cs typeface="Segoe UI" pitchFamily="34" charset="-120"/>
               </a:rPr>
-              <a:t>Stop the middleware. Staff Spec Ack is unchanged.</a:t>
-            </a:r>
-            <a:endParaRPr lang="en-US" sz="1125" dirty="0"/>
-          </a:p>
-        </p:txBody>
-      </p:sp>
-      <p:sp>
-        <p:nvSpPr>
-          <p:cNvPr id="22" name="Text 18"/>
-          <p:cNvSpPr/>
-          <p:nvPr/>
-        </p:nvSpPr>
-        <p:spPr>
-          <a:xfrm>
-            <a:off x="6521196" y="3595449"/>
-            <a:ext cx="228600" cy="228600"/>
-          </a:xfrm>
-          <a:prstGeom prst="ellipse">
-            <a:avLst/>
-          </a:prstGeom>
-          <a:solidFill>
-            <a:srgbClr val="FEE2E2"/>
-          </a:solidFill>
-          <a:ln>
-            <a:solidFill>
-              <a:srgbClr val="FEE2E2"/>
-            </a:solidFill>
-          </a:ln>
-        </p:spPr>
-        <p:txBody>
-          <a:bodyPr wrap="square" lIns="0" tIns="0" rIns="0" bIns="0" rtlCol="0" anchor="ctr"/>
-          <a:lstStyle/>
-          <a:p>
-            <a:pPr algn="ctr" indent="0" marL="0">
-              <a:buNone/>
-            </a:pPr>
-            <a:r>
-              <a:rPr lang="en-US" sz="975" b="1" dirty="0">
-                <a:solidFill>
-                  <a:srgbClr val="B91C1C"/>
+              <a:t>• REGISTERED only</a:t>
+            </a:r>
+            <a:endParaRPr lang="en-US" sz="1350" dirty="0"/>
+          </a:p>
+        </p:txBody>
+      </p:sp>
+      <p:sp>
+        <p:nvSpPr>
+          <p:cNvPr id="12" name="Text 8"/>
+          <p:cNvSpPr/>
+          <p:nvPr/>
+        </p:nvSpPr>
+        <p:spPr>
+          <a:xfrm>
+            <a:off x="609600" y="4865846"/>
+            <a:ext cx="10972800" cy="365760"/>
+          </a:xfrm>
+          <a:prstGeom prst="rect">
+            <a:avLst/>
+          </a:prstGeom>
+          <a:noFill/>
+          <a:ln/>
+        </p:spPr>
+        <p:txBody>
+          <a:bodyPr wrap="square" lIns="0" tIns="0" rIns="0" bIns="0" rtlCol="0" anchor="t"/>
+          <a:lstStyle/>
+          <a:p>
+            <a:pPr algn="l" indent="0" marL="0">
+              <a:lnSpc>
+                <a:spcPct val="120000"/>
+              </a:lnSpc>
+              <a:buNone/>
+            </a:pPr>
+            <a:r>
+              <a:rPr lang="en-US" sz="1200" b="1" dirty="0">
+                <a:solidFill>
+                  <a:srgbClr val="0284C7"/>
                 </a:solidFill>
                 <a:latin typeface="Segoe UI" pitchFamily="34" charset="0"/>
                 <a:ea typeface="Segoe UI" pitchFamily="34" charset="-122"/>
                 <a:cs typeface="Segoe UI" pitchFamily="34" charset="-120"/>
               </a:rPr>
-              <a:t>2</a:t>
-            </a:r>
-            <a:endParaRPr lang="en-US" sz="975" dirty="0"/>
-          </a:p>
-        </p:txBody>
-      </p:sp>
-      <p:sp>
-        <p:nvSpPr>
-          <p:cNvPr id="23" name="Text 19"/>
-          <p:cNvSpPr/>
-          <p:nvPr/>
-        </p:nvSpPr>
-        <p:spPr>
-          <a:xfrm>
-            <a:off x="6859524" y="3622881"/>
-            <a:ext cx="4448556" cy="196882"/>
-          </a:xfrm>
-          <a:prstGeom prst="rect">
-            <a:avLst/>
-          </a:prstGeom>
-          <a:noFill/>
-          <a:ln/>
-        </p:spPr>
-        <p:txBody>
-          <a:bodyPr wrap="square" lIns="0" tIns="0" rIns="0" bIns="0" rtlCol="0" anchor="t"/>
-          <a:lstStyle/>
-          <a:p>
+              <a:t>Other statuses.  </a:t>
+            </a:r>
             <a:pPr algn="l" indent="0" marL="0">
               <a:lnSpc>
-                <a:spcPct val="115000"/>
+                <a:spcPct val="120000"/>
               </a:lnSpc>
               <a:buNone/>
             </a:pPr>
             <a:r>
-              <a:rPr lang="en-US" sz="1125" dirty="0">
-                <a:solidFill>
-                  <a:srgbClr val="334155"/>
+              <a:rPr lang="en-US" sz="1200" dirty="0">
+                <a:solidFill>
+                  <a:srgbClr val="64748B"/>
                 </a:solidFill>
                 <a:latin typeface="Segoe UI" pitchFamily="34" charset="0"/>
                 <a:ea typeface="Segoe UI" pitchFamily="34" charset="-122"/>
                 <a:cs typeface="Segoe UI" pitchFamily="34" charset="-120"/>
               </a:rPr>
-              <a:t>Drop the map table if it was created.</a:t>
-            </a:r>
-            <a:endParaRPr lang="en-US" sz="1125" dirty="0"/>
-          </a:p>
-        </p:txBody>
-      </p:sp>
-      <p:sp>
-        <p:nvSpPr>
-          <p:cNvPr id="24" name="Text 20"/>
-          <p:cNvSpPr/>
-          <p:nvPr/>
-        </p:nvSpPr>
-        <p:spPr>
-          <a:xfrm>
-            <a:off x="6521196" y="3929491"/>
-            <a:ext cx="228600" cy="228600"/>
-          </a:xfrm>
-          <a:prstGeom prst="ellipse">
-            <a:avLst/>
-          </a:prstGeom>
-          <a:solidFill>
-            <a:srgbClr val="FEE2E2"/>
-          </a:solidFill>
-          <a:ln>
-            <a:solidFill>
-              <a:srgbClr val="FEE2E2"/>
-            </a:solidFill>
-          </a:ln>
-        </p:spPr>
-        <p:txBody>
-          <a:bodyPr wrap="square" lIns="0" tIns="0" rIns="0" bIns="0" rtlCol="0" anchor="ctr"/>
-          <a:lstStyle/>
-          <a:p>
-            <a:pPr algn="ctr" indent="0" marL="0">
-              <a:buNone/>
-            </a:pPr>
-            <a:r>
-              <a:rPr lang="en-US" sz="975" b="1" dirty="0">
-                <a:solidFill>
-                  <a:srgbClr val="B91C1C"/>
-                </a:solidFill>
-                <a:latin typeface="Segoe UI" pitchFamily="34" charset="0"/>
-                <a:ea typeface="Segoe UI" pitchFamily="34" charset="-122"/>
-                <a:cs typeface="Segoe UI" pitchFamily="34" charset="-120"/>
-              </a:rPr>
-              <a:t>3</a:t>
-            </a:r>
-            <a:endParaRPr lang="en-US" sz="975" dirty="0"/>
-          </a:p>
-        </p:txBody>
-      </p:sp>
-      <p:sp>
-        <p:nvSpPr>
-          <p:cNvPr id="25" name="Text 21"/>
-          <p:cNvSpPr/>
-          <p:nvPr/>
-        </p:nvSpPr>
-        <p:spPr>
-          <a:xfrm>
-            <a:off x="6859524" y="3956923"/>
-            <a:ext cx="4448556" cy="196882"/>
-          </a:xfrm>
-          <a:prstGeom prst="rect">
-            <a:avLst/>
-          </a:prstGeom>
-          <a:noFill/>
-          <a:ln/>
-        </p:spPr>
-        <p:txBody>
-          <a:bodyPr wrap="square" lIns="0" tIns="0" rIns="0" bIns="0" rtlCol="0" anchor="t"/>
-          <a:lstStyle/>
-          <a:p>
-            <a:pPr algn="l" indent="0" marL="0">
-              <a:lnSpc>
-                <a:spcPct val="115000"/>
-              </a:lnSpc>
-              <a:buNone/>
-            </a:pPr>
-            <a:r>
-              <a:rPr lang="en-US" sz="1125" dirty="0">
-                <a:solidFill>
-                  <a:srgbClr val="334155"/>
-                </a:solidFill>
-                <a:latin typeface="Segoe UI" pitchFamily="34" charset="0"/>
-                <a:ea typeface="Segoe UI" pitchFamily="34" charset="-122"/>
-                <a:cs typeface="Segoe UI" pitchFamily="34" charset="-120"/>
-              </a:rPr>
-              <a:t>No conversion of historical requests.</a:t>
-            </a:r>
-            <a:endParaRPr lang="en-US" sz="1125" dirty="0"/>
+              <a:t>SEND_OUT, RELABEL and FAILURE do not print or call PHLC. A late worksheet does not change a status already returned. Print failure is an ALS warning.</a:t>
+            </a:r>
+            <a:endParaRPr lang="en-US" sz="1200" dirty="0"/>
           </a:p>
         </p:txBody>
       </p:sp>
@@ -11992,6 +11588,998 @@
 <file path=ppt/slides/slide18.xml><?xml version="1.0" encoding="utf-8"?>
 <p:sld xmlns:a="http://schemas.openxmlformats.org/drawingml/2006/main" xmlns:r="http://schemas.openxmlformats.org/officeDocument/2006/relationships" xmlns:p="http://schemas.openxmlformats.org/presentationml/2006/main">
   <p:cSld name="Slide 18">
+    <p:bg>
+      <p:bgPr>
+        <a:solidFill>
+          <a:srgbClr val="F8FAFC"/>
+        </a:solidFill>
+      </p:bgPr>
+    </p:bg>
+    <p:spTree>
+      <p:nvGrpSpPr>
+        <p:cNvPr id="1" name=""/>
+        <p:cNvGrpSpPr/>
+        <p:nvPr/>
+      </p:nvGrpSpPr>
+      <p:grpSpPr>
+        <a:xfrm>
+          <a:off x="0" y="0"/>
+          <a:ext cx="0" cy="0"/>
+          <a:chOff x="0" y="0"/>
+          <a:chExt cx="0" cy="0"/>
+        </a:xfrm>
+      </p:grpSpPr>
+      <p:sp>
+        <p:nvSpPr>
+          <p:cNvPr id="2" name="Text 0"/>
+          <p:cNvSpPr/>
+          <p:nvPr/>
+        </p:nvSpPr>
+        <p:spPr>
+          <a:xfrm>
+            <a:off x="609600" y="457200"/>
+            <a:ext cx="10972800" cy="228600"/>
+          </a:xfrm>
+          <a:prstGeom prst="rect">
+            <a:avLst/>
+          </a:prstGeom>
+          <a:noFill/>
+          <a:ln/>
+        </p:spPr>
+        <p:txBody>
+          <a:bodyPr wrap="square" lIns="0" tIns="0" rIns="0" bIns="0" rtlCol="0" anchor="ctr"/>
+          <a:lstStyle/>
+          <a:p>
+            <a:pPr indent="0" marL="0">
+              <a:buNone/>
+            </a:pPr>
+            <a:r>
+              <a:rPr lang="en-US" sz="1050" spc="150" kern="0" dirty="0">
+                <a:solidFill>
+                  <a:srgbClr val="0284C7"/>
+                </a:solidFill>
+                <a:latin typeface="Segoe UI Semibold" pitchFamily="34" charset="0"/>
+                <a:ea typeface="Segoe UI Semibold" pitchFamily="34" charset="-122"/>
+                <a:cs typeface="Segoe UI Semibold" pitchFamily="34" charset="-120"/>
+              </a:rPr>
+              <a:t>06. PROMOTION AND FALLBACK</a:t>
+            </a:r>
+            <a:endParaRPr lang="en-US" sz="1050" dirty="0"/>
+          </a:p>
+        </p:txBody>
+      </p:sp>
+      <p:sp>
+        <p:nvSpPr>
+          <p:cNvPr id="3" name="Text 1"/>
+          <p:cNvSpPr/>
+          <p:nvPr/>
+        </p:nvSpPr>
+        <p:spPr>
+          <a:xfrm>
+            <a:off x="609600" y="722376"/>
+            <a:ext cx="10972800" cy="457200"/>
+          </a:xfrm>
+          <a:prstGeom prst="rect">
+            <a:avLst/>
+          </a:prstGeom>
+          <a:noFill/>
+          <a:ln/>
+        </p:spPr>
+        <p:txBody>
+          <a:bodyPr wrap="square" lIns="0" tIns="0" rIns="0" bIns="0" rtlCol="0" anchor="ctr"/>
+          <a:lstStyle/>
+          <a:p>
+            <a:pPr indent="0" marL="0">
+              <a:buNone/>
+            </a:pPr>
+            <a:r>
+              <a:rPr lang="en-US" sz="2400" dirty="0">
+                <a:solidFill>
+                  <a:srgbClr val="0F172A"/>
+                </a:solidFill>
+                <a:latin typeface="Segoe UI Semibold" pitchFamily="34" charset="0"/>
+                <a:ea typeface="Segoe UI Semibold" pitchFamily="34" charset="-122"/>
+                <a:cs typeface="Segoe UI Semibold" pitchFamily="34" charset="-120"/>
+              </a:rPr>
+              <a:t>Seed workbench, open the gateway path, pilot CPS and HMS</a:t>
+            </a:r>
+            <a:endParaRPr lang="en-US" sz="2400" dirty="0"/>
+          </a:p>
+        </p:txBody>
+      </p:sp>
+      <p:sp>
+        <p:nvSpPr>
+          <p:cNvPr id="4" name="Shape 2"/>
+          <p:cNvSpPr/>
+          <p:nvPr/>
+        </p:nvSpPr>
+        <p:spPr>
+          <a:xfrm>
+            <a:off x="609600" y="2539032"/>
+            <a:ext cx="5335524" cy="2694337"/>
+          </a:xfrm>
+          <a:prstGeom prst="roundRect">
+            <a:avLst>
+              <a:gd name="adj" fmla="val 4073"/>
+            </a:avLst>
+          </a:prstGeom>
+          <a:solidFill>
+            <a:srgbClr val="FFFFFF"/>
+          </a:solidFill>
+          <a:ln w="9525">
+            <a:solidFill>
+              <a:srgbClr val="E2E8F0"/>
+            </a:solidFill>
+            <a:prstDash val="solid"/>
+          </a:ln>
+        </p:spPr>
+      </p:sp>
+      <p:pic>
+        <p:nvPicPr>
+          <p:cNvPr id="5" name="Image 0" descr="D:\Github\HA-Notes\LIS\skills\design-review-pptx\assets\icons\png\success\cloud-arrow-up.png">    </p:cNvPr>
+          <p:cNvPicPr>
+            <a:picLocks noChangeAspect="1"/>
+          </p:cNvPicPr>
+          <p:nvPr/>
+        </p:nvPicPr>
+        <p:blipFill>
+          <a:blip r:embed="rId1"/>
+          <a:stretch>
+            <a:fillRect/>
+          </a:stretch>
+        </p:blipFill>
+        <p:spPr>
+          <a:xfrm>
+            <a:off x="883920" y="2845356"/>
+            <a:ext cx="265176" cy="265176"/>
+          </a:xfrm>
+          <a:prstGeom prst="rect">
+            <a:avLst/>
+          </a:prstGeom>
+        </p:spPr>
+      </p:pic>
+      <p:sp>
+        <p:nvSpPr>
+          <p:cNvPr id="6" name="Text 3"/>
+          <p:cNvSpPr/>
+          <p:nvPr/>
+        </p:nvSpPr>
+        <p:spPr>
+          <a:xfrm>
+            <a:off x="1249680" y="2831640"/>
+            <a:ext cx="4421124" cy="292608"/>
+          </a:xfrm>
+          <a:prstGeom prst="rect">
+            <a:avLst/>
+          </a:prstGeom>
+          <a:noFill/>
+          <a:ln/>
+        </p:spPr>
+        <p:txBody>
+          <a:bodyPr wrap="square" lIns="0" tIns="0" rIns="0" bIns="0" rtlCol="0" anchor="ctr"/>
+          <a:lstStyle/>
+          <a:p>
+            <a:pPr algn="l" indent="0" marL="0">
+              <a:lnSpc>
+                <a:spcPct val="115000"/>
+              </a:lnSpc>
+              <a:buNone/>
+            </a:pPr>
+            <a:r>
+              <a:rPr lang="en-US" sz="1500" dirty="0">
+                <a:solidFill>
+                  <a:srgbClr val="0F172A"/>
+                </a:solidFill>
+                <a:latin typeface="Segoe UI Semibold" pitchFamily="34" charset="0"/>
+                <a:ea typeface="Segoe UI Semibold" pitchFamily="34" charset="-122"/>
+                <a:cs typeface="Segoe UI Semibold" pitchFamily="34" charset="-120"/>
+              </a:rPr>
+              <a:t>Promotion</a:t>
+            </a:r>
+            <a:endParaRPr lang="en-US" sz="1500" dirty="0"/>
+          </a:p>
+        </p:txBody>
+      </p:sp>
+      <p:sp>
+        <p:nvSpPr>
+          <p:cNvPr id="7" name="Text 4"/>
+          <p:cNvSpPr/>
+          <p:nvPr/>
+        </p:nvSpPr>
+        <p:spPr>
+          <a:xfrm>
+            <a:off x="883920" y="3261408"/>
+            <a:ext cx="228600" cy="228600"/>
+          </a:xfrm>
+          <a:prstGeom prst="ellipse">
+            <a:avLst/>
+          </a:prstGeom>
+          <a:solidFill>
+            <a:srgbClr val="DCFCE7"/>
+          </a:solidFill>
+          <a:ln>
+            <a:solidFill>
+              <a:srgbClr val="DCFCE7"/>
+            </a:solidFill>
+          </a:ln>
+        </p:spPr>
+        <p:txBody>
+          <a:bodyPr wrap="square" lIns="0" tIns="0" rIns="0" bIns="0" rtlCol="0" anchor="ctr"/>
+          <a:lstStyle/>
+          <a:p>
+            <a:pPr algn="ctr" indent="0" marL="0">
+              <a:buNone/>
+            </a:pPr>
+            <a:r>
+              <a:rPr lang="en-US" sz="975" b="1" dirty="0">
+                <a:solidFill>
+                  <a:srgbClr val="15803D"/>
+                </a:solidFill>
+                <a:latin typeface="Segoe UI" pitchFamily="34" charset="0"/>
+                <a:ea typeface="Segoe UI" pitchFamily="34" charset="-122"/>
+                <a:cs typeface="Segoe UI" pitchFamily="34" charset="-120"/>
+              </a:rPr>
+              <a:t>1</a:t>
+            </a:r>
+            <a:endParaRPr lang="en-US" sz="975" dirty="0"/>
+          </a:p>
+        </p:txBody>
+      </p:sp>
+      <p:sp>
+        <p:nvSpPr>
+          <p:cNvPr id="8" name="Text 5"/>
+          <p:cNvSpPr/>
+          <p:nvPr/>
+        </p:nvSpPr>
+        <p:spPr>
+          <a:xfrm>
+            <a:off x="1222248" y="3288840"/>
+            <a:ext cx="4448556" cy="196882"/>
+          </a:xfrm>
+          <a:prstGeom prst="rect">
+            <a:avLst/>
+          </a:prstGeom>
+          <a:noFill/>
+          <a:ln/>
+        </p:spPr>
+        <p:txBody>
+          <a:bodyPr wrap="square" lIns="0" tIns="0" rIns="0" bIns="0" rtlCol="0" anchor="t"/>
+          <a:lstStyle/>
+          <a:p>
+            <a:pPr algn="l" indent="0" marL="0">
+              <a:lnSpc>
+                <a:spcPct val="115000"/>
+              </a:lnSpc>
+              <a:buNone/>
+            </a:pPr>
+            <a:r>
+              <a:rPr lang="en-US" sz="1125" dirty="0">
+                <a:solidFill>
+                  <a:srgbClr val="334155"/>
+                </a:solidFill>
+                <a:latin typeface="Segoe UI" pitchFamily="34" charset="0"/>
+                <a:ea typeface="Segoe UI" pitchFamily="34" charset="-122"/>
+                <a:cs typeface="Segoe UI" pitchFamily="34" charset="-120"/>
+              </a:rPr>
+              <a:t>Seed workbench: station name = sorter id, user = wkbh_id.</a:t>
+            </a:r>
+            <a:endParaRPr lang="en-US" sz="1125" dirty="0"/>
+          </a:p>
+        </p:txBody>
+      </p:sp>
+      <p:sp>
+        <p:nvSpPr>
+          <p:cNvPr id="9" name="Text 6"/>
+          <p:cNvSpPr/>
+          <p:nvPr/>
+        </p:nvSpPr>
+        <p:spPr>
+          <a:xfrm>
+            <a:off x="883920" y="3595449"/>
+            <a:ext cx="228600" cy="228600"/>
+          </a:xfrm>
+          <a:prstGeom prst="ellipse">
+            <a:avLst/>
+          </a:prstGeom>
+          <a:solidFill>
+            <a:srgbClr val="DCFCE7"/>
+          </a:solidFill>
+          <a:ln>
+            <a:solidFill>
+              <a:srgbClr val="DCFCE7"/>
+            </a:solidFill>
+          </a:ln>
+        </p:spPr>
+        <p:txBody>
+          <a:bodyPr wrap="square" lIns="0" tIns="0" rIns="0" bIns="0" rtlCol="0" anchor="ctr"/>
+          <a:lstStyle/>
+          <a:p>
+            <a:pPr algn="ctr" indent="0" marL="0">
+              <a:buNone/>
+            </a:pPr>
+            <a:r>
+              <a:rPr lang="en-US" sz="975" b="1" dirty="0">
+                <a:solidFill>
+                  <a:srgbClr val="15803D"/>
+                </a:solidFill>
+                <a:latin typeface="Segoe UI" pitchFamily="34" charset="0"/>
+                <a:ea typeface="Segoe UI" pitchFamily="34" charset="-122"/>
+                <a:cs typeface="Segoe UI" pitchFamily="34" charset="-120"/>
+              </a:rPr>
+              <a:t>2</a:t>
+            </a:r>
+            <a:endParaRPr lang="en-US" sz="975" dirty="0"/>
+          </a:p>
+        </p:txBody>
+      </p:sp>
+      <p:sp>
+        <p:nvSpPr>
+          <p:cNvPr id="10" name="Text 7"/>
+          <p:cNvSpPr/>
+          <p:nvPr/>
+        </p:nvSpPr>
+        <p:spPr>
+          <a:xfrm>
+            <a:off x="1222248" y="3622881"/>
+            <a:ext cx="4448556" cy="196882"/>
+          </a:xfrm>
+          <a:prstGeom prst="rect">
+            <a:avLst/>
+          </a:prstGeom>
+          <a:noFill/>
+          <a:ln/>
+        </p:spPr>
+        <p:txBody>
+          <a:bodyPr wrap="square" lIns="0" tIns="0" rIns="0" bIns="0" rtlCol="0" anchor="t"/>
+          <a:lstStyle/>
+          <a:p>
+            <a:pPr algn="l" indent="0" marL="0">
+              <a:lnSpc>
+                <a:spcPct val="115000"/>
+              </a:lnSpc>
+              <a:buNone/>
+            </a:pPr>
+            <a:r>
+              <a:rPr lang="en-US" sz="1125" dirty="0">
+                <a:solidFill>
+                  <a:srgbClr val="334155"/>
+                </a:solidFill>
+                <a:latin typeface="Segoe UI" pitchFamily="34" charset="0"/>
+                <a:ea typeface="Segoe UI" pitchFamily="34" charset="-122"/>
+                <a:cs typeface="Segoe UI" pitchFamily="34" charset="-120"/>
+              </a:rPr>
+              <a:t>Map row only if hospital can be omitted.</a:t>
+            </a:r>
+            <a:endParaRPr lang="en-US" sz="1125" dirty="0"/>
+          </a:p>
+        </p:txBody>
+      </p:sp>
+      <p:sp>
+        <p:nvSpPr>
+          <p:cNvPr id="11" name="Text 8"/>
+          <p:cNvSpPr/>
+          <p:nvPr/>
+        </p:nvSpPr>
+        <p:spPr>
+          <a:xfrm>
+            <a:off x="883920" y="3929491"/>
+            <a:ext cx="228600" cy="228600"/>
+          </a:xfrm>
+          <a:prstGeom prst="ellipse">
+            <a:avLst/>
+          </a:prstGeom>
+          <a:solidFill>
+            <a:srgbClr val="DCFCE7"/>
+          </a:solidFill>
+          <a:ln>
+            <a:solidFill>
+              <a:srgbClr val="DCFCE7"/>
+            </a:solidFill>
+          </a:ln>
+        </p:spPr>
+        <p:txBody>
+          <a:bodyPr wrap="square" lIns="0" tIns="0" rIns="0" bIns="0" rtlCol="0" anchor="ctr"/>
+          <a:lstStyle/>
+          <a:p>
+            <a:pPr algn="ctr" indent="0" marL="0">
+              <a:buNone/>
+            </a:pPr>
+            <a:r>
+              <a:rPr lang="en-US" sz="975" b="1" dirty="0">
+                <a:solidFill>
+                  <a:srgbClr val="15803D"/>
+                </a:solidFill>
+                <a:latin typeface="Segoe UI" pitchFamily="34" charset="0"/>
+                <a:ea typeface="Segoe UI" pitchFamily="34" charset="-122"/>
+                <a:cs typeface="Segoe UI" pitchFamily="34" charset="-120"/>
+              </a:rPr>
+              <a:t>3</a:t>
+            </a:r>
+            <a:endParaRPr lang="en-US" sz="975" dirty="0"/>
+          </a:p>
+        </p:txBody>
+      </p:sp>
+      <p:sp>
+        <p:nvSpPr>
+          <p:cNvPr id="12" name="Text 9"/>
+          <p:cNvSpPr/>
+          <p:nvPr/>
+        </p:nvSpPr>
+        <p:spPr>
+          <a:xfrm>
+            <a:off x="1222248" y="3956923"/>
+            <a:ext cx="4448556" cy="196882"/>
+          </a:xfrm>
+          <a:prstGeom prst="rect">
+            <a:avLst/>
+          </a:prstGeom>
+          <a:noFill/>
+          <a:ln/>
+        </p:spPr>
+        <p:txBody>
+          <a:bodyPr wrap="square" lIns="0" tIns="0" rIns="0" bIns="0" rtlCol="0" anchor="t"/>
+          <a:lstStyle/>
+          <a:p>
+            <a:pPr algn="l" indent="0" marL="0">
+              <a:lnSpc>
+                <a:spcPct val="115000"/>
+              </a:lnSpc>
+              <a:buNone/>
+            </a:pPr>
+            <a:r>
+              <a:rPr lang="en-US" sz="1125" dirty="0">
+                <a:solidFill>
+                  <a:srgbClr val="334155"/>
+                </a:solidFill>
+                <a:latin typeface="Segoe UI" pitchFamily="34" charset="0"/>
+                <a:ea typeface="Segoe UI" pitchFamily="34" charset="-122"/>
+                <a:cs typeface="Segoe UI" pitchFamily="34" charset="-120"/>
+              </a:rPr>
+              <a:t>Deploy lis-crs-spec-ack-svc.</a:t>
+            </a:r>
+            <a:endParaRPr lang="en-US" sz="1125" dirty="0"/>
+          </a:p>
+        </p:txBody>
+      </p:sp>
+      <p:sp>
+        <p:nvSpPr>
+          <p:cNvPr id="13" name="Text 10"/>
+          <p:cNvSpPr/>
+          <p:nvPr/>
+        </p:nvSpPr>
+        <p:spPr>
+          <a:xfrm>
+            <a:off x="883920" y="4263533"/>
+            <a:ext cx="228600" cy="228600"/>
+          </a:xfrm>
+          <a:prstGeom prst="ellipse">
+            <a:avLst/>
+          </a:prstGeom>
+          <a:solidFill>
+            <a:srgbClr val="DCFCE7"/>
+          </a:solidFill>
+          <a:ln>
+            <a:solidFill>
+              <a:srgbClr val="DCFCE7"/>
+            </a:solidFill>
+          </a:ln>
+        </p:spPr>
+        <p:txBody>
+          <a:bodyPr wrap="square" lIns="0" tIns="0" rIns="0" bIns="0" rtlCol="0" anchor="ctr"/>
+          <a:lstStyle/>
+          <a:p>
+            <a:pPr algn="ctr" indent="0" marL="0">
+              <a:buNone/>
+            </a:pPr>
+            <a:r>
+              <a:rPr lang="en-US" sz="975" b="1" dirty="0">
+                <a:solidFill>
+                  <a:srgbClr val="15803D"/>
+                </a:solidFill>
+                <a:latin typeface="Segoe UI" pitchFamily="34" charset="0"/>
+                <a:ea typeface="Segoe UI" pitchFamily="34" charset="-122"/>
+                <a:cs typeface="Segoe UI" pitchFamily="34" charset="-120"/>
+              </a:rPr>
+              <a:t>4</a:t>
+            </a:r>
+            <a:endParaRPr lang="en-US" sz="975" dirty="0"/>
+          </a:p>
+        </p:txBody>
+      </p:sp>
+      <p:sp>
+        <p:nvSpPr>
+          <p:cNvPr id="14" name="Text 11"/>
+          <p:cNvSpPr/>
+          <p:nvPr/>
+        </p:nvSpPr>
+        <p:spPr>
+          <a:xfrm>
+            <a:off x="1222248" y="4290965"/>
+            <a:ext cx="4448556" cy="196882"/>
+          </a:xfrm>
+          <a:prstGeom prst="rect">
+            <a:avLst/>
+          </a:prstGeom>
+          <a:noFill/>
+          <a:ln/>
+        </p:spPr>
+        <p:txBody>
+          <a:bodyPr wrap="square" lIns="0" tIns="0" rIns="0" bIns="0" rtlCol="0" anchor="t"/>
+          <a:lstStyle/>
+          <a:p>
+            <a:pPr algn="l" indent="0" marL="0">
+              <a:lnSpc>
+                <a:spcPct val="115000"/>
+              </a:lnSpc>
+              <a:buNone/>
+            </a:pPr>
+            <a:r>
+              <a:rPr lang="en-US" sz="1125" dirty="0">
+                <a:solidFill>
+                  <a:srgbClr val="334155"/>
+                </a:solidFill>
+                <a:latin typeface="Segoe UI" pitchFamily="34" charset="0"/>
+                <a:ea typeface="Segoe UI" pitchFamily="34" charset="-122"/>
+                <a:cs typeface="Segoe UI" pitchFamily="34" charset="-120"/>
+              </a:rPr>
+              <a:t>Publish the APIM product and NetworkPolicy.</a:t>
+            </a:r>
+            <a:endParaRPr lang="en-US" sz="1125" dirty="0"/>
+          </a:p>
+        </p:txBody>
+      </p:sp>
+      <p:sp>
+        <p:nvSpPr>
+          <p:cNvPr id="15" name="Text 12"/>
+          <p:cNvSpPr/>
+          <p:nvPr/>
+        </p:nvSpPr>
+        <p:spPr>
+          <a:xfrm>
+            <a:off x="883920" y="4597575"/>
+            <a:ext cx="228600" cy="228600"/>
+          </a:xfrm>
+          <a:prstGeom prst="ellipse">
+            <a:avLst/>
+          </a:prstGeom>
+          <a:solidFill>
+            <a:srgbClr val="DCFCE7"/>
+          </a:solidFill>
+          <a:ln>
+            <a:solidFill>
+              <a:srgbClr val="DCFCE7"/>
+            </a:solidFill>
+          </a:ln>
+        </p:spPr>
+        <p:txBody>
+          <a:bodyPr wrap="square" lIns="0" tIns="0" rIns="0" bIns="0" rtlCol="0" anchor="ctr"/>
+          <a:lstStyle/>
+          <a:p>
+            <a:pPr algn="ctr" indent="0" marL="0">
+              <a:buNone/>
+            </a:pPr>
+            <a:r>
+              <a:rPr lang="en-US" sz="975" b="1" dirty="0">
+                <a:solidFill>
+                  <a:srgbClr val="15803D"/>
+                </a:solidFill>
+                <a:latin typeface="Segoe UI" pitchFamily="34" charset="0"/>
+                <a:ea typeface="Segoe UI" pitchFamily="34" charset="-122"/>
+                <a:cs typeface="Segoe UI" pitchFamily="34" charset="-120"/>
+              </a:rPr>
+              <a:t>5</a:t>
+            </a:r>
+            <a:endParaRPr lang="en-US" sz="975" dirty="0"/>
+          </a:p>
+        </p:txBody>
+      </p:sp>
+      <p:sp>
+        <p:nvSpPr>
+          <p:cNvPr id="16" name="Text 13"/>
+          <p:cNvSpPr/>
+          <p:nvPr/>
+        </p:nvSpPr>
+        <p:spPr>
+          <a:xfrm>
+            <a:off x="1222248" y="4625007"/>
+            <a:ext cx="4448556" cy="196882"/>
+          </a:xfrm>
+          <a:prstGeom prst="rect">
+            <a:avLst/>
+          </a:prstGeom>
+          <a:noFill/>
+          <a:ln/>
+        </p:spPr>
+        <p:txBody>
+          <a:bodyPr wrap="square" lIns="0" tIns="0" rIns="0" bIns="0" rtlCol="0" anchor="t"/>
+          <a:lstStyle/>
+          <a:p>
+            <a:pPr algn="l" indent="0" marL="0">
+              <a:lnSpc>
+                <a:spcPct val="115000"/>
+              </a:lnSpc>
+              <a:buNone/>
+            </a:pPr>
+            <a:r>
+              <a:rPr lang="en-US" sz="1125" dirty="0">
+                <a:solidFill>
+                  <a:srgbClr val="334155"/>
+                </a:solidFill>
+                <a:latin typeface="Segoe UI" pitchFamily="34" charset="0"/>
+                <a:ea typeface="Segoe UI" pitchFamily="34" charset="-122"/>
+                <a:cs typeface="Segoe UI" pitchFamily="34" charset="-120"/>
+              </a:rPr>
+              <a:t>Pilot CPS and HMS.</a:t>
+            </a:r>
+            <a:endParaRPr lang="en-US" sz="1125" dirty="0"/>
+          </a:p>
+        </p:txBody>
+      </p:sp>
+      <p:sp>
+        <p:nvSpPr>
+          <p:cNvPr id="17" name="Shape 14"/>
+          <p:cNvSpPr/>
+          <p:nvPr/>
+        </p:nvSpPr>
+        <p:spPr>
+          <a:xfrm>
+            <a:off x="6246876" y="2539032"/>
+            <a:ext cx="5335524" cy="2694337"/>
+          </a:xfrm>
+          <a:prstGeom prst="roundRect">
+            <a:avLst>
+              <a:gd name="adj" fmla="val 4073"/>
+            </a:avLst>
+          </a:prstGeom>
+          <a:solidFill>
+            <a:srgbClr val="FFFFFF"/>
+          </a:solidFill>
+          <a:ln w="9525">
+            <a:solidFill>
+              <a:srgbClr val="E2E8F0"/>
+            </a:solidFill>
+            <a:prstDash val="solid"/>
+          </a:ln>
+        </p:spPr>
+      </p:sp>
+      <p:pic>
+        <p:nvPicPr>
+          <p:cNvPr id="18" name="Image 1" descr="D:\Github\HA-Notes\LIS\skills\design-review-pptx\assets\icons\png\danger\rotate-left.png">    </p:cNvPr>
+          <p:cNvPicPr>
+            <a:picLocks noChangeAspect="1"/>
+          </p:cNvPicPr>
+          <p:nvPr/>
+        </p:nvPicPr>
+        <p:blipFill>
+          <a:blip r:embed="rId2"/>
+          <a:stretch>
+            <a:fillRect/>
+          </a:stretch>
+        </p:blipFill>
+        <p:spPr>
+          <a:xfrm>
+            <a:off x="6521196" y="2845356"/>
+            <a:ext cx="265176" cy="265176"/>
+          </a:xfrm>
+          <a:prstGeom prst="rect">
+            <a:avLst/>
+          </a:prstGeom>
+        </p:spPr>
+      </p:pic>
+      <p:sp>
+        <p:nvSpPr>
+          <p:cNvPr id="19" name="Text 15"/>
+          <p:cNvSpPr/>
+          <p:nvPr/>
+        </p:nvSpPr>
+        <p:spPr>
+          <a:xfrm>
+            <a:off x="6886956" y="2831640"/>
+            <a:ext cx="4421124" cy="292608"/>
+          </a:xfrm>
+          <a:prstGeom prst="rect">
+            <a:avLst/>
+          </a:prstGeom>
+          <a:noFill/>
+          <a:ln/>
+        </p:spPr>
+        <p:txBody>
+          <a:bodyPr wrap="square" lIns="0" tIns="0" rIns="0" bIns="0" rtlCol="0" anchor="ctr"/>
+          <a:lstStyle/>
+          <a:p>
+            <a:pPr algn="l" indent="0" marL="0">
+              <a:lnSpc>
+                <a:spcPct val="115000"/>
+              </a:lnSpc>
+              <a:buNone/>
+            </a:pPr>
+            <a:r>
+              <a:rPr lang="en-US" sz="1500" dirty="0">
+                <a:solidFill>
+                  <a:srgbClr val="0F172A"/>
+                </a:solidFill>
+                <a:latin typeface="Segoe UI Semibold" pitchFamily="34" charset="0"/>
+                <a:ea typeface="Segoe UI Semibold" pitchFamily="34" charset="-122"/>
+                <a:cs typeface="Segoe UI Semibold" pitchFamily="34" charset="-120"/>
+              </a:rPr>
+              <a:t>Fallback</a:t>
+            </a:r>
+            <a:endParaRPr lang="en-US" sz="1500" dirty="0"/>
+          </a:p>
+        </p:txBody>
+      </p:sp>
+      <p:sp>
+        <p:nvSpPr>
+          <p:cNvPr id="20" name="Text 16"/>
+          <p:cNvSpPr/>
+          <p:nvPr/>
+        </p:nvSpPr>
+        <p:spPr>
+          <a:xfrm>
+            <a:off x="6521196" y="3261408"/>
+            <a:ext cx="228600" cy="228600"/>
+          </a:xfrm>
+          <a:prstGeom prst="ellipse">
+            <a:avLst/>
+          </a:prstGeom>
+          <a:solidFill>
+            <a:srgbClr val="FEE2E2"/>
+          </a:solidFill>
+          <a:ln>
+            <a:solidFill>
+              <a:srgbClr val="FEE2E2"/>
+            </a:solidFill>
+          </a:ln>
+        </p:spPr>
+        <p:txBody>
+          <a:bodyPr wrap="square" lIns="0" tIns="0" rIns="0" bIns="0" rtlCol="0" anchor="ctr"/>
+          <a:lstStyle/>
+          <a:p>
+            <a:pPr algn="ctr" indent="0" marL="0">
+              <a:buNone/>
+            </a:pPr>
+            <a:r>
+              <a:rPr lang="en-US" sz="975" b="1" dirty="0">
+                <a:solidFill>
+                  <a:srgbClr val="B91C1C"/>
+                </a:solidFill>
+                <a:latin typeface="Segoe UI" pitchFamily="34" charset="0"/>
+                <a:ea typeface="Segoe UI" pitchFamily="34" charset="-122"/>
+                <a:cs typeface="Segoe UI" pitchFamily="34" charset="-120"/>
+              </a:rPr>
+              <a:t>1</a:t>
+            </a:r>
+            <a:endParaRPr lang="en-US" sz="975" dirty="0"/>
+          </a:p>
+        </p:txBody>
+      </p:sp>
+      <p:sp>
+        <p:nvSpPr>
+          <p:cNvPr id="21" name="Text 17"/>
+          <p:cNvSpPr/>
+          <p:nvPr/>
+        </p:nvSpPr>
+        <p:spPr>
+          <a:xfrm>
+            <a:off x="6859524" y="3288840"/>
+            <a:ext cx="4448556" cy="196882"/>
+          </a:xfrm>
+          <a:prstGeom prst="rect">
+            <a:avLst/>
+          </a:prstGeom>
+          <a:noFill/>
+          <a:ln/>
+        </p:spPr>
+        <p:txBody>
+          <a:bodyPr wrap="square" lIns="0" tIns="0" rIns="0" bIns="0" rtlCol="0" anchor="t"/>
+          <a:lstStyle/>
+          <a:p>
+            <a:pPr algn="l" indent="0" marL="0">
+              <a:lnSpc>
+                <a:spcPct val="115000"/>
+              </a:lnSpc>
+              <a:buNone/>
+            </a:pPr>
+            <a:r>
+              <a:rPr lang="en-US" sz="1125" dirty="0">
+                <a:solidFill>
+                  <a:srgbClr val="334155"/>
+                </a:solidFill>
+                <a:latin typeface="Segoe UI" pitchFamily="34" charset="0"/>
+                <a:ea typeface="Segoe UI" pitchFamily="34" charset="-122"/>
+                <a:cs typeface="Segoe UI" pitchFamily="34" charset="-120"/>
+              </a:rPr>
+              <a:t>Stop the middleware. Staff Spec Ack is unchanged.</a:t>
+            </a:r>
+            <a:endParaRPr lang="en-US" sz="1125" dirty="0"/>
+          </a:p>
+        </p:txBody>
+      </p:sp>
+      <p:sp>
+        <p:nvSpPr>
+          <p:cNvPr id="22" name="Text 18"/>
+          <p:cNvSpPr/>
+          <p:nvPr/>
+        </p:nvSpPr>
+        <p:spPr>
+          <a:xfrm>
+            <a:off x="6521196" y="3595449"/>
+            <a:ext cx="228600" cy="228600"/>
+          </a:xfrm>
+          <a:prstGeom prst="ellipse">
+            <a:avLst/>
+          </a:prstGeom>
+          <a:solidFill>
+            <a:srgbClr val="FEE2E2"/>
+          </a:solidFill>
+          <a:ln>
+            <a:solidFill>
+              <a:srgbClr val="FEE2E2"/>
+            </a:solidFill>
+          </a:ln>
+        </p:spPr>
+        <p:txBody>
+          <a:bodyPr wrap="square" lIns="0" tIns="0" rIns="0" bIns="0" rtlCol="0" anchor="ctr"/>
+          <a:lstStyle/>
+          <a:p>
+            <a:pPr algn="ctr" indent="0" marL="0">
+              <a:buNone/>
+            </a:pPr>
+            <a:r>
+              <a:rPr lang="en-US" sz="975" b="1" dirty="0">
+                <a:solidFill>
+                  <a:srgbClr val="B91C1C"/>
+                </a:solidFill>
+                <a:latin typeface="Segoe UI" pitchFamily="34" charset="0"/>
+                <a:ea typeface="Segoe UI" pitchFamily="34" charset="-122"/>
+                <a:cs typeface="Segoe UI" pitchFamily="34" charset="-120"/>
+              </a:rPr>
+              <a:t>2</a:t>
+            </a:r>
+            <a:endParaRPr lang="en-US" sz="975" dirty="0"/>
+          </a:p>
+        </p:txBody>
+      </p:sp>
+      <p:sp>
+        <p:nvSpPr>
+          <p:cNvPr id="23" name="Text 19"/>
+          <p:cNvSpPr/>
+          <p:nvPr/>
+        </p:nvSpPr>
+        <p:spPr>
+          <a:xfrm>
+            <a:off x="6859524" y="3622881"/>
+            <a:ext cx="4448556" cy="196882"/>
+          </a:xfrm>
+          <a:prstGeom prst="rect">
+            <a:avLst/>
+          </a:prstGeom>
+          <a:noFill/>
+          <a:ln/>
+        </p:spPr>
+        <p:txBody>
+          <a:bodyPr wrap="square" lIns="0" tIns="0" rIns="0" bIns="0" rtlCol="0" anchor="t"/>
+          <a:lstStyle/>
+          <a:p>
+            <a:pPr algn="l" indent="0" marL="0">
+              <a:lnSpc>
+                <a:spcPct val="115000"/>
+              </a:lnSpc>
+              <a:buNone/>
+            </a:pPr>
+            <a:r>
+              <a:rPr lang="en-US" sz="1125" dirty="0">
+                <a:solidFill>
+                  <a:srgbClr val="334155"/>
+                </a:solidFill>
+                <a:latin typeface="Segoe UI" pitchFamily="34" charset="0"/>
+                <a:ea typeface="Segoe UI" pitchFamily="34" charset="-122"/>
+                <a:cs typeface="Segoe UI" pitchFamily="34" charset="-120"/>
+              </a:rPr>
+              <a:t>Drop the map table if it was created.</a:t>
+            </a:r>
+            <a:endParaRPr lang="en-US" sz="1125" dirty="0"/>
+          </a:p>
+        </p:txBody>
+      </p:sp>
+      <p:sp>
+        <p:nvSpPr>
+          <p:cNvPr id="24" name="Text 20"/>
+          <p:cNvSpPr/>
+          <p:nvPr/>
+        </p:nvSpPr>
+        <p:spPr>
+          <a:xfrm>
+            <a:off x="6521196" y="3929491"/>
+            <a:ext cx="228600" cy="228600"/>
+          </a:xfrm>
+          <a:prstGeom prst="ellipse">
+            <a:avLst/>
+          </a:prstGeom>
+          <a:solidFill>
+            <a:srgbClr val="FEE2E2"/>
+          </a:solidFill>
+          <a:ln>
+            <a:solidFill>
+              <a:srgbClr val="FEE2E2"/>
+            </a:solidFill>
+          </a:ln>
+        </p:spPr>
+        <p:txBody>
+          <a:bodyPr wrap="square" lIns="0" tIns="0" rIns="0" bIns="0" rtlCol="0" anchor="ctr"/>
+          <a:lstStyle/>
+          <a:p>
+            <a:pPr algn="ctr" indent="0" marL="0">
+              <a:buNone/>
+            </a:pPr>
+            <a:r>
+              <a:rPr lang="en-US" sz="975" b="1" dirty="0">
+                <a:solidFill>
+                  <a:srgbClr val="B91C1C"/>
+                </a:solidFill>
+                <a:latin typeface="Segoe UI" pitchFamily="34" charset="0"/>
+                <a:ea typeface="Segoe UI" pitchFamily="34" charset="-122"/>
+                <a:cs typeface="Segoe UI" pitchFamily="34" charset="-120"/>
+              </a:rPr>
+              <a:t>3</a:t>
+            </a:r>
+            <a:endParaRPr lang="en-US" sz="975" dirty="0"/>
+          </a:p>
+        </p:txBody>
+      </p:sp>
+      <p:sp>
+        <p:nvSpPr>
+          <p:cNvPr id="25" name="Text 21"/>
+          <p:cNvSpPr/>
+          <p:nvPr/>
+        </p:nvSpPr>
+        <p:spPr>
+          <a:xfrm>
+            <a:off x="6859524" y="3956923"/>
+            <a:ext cx="4448556" cy="196882"/>
+          </a:xfrm>
+          <a:prstGeom prst="rect">
+            <a:avLst/>
+          </a:prstGeom>
+          <a:noFill/>
+          <a:ln/>
+        </p:spPr>
+        <p:txBody>
+          <a:bodyPr wrap="square" lIns="0" tIns="0" rIns="0" bIns="0" rtlCol="0" anchor="t"/>
+          <a:lstStyle/>
+          <a:p>
+            <a:pPr algn="l" indent="0" marL="0">
+              <a:lnSpc>
+                <a:spcPct val="115000"/>
+              </a:lnSpc>
+              <a:buNone/>
+            </a:pPr>
+            <a:r>
+              <a:rPr lang="en-US" sz="1125" dirty="0">
+                <a:solidFill>
+                  <a:srgbClr val="334155"/>
+                </a:solidFill>
+                <a:latin typeface="Segoe UI" pitchFamily="34" charset="0"/>
+                <a:ea typeface="Segoe UI" pitchFamily="34" charset="-122"/>
+                <a:cs typeface="Segoe UI" pitchFamily="34" charset="-120"/>
+              </a:rPr>
+              <a:t>No conversion of historical requests.</a:t>
+            </a:r>
+            <a:endParaRPr lang="en-US" sz="1125" dirty="0"/>
+          </a:p>
+        </p:txBody>
+      </p:sp>
+    </p:spTree>
+  </p:cSld>
+  <p:clrMapOvr>
+    <a:masterClrMapping/>
+  </p:clrMapOvr>
+</p:sld>
+</file>
+
+<file path=ppt/slides/slide19.xml><?xml version="1.0" encoding="utf-8"?>
+<p:sld xmlns:a="http://schemas.openxmlformats.org/drawingml/2006/main" xmlns:r="http://schemas.openxmlformats.org/officeDocument/2006/relationships" xmlns:p="http://schemas.openxmlformats.org/presentationml/2006/main">
+  <p:cSld name="Slide 19">
     <p:bg>
       <p:bgPr>
         <a:solidFill>

</xml_diff>

<commit_message>
vault backup: 2026-09-22 16:08:16
</commit_message>
<xml_diff>
--- a/SDLC/Projects/TMP-specimen-sorter-api — Specimen Sorter API/assets/Specimen Sorter API v3.pptx
+++ b/SDLC/Projects/TMP-specimen-sorter-api — Specimen Sorter API/assets/Specimen Sorter API v3.pptx
@@ -1136,7 +1136,7 @@
           <a:p>
             <a:r>
               <a:rPr lang="en-US" dirty="0"/>
-              <a:t>SORT_* plus today's REG and SEND_OUT sit on LOE_AUDIT_TRAIL. Confirm the Audit Trail filter shows SORT_* before the pilot.</a:t>
+              <a:t>SORT_* plus today's REG and SEND_OUT sit on LOE_AUDIT_TRAIL. Print and PHLC fail are extra rows, not a fifth status.</a:t>
             </a:r>
             <a:endParaRPr lang="en-US" dirty="0"/>
           </a:p>
@@ -1224,7 +1224,7 @@
           <a:p>
             <a:r>
               <a:rPr lang="en-US" dirty="0"/>
-              <a:t>Print sits outside the response. A late worksheet does not change a status already returned.</a:t>
+              <a:t>Print sits outside the response. A late or failed worksheet does not change a status already returned.</a:t>
             </a:r>
             <a:endParaRPr lang="en-US" dirty="0"/>
           </a:p>
@@ -1312,7 +1312,7 @@
           <a:p>
             <a:r>
               <a:rPr lang="en-US" dirty="0"/>
-              <a:t>Confirm the Audit Trail filter shows SORT_* before the pilot, or staff cannot find the sorter's attempts.</a:t>
+              <a:t>Confirm the Audit Trail filter shows SORT_* including SORT_WS_FAIL and SORT_PHLC_FAIL, or staff cannot find a print or PHLC fail.</a:t>
             </a:r>
             <a:endParaRPr lang="en-US" dirty="0"/>
           </a:p>
@@ -11196,12 +11196,12 @@
         </p:nvSpPr>
         <p:spPr>
           <a:xfrm>
-            <a:off x="609600" y="2586514"/>
-            <a:ext cx="5335524" cy="2050732"/>
+            <a:off x="609600" y="2693670"/>
+            <a:ext cx="5335524" cy="1836420"/>
           </a:xfrm>
           <a:prstGeom prst="roundRect">
             <a:avLst>
-              <a:gd name="adj" fmla="val 5351"/>
+              <a:gd name="adj" fmla="val 5975"/>
             </a:avLst>
           </a:prstGeom>
           <a:solidFill>
@@ -11231,7 +11231,7 @@
         </p:blipFill>
         <p:spPr>
           <a:xfrm>
-            <a:off x="883920" y="2906554"/>
+            <a:off x="883920" y="3013710"/>
             <a:ext cx="265176" cy="265176"/>
           </a:xfrm>
           <a:prstGeom prst="rect">
@@ -11247,7 +11247,7 @@
         </p:nvSpPr>
         <p:spPr>
           <a:xfrm>
-            <a:off x="883920" y="3363754"/>
+            <a:off x="883920" y="3470910"/>
             <a:ext cx="4786884" cy="219075"/>
           </a:xfrm>
           <a:prstGeom prst="rect">
@@ -11289,8 +11289,8 @@
         </p:nvSpPr>
         <p:spPr>
           <a:xfrm>
-            <a:off x="883920" y="3674269"/>
-            <a:ext cx="4786884" cy="798385"/>
+            <a:off x="883920" y="3781425"/>
+            <a:ext cx="4786884" cy="584073"/>
           </a:xfrm>
           <a:prstGeom prst="rect">
             <a:avLst/>
@@ -11317,7 +11317,7 @@
                 <a:ea typeface="Segoe UI" pitchFamily="34" charset="-122"/>
                 <a:cs typeface="Segoe UI" pitchFamily="34" charset="-120"/>
               </a:rPr>
-              <a:t>• All worksheets after return</a:t>
+              <a:t>• REGISTERED only, after return</a:t>
             </a:r>
             <a:endParaRPr lang="en-US" sz="1350" dirty="0"/>
           </a:p>
@@ -11337,30 +11337,10 @@
                 <a:ea typeface="Segoe UI" pitchFamily="34" charset="-122"/>
                 <a:cs typeface="Segoe UI" pitchFamily="34" charset="-120"/>
               </a:rPr>
-              <a:t>• Worksheet, send-out and SH Ro</a:t>
+              <a:t>• Fail writes SORT_WS_FAIL</a:t>
             </a:r>
             <a:endParaRPr lang="en-US" sz="1350" dirty="0"/>
           </a:p>
-          <a:p>
-            <a:pPr algn="l" indent="0" marL="0">
-              <a:lnSpc>
-                <a:spcPct val="120000"/>
-              </a:lnSpc>
-              <a:buNone/>
-            </a:pPr>
-            <a:r>
-              <a:rPr lang="en-US" sz="1350" dirty="0">
-                <a:solidFill>
-                  <a:srgbClr val="475569"/>
-                </a:solidFill>
-                <a:latin typeface="Segoe UI" pitchFamily="34" charset="0"/>
-                <a:ea typeface="Segoe UI" pitchFamily="34" charset="-122"/>
-                <a:cs typeface="Segoe UI" pitchFamily="34" charset="-120"/>
-              </a:rPr>
-              <a:t>• REGISTERED only</a:t>
-            </a:r>
-            <a:endParaRPr lang="en-US" sz="1350" dirty="0"/>
-          </a:p>
         </p:txBody>
       </p:sp>
       <p:sp>
@@ -11371,12 +11351,12 @@
         </p:nvSpPr>
         <p:spPr>
           <a:xfrm>
-            <a:off x="6246876" y="2586514"/>
-            <a:ext cx="5335524" cy="2050732"/>
+            <a:off x="6246876" y="2693670"/>
+            <a:ext cx="5335524" cy="1836420"/>
           </a:xfrm>
           <a:prstGeom prst="roundRect">
             <a:avLst>
-              <a:gd name="adj" fmla="val 5351"/>
+              <a:gd name="adj" fmla="val 5975"/>
             </a:avLst>
           </a:prstGeom>
           <a:solidFill>
@@ -11406,7 +11386,7 @@
         </p:blipFill>
         <p:spPr>
           <a:xfrm>
-            <a:off x="6521196" y="2906554"/>
+            <a:off x="6521196" y="3013710"/>
             <a:ext cx="265176" cy="265176"/>
           </a:xfrm>
           <a:prstGeom prst="rect">
@@ -11422,7 +11402,7 @@
         </p:nvSpPr>
         <p:spPr>
           <a:xfrm>
-            <a:off x="6521196" y="3363754"/>
+            <a:off x="6521196" y="3470910"/>
             <a:ext cx="4786884" cy="219075"/>
           </a:xfrm>
           <a:prstGeom prst="rect">
@@ -11464,8 +11444,8 @@
         </p:nvSpPr>
         <p:spPr>
           <a:xfrm>
-            <a:off x="6521196" y="3674269"/>
-            <a:ext cx="4786884" cy="798385"/>
+            <a:off x="6521196" y="3781425"/>
+            <a:ext cx="4786884" cy="584073"/>
           </a:xfrm>
           <a:prstGeom prst="rect">
             <a:avLst/>
@@ -11492,7 +11472,7 @@
                 <a:ea typeface="Segoe UI" pitchFamily="34" charset="-122"/>
                 <a:cs typeface="Segoe UI" pitchFamily="34" charset="-120"/>
               </a:rPr>
-              <a:t>• createPhlcLabOrder after return</a:t>
+              <a:t>• REGISTERED only, after return</a:t>
             </a:r>
             <a:endParaRPr lang="en-US" sz="1350" dirty="0"/>
           </a:p>
@@ -11512,7 +11492,7 @@
                 <a:ea typeface="Segoe UI" pitchFamily="34" charset="-122"/>
                 <a:cs typeface="Segoe UI" pitchFamily="34" charset="-120"/>
               </a:rPr>
-              <a:t>• REGISTERED only</a:t>
+              <a:t>• Fail writes SORT_PHLC_FAIL</a:t>
             </a:r>
             <a:endParaRPr lang="en-US" sz="1350" dirty="0"/>
           </a:p>
@@ -11526,7 +11506,7 @@
         </p:nvSpPr>
         <p:spPr>
           <a:xfrm>
-            <a:off x="609600" y="4865846"/>
+            <a:off x="609600" y="4758690"/>
             <a:ext cx="10972800" cy="365760"/>
           </a:xfrm>
           <a:prstGeom prst="rect">
@@ -11554,7 +11534,7 @@
                 <a:ea typeface="Segoe UI" pitchFamily="34" charset="-122"/>
                 <a:cs typeface="Segoe UI" pitchFamily="34" charset="-120"/>
               </a:rPr>
-              <a:t>Other statuses.  </a:t>
+              <a:t>Status stays REGISTERED.  </a:t>
             </a:r>
             <a:pPr algn="l" indent="0" marL="0">
               <a:lnSpc>
@@ -11571,7 +11551,7 @@
                 <a:ea typeface="Segoe UI" pitchFamily="34" charset="-122"/>
                 <a:cs typeface="Segoe UI" pitchFamily="34" charset="-120"/>
               </a:rPr>
-              <a:t>SEND_OUT, RELABEL and FAILURE do not print or call PHLC. A late worksheet does not change a status already returned. Print failure is an ALS warning.</a:t>
+              <a:t>ALS still warns. Put SORT_WS_FAIL and SORT_PHLC_FAIL on the Audit Trail filter. SEND_OUT, RELABEL and FAILURE do not print or call PHLC.</a:t>
             </a:r>
             <a:endParaRPr lang="en-US" sz="1200" dirty="0"/>
           </a:p>
@@ -16422,7 +16402,7 @@
                 <a:ea typeface="Segoe UI" pitchFamily="34" charset="-122"/>
                 <a:cs typeface="Segoe UI" pitchFamily="34" charset="-120"/>
               </a:rPr>
-              <a:t>• New SORT_* audits on LOE_AUDIT_TRAIL</a:t>
+              <a:t>• New SORT_* on LOE_AUDIT_TRAIL</a:t>
             </a:r>
             <a:endParaRPr lang="en-US" sz="1200" dirty="0"/>
           </a:p>
@@ -16442,7 +16422,7 @@
                 <a:ea typeface="Segoe UI" pitchFamily="34" charset="-122"/>
                 <a:cs typeface="Segoe UI" pitchFamily="34" charset="-120"/>
               </a:rPr>
-              <a:t>• Same today's REG and SEND_OUT</a:t>
+              <a:t>• Print or PHLC fail writes SORT_WS_FAIL / SORT_PHLC_FAIL</a:t>
             </a:r>
             <a:endParaRPr lang="en-US" sz="1200" dirty="0"/>
           </a:p>

</xml_diff>

<commit_message>
vault backup: 2026-09-22 17:43:45
</commit_message>
<xml_diff>
--- a/SDLC/Projects/TMP-specimen-sorter-api — Specimen Sorter API/assets/Specimen Sorter API v3.pptx
+++ b/SDLC/Projects/TMP-specimen-sorter-api — Specimen Sorter API/assets/Specimen Sorter API v3.pptx
@@ -11551,7 +11551,7 @@
                 <a:ea typeface="Segoe UI" pitchFamily="34" charset="-122"/>
                 <a:cs typeface="Segoe UI" pitchFamily="34" charset="-120"/>
               </a:rPr>
-              <a:t>ALS still warns. Put SORT_WS_FAIL and SORT_PHLC_FAIL on the Audit Trail filter. SEND_OUT, RELABEL and FAILURE do not print or call PHLC.</a:t>
+              <a:t>Put SORT_WS_FAIL and SORT_PHLC_FAIL on the Audit Trail action. SEND_OUT, RELABEL and FAILURE do not print or call PHLC.</a:t>
             </a:r>
             <a:endParaRPr lang="en-US" sz="1200" dirty="0"/>
           </a:p>
@@ -11661,7 +11661,7 @@
                 <a:ea typeface="Segoe UI Semibold" pitchFamily="34" charset="-122"/>
                 <a:cs typeface="Segoe UI Semibold" pitchFamily="34" charset="-120"/>
               </a:rPr>
-              <a:t>Seed workbench, open the gateway path, pilot CPS and HMS</a:t>
+              <a:t>Apply for the APIM provider, then seed workbench and labuser</a:t>
             </a:r>
             <a:endParaRPr lang="en-US" sz="2400" dirty="0"/>
           </a:p>
@@ -11675,12 +11675,12 @@
         </p:nvSpPr>
         <p:spPr>
           <a:xfrm>
-            <a:off x="609600" y="2539032"/>
-            <a:ext cx="5335524" cy="2694337"/>
+            <a:off x="609600" y="2706053"/>
+            <a:ext cx="5335524" cy="2360295"/>
           </a:xfrm>
           <a:prstGeom prst="roundRect">
             <a:avLst>
-              <a:gd name="adj" fmla="val 4073"/>
+              <a:gd name="adj" fmla="val 4649"/>
             </a:avLst>
           </a:prstGeom>
           <a:solidFill>
@@ -11710,7 +11710,7 @@
         </p:blipFill>
         <p:spPr>
           <a:xfrm>
-            <a:off x="883920" y="2845356"/>
+            <a:off x="883920" y="3012377"/>
             <a:ext cx="265176" cy="265176"/>
           </a:xfrm>
           <a:prstGeom prst="rect">
@@ -11726,7 +11726,7 @@
         </p:nvSpPr>
         <p:spPr>
           <a:xfrm>
-            <a:off x="1249680" y="2831640"/>
+            <a:off x="1249680" y="2998661"/>
             <a:ext cx="4421124" cy="292608"/>
           </a:xfrm>
           <a:prstGeom prst="rect">
@@ -11768,7 +11768,7 @@
         </p:nvSpPr>
         <p:spPr>
           <a:xfrm>
-            <a:off x="883920" y="3261408"/>
+            <a:off x="883920" y="3428429"/>
             <a:ext cx="228600" cy="228600"/>
           </a:xfrm>
           <a:prstGeom prst="ellipse">
@@ -11813,7 +11813,7 @@
         </p:nvSpPr>
         <p:spPr>
           <a:xfrm>
-            <a:off x="1222248" y="3288840"/>
+            <a:off x="1222248" y="3455861"/>
             <a:ext cx="4448556" cy="196882"/>
           </a:xfrm>
           <a:prstGeom prst="rect">
@@ -11841,7 +11841,7 @@
                 <a:ea typeface="Segoe UI" pitchFamily="34" charset="-122"/>
                 <a:cs typeface="Segoe UI" pitchFamily="34" charset="-120"/>
               </a:rPr>
-              <a:t>Seed workbench: station name = sorter id, user = wkbh_id.</a:t>
+              <a:t>Apply for the API provider on APIM.</a:t>
             </a:r>
             <a:endParaRPr lang="en-US" sz="1125" dirty="0"/>
           </a:p>
@@ -11855,7 +11855,7 @@
         </p:nvSpPr>
         <p:spPr>
           <a:xfrm>
-            <a:off x="883920" y="3595449"/>
+            <a:off x="883920" y="3762470"/>
             <a:ext cx="228600" cy="228600"/>
           </a:xfrm>
           <a:prstGeom prst="ellipse">
@@ -11900,7 +11900,7 @@
         </p:nvSpPr>
         <p:spPr>
           <a:xfrm>
-            <a:off x="1222248" y="3622881"/>
+            <a:off x="1222248" y="3789902"/>
             <a:ext cx="4448556" cy="196882"/>
           </a:xfrm>
           <a:prstGeom prst="rect">
@@ -11928,7 +11928,7 @@
                 <a:ea typeface="Segoe UI" pitchFamily="34" charset="-122"/>
                 <a:cs typeface="Segoe UI" pitchFamily="34" charset="-120"/>
               </a:rPr>
-              <a:t>Map row only if hospital can be omitted.</a:t>
+              <a:t>Seed workbench and labuser.</a:t>
             </a:r>
             <a:endParaRPr lang="en-US" sz="1125" dirty="0"/>
           </a:p>
@@ -11942,7 +11942,7 @@
         </p:nvSpPr>
         <p:spPr>
           <a:xfrm>
-            <a:off x="883920" y="3929491"/>
+            <a:off x="883920" y="4096512"/>
             <a:ext cx="228600" cy="228600"/>
           </a:xfrm>
           <a:prstGeom prst="ellipse">
@@ -11987,7 +11987,7 @@
         </p:nvSpPr>
         <p:spPr>
           <a:xfrm>
-            <a:off x="1222248" y="3956923"/>
+            <a:off x="1222248" y="4123944"/>
             <a:ext cx="4448556" cy="196882"/>
           </a:xfrm>
           <a:prstGeom prst="rect">
@@ -12015,7 +12015,7 @@
                 <a:ea typeface="Segoe UI" pitchFamily="34" charset="-122"/>
                 <a:cs typeface="Segoe UI" pitchFamily="34" charset="-120"/>
               </a:rPr>
-              <a:t>Deploy lis-crs-spec-ack-svc.</a:t>
+              <a:t>loe_specimen_sorter_map if hospital is omitted.</a:t>
             </a:r>
             <a:endParaRPr lang="en-US" sz="1125" dirty="0"/>
           </a:p>
@@ -12029,7 +12029,7 @@
         </p:nvSpPr>
         <p:spPr>
           <a:xfrm>
-            <a:off x="883920" y="4263533"/>
+            <a:off x="883920" y="4430554"/>
             <a:ext cx="228600" cy="228600"/>
           </a:xfrm>
           <a:prstGeom prst="ellipse">
@@ -12074,7 +12074,7 @@
         </p:nvSpPr>
         <p:spPr>
           <a:xfrm>
-            <a:off x="1222248" y="4290965"/>
+            <a:off x="1222248" y="4457986"/>
             <a:ext cx="4448556" cy="196882"/>
           </a:xfrm>
           <a:prstGeom prst="rect">
@@ -12102,7 +12102,7 @@
                 <a:ea typeface="Segoe UI" pitchFamily="34" charset="-122"/>
                 <a:cs typeface="Segoe UI" pitchFamily="34" charset="-120"/>
               </a:rPr>
-              <a:t>Publish the APIM product and NetworkPolicy.</a:t>
+              <a:t>Deploy lis-crs-spec-ack-svc.</a:t>
             </a:r>
             <a:endParaRPr lang="en-US" sz="1125" dirty="0"/>
           </a:p>
@@ -12110,105 +12110,18 @@
       </p:sp>
       <p:sp>
         <p:nvSpPr>
-          <p:cNvPr id="15" name="Text 12"/>
-          <p:cNvSpPr/>
-          <p:nvPr/>
-        </p:nvSpPr>
-        <p:spPr>
-          <a:xfrm>
-            <a:off x="883920" y="4597575"/>
-            <a:ext cx="228600" cy="228600"/>
-          </a:xfrm>
-          <a:prstGeom prst="ellipse">
-            <a:avLst/>
-          </a:prstGeom>
-          <a:solidFill>
-            <a:srgbClr val="DCFCE7"/>
-          </a:solidFill>
-          <a:ln>
-            <a:solidFill>
-              <a:srgbClr val="DCFCE7"/>
-            </a:solidFill>
-          </a:ln>
-        </p:spPr>
-        <p:txBody>
-          <a:bodyPr wrap="square" lIns="0" tIns="0" rIns="0" bIns="0" rtlCol="0" anchor="ctr"/>
-          <a:lstStyle/>
-          <a:p>
-            <a:pPr algn="ctr" indent="0" marL="0">
-              <a:buNone/>
-            </a:pPr>
-            <a:r>
-              <a:rPr lang="en-US" sz="975" b="1" dirty="0">
-                <a:solidFill>
-                  <a:srgbClr val="15803D"/>
-                </a:solidFill>
-                <a:latin typeface="Segoe UI" pitchFamily="34" charset="0"/>
-                <a:ea typeface="Segoe UI" pitchFamily="34" charset="-122"/>
-                <a:cs typeface="Segoe UI" pitchFamily="34" charset="-120"/>
-              </a:rPr>
-              <a:t>5</a:t>
-            </a:r>
-            <a:endParaRPr lang="en-US" sz="975" dirty="0"/>
-          </a:p>
-        </p:txBody>
-      </p:sp>
-      <p:sp>
-        <p:nvSpPr>
-          <p:cNvPr id="16" name="Text 13"/>
-          <p:cNvSpPr/>
-          <p:nvPr/>
-        </p:nvSpPr>
-        <p:spPr>
-          <a:xfrm>
-            <a:off x="1222248" y="4625007"/>
-            <a:ext cx="4448556" cy="196882"/>
-          </a:xfrm>
-          <a:prstGeom prst="rect">
-            <a:avLst/>
-          </a:prstGeom>
-          <a:noFill/>
-          <a:ln/>
-        </p:spPr>
-        <p:txBody>
-          <a:bodyPr wrap="square" lIns="0" tIns="0" rIns="0" bIns="0" rtlCol="0" anchor="t"/>
-          <a:lstStyle/>
-          <a:p>
-            <a:pPr algn="l" indent="0" marL="0">
-              <a:lnSpc>
-                <a:spcPct val="115000"/>
-              </a:lnSpc>
-              <a:buNone/>
-            </a:pPr>
-            <a:r>
-              <a:rPr lang="en-US" sz="1125" dirty="0">
-                <a:solidFill>
-                  <a:srgbClr val="334155"/>
-                </a:solidFill>
-                <a:latin typeface="Segoe UI" pitchFamily="34" charset="0"/>
-                <a:ea typeface="Segoe UI" pitchFamily="34" charset="-122"/>
-                <a:cs typeface="Segoe UI" pitchFamily="34" charset="-120"/>
-              </a:rPr>
-              <a:t>Pilot CPS and HMS.</a:t>
-            </a:r>
-            <a:endParaRPr lang="en-US" sz="1125" dirty="0"/>
-          </a:p>
-        </p:txBody>
-      </p:sp>
-      <p:sp>
-        <p:nvSpPr>
-          <p:cNvPr id="17" name="Shape 14"/>
-          <p:cNvSpPr/>
-          <p:nvPr/>
-        </p:nvSpPr>
-        <p:spPr>
-          <a:xfrm>
-            <a:off x="6246876" y="2539032"/>
-            <a:ext cx="5335524" cy="2694337"/>
+          <p:cNvPr id="15" name="Shape 12"/>
+          <p:cNvSpPr/>
+          <p:nvPr/>
+        </p:nvSpPr>
+        <p:spPr>
+          <a:xfrm>
+            <a:off x="6246876" y="2706053"/>
+            <a:ext cx="5335524" cy="2360295"/>
           </a:xfrm>
           <a:prstGeom prst="roundRect">
             <a:avLst>
-              <a:gd name="adj" fmla="val 4073"/>
+              <a:gd name="adj" fmla="val 4649"/>
             </a:avLst>
           </a:prstGeom>
           <a:solidFill>
@@ -12224,7 +12137,7 @@
       </p:sp>
       <p:pic>
         <p:nvPicPr>
-          <p:cNvPr id="18" name="Image 1" descr="D:\Github\HA-Notes\LIS\skills\design-review-pptx\assets\icons\png\danger\rotate-left.png">    </p:cNvPr>
+          <p:cNvPr id="16" name="Image 1" descr="D:\Github\HA-Notes\LIS\skills\design-review-pptx\assets\icons\png\danger\rotate-left.png">    </p:cNvPr>
           <p:cNvPicPr>
             <a:picLocks noChangeAspect="1"/>
           </p:cNvPicPr>
@@ -12238,7 +12151,7 @@
         </p:blipFill>
         <p:spPr>
           <a:xfrm>
-            <a:off x="6521196" y="2845356"/>
+            <a:off x="6521196" y="3012377"/>
             <a:ext cx="265176" cy="265176"/>
           </a:xfrm>
           <a:prstGeom prst="rect">
@@ -12248,13 +12161,13 @@
       </p:pic>
       <p:sp>
         <p:nvSpPr>
-          <p:cNvPr id="19" name="Text 15"/>
-          <p:cNvSpPr/>
-          <p:nvPr/>
-        </p:nvSpPr>
-        <p:spPr>
-          <a:xfrm>
-            <a:off x="6886956" y="2831640"/>
+          <p:cNvPr id="17" name="Text 13"/>
+          <p:cNvSpPr/>
+          <p:nvPr/>
+        </p:nvSpPr>
+        <p:spPr>
+          <a:xfrm>
+            <a:off x="6886956" y="2998661"/>
             <a:ext cx="4421124" cy="292608"/>
           </a:xfrm>
           <a:prstGeom prst="rect">
@@ -12290,13 +12203,13 @@
       </p:sp>
       <p:sp>
         <p:nvSpPr>
-          <p:cNvPr id="20" name="Text 16"/>
-          <p:cNvSpPr/>
-          <p:nvPr/>
-        </p:nvSpPr>
-        <p:spPr>
-          <a:xfrm>
-            <a:off x="6521196" y="3261408"/>
+          <p:cNvPr id="18" name="Text 14"/>
+          <p:cNvSpPr/>
+          <p:nvPr/>
+        </p:nvSpPr>
+        <p:spPr>
+          <a:xfrm>
+            <a:off x="6521196" y="3428429"/>
             <a:ext cx="228600" cy="228600"/>
           </a:xfrm>
           <a:prstGeom prst="ellipse">
@@ -12335,13 +12248,13 @@
       </p:sp>
       <p:sp>
         <p:nvSpPr>
-          <p:cNvPr id="21" name="Text 17"/>
-          <p:cNvSpPr/>
-          <p:nvPr/>
-        </p:nvSpPr>
-        <p:spPr>
-          <a:xfrm>
-            <a:off x="6859524" y="3288840"/>
+          <p:cNvPr id="19" name="Text 15"/>
+          <p:cNvSpPr/>
+          <p:nvPr/>
+        </p:nvSpPr>
+        <p:spPr>
+          <a:xfrm>
+            <a:off x="6859524" y="3455861"/>
             <a:ext cx="4448556" cy="196882"/>
           </a:xfrm>
           <a:prstGeom prst="rect">
@@ -12377,13 +12290,13 @@
       </p:sp>
       <p:sp>
         <p:nvSpPr>
-          <p:cNvPr id="22" name="Text 18"/>
-          <p:cNvSpPr/>
-          <p:nvPr/>
-        </p:nvSpPr>
-        <p:spPr>
-          <a:xfrm>
-            <a:off x="6521196" y="3595449"/>
+          <p:cNvPr id="20" name="Text 16"/>
+          <p:cNvSpPr/>
+          <p:nvPr/>
+        </p:nvSpPr>
+        <p:spPr>
+          <a:xfrm>
+            <a:off x="6521196" y="3762470"/>
             <a:ext cx="228600" cy="228600"/>
           </a:xfrm>
           <a:prstGeom prst="ellipse">
@@ -12422,13 +12335,13 @@
       </p:sp>
       <p:sp>
         <p:nvSpPr>
-          <p:cNvPr id="23" name="Text 19"/>
-          <p:cNvSpPr/>
-          <p:nvPr/>
-        </p:nvSpPr>
-        <p:spPr>
-          <a:xfrm>
-            <a:off x="6859524" y="3622881"/>
+          <p:cNvPr id="21" name="Text 17"/>
+          <p:cNvSpPr/>
+          <p:nvPr/>
+        </p:nvSpPr>
+        <p:spPr>
+          <a:xfrm>
+            <a:off x="6859524" y="3789902"/>
             <a:ext cx="4448556" cy="196882"/>
           </a:xfrm>
           <a:prstGeom prst="rect">
@@ -12464,13 +12377,13 @@
       </p:sp>
       <p:sp>
         <p:nvSpPr>
-          <p:cNvPr id="24" name="Text 20"/>
-          <p:cNvSpPr/>
-          <p:nvPr/>
-        </p:nvSpPr>
-        <p:spPr>
-          <a:xfrm>
-            <a:off x="6521196" y="3929491"/>
+          <p:cNvPr id="22" name="Text 18"/>
+          <p:cNvSpPr/>
+          <p:nvPr/>
+        </p:nvSpPr>
+        <p:spPr>
+          <a:xfrm>
+            <a:off x="6521196" y="4096512"/>
             <a:ext cx="228600" cy="228600"/>
           </a:xfrm>
           <a:prstGeom prst="ellipse">
@@ -12509,13 +12422,13 @@
       </p:sp>
       <p:sp>
         <p:nvSpPr>
-          <p:cNvPr id="25" name="Text 21"/>
-          <p:cNvSpPr/>
-          <p:nvPr/>
-        </p:nvSpPr>
-        <p:spPr>
-          <a:xfrm>
-            <a:off x="6859524" y="3956923"/>
+          <p:cNvPr id="23" name="Text 19"/>
+          <p:cNvSpPr/>
+          <p:nvPr/>
+        </p:nvSpPr>
+        <p:spPr>
+          <a:xfrm>
+            <a:off x="6859524" y="4123944"/>
             <a:ext cx="4448556" cy="196882"/>
           </a:xfrm>
           <a:prstGeom prst="rect">

</xml_diff>

<commit_message>
vault backup: 2026-09-23 09:59:25
</commit_message>
<xml_diff>
--- a/SDLC/Projects/TMP-specimen-sorter-api — Specimen Sorter API/assets/Specimen Sorter API v3.pptx
+++ b/SDLC/Projects/TMP-specimen-sorter-api — Specimen Sorter API/assets/Specimen Sorter API v3.pptx
@@ -12282,7 +12282,7 @@
                 <a:ea typeface="Segoe UI" pitchFamily="34" charset="-122"/>
                 <a:cs typeface="Segoe UI" pitchFamily="34" charset="-120"/>
               </a:rPr>
-              <a:t>Stop the middleware. Staff Spec Ack is unchanged.</a:t>
+              <a:t>Undeploy lis-crs-spec-ack-svc.</a:t>
             </a:r>
             <a:endParaRPr lang="en-US" sz="1125" dirty="0"/>
           </a:p>
@@ -12456,7 +12456,7 @@
                 <a:ea typeface="Segoe UI" pitchFamily="34" charset="-122"/>
                 <a:cs typeface="Segoe UI" pitchFamily="34" charset="-120"/>
               </a:rPr>
-              <a:t>No conversion of historical requests.</a:t>
+              <a:t>Remove created workbench and labuser.</a:t>
             </a:r>
             <a:endParaRPr lang="en-US" sz="1125" dirty="0"/>
           </a:p>

</xml_diff>

<commit_message>
vault backup: 2026-09-24 16:34:58
</commit_message>
<xml_diff>
--- a/SDLC/Projects/TMP-specimen-sorter-api — Specimen Sorter API/assets/Specimen Sorter API v3.pptx
+++ b/SDLC/Projects/TMP-specimen-sorter-api — Specimen Sorter API/assets/Specimen Sorter API v3.pptx
@@ -15452,7 +15452,7 @@
                           <a:ea typeface="Segoe UI" pitchFamily="34" charset="-122"/>
                           <a:cs typeface="Segoe UI" pitchFamily="34" charset="-120"/>
                         </a:rPr>
-                        <a:t>Screen does</a:t>
+                        <a:t>Spec Ack Front-end</a:t>
                       </a:r>
                       <a:endParaRPr lang="en-US" sz="1125" dirty="0">
                         <a:latin typeface="Segoe UI" charset="0"/>
@@ -15502,7 +15502,7 @@
                           <a:ea typeface="Segoe UI" pitchFamily="34" charset="-122"/>
                           <a:cs typeface="Segoe UI" pitchFamily="34" charset="-120"/>
                         </a:rPr>
-                        <a:t>Service does</a:t>
+                        <a:t>Spec Ack Back-end</a:t>
                       </a:r>
                       <a:endParaRPr lang="en-US" sz="1125" dirty="0">
                         <a:latin typeface="Segoe UI" charset="0"/>
@@ -15654,7 +15654,7 @@
                           <a:ea typeface="Segoe UI" pitchFamily="34" charset="-122"/>
                           <a:cs typeface="Segoe UI" pitchFamily="34" charset="-120"/>
                         </a:rPr>
-                        <a:t>Scans USID, calls retrieve</a:t>
+                        <a:t>Scans USID, calls backend</a:t>
                       </a:r>
                       <a:endParaRPr lang="en-US" sz="1125" dirty="0">
                         <a:latin typeface="Segoe UI" charset="0"/>
@@ -15704,7 +15704,7 @@
                           <a:ea typeface="Consolas" pitchFamily="34" charset="-122"/>
                           <a:cs typeface="Consolas" pitchFamily="34" charset="-120"/>
                         </a:rPr>
-                        <a:t>retrieveGcrOrder</a:t>
+                        <a:t>retrieveGcrOrder()</a:t>
                       </a:r>
                       <a:endParaRPr lang="en-US" sz="1125" dirty="0">
                         <a:latin typeface="Consolas" charset="0"/>
@@ -15856,7 +15856,7 @@
                           <a:ea typeface="Segoe UI" pitchFamily="34" charset="-122"/>
                           <a:cs typeface="Segoe UI" pitchFamily="34" charset="-120"/>
                         </a:rPr>
-                        <a:t>Staff click</a:t>
+                        <a:t>Staff click, calls backend</a:t>
                       </a:r>
                       <a:endParaRPr lang="en-US" sz="1125" dirty="0">
                         <a:latin typeface="Segoe UI" charset="0"/>
@@ -15906,7 +15906,7 @@
                           <a:ea typeface="Consolas" pitchFamily="34" charset="-122"/>
                           <a:cs typeface="Consolas" pitchFamily="34" charset="-120"/>
                         </a:rPr>
-                        <a:t>sendOutSpecimen</a:t>
+                        <a:t>sendOutSpecimen()</a:t>
                       </a:r>
                       <a:endParaRPr lang="en-US" sz="1125" dirty="0">
                         <a:latin typeface="Consolas" charset="0"/>
@@ -16099,17 +16099,6 @@
                       <a:pPr algn="l" indent="0" marL="0">
                         <a:buNone/>
                       </a:pPr>
-                      <a:r>
-                        <a:rPr lang="en-US" sz="1125" dirty="0">
-                          <a:solidFill>
-                            <a:srgbClr val="475569"/>
-                          </a:solidFill>
-                          <a:latin typeface="Segoe UI" pitchFamily="34" charset="0"/>
-                          <a:ea typeface="Segoe UI" pitchFamily="34" charset="-122"/>
-                          <a:cs typeface="Segoe UI" pitchFamily="34" charset="-120"/>
-                        </a:rPr>
-                        <a:t>Assumes checks passed</a:t>
-                      </a:r>
                       <a:endParaRPr lang="en-US" sz="1125" dirty="0">
                         <a:latin typeface="Segoe UI" charset="0"/>
                         <a:ea typeface="Segoe UI" charset="0"/>
@@ -16210,7 +16199,7 @@
                           <a:ea typeface="Segoe UI" pitchFamily="34" charset="-122"/>
                           <a:cs typeface="Segoe UI" pitchFamily="34" charset="-120"/>
                         </a:rPr>
-                        <a:t>Packing</a:t>
+                        <a:t>Registration</a:t>
                       </a:r>
                       <a:endParaRPr lang="en-US" sz="1125" dirty="0">
                         <a:latin typeface="Segoe UI" charset="0"/>
@@ -16260,7 +16249,7 @@
                           <a:ea typeface="Segoe UI" pitchFamily="34" charset="-122"/>
                           <a:cs typeface="Segoe UI" pitchFamily="34" charset="-120"/>
                         </a:rPr>
-                        <a:t>Groups tests, request no., ward and doctor</a:t>
+                        <a:t>Groups tests, request no. assignment, ward and doctor conversions, calls backend</a:t>
                       </a:r>
                       <a:endParaRPr lang="en-US" sz="1125" dirty="0">
                         <a:latin typeface="Segoe UI" charset="0"/>
@@ -16310,7 +16299,7 @@
                           <a:ea typeface="Consolas" pitchFamily="34" charset="-122"/>
                           <a:cs typeface="Consolas" pitchFamily="34" charset="-120"/>
                         </a:rPr>
-                        <a:t>register() needs the packing</a:t>
+                        <a:t>register()</a:t>
                       </a:r>
                       <a:endParaRPr lang="en-US" sz="1125" dirty="0">
                         <a:latin typeface="Consolas" charset="0"/>
@@ -16462,7 +16451,7 @@
                           <a:ea typeface="Segoe UI" pitchFamily="34" charset="-122"/>
                           <a:cs typeface="Segoe UI" pitchFamily="34" charset="-120"/>
                         </a:rPr>
-                        <a:t>Data conversion, staff pick</a:t>
+                        <a:t>Data conversion, staff pick, calls backend</a:t>
                       </a:r>
                       <a:endParaRPr lang="en-US" sz="1125" dirty="0">
                         <a:latin typeface="Segoe UI" charset="0"/>
@@ -16658,7 +16647,7 @@
                           <a:ea typeface="Segoe UI" pitchFamily="34" charset="-122"/>
                           <a:cs typeface="Segoe UI" pitchFamily="34" charset="-120"/>
                         </a:rPr>
-                        <a:t>Calls after register</a:t>
+                        <a:t>Calls after register, calls backend</a:t>
                       </a:r>
                       <a:endParaRPr lang="en-US" sz="1125" dirty="0">
                         <a:latin typeface="Segoe UI" charset="0"/>
@@ -16702,7 +16691,7 @@
                           <a:ea typeface="Consolas" pitchFamily="34" charset="-122"/>
                           <a:cs typeface="Consolas" pitchFamily="34" charset="-120"/>
                         </a:rPr>
-                        <a:t>createPhlcLabOrder</a:t>
+                        <a:t>createPhlcLabOrder()</a:t>
                       </a:r>
                       <a:endParaRPr lang="en-US" sz="1125" dirty="0">
                         <a:latin typeface="Consolas" charset="0"/>

</xml_diff>

<commit_message>
vault backup: 2026-09-24 16:47:28
</commit_message>
<xml_diff>
--- a/SDLC/Projects/TMP-specimen-sorter-api — Specimen Sorter API/assets/Specimen Sorter API v3.pptx
+++ b/SDLC/Projects/TMP-specimen-sorter-api — Specimen Sorter API/assets/Specimen Sorter API v3.pptx
@@ -15371,7 +15371,7 @@
           </p:nvPr>
         </p:nvGraphicFramePr>
         <p:xfrm>
-          <a:off x="609600" y="2286000"/>
+          <a:off x="609600" y="1520904"/>
           <a:ext cx="10972800" cy="914400"/>
         </p:xfrm>
         <a:graphic>
@@ -15384,7 +15384,7 @@
                 <a:gridCol w="3200400"/>
                 <a:gridCol w="3017520"/>
               </a:tblGrid>
-              <a:tr h="457200">
+              <a:tr h="675799">
                 <a:tc>
                   <a:txBody>
                     <a:bodyPr/>
@@ -15586,7 +15586,7 @@
                   </a:tcPr>
                 </a:tc>
               </a:tr>
-              <a:tr h="457200">
+              <a:tr h="675799">
                 <a:tc>
                   <a:txBody>
                     <a:bodyPr/>
@@ -15788,7 +15788,7 @@
                   </a:tcPr>
                 </a:tc>
               </a:tr>
-              <a:tr h="457200">
+              <a:tr h="675799">
                 <a:tc>
                   <a:txBody>
                     <a:bodyPr/>
@@ -15990,7 +15990,7 @@
                   </a:tcPr>
                 </a:tc>
               </a:tr>
-              <a:tr h="457200">
+              <a:tr h="675799">
                 <a:tc>
                   <a:txBody>
                     <a:bodyPr/>
@@ -16181,7 +16181,7 @@
                   </a:tcPr>
                 </a:tc>
               </a:tr>
-              <a:tr h="457200">
+              <a:tr h="675799">
                 <a:tc>
                   <a:txBody>
                     <a:bodyPr/>
@@ -16383,7 +16383,7 @@
                   </a:tcPr>
                 </a:tc>
               </a:tr>
-              <a:tr h="457200">
+              <a:tr h="675799">
                 <a:tc>
                   <a:txBody>
                     <a:bodyPr/>
@@ -16585,7 +16585,7 @@
                   </a:tcPr>
                 </a:tc>
               </a:tr>
-              <a:tr h="457200">
+              <a:tr h="675799">
                 <a:tc>
                   <a:txBody>
                     <a:bodyPr/>
@@ -16775,12 +16775,12 @@
         </p:nvSpPr>
         <p:spPr>
           <a:xfrm>
-            <a:off x="609600" y="2286000"/>
-            <a:ext cx="10972800" cy="3200400"/>
+            <a:off x="609600" y="1520904"/>
+            <a:ext cx="10972800" cy="4730591"/>
           </a:xfrm>
           <a:prstGeom prst="roundRect">
             <a:avLst>
-              <a:gd name="adj" fmla="val 3429"/>
+              <a:gd name="adj" fmla="val 2320"/>
             </a:avLst>
           </a:prstGeom>
           <a:solidFill>

</xml_diff>

<commit_message>
vault backup: 2026-09-24 17:06:03
</commit_message>
<xml_diff>
--- a/SDLC/Projects/TMP-specimen-sorter-api — Specimen Sorter API/assets/Specimen Sorter API v3.pptx
+++ b/SDLC/Projects/TMP-specimen-sorter-api — Specimen Sorter API/assets/Specimen Sorter API v3.pptx
@@ -9399,7 +9399,7 @@
           </p:nvPr>
         </p:nvGraphicFramePr>
         <p:xfrm>
-          <a:off x="609600" y="1453896"/>
+          <a:off x="609600" y="1545336"/>
           <a:ext cx="10972800" cy="914400"/>
         </p:xfrm>
         <a:graphic>
@@ -10814,7 +10814,7 @@
         </p:nvSpPr>
         <p:spPr>
           <a:xfrm>
-            <a:off x="609600" y="1453896"/>
+            <a:off x="609600" y="1545336"/>
             <a:ext cx="10972800" cy="3200400"/>
           </a:xfrm>
           <a:prstGeom prst="roundRect">
@@ -10843,12 +10843,12 @@
         </p:nvSpPr>
         <p:spPr>
           <a:xfrm>
-            <a:off x="609600" y="4928616"/>
-            <a:ext cx="5335524" cy="1389888"/>
+            <a:off x="609600" y="5020056"/>
+            <a:ext cx="5335524" cy="1207008"/>
           </a:xfrm>
           <a:prstGeom prst="roundRect">
             <a:avLst>
-              <a:gd name="adj" fmla="val 7895"/>
+              <a:gd name="adj" fmla="val 9091"/>
             </a:avLst>
           </a:prstGeom>
           <a:solidFill>
@@ -10870,7 +10870,7 @@
         </p:nvSpPr>
         <p:spPr>
           <a:xfrm>
-            <a:off x="883920" y="5166360"/>
+            <a:off x="883920" y="5257800"/>
             <a:ext cx="4786884" cy="274320"/>
           </a:xfrm>
           <a:prstGeom prst="rect">
@@ -10912,8 +10912,8 @@
         </p:nvSpPr>
         <p:spPr>
           <a:xfrm>
-            <a:off x="883920" y="5495544"/>
-            <a:ext cx="4786884" cy="658368"/>
+            <a:off x="883920" y="5586984"/>
+            <a:ext cx="4786884" cy="475488"/>
           </a:xfrm>
           <a:prstGeom prst="rect">
             <a:avLst/>
@@ -10960,30 +10960,10 @@
                 <a:ea typeface="Segoe UI" pitchFamily="34" charset="-122"/>
                 <a:cs typeface="Segoe UI" pitchFamily="34" charset="-120"/>
               </a:rPr>
-              <a:t>• Hospital sent: skip the map</a:t>
+              <a:t>• Do not need the map if caller sends hospital.</a:t>
             </a:r>
             <a:endParaRPr lang="en-US" sz="1200" dirty="0"/>
           </a:p>
-          <a:p>
-            <a:pPr algn="l" indent="0" marL="0">
-              <a:lnSpc>
-                <a:spcPct val="115000"/>
-              </a:lnSpc>
-              <a:buNone/>
-            </a:pPr>
-            <a:r>
-              <a:rPr lang="en-US" sz="1200" dirty="0">
-                <a:solidFill>
-                  <a:srgbClr val="475569"/>
-                </a:solidFill>
-                <a:latin typeface="Segoe UI" pitchFamily="34" charset="0"/>
-                <a:ea typeface="Segoe UI" pitchFamily="34" charset="-122"/>
-                <a:cs typeface="Segoe UI" pitchFamily="34" charset="-120"/>
-              </a:rPr>
-              <a:t>• Do not seed the map if every caller sends hospital.</a:t>
-            </a:r>
-            <a:endParaRPr lang="en-US" sz="1200" dirty="0"/>
-          </a:p>
         </p:txBody>
       </p:sp>
       <p:sp>
@@ -10994,12 +10974,12 @@
         </p:nvSpPr>
         <p:spPr>
           <a:xfrm>
-            <a:off x="6246876" y="4928616"/>
-            <a:ext cx="5335524" cy="1389888"/>
+            <a:off x="6246876" y="5020056"/>
+            <a:ext cx="5335524" cy="1207008"/>
           </a:xfrm>
           <a:prstGeom prst="roundRect">
             <a:avLst>
-              <a:gd name="adj" fmla="val 7895"/>
+              <a:gd name="adj" fmla="val 9091"/>
             </a:avLst>
           </a:prstGeom>
           <a:solidFill>
@@ -11021,7 +11001,7 @@
         </p:nvSpPr>
         <p:spPr>
           <a:xfrm>
-            <a:off x="6521196" y="5166360"/>
+            <a:off x="6521196" y="5257800"/>
             <a:ext cx="4786884" cy="274320"/>
           </a:xfrm>
           <a:prstGeom prst="rect">
@@ -11063,8 +11043,8 @@
         </p:nvSpPr>
         <p:spPr>
           <a:xfrm>
-            <a:off x="6521196" y="5495544"/>
-            <a:ext cx="4786884" cy="658368"/>
+            <a:off x="6521196" y="5586984"/>
+            <a:ext cx="4786884" cy="475488"/>
           </a:xfrm>
           <a:prstGeom prst="rect">
             <a:avLst/>
@@ -12747,7 +12727,7 @@
                 <a:ea typeface="Segoe UI" pitchFamily="34" charset="-122"/>
                 <a:cs typeface="Segoe UI" pitchFamily="34" charset="-120"/>
               </a:rPr>
-              <a:t>Put SORT_WS_FAIL and SORT_PHLC_FAIL on the Audit Trail action. SEND_OUT, RELABEL and FAILURE do not print or call PHLC.</a:t>
+              <a:t>Put SORT_WS_FAIL and SORT_PHLC_FAIL on the Audit Trail action.</a:t>
             </a:r>
             <a:endParaRPr lang="en-US" sz="1200" dirty="0"/>
           </a:p>
@@ -13776,12 +13756,12 @@
         </p:nvSpPr>
         <p:spPr>
           <a:xfrm>
-            <a:off x="609600" y="1371600"/>
-            <a:ext cx="10972800" cy="716280"/>
+            <a:off x="609600" y="1581912"/>
+            <a:ext cx="10972800" cy="804672"/>
           </a:xfrm>
           <a:prstGeom prst="roundRect">
             <a:avLst>
-              <a:gd name="adj" fmla="val 15319"/>
+              <a:gd name="adj" fmla="val 13636"/>
             </a:avLst>
           </a:prstGeom>
           <a:solidFill>
@@ -13803,8 +13783,8 @@
         </p:nvSpPr>
         <p:spPr>
           <a:xfrm>
-            <a:off x="847344" y="1371600"/>
-            <a:ext cx="502920" cy="716280"/>
+            <a:off x="847344" y="1581912"/>
+            <a:ext cx="502920" cy="804672"/>
           </a:xfrm>
           <a:prstGeom prst="rect">
             <a:avLst/>
@@ -13845,8 +13825,8 @@
         </p:nvSpPr>
         <p:spPr>
           <a:xfrm>
-            <a:off x="1341120" y="1371600"/>
-            <a:ext cx="10003536" cy="716280"/>
+            <a:off x="1341120" y="1581912"/>
+            <a:ext cx="10003536" cy="804672"/>
           </a:xfrm>
           <a:prstGeom prst="rect">
             <a:avLst/>
@@ -13887,12 +13867,12 @@
         </p:nvSpPr>
         <p:spPr>
           <a:xfrm>
-            <a:off x="609600" y="2234184"/>
-            <a:ext cx="10972800" cy="716280"/>
+            <a:off x="609600" y="2532888"/>
+            <a:ext cx="10972800" cy="804672"/>
           </a:xfrm>
           <a:prstGeom prst="roundRect">
             <a:avLst>
-              <a:gd name="adj" fmla="val 15319"/>
+              <a:gd name="adj" fmla="val 13636"/>
             </a:avLst>
           </a:prstGeom>
           <a:solidFill>
@@ -13914,8 +13894,8 @@
         </p:nvSpPr>
         <p:spPr>
           <a:xfrm>
-            <a:off x="847344" y="2234184"/>
-            <a:ext cx="502920" cy="716280"/>
+            <a:off x="847344" y="2532888"/>
+            <a:ext cx="502920" cy="804672"/>
           </a:xfrm>
           <a:prstGeom prst="rect">
             <a:avLst/>
@@ -13956,8 +13936,8 @@
         </p:nvSpPr>
         <p:spPr>
           <a:xfrm>
-            <a:off x="1341120" y="2234184"/>
-            <a:ext cx="10003536" cy="716280"/>
+            <a:off x="1341120" y="2532888"/>
+            <a:ext cx="10003536" cy="804672"/>
           </a:xfrm>
           <a:prstGeom prst="rect">
             <a:avLst/>
@@ -13998,12 +13978,12 @@
         </p:nvSpPr>
         <p:spPr>
           <a:xfrm>
-            <a:off x="609600" y="3096768"/>
-            <a:ext cx="10972800" cy="716280"/>
+            <a:off x="609600" y="3483864"/>
+            <a:ext cx="10972800" cy="804672"/>
           </a:xfrm>
           <a:prstGeom prst="roundRect">
             <a:avLst>
-              <a:gd name="adj" fmla="val 15319"/>
+              <a:gd name="adj" fmla="val 13636"/>
             </a:avLst>
           </a:prstGeom>
           <a:solidFill>
@@ -14025,8 +14005,8 @@
         </p:nvSpPr>
         <p:spPr>
           <a:xfrm>
-            <a:off x="847344" y="3096768"/>
-            <a:ext cx="502920" cy="716280"/>
+            <a:off x="847344" y="3483864"/>
+            <a:ext cx="502920" cy="804672"/>
           </a:xfrm>
           <a:prstGeom prst="rect">
             <a:avLst/>
@@ -14067,8 +14047,8 @@
         </p:nvSpPr>
         <p:spPr>
           <a:xfrm>
-            <a:off x="1341120" y="3096768"/>
-            <a:ext cx="10003536" cy="716280"/>
+            <a:off x="1341120" y="3483864"/>
+            <a:ext cx="10003536" cy="804672"/>
           </a:xfrm>
           <a:prstGeom prst="rect">
             <a:avLst/>
@@ -14109,12 +14089,12 @@
         </p:nvSpPr>
         <p:spPr>
           <a:xfrm>
-            <a:off x="609600" y="3959352"/>
-            <a:ext cx="10972800" cy="716280"/>
+            <a:off x="609600" y="4434840"/>
+            <a:ext cx="10972800" cy="804672"/>
           </a:xfrm>
           <a:prstGeom prst="roundRect">
             <a:avLst>
-              <a:gd name="adj" fmla="val 15319"/>
+              <a:gd name="adj" fmla="val 13636"/>
             </a:avLst>
           </a:prstGeom>
           <a:solidFill>
@@ -14136,8 +14116,8 @@
         </p:nvSpPr>
         <p:spPr>
           <a:xfrm>
-            <a:off x="847344" y="3959352"/>
-            <a:ext cx="502920" cy="716280"/>
+            <a:off x="847344" y="4434840"/>
+            <a:ext cx="502920" cy="804672"/>
           </a:xfrm>
           <a:prstGeom prst="rect">
             <a:avLst/>
@@ -14178,8 +14158,8 @@
         </p:nvSpPr>
         <p:spPr>
           <a:xfrm>
-            <a:off x="1341120" y="3959352"/>
-            <a:ext cx="10003536" cy="716280"/>
+            <a:off x="1341120" y="4434840"/>
+            <a:ext cx="10003536" cy="804672"/>
           </a:xfrm>
           <a:prstGeom prst="rect">
             <a:avLst/>
@@ -14206,7 +14186,7 @@
                 <a:ea typeface="Segoe UI" pitchFamily="34" charset="-122"/>
                 <a:cs typeface="Segoe UI" pitchFamily="34" charset="-120"/>
               </a:rPr>
-              <a:t>Send-out</a:t>
+              <a:t>API contract and data</a:t>
             </a:r>
             <a:endParaRPr lang="en-US" sz="1350" dirty="0"/>
           </a:p>
@@ -14220,12 +14200,12 @@
         </p:nvSpPr>
         <p:spPr>
           <a:xfrm>
-            <a:off x="609600" y="4821936"/>
-            <a:ext cx="10972800" cy="716280"/>
+            <a:off x="609600" y="5385816"/>
+            <a:ext cx="10972800" cy="804672"/>
           </a:xfrm>
           <a:prstGeom prst="roundRect">
             <a:avLst>
-              <a:gd name="adj" fmla="val 15319"/>
+              <a:gd name="adj" fmla="val 13636"/>
             </a:avLst>
           </a:prstGeom>
           <a:solidFill>
@@ -14247,8 +14227,8 @@
         </p:nvSpPr>
         <p:spPr>
           <a:xfrm>
-            <a:off x="847344" y="4821936"/>
-            <a:ext cx="502920" cy="716280"/>
+            <a:off x="847344" y="5385816"/>
+            <a:ext cx="502920" cy="804672"/>
           </a:xfrm>
           <a:prstGeom prst="rect">
             <a:avLst/>
@@ -14289,119 +14269,8 @@
         </p:nvSpPr>
         <p:spPr>
           <a:xfrm>
-            <a:off x="1341120" y="4821936"/>
-            <a:ext cx="10003536" cy="716280"/>
-          </a:xfrm>
-          <a:prstGeom prst="rect">
-            <a:avLst/>
-          </a:prstGeom>
-          <a:noFill/>
-          <a:ln/>
-        </p:spPr>
-        <p:txBody>
-          <a:bodyPr wrap="square" lIns="0" tIns="0" rIns="0" bIns="0" rtlCol="0" anchor="ctr"/>
-          <a:lstStyle/>
-          <a:p>
-            <a:pPr algn="l" indent="0" marL="0">
-              <a:lnSpc>
-                <a:spcPct val="115000"/>
-              </a:lnSpc>
-              <a:buNone/>
-            </a:pPr>
-            <a:r>
-              <a:rPr lang="en-US" sz="1350" b="1" dirty="0">
-                <a:solidFill>
-                  <a:srgbClr val="0F172A"/>
-                </a:solidFill>
-                <a:latin typeface="Segoe UI" pitchFamily="34" charset="0"/>
-                <a:ea typeface="Segoe UI" pitchFamily="34" charset="-122"/>
-                <a:cs typeface="Segoe UI" pitchFamily="34" charset="-120"/>
-              </a:rPr>
-              <a:t>API contract and data</a:t>
-            </a:r>
-            <a:endParaRPr lang="en-US" sz="1350" dirty="0"/>
-          </a:p>
-        </p:txBody>
-      </p:sp>
-      <p:sp>
-        <p:nvSpPr>
-          <p:cNvPr id="19" name="Shape 17"/>
-          <p:cNvSpPr/>
-          <p:nvPr/>
-        </p:nvSpPr>
-        <p:spPr>
-          <a:xfrm>
-            <a:off x="609600" y="5684520"/>
-            <a:ext cx="10972800" cy="716280"/>
-          </a:xfrm>
-          <a:prstGeom prst="roundRect">
-            <a:avLst>
-              <a:gd name="adj" fmla="val 15319"/>
-            </a:avLst>
-          </a:prstGeom>
-          <a:solidFill>
-            <a:srgbClr val="FFFFFF"/>
-          </a:solidFill>
-          <a:ln w="9525">
-            <a:solidFill>
-              <a:srgbClr val="E2E8F0"/>
-            </a:solidFill>
-            <a:prstDash val="solid"/>
-          </a:ln>
-        </p:spPr>
-      </p:sp>
-      <p:sp>
-        <p:nvSpPr>
-          <p:cNvPr id="20" name="Text 18"/>
-          <p:cNvSpPr/>
-          <p:nvPr/>
-        </p:nvSpPr>
-        <p:spPr>
-          <a:xfrm>
-            <a:off x="847344" y="5684520"/>
-            <a:ext cx="502920" cy="716280"/>
-          </a:xfrm>
-          <a:prstGeom prst="rect">
-            <a:avLst/>
-          </a:prstGeom>
-          <a:noFill/>
-          <a:ln/>
-        </p:spPr>
-        <p:txBody>
-          <a:bodyPr wrap="square" lIns="0" tIns="0" rIns="0" bIns="0" rtlCol="0" anchor="ctr"/>
-          <a:lstStyle/>
-          <a:p>
-            <a:pPr algn="l" indent="0" marL="0">
-              <a:lnSpc>
-                <a:spcPct val="115000"/>
-              </a:lnSpc>
-              <a:buNone/>
-            </a:pPr>
-            <a:r>
-              <a:rPr lang="en-US" sz="1500" dirty="0">
-                <a:solidFill>
-                  <a:srgbClr val="0284C7"/>
-                </a:solidFill>
-                <a:latin typeface="Segoe UI Semibold" pitchFamily="34" charset="0"/>
-                <a:ea typeface="Segoe UI Semibold" pitchFamily="34" charset="-122"/>
-                <a:cs typeface="Segoe UI Semibold" pitchFamily="34" charset="-120"/>
-              </a:rPr>
-              <a:t>06</a:t>
-            </a:r>
-            <a:endParaRPr lang="en-US" sz="1500" dirty="0"/>
-          </a:p>
-        </p:txBody>
-      </p:sp>
-      <p:sp>
-        <p:nvSpPr>
-          <p:cNvPr id="21" name="Text 19"/>
-          <p:cNvSpPr/>
-          <p:nvPr/>
-        </p:nvSpPr>
-        <p:spPr>
-          <a:xfrm>
-            <a:off x="1341120" y="5684520"/>
-            <a:ext cx="10003536" cy="716280"/>
+            <a:off x="1341120" y="5385816"/>
+            <a:ext cx="10003536" cy="804672"/>
           </a:xfrm>
           <a:prstGeom prst="rect">
             <a:avLst/>
@@ -16349,7 +16218,7 @@
                           <a:ea typeface="Segoe UI" pitchFamily="34" charset="-122"/>
                           <a:cs typeface="Segoe UI" pitchFamily="34" charset="-120"/>
                         </a:rPr>
-                        <a:t>Server-side convertor</a:t>
+                        <a:t>Server-side convertor, same registration path</a:t>
                       </a:r>
                       <a:endParaRPr lang="en-US" sz="1125" dirty="0">
                         <a:latin typeface="Segoe UI" charset="0"/>
@@ -16551,7 +16420,7 @@
                           <a:ea typeface="Segoe UI" pitchFamily="34" charset="-122"/>
                           <a:cs typeface="Segoe UI" pitchFamily="34" charset="-120"/>
                         </a:rPr>
-                        <a:t>Print all, after Registered</a:t>
+                        <a:t>Server-side convertor, same worksheet printing path</a:t>
                       </a:r>
                       <a:endParaRPr lang="en-US" sz="1125" dirty="0">
                         <a:latin typeface="Segoe UI" charset="0"/>
@@ -16735,7 +16604,7 @@
                           <a:ea typeface="Segoe UI" pitchFamily="34" charset="-122"/>
                           <a:cs typeface="Segoe UI" pitchFamily="34" charset="-120"/>
                         </a:rPr>
-                        <a:t>After Registered</a:t>
+                        <a:t>Same phlc e-order path</a:t>
                       </a:r>
                       <a:endParaRPr lang="en-US" sz="1125" dirty="0">
                         <a:latin typeface="Segoe UI" charset="0"/>

</xml_diff>

<commit_message>
vault backup: 2026-09-24 17:09:39
</commit_message>
<xml_diff>
--- a/SDLC/Projects/TMP-specimen-sorter-api — Specimen Sorter API/assets/Specimen Sorter API v3.pptx
+++ b/SDLC/Projects/TMP-specimen-sorter-api — Specimen Sorter API/assets/Specimen Sorter API v3.pptx
@@ -20537,7 +20537,7 @@
                 <a:ea typeface="Segoe UI Semibold" pitchFamily="34" charset="-122"/>
                 <a:cs typeface="Segoe UI Semibold" pitchFamily="34" charset="-120"/>
               </a:rPr>
-              <a:t>No sorter flag</a:t>
+              <a:t>Neither local nor send-out</a:t>
             </a:r>
             <a:endParaRPr lang="en-US" sz="1275" dirty="0"/>
           </a:p>
@@ -20579,7 +20579,7 @@
                 <a:ea typeface="Segoe UI" pitchFamily="34" charset="-122"/>
                 <a:cs typeface="Segoe UI" pitchFamily="34" charset="-120"/>
               </a:rPr>
-              <a:t>The request does not say send-out. The table does.</a:t>
+              <a:t>Not a local test and not a defined send-out test. FAILURE.</a:t>
             </a:r>
             <a:endParaRPr lang="en-US" sz="1125" dirty="0"/>
           </a:p>

</xml_diff>

<commit_message>
vault backup: 2026-09-24 17:33:57
</commit_message>
<xml_diff>
--- a/SDLC/Projects/TMP-specimen-sorter-api — Specimen Sorter API/assets/Specimen Sorter API v3.pptx
+++ b/SDLC/Projects/TMP-specimen-sorter-api — Specimen Sorter API/assets/Specimen Sorter API v3.pptx
@@ -8337,7 +8337,7 @@
       </p:sp>
       <p:pic>
         <p:nvPicPr>
-          <p:cNvPr id="13" name="Image 1" descr="D:\Github\HA-Notes\LIS\skills\design-review-pptx\assets\icons\png\accent\server.png">    </p:cNvPr>
+          <p:cNvPr id="13" name="Image 1" descr="D:\Github\HA-Notes\LIS\skills\design-review-pptx\assets\icons\png\accent\hospital.png">    </p:cNvPr>
           <p:cNvPicPr>
             <a:picLocks noChangeAspect="1"/>
           </p:cNvPicPr>
@@ -12393,7 +12393,7 @@
       </p:sp>
       <p:pic>
         <p:nvPicPr>
-          <p:cNvPr id="5" name="Image 0" descr="D:\Github\HA-Notes\LIS\skills\design-review-pptx\assets\icons\png\accent\list-check.png">    </p:cNvPr>
+          <p:cNvPr id="5" name="Image 0" descr="D:\Github\HA-Notes\LIS\skills\design-review-pptx\assets\icons\png\accent\print.png">    </p:cNvPr>
           <p:cNvPicPr>
             <a:picLocks noChangeAspect="1"/>
           </p:cNvPicPr>
@@ -12548,7 +12548,7 @@
       </p:sp>
       <p:pic>
         <p:nvPicPr>
-          <p:cNvPr id="9" name="Image 1" descr="D:\Github\HA-Notes\LIS\skills\design-review-pptx\assets\icons\png\accent\clipboard-check.png">    </p:cNvPr>
+          <p:cNvPr id="9" name="Image 1" descr="D:\Github\HA-Notes\LIS\skills\design-review-pptx\assets\icons\png\accent\file-export.png">    </p:cNvPr>
           <p:cNvPicPr>
             <a:picLocks noChangeAspect="1"/>
           </p:cNvPicPr>
@@ -16959,7 +16959,7 @@
       </p:sp>
       <p:pic>
         <p:nvPicPr>
-          <p:cNvPr id="9" name="Image 1" descr="D:\Github\HA-Notes\LIS\skills\design-review-pptx\assets\icons\png\accent\layer-group.png">    </p:cNvPr>
+          <p:cNvPr id="9" name="Image 1" descr="D:\Github\HA-Notes\LIS\skills\design-review-pptx\assets\icons\png\accent\share-nodes.png">    </p:cNvPr>
           <p:cNvPicPr>
             <a:picLocks noChangeAspect="1"/>
           </p:cNvPicPr>
@@ -17114,7 +17114,7 @@
       </p:sp>
       <p:pic>
         <p:nvPicPr>
-          <p:cNvPr id="13" name="Image 2" descr="D:\Github\HA-Notes\LIS\skills\design-review-pptx\assets\icons\png\accent\table.png">    </p:cNvPr>
+          <p:cNvPr id="13" name="Image 2" descr="D:\Github\HA-Notes\LIS\skills\design-review-pptx\assets\icons\png\accent\desktop.png">    </p:cNvPr>
           <p:cNvPicPr>
             <a:picLocks noChangeAspect="1"/>
           </p:cNvPicPr>
@@ -17269,7 +17269,7 @@
       </p:sp>
       <p:pic>
         <p:nvPicPr>
-          <p:cNvPr id="17" name="Image 3" descr="D:\Github\HA-Notes\LIS\skills\design-review-pptx\assets\icons\png\accent\clipboard-check.png">    </p:cNvPr>
+          <p:cNvPr id="17" name="Image 3" descr="D:\Github\HA-Notes\LIS\skills\design-review-pptx\assets\icons\png\accent\timeline.png">    </p:cNvPr>
           <p:cNvPicPr>
             <a:picLocks noChangeAspect="1"/>
           </p:cNvPicPr>
@@ -20209,7 +20209,7 @@
       </p:sp>
       <p:pic>
         <p:nvPicPr>
-          <p:cNvPr id="9" name="Image 0" descr="D:\Github\HA-Notes\LIS\skills\design-review-pptx\assets\icons\png\accent\vial.png">    </p:cNvPr>
+          <p:cNvPr id="9" name="Image 0" descr="D:\Github\HA-Notes\LIS\skills\design-review-pptx\assets\icons\png\accent\truck.png">    </p:cNvPr>
           <p:cNvPicPr>
             <a:picLocks noChangeAspect="1"/>
           </p:cNvPicPr>

</xml_diff>